<commit_message>
Add polished PowerPoint animations
Co-authored-by: M0ntecia <M0ntecia@users.noreply.github.com>
</commit_message>
<xml_diff>
--- a/praesentation/schule_wohlbefinden_praesentation.pptx
+++ b/praesentation/schule_wohlbefinden_praesentation.pptx
@@ -3092,7 +3092,7 @@
 </file>
 
 <file path=ppt/slides/slide1.xml><?xml version="1.0" encoding="utf-8"?>
-<p:sld xmlns:a="http://schemas.openxmlformats.org/drawingml/2006/main" xmlns:p="http://schemas.openxmlformats.org/presentationml/2006/main" xmlns:r="http://schemas.openxmlformats.org/officeDocument/2006/relationships">
+<p:sld xmlns:a="http://schemas.openxmlformats.org/drawingml/2006/main" xmlns:p="http://schemas.openxmlformats.org/presentationml/2006/main" xmlns:r="http://schemas.openxmlformats.org/officeDocument/2006/relationships" xmlns:ns0="http://schemas.openxmlformats.org/markup-compatibility/2006" ns0:Ignorable="p14">
   <p:cSld>
     <p:bg>
       <p:bgPr>
@@ -3678,11 +3678,118 @@
   <p:clrMapOvr>
     <a:masterClrMapping/>
   </p:clrMapOvr>
+  <ns0:AlternateContent xmlns:p14="http://schemas.microsoft.com/office/powerpoint/2010/main">
+    <ns0:Choice Requires="p14">
+      <p:transition spd="med" p14:dur="700">
+        <p:fade/>
+      </p:transition>
+    </ns0:Choice>
+    <ns0:Fallback>
+      <p:transition spd="med">
+        <p:fade/>
+      </p:transition>
+    </ns0:Fallback>
+  </ns0:AlternateContent>
+  <p:timing>
+    <p:tnLst>
+      <p:seq concurrent="1" nextAc="seek">
+        <p:cTn id="1" dur="indefinite" nodeType="mainSeq">
+          <p:stCondLst>
+            <p:cond delay="0"/>
+          </p:stCondLst>
+          <p:childTnLst>
+            <p:par>
+              <p:cTn id="2" fill="hold" nodeType="afterEffect">
+                <p:stCondLst>
+                  <p:cond delay="0"/>
+                </p:stCondLst>
+                <p:childTnLst>
+                  <p:animEffect transition="in" filter="fade">
+                    <p:cBhvr>
+                      <p:cTn id="3" dur="500" fill="hold"/>
+                      <p:tgtEl>
+                        <p:spTgt spid="10"/>
+                      </p:tgtEl>
+                    </p:cBhvr>
+                  </p:animEffect>
+                </p:childTnLst>
+              </p:cTn>
+            </p:par>
+            <p:par>
+              <p:cTn id="4" fill="hold" nodeType="afterEffect">
+                <p:stCondLst>
+                  <p:cond delay="560"/>
+                </p:stCondLst>
+                <p:childTnLst>
+                  <p:animEffect transition="in" filter="fade">
+                    <p:cBhvr>
+                      <p:cTn id="5" dur="450" fill="hold"/>
+                      <p:tgtEl>
+                        <p:spTgt spid="11"/>
+                      </p:tgtEl>
+                    </p:cBhvr>
+                  </p:animEffect>
+                </p:childTnLst>
+              </p:cTn>
+            </p:par>
+            <p:par>
+              <p:cTn id="6" fill="hold" nodeType="afterEffect">
+                <p:stCondLst>
+                  <p:cond delay="840"/>
+                </p:stCondLst>
+                <p:childTnLst>
+                  <p:animEffect transition="in" filter="fade">
+                    <p:cBhvr>
+                      <p:cTn id="7" dur="450" fill="hold"/>
+                      <p:tgtEl>
+                        <p:spTgt spid="12"/>
+                      </p:tgtEl>
+                    </p:cBhvr>
+                  </p:animEffect>
+                </p:childTnLst>
+              </p:cTn>
+            </p:par>
+            <p:par>
+              <p:cTn id="8" fill="hold" nodeType="afterEffect">
+                <p:stCondLst>
+                  <p:cond delay="1120"/>
+                </p:stCondLst>
+                <p:childTnLst>
+                  <p:animEffect transition="in" filter="fade">
+                    <p:cBhvr>
+                      <p:cTn id="9" dur="450" fill="hold"/>
+                      <p:tgtEl>
+                        <p:spTgt spid="13"/>
+                      </p:tgtEl>
+                    </p:cBhvr>
+                  </p:animEffect>
+                </p:childTnLst>
+              </p:cTn>
+            </p:par>
+          </p:childTnLst>
+        </p:cTn>
+        <p:prevCondLst>
+          <p:cond evt="onPrev" delay="0">
+            <p:tgtEl>
+              <p:sldTgt/>
+            </p:tgtEl>
+          </p:cond>
+        </p:prevCondLst>
+        <p:nextCondLst>
+          <p:cond evt="onNext" delay="0">
+            <p:tgtEl>
+              <p:sldTgt/>
+            </p:tgtEl>
+          </p:cond>
+        </p:nextCondLst>
+      </p:seq>
+    </p:tnLst>
+  </p:timing>
 </p:sld>
 </file>
 
 <file path=ppt/slides/slide10.xml><?xml version="1.0" encoding="utf-8"?>
-<p:sld xmlns:a="http://schemas.openxmlformats.org/drawingml/2006/main" xmlns:p="http://schemas.openxmlformats.org/presentationml/2006/main" xmlns:r="http://schemas.openxmlformats.org/officeDocument/2006/relationships">
+<p:sld xmlns:a="http://schemas.openxmlformats.org/drawingml/2006/main" xmlns:p="http://schemas.openxmlformats.org/presentationml/2006/main" xmlns:r="http://schemas.openxmlformats.org/officeDocument/2006/relationships" xmlns:ns0="http://schemas.openxmlformats.org/markup-compatibility/2006" ns0:Ignorable="p14">
   <p:cSld>
     <p:bg>
       <p:bgPr>
@@ -4561,11 +4668,169 @@
   <p:clrMapOvr>
     <a:masterClrMapping/>
   </p:clrMapOvr>
+  <ns0:AlternateContent xmlns:p14="http://schemas.microsoft.com/office/powerpoint/2010/main">
+    <ns0:Choice Requires="p14">
+      <p:transition spd="med" p14:dur="700">
+        <p:fade/>
+      </p:transition>
+    </ns0:Choice>
+    <ns0:Fallback>
+      <p:transition spd="med">
+        <p:fade/>
+      </p:transition>
+    </ns0:Fallback>
+  </ns0:AlternateContent>
+  <p:timing>
+    <p:tnLst>
+      <p:seq concurrent="1" nextAc="seek">
+        <p:cTn id="1" dur="indefinite" nodeType="mainSeq">
+          <p:stCondLst>
+            <p:cond delay="0"/>
+          </p:stCondLst>
+          <p:childTnLst>
+            <p:par>
+              <p:cTn id="2" fill="hold" nodeType="afterEffect">
+                <p:stCondLst>
+                  <p:cond delay="0"/>
+                </p:stCondLst>
+                <p:childTnLst>
+                  <p:animEffect transition="in" filter="fade">
+                    <p:cBhvr>
+                      <p:cTn id="3" dur="500" fill="hold"/>
+                      <p:tgtEl>
+                        <p:spTgt spid="8"/>
+                      </p:tgtEl>
+                    </p:cBhvr>
+                  </p:animEffect>
+                </p:childTnLst>
+              </p:cTn>
+            </p:par>
+            <p:par>
+              <p:cTn id="4" fill="hold" nodeType="afterEffect">
+                <p:stCondLst>
+                  <p:cond delay="560"/>
+                </p:stCondLst>
+                <p:childTnLst>
+                  <p:animEffect transition="in" filter="fade">
+                    <p:cBhvr>
+                      <p:cTn id="5" dur="430" fill="hold"/>
+                      <p:tgtEl>
+                        <p:spTgt spid="11"/>
+                      </p:tgtEl>
+                    </p:cBhvr>
+                  </p:animEffect>
+                </p:childTnLst>
+              </p:cTn>
+            </p:par>
+            <p:par>
+              <p:cTn id="6" fill="hold" nodeType="withEffect">
+                <p:stCondLst>
+                  <p:cond delay="560"/>
+                </p:stCondLst>
+                <p:childTnLst>
+                  <p:animEffect transition="in" filter="fade">
+                    <p:cBhvr>
+                      <p:cTn id="7" dur="430" fill="hold"/>
+                      <p:tgtEl>
+                        <p:spTgt spid="12"/>
+                      </p:tgtEl>
+                    </p:cBhvr>
+                  </p:animEffect>
+                </p:childTnLst>
+              </p:cTn>
+            </p:par>
+            <p:par>
+              <p:cTn id="8" fill="hold" nodeType="afterEffect">
+                <p:stCondLst>
+                  <p:cond delay="830"/>
+                </p:stCondLst>
+                <p:childTnLst>
+                  <p:animEffect transition="in" filter="fade">
+                    <p:cBhvr>
+                      <p:cTn id="9" dur="430" fill="hold"/>
+                      <p:tgtEl>
+                        <p:spTgt spid="15"/>
+                      </p:tgtEl>
+                    </p:cBhvr>
+                  </p:animEffect>
+                </p:childTnLst>
+              </p:cTn>
+            </p:par>
+            <p:par>
+              <p:cTn id="10" fill="hold" nodeType="withEffect">
+                <p:stCondLst>
+                  <p:cond delay="830"/>
+                </p:stCondLst>
+                <p:childTnLst>
+                  <p:animEffect transition="in" filter="fade">
+                    <p:cBhvr>
+                      <p:cTn id="11" dur="430" fill="hold"/>
+                      <p:tgtEl>
+                        <p:spTgt spid="16"/>
+                      </p:tgtEl>
+                    </p:cBhvr>
+                  </p:animEffect>
+                </p:childTnLst>
+              </p:cTn>
+            </p:par>
+            <p:par>
+              <p:cTn id="12" fill="hold" nodeType="afterEffect">
+                <p:stCondLst>
+                  <p:cond delay="1100"/>
+                </p:stCondLst>
+                <p:childTnLst>
+                  <p:animEffect transition="in" filter="fade">
+                    <p:cBhvr>
+                      <p:cTn id="13" dur="430" fill="hold"/>
+                      <p:tgtEl>
+                        <p:spTgt spid="19"/>
+                      </p:tgtEl>
+                    </p:cBhvr>
+                  </p:animEffect>
+                </p:childTnLst>
+              </p:cTn>
+            </p:par>
+            <p:par>
+              <p:cTn id="14" fill="hold" nodeType="withEffect">
+                <p:stCondLst>
+                  <p:cond delay="1100"/>
+                </p:stCondLst>
+                <p:childTnLst>
+                  <p:animEffect transition="in" filter="fade">
+                    <p:cBhvr>
+                      <p:cTn id="15" dur="430" fill="hold"/>
+                      <p:tgtEl>
+                        <p:spTgt spid="20"/>
+                      </p:tgtEl>
+                    </p:cBhvr>
+                  </p:animEffect>
+                </p:childTnLst>
+              </p:cTn>
+            </p:par>
+          </p:childTnLst>
+        </p:cTn>
+        <p:prevCondLst>
+          <p:cond evt="onPrev" delay="0">
+            <p:tgtEl>
+              <p:sldTgt/>
+            </p:tgtEl>
+          </p:cond>
+        </p:prevCondLst>
+        <p:nextCondLst>
+          <p:cond evt="onNext" delay="0">
+            <p:tgtEl>
+              <p:sldTgt/>
+            </p:tgtEl>
+          </p:cond>
+        </p:nextCondLst>
+      </p:seq>
+    </p:tnLst>
+  </p:timing>
 </p:sld>
 </file>
 
 <file path=ppt/slides/slide11.xml><?xml version="1.0" encoding="utf-8"?>
-<p:sld xmlns:a="http://schemas.openxmlformats.org/drawingml/2006/main" xmlns:p="http://schemas.openxmlformats.org/presentationml/2006/main" xmlns:r="http://schemas.openxmlformats.org/officeDocument/2006/relationships">
+<p:sld xmlns:a="http://schemas.openxmlformats.org/drawingml/2006/main" xmlns:p="http://schemas.openxmlformats.org/presentationml/2006/main" xmlns:r="http://schemas.openxmlformats.org/officeDocument/2006/relationships" xmlns:ns0="http://schemas.openxmlformats.org/markup-compatibility/2006" ns0:Ignorable="p14">
   <p:cSld>
     <p:bg>
       <p:bgPr>
@@ -5550,11 +5815,252 @@
   <p:clrMapOvr>
     <a:masterClrMapping/>
   </p:clrMapOvr>
+  <ns0:AlternateContent xmlns:p14="http://schemas.microsoft.com/office/powerpoint/2010/main">
+    <ns0:Choice Requires="p14">
+      <p:transition spd="med" p14:dur="700">
+        <p:fade/>
+      </p:transition>
+    </ns0:Choice>
+    <ns0:Fallback>
+      <p:transition spd="med">
+        <p:fade/>
+      </p:transition>
+    </ns0:Fallback>
+  </ns0:AlternateContent>
+  <p:timing>
+    <p:tnLst>
+      <p:seq concurrent="1" nextAc="seek">
+        <p:cTn id="1" dur="indefinite" nodeType="mainSeq">
+          <p:stCondLst>
+            <p:cond delay="0"/>
+          </p:stCondLst>
+          <p:childTnLst>
+            <p:par>
+              <p:cTn id="2" fill="hold" nodeType="afterEffect">
+                <p:stCondLst>
+                  <p:cond delay="0"/>
+                </p:stCondLst>
+                <p:childTnLst>
+                  <p:animEffect transition="in" filter="fade">
+                    <p:cBhvr>
+                      <p:cTn id="3" dur="500" fill="hold"/>
+                      <p:tgtEl>
+                        <p:spTgt spid="8"/>
+                      </p:tgtEl>
+                    </p:cBhvr>
+                  </p:animEffect>
+                </p:childTnLst>
+              </p:cTn>
+            </p:par>
+            <p:par>
+              <p:cTn id="4" fill="hold" nodeType="afterEffect">
+                <p:stCondLst>
+                  <p:cond delay="560"/>
+                </p:stCondLst>
+                <p:childTnLst>
+                  <p:animEffect transition="in" filter="fade">
+                    <p:cBhvr>
+                      <p:cTn id="5" dur="430" fill="hold"/>
+                      <p:tgtEl>
+                        <p:spTgt spid="11"/>
+                      </p:tgtEl>
+                    </p:cBhvr>
+                  </p:animEffect>
+                </p:childTnLst>
+              </p:cTn>
+            </p:par>
+            <p:par>
+              <p:cTn id="6" fill="hold" nodeType="withEffect">
+                <p:stCondLst>
+                  <p:cond delay="560"/>
+                </p:stCondLst>
+                <p:childTnLst>
+                  <p:animEffect transition="in" filter="fade">
+                    <p:cBhvr>
+                      <p:cTn id="7" dur="430" fill="hold"/>
+                      <p:tgtEl>
+                        <p:spTgt spid="12"/>
+                      </p:tgtEl>
+                    </p:cBhvr>
+                  </p:animEffect>
+                </p:childTnLst>
+              </p:cTn>
+            </p:par>
+            <p:par>
+              <p:cTn id="8" fill="hold" nodeType="afterEffect">
+                <p:stCondLst>
+                  <p:cond delay="830"/>
+                </p:stCondLst>
+                <p:childTnLst>
+                  <p:animEffect transition="in" filter="fade">
+                    <p:cBhvr>
+                      <p:cTn id="9" dur="430" fill="hold"/>
+                      <p:tgtEl>
+                        <p:spTgt spid="15"/>
+                      </p:tgtEl>
+                    </p:cBhvr>
+                  </p:animEffect>
+                </p:childTnLst>
+              </p:cTn>
+            </p:par>
+            <p:par>
+              <p:cTn id="10" fill="hold" nodeType="withEffect">
+                <p:stCondLst>
+                  <p:cond delay="830"/>
+                </p:stCondLst>
+                <p:childTnLst>
+                  <p:animEffect transition="in" filter="fade">
+                    <p:cBhvr>
+                      <p:cTn id="11" dur="430" fill="hold"/>
+                      <p:tgtEl>
+                        <p:spTgt spid="16"/>
+                      </p:tgtEl>
+                    </p:cBhvr>
+                  </p:animEffect>
+                </p:childTnLst>
+              </p:cTn>
+            </p:par>
+            <p:par>
+              <p:cTn id="12" fill="hold" nodeType="afterEffect">
+                <p:stCondLst>
+                  <p:cond delay="1100"/>
+                </p:stCondLst>
+                <p:childTnLst>
+                  <p:animEffect transition="in" filter="fade">
+                    <p:cBhvr>
+                      <p:cTn id="13" dur="430" fill="hold"/>
+                      <p:tgtEl>
+                        <p:spTgt spid="19"/>
+                      </p:tgtEl>
+                    </p:cBhvr>
+                  </p:animEffect>
+                </p:childTnLst>
+              </p:cTn>
+            </p:par>
+            <p:par>
+              <p:cTn id="14" fill="hold" nodeType="withEffect">
+                <p:stCondLst>
+                  <p:cond delay="1100"/>
+                </p:stCondLst>
+                <p:childTnLst>
+                  <p:animEffect transition="in" filter="fade">
+                    <p:cBhvr>
+                      <p:cTn id="15" dur="430" fill="hold"/>
+                      <p:tgtEl>
+                        <p:spTgt spid="20"/>
+                      </p:tgtEl>
+                    </p:cBhvr>
+                  </p:animEffect>
+                </p:childTnLst>
+              </p:cTn>
+            </p:par>
+            <p:par>
+              <p:cTn id="16" fill="hold" nodeType="afterEffect">
+                <p:stCondLst>
+                  <p:cond delay="1380"/>
+                </p:stCondLst>
+                <p:childTnLst>
+                  <p:animEffect transition="in" filter="fade">
+                    <p:cBhvr>
+                      <p:cTn id="17" dur="340" fill="hold"/>
+                      <p:tgtEl>
+                        <p:spTgt spid="21"/>
+                      </p:tgtEl>
+                    </p:cBhvr>
+                  </p:animEffect>
+                </p:childTnLst>
+              </p:cTn>
+            </p:par>
+            <p:par>
+              <p:cTn id="18" fill="hold" nodeType="afterEffect">
+                <p:stCondLst>
+                  <p:cond delay="1610"/>
+                </p:stCondLst>
+                <p:childTnLst>
+                  <p:animEffect transition="in" filter="fade">
+                    <p:cBhvr>
+                      <p:cTn id="19" dur="300" fill="hold"/>
+                      <p:tgtEl>
+                        <p:spTgt spid="22">
+                          <p:txEl>
+                            <p:pRg st="0" end="0"/>
+                          </p:txEl>
+                        </p:spTgt>
+                      </p:tgtEl>
+                    </p:cBhvr>
+                  </p:animEffect>
+                </p:childTnLst>
+              </p:cTn>
+            </p:par>
+            <p:par>
+              <p:cTn id="20" fill="hold" nodeType="afterEffect">
+                <p:stCondLst>
+                  <p:cond delay="1820"/>
+                </p:stCondLst>
+                <p:childTnLst>
+                  <p:animEffect transition="in" filter="fade">
+                    <p:cBhvr>
+                      <p:cTn id="21" dur="300" fill="hold"/>
+                      <p:tgtEl>
+                        <p:spTgt spid="22">
+                          <p:txEl>
+                            <p:pRg st="1" end="1"/>
+                          </p:txEl>
+                        </p:spTgt>
+                      </p:tgtEl>
+                    </p:cBhvr>
+                  </p:animEffect>
+                </p:childTnLst>
+              </p:cTn>
+            </p:par>
+            <p:par>
+              <p:cTn id="22" fill="hold" nodeType="afterEffect">
+                <p:stCondLst>
+                  <p:cond delay="2030"/>
+                </p:stCondLst>
+                <p:childTnLst>
+                  <p:animEffect transition="in" filter="fade">
+                    <p:cBhvr>
+                      <p:cTn id="23" dur="300" fill="hold"/>
+                      <p:tgtEl>
+                        <p:spTgt spid="22">
+                          <p:txEl>
+                            <p:pRg st="2" end="2"/>
+                          </p:txEl>
+                        </p:spTgt>
+                      </p:tgtEl>
+                    </p:cBhvr>
+                  </p:animEffect>
+                </p:childTnLst>
+              </p:cTn>
+            </p:par>
+          </p:childTnLst>
+        </p:cTn>
+        <p:prevCondLst>
+          <p:cond evt="onPrev" delay="0">
+            <p:tgtEl>
+              <p:sldTgt/>
+            </p:tgtEl>
+          </p:cond>
+        </p:prevCondLst>
+        <p:nextCondLst>
+          <p:cond evt="onNext" delay="0">
+            <p:tgtEl>
+              <p:sldTgt/>
+            </p:tgtEl>
+          </p:cond>
+        </p:nextCondLst>
+      </p:seq>
+    </p:tnLst>
+    <p:bldLst>
+      <p:bldP spid="22" grpId="0" build="p"/>
+    </p:bldLst>
+  </p:timing>
 </p:sld>
 </file>
 
 <file path=ppt/slides/slide12.xml><?xml version="1.0" encoding="utf-8"?>
-<p:sld xmlns:a="http://schemas.openxmlformats.org/drawingml/2006/main" xmlns:p="http://schemas.openxmlformats.org/presentationml/2006/main" xmlns:r="http://schemas.openxmlformats.org/officeDocument/2006/relationships">
+<p:sld xmlns:a="http://schemas.openxmlformats.org/drawingml/2006/main" xmlns:p="http://schemas.openxmlformats.org/presentationml/2006/main" xmlns:r="http://schemas.openxmlformats.org/officeDocument/2006/relationships" xmlns:ns0="http://schemas.openxmlformats.org/markup-compatibility/2006" ns0:Ignorable="p14">
   <p:cSld>
     <p:bg>
       <p:bgPr>
@@ -6275,11 +6781,273 @@
   <p:clrMapOvr>
     <a:masterClrMapping/>
   </p:clrMapOvr>
+  <ns0:AlternateContent xmlns:p14="http://schemas.microsoft.com/office/powerpoint/2010/main">
+    <ns0:Choice Requires="p14">
+      <p:transition spd="med" p14:dur="700">
+        <p:fade/>
+      </p:transition>
+    </ns0:Choice>
+    <ns0:Fallback>
+      <p:transition spd="med">
+        <p:fade/>
+      </p:transition>
+    </ns0:Fallback>
+  </ns0:AlternateContent>
+  <p:timing>
+    <p:tnLst>
+      <p:seq concurrent="1" nextAc="seek">
+        <p:cTn id="1" dur="indefinite" nodeType="mainSeq">
+          <p:stCondLst>
+            <p:cond delay="0"/>
+          </p:stCondLst>
+          <p:childTnLst>
+            <p:par>
+              <p:cTn id="2" fill="hold" nodeType="afterEffect">
+                <p:stCondLst>
+                  <p:cond delay="0"/>
+                </p:stCondLst>
+                <p:childTnLst>
+                  <p:animEffect transition="in" filter="fade">
+                    <p:cBhvr>
+                      <p:cTn id="3" dur="500" fill="hold"/>
+                      <p:tgtEl>
+                        <p:spTgt spid="8"/>
+                      </p:tgtEl>
+                    </p:cBhvr>
+                  </p:animEffect>
+                </p:childTnLst>
+              </p:cTn>
+            </p:par>
+            <p:par>
+              <p:cTn id="4" fill="hold" nodeType="afterEffect">
+                <p:stCondLst>
+                  <p:cond delay="560"/>
+                </p:stCondLst>
+                <p:childTnLst>
+                  <p:animEffect transition="in" filter="fade">
+                    <p:cBhvr>
+                      <p:cTn id="5" dur="340" fill="hold"/>
+                      <p:tgtEl>
+                        <p:spTgt spid="11"/>
+                      </p:tgtEl>
+                    </p:cBhvr>
+                  </p:animEffect>
+                </p:childTnLst>
+              </p:cTn>
+            </p:par>
+            <p:par>
+              <p:cTn id="6" fill="hold" nodeType="afterEffect">
+                <p:stCondLst>
+                  <p:cond delay="750"/>
+                </p:stCondLst>
+                <p:childTnLst>
+                  <p:animEffect transition="in" filter="fade">
+                    <p:cBhvr>
+                      <p:cTn id="7" dur="290" fill="hold"/>
+                      <p:tgtEl>
+                        <p:spTgt spid="12">
+                          <p:txEl>
+                            <p:pRg st="0" end="0"/>
+                          </p:txEl>
+                        </p:spTgt>
+                      </p:tgtEl>
+                    </p:cBhvr>
+                  </p:animEffect>
+                </p:childTnLst>
+              </p:cTn>
+            </p:par>
+            <p:par>
+              <p:cTn id="8" fill="hold" nodeType="afterEffect">
+                <p:stCondLst>
+                  <p:cond delay="905"/>
+                </p:stCondLst>
+                <p:childTnLst>
+                  <p:animEffect transition="in" filter="fade">
+                    <p:cBhvr>
+                      <p:cTn id="9" dur="290" fill="hold"/>
+                      <p:tgtEl>
+                        <p:spTgt spid="12">
+                          <p:txEl>
+                            <p:pRg st="1" end="1"/>
+                          </p:txEl>
+                        </p:spTgt>
+                      </p:tgtEl>
+                    </p:cBhvr>
+                  </p:animEffect>
+                </p:childTnLst>
+              </p:cTn>
+            </p:par>
+            <p:par>
+              <p:cTn id="10" fill="hold" nodeType="afterEffect">
+                <p:stCondLst>
+                  <p:cond delay="1060"/>
+                </p:stCondLst>
+                <p:childTnLst>
+                  <p:animEffect transition="in" filter="fade">
+                    <p:cBhvr>
+                      <p:cTn id="11" dur="290" fill="hold"/>
+                      <p:tgtEl>
+                        <p:spTgt spid="12">
+                          <p:txEl>
+                            <p:pRg st="2" end="2"/>
+                          </p:txEl>
+                        </p:spTgt>
+                      </p:tgtEl>
+                    </p:cBhvr>
+                  </p:animEffect>
+                </p:childTnLst>
+              </p:cTn>
+            </p:par>
+            <p:par>
+              <p:cTn id="12" fill="hold" nodeType="afterEffect">
+                <p:stCondLst>
+                  <p:cond delay="1215"/>
+                </p:stCondLst>
+                <p:childTnLst>
+                  <p:animEffect transition="in" filter="fade">
+                    <p:cBhvr>
+                      <p:cTn id="13" dur="290" fill="hold"/>
+                      <p:tgtEl>
+                        <p:spTgt spid="12">
+                          <p:txEl>
+                            <p:pRg st="3" end="3"/>
+                          </p:txEl>
+                        </p:spTgt>
+                      </p:tgtEl>
+                    </p:cBhvr>
+                  </p:animEffect>
+                </p:childTnLst>
+              </p:cTn>
+            </p:par>
+            <p:par>
+              <p:cTn id="14" fill="hold" nodeType="afterEffect">
+                <p:stCondLst>
+                  <p:cond delay="1370"/>
+                </p:stCondLst>
+                <p:childTnLst>
+                  <p:animEffect transition="in" filter="fade">
+                    <p:cBhvr>
+                      <p:cTn id="15" dur="340" fill="hold"/>
+                      <p:tgtEl>
+                        <p:spTgt spid="13"/>
+                      </p:tgtEl>
+                    </p:cBhvr>
+                  </p:animEffect>
+                </p:childTnLst>
+              </p:cTn>
+            </p:par>
+            <p:par>
+              <p:cTn id="16" fill="hold" nodeType="afterEffect">
+                <p:stCondLst>
+                  <p:cond delay="1560"/>
+                </p:stCondLst>
+                <p:childTnLst>
+                  <p:animEffect transition="in" filter="fade">
+                    <p:cBhvr>
+                      <p:cTn id="17" dur="290" fill="hold"/>
+                      <p:tgtEl>
+                        <p:spTgt spid="14">
+                          <p:txEl>
+                            <p:pRg st="0" end="0"/>
+                          </p:txEl>
+                        </p:spTgt>
+                      </p:tgtEl>
+                    </p:cBhvr>
+                  </p:animEffect>
+                </p:childTnLst>
+              </p:cTn>
+            </p:par>
+            <p:par>
+              <p:cTn id="18" fill="hold" nodeType="afterEffect">
+                <p:stCondLst>
+                  <p:cond delay="1715"/>
+                </p:stCondLst>
+                <p:childTnLst>
+                  <p:animEffect transition="in" filter="fade">
+                    <p:cBhvr>
+                      <p:cTn id="19" dur="290" fill="hold"/>
+                      <p:tgtEl>
+                        <p:spTgt spid="14">
+                          <p:txEl>
+                            <p:pRg st="1" end="1"/>
+                          </p:txEl>
+                        </p:spTgt>
+                      </p:tgtEl>
+                    </p:cBhvr>
+                  </p:animEffect>
+                </p:childTnLst>
+              </p:cTn>
+            </p:par>
+            <p:par>
+              <p:cTn id="20" fill="hold" nodeType="afterEffect">
+                <p:stCondLst>
+                  <p:cond delay="1870"/>
+                </p:stCondLst>
+                <p:childTnLst>
+                  <p:animEffect transition="in" filter="fade">
+                    <p:cBhvr>
+                      <p:cTn id="21" dur="290" fill="hold"/>
+                      <p:tgtEl>
+                        <p:spTgt spid="14">
+                          <p:txEl>
+                            <p:pRg st="2" end="2"/>
+                          </p:txEl>
+                        </p:spTgt>
+                      </p:tgtEl>
+                    </p:cBhvr>
+                  </p:animEffect>
+                </p:childTnLst>
+              </p:cTn>
+            </p:par>
+            <p:par>
+              <p:cTn id="22" fill="hold" nodeType="afterEffect">
+                <p:stCondLst>
+                  <p:cond delay="2025"/>
+                </p:stCondLst>
+                <p:childTnLst>
+                  <p:animEffect transition="in" filter="fade">
+                    <p:cBhvr>
+                      <p:cTn id="23" dur="290" fill="hold"/>
+                      <p:tgtEl>
+                        <p:spTgt spid="14">
+                          <p:txEl>
+                            <p:pRg st="3" end="3"/>
+                          </p:txEl>
+                        </p:spTgt>
+                      </p:tgtEl>
+                    </p:cBhvr>
+                  </p:animEffect>
+                </p:childTnLst>
+              </p:cTn>
+            </p:par>
+          </p:childTnLst>
+        </p:cTn>
+        <p:prevCondLst>
+          <p:cond evt="onPrev" delay="0">
+            <p:tgtEl>
+              <p:sldTgt/>
+            </p:tgtEl>
+          </p:cond>
+        </p:prevCondLst>
+        <p:nextCondLst>
+          <p:cond evt="onNext" delay="0">
+            <p:tgtEl>
+              <p:sldTgt/>
+            </p:tgtEl>
+          </p:cond>
+        </p:nextCondLst>
+      </p:seq>
+    </p:tnLst>
+    <p:bldLst>
+      <p:bldP spid="12" grpId="0" build="p"/>
+      <p:bldP spid="14" grpId="0" build="p"/>
+    </p:bldLst>
+  </p:timing>
 </p:sld>
 </file>
 
 <file path=ppt/slides/slide13.xml><?xml version="1.0" encoding="utf-8"?>
-<p:sld xmlns:a="http://schemas.openxmlformats.org/drawingml/2006/main" xmlns:p="http://schemas.openxmlformats.org/presentationml/2006/main" xmlns:r="http://schemas.openxmlformats.org/officeDocument/2006/relationships">
+<p:sld xmlns:a="http://schemas.openxmlformats.org/drawingml/2006/main" xmlns:p="http://schemas.openxmlformats.org/presentationml/2006/main" xmlns:r="http://schemas.openxmlformats.org/officeDocument/2006/relationships" xmlns:ns0="http://schemas.openxmlformats.org/markup-compatibility/2006" ns0:Ignorable="p14">
   <p:cSld>
     <p:bg>
       <p:bgPr>
@@ -7433,11 +8201,186 @@
   <p:clrMapOvr>
     <a:masterClrMapping/>
   </p:clrMapOvr>
+  <ns0:AlternateContent xmlns:p14="http://schemas.microsoft.com/office/powerpoint/2010/main">
+    <ns0:Choice Requires="p14">
+      <p:transition spd="med" p14:dur="700">
+        <p:fade/>
+      </p:transition>
+    </ns0:Choice>
+    <ns0:Fallback>
+      <p:transition spd="med">
+        <p:fade/>
+      </p:transition>
+    </ns0:Fallback>
+  </ns0:AlternateContent>
+  <p:timing>
+    <p:tnLst>
+      <p:seq concurrent="1" nextAc="seek">
+        <p:cTn id="1" dur="indefinite" nodeType="mainSeq">
+          <p:stCondLst>
+            <p:cond delay="0"/>
+          </p:stCondLst>
+          <p:childTnLst>
+            <p:par>
+              <p:cTn id="2" fill="hold" nodeType="afterEffect">
+                <p:stCondLst>
+                  <p:cond delay="0"/>
+                </p:stCondLst>
+                <p:childTnLst>
+                  <p:animEffect transition="in" filter="fade">
+                    <p:cBhvr>
+                      <p:cTn id="3" dur="500" fill="hold"/>
+                      <p:tgtEl>
+                        <p:spTgt spid="8"/>
+                      </p:tgtEl>
+                    </p:cBhvr>
+                  </p:animEffect>
+                </p:childTnLst>
+              </p:cTn>
+            </p:par>
+            <p:par>
+              <p:cTn id="4" fill="hold" nodeType="afterEffect">
+                <p:stCondLst>
+                  <p:cond delay="560"/>
+                </p:stCondLst>
+                <p:childTnLst>
+                  <p:animEffect transition="in" filter="fade">
+                    <p:cBhvr>
+                      <p:cTn id="5" dur="420" fill="hold"/>
+                      <p:tgtEl>
+                        <p:spTgt spid="11"/>
+                      </p:tgtEl>
+                    </p:cBhvr>
+                  </p:animEffect>
+                </p:childTnLst>
+              </p:cTn>
+            </p:par>
+            <p:par>
+              <p:cTn id="6" fill="hold" nodeType="withEffect">
+                <p:stCondLst>
+                  <p:cond delay="560"/>
+                </p:stCondLst>
+                <p:childTnLst>
+                  <p:animEffect transition="in" filter="fade">
+                    <p:cBhvr>
+                      <p:cTn id="7" dur="420" fill="hold"/>
+                      <p:tgtEl>
+                        <p:spTgt spid="12"/>
+                      </p:tgtEl>
+                    </p:cBhvr>
+                  </p:animEffect>
+                </p:childTnLst>
+              </p:cTn>
+            </p:par>
+            <p:par>
+              <p:cTn id="8" fill="hold" nodeType="afterEffect">
+                <p:stCondLst>
+                  <p:cond delay="860"/>
+                </p:stCondLst>
+                <p:childTnLst>
+                  <p:animEffect transition="in" filter="fade">
+                    <p:cBhvr>
+                      <p:cTn id="9" dur="420" fill="hold"/>
+                      <p:tgtEl>
+                        <p:spTgt spid="17"/>
+                      </p:tgtEl>
+                    </p:cBhvr>
+                  </p:animEffect>
+                </p:childTnLst>
+              </p:cTn>
+            </p:par>
+            <p:par>
+              <p:cTn id="10" fill="hold" nodeType="withEffect">
+                <p:stCondLst>
+                  <p:cond delay="860"/>
+                </p:stCondLst>
+                <p:childTnLst>
+                  <p:animEffect transition="in" filter="fade">
+                    <p:cBhvr>
+                      <p:cTn id="11" dur="420" fill="hold"/>
+                      <p:tgtEl>
+                        <p:spTgt spid="18"/>
+                      </p:tgtEl>
+                    </p:cBhvr>
+                  </p:animEffect>
+                </p:childTnLst>
+              </p:cTn>
+            </p:par>
+            <p:par>
+              <p:cTn id="12" fill="hold" nodeType="afterEffect">
+                <p:stCondLst>
+                  <p:cond delay="1160"/>
+                </p:stCondLst>
+                <p:childTnLst>
+                  <p:animEffect transition="in" filter="fade">
+                    <p:cBhvr>
+                      <p:cTn id="13" dur="420" fill="hold"/>
+                      <p:tgtEl>
+                        <p:spTgt spid="23"/>
+                      </p:tgtEl>
+                    </p:cBhvr>
+                  </p:animEffect>
+                </p:childTnLst>
+              </p:cTn>
+            </p:par>
+            <p:par>
+              <p:cTn id="14" fill="hold" nodeType="withEffect">
+                <p:stCondLst>
+                  <p:cond delay="1160"/>
+                </p:stCondLst>
+                <p:childTnLst>
+                  <p:animEffect transition="in" filter="fade">
+                    <p:cBhvr>
+                      <p:cTn id="15" dur="420" fill="hold"/>
+                      <p:tgtEl>
+                        <p:spTgt spid="24"/>
+                      </p:tgtEl>
+                    </p:cBhvr>
+                  </p:animEffect>
+                </p:childTnLst>
+              </p:cTn>
+            </p:par>
+            <p:par>
+              <p:cTn id="16" fill="hold" nodeType="afterEffect">
+                <p:stCondLst>
+                  <p:cond delay="1560"/>
+                </p:stCondLst>
+                <p:childTnLst>
+                  <p:animEffect transition="in" filter="fade">
+                    <p:cBhvr>
+                      <p:cTn id="17" dur="380" fill="hold"/>
+                      <p:tgtEl>
+                        <p:spTgt spid="27"/>
+                      </p:tgtEl>
+                    </p:cBhvr>
+                  </p:animEffect>
+                </p:childTnLst>
+              </p:cTn>
+            </p:par>
+          </p:childTnLst>
+        </p:cTn>
+        <p:prevCondLst>
+          <p:cond evt="onPrev" delay="0">
+            <p:tgtEl>
+              <p:sldTgt/>
+            </p:tgtEl>
+          </p:cond>
+        </p:prevCondLst>
+        <p:nextCondLst>
+          <p:cond evt="onNext" delay="0">
+            <p:tgtEl>
+              <p:sldTgt/>
+            </p:tgtEl>
+          </p:cond>
+        </p:nextCondLst>
+      </p:seq>
+    </p:tnLst>
+  </p:timing>
 </p:sld>
 </file>
 
 <file path=ppt/slides/slide14.xml><?xml version="1.0" encoding="utf-8"?>
-<p:sld xmlns:a="http://schemas.openxmlformats.org/drawingml/2006/main" xmlns:p="http://schemas.openxmlformats.org/presentationml/2006/main" xmlns:r="http://schemas.openxmlformats.org/officeDocument/2006/relationships">
+<p:sld xmlns:a="http://schemas.openxmlformats.org/drawingml/2006/main" xmlns:p="http://schemas.openxmlformats.org/presentationml/2006/main" xmlns:r="http://schemas.openxmlformats.org/officeDocument/2006/relationships" xmlns:ns0="http://schemas.openxmlformats.org/markup-compatibility/2006" ns0:Ignorable="p14">
   <p:cSld>
     <p:bg>
       <p:bgPr>
@@ -8259,11 +9202,169 @@
   <p:clrMapOvr>
     <a:masterClrMapping/>
   </p:clrMapOvr>
+  <ns0:AlternateContent xmlns:p14="http://schemas.microsoft.com/office/powerpoint/2010/main">
+    <ns0:Choice Requires="p14">
+      <p:transition spd="med" p14:dur="700">
+        <p:fade/>
+      </p:transition>
+    </ns0:Choice>
+    <ns0:Fallback>
+      <p:transition spd="med">
+        <p:fade/>
+      </p:transition>
+    </ns0:Fallback>
+  </ns0:AlternateContent>
+  <p:timing>
+    <p:tnLst>
+      <p:seq concurrent="1" nextAc="seek">
+        <p:cTn id="1" dur="indefinite" nodeType="mainSeq">
+          <p:stCondLst>
+            <p:cond delay="0"/>
+          </p:stCondLst>
+          <p:childTnLst>
+            <p:par>
+              <p:cTn id="2" fill="hold" nodeType="afterEffect">
+                <p:stCondLst>
+                  <p:cond delay="0"/>
+                </p:stCondLst>
+                <p:childTnLst>
+                  <p:animEffect transition="in" filter="fade">
+                    <p:cBhvr>
+                      <p:cTn id="3" dur="500" fill="hold"/>
+                      <p:tgtEl>
+                        <p:spTgt spid="8"/>
+                      </p:tgtEl>
+                    </p:cBhvr>
+                  </p:animEffect>
+                </p:childTnLst>
+              </p:cTn>
+            </p:par>
+            <p:par>
+              <p:cTn id="4" fill="hold" nodeType="afterEffect">
+                <p:stCondLst>
+                  <p:cond delay="560"/>
+                </p:stCondLst>
+                <p:childTnLst>
+                  <p:animEffect transition="in" filter="fade">
+                    <p:cBhvr>
+                      <p:cTn id="5" dur="500" fill="hold"/>
+                      <p:tgtEl>
+                        <p:spTgt spid="9"/>
+                      </p:tgtEl>
+                    </p:cBhvr>
+                  </p:animEffect>
+                </p:childTnLst>
+              </p:cTn>
+            </p:par>
+            <p:par>
+              <p:cTn id="6" fill="hold" nodeType="withEffect">
+                <p:stCondLst>
+                  <p:cond delay="560"/>
+                </p:stCondLst>
+                <p:childTnLst>
+                  <p:animEffect transition="in" filter="fade">
+                    <p:cBhvr>
+                      <p:cTn id="7" dur="500" fill="hold"/>
+                      <p:tgtEl>
+                        <p:spTgt spid="11"/>
+                      </p:tgtEl>
+                    </p:cBhvr>
+                  </p:animEffect>
+                </p:childTnLst>
+              </p:cTn>
+            </p:par>
+            <p:par>
+              <p:cTn id="8" fill="hold" nodeType="afterEffect">
+                <p:stCondLst>
+                  <p:cond delay="990"/>
+                </p:stCondLst>
+                <p:childTnLst>
+                  <p:animEffect transition="in" filter="fade">
+                    <p:cBhvr>
+                      <p:cTn id="9" dur="360" fill="hold"/>
+                      <p:tgtEl>
+                        <p:spTgt spid="13"/>
+                      </p:tgtEl>
+                    </p:cBhvr>
+                  </p:animEffect>
+                </p:childTnLst>
+              </p:cTn>
+            </p:par>
+            <p:par>
+              <p:cTn id="10" fill="hold" nodeType="afterEffect">
+                <p:stCondLst>
+                  <p:cond delay="1250"/>
+                </p:stCondLst>
+                <p:childTnLst>
+                  <p:animEffect transition="in" filter="fade">
+                    <p:cBhvr>
+                      <p:cTn id="11" dur="360" fill="hold"/>
+                      <p:tgtEl>
+                        <p:spTgt spid="15"/>
+                      </p:tgtEl>
+                    </p:cBhvr>
+                  </p:animEffect>
+                </p:childTnLst>
+              </p:cTn>
+            </p:par>
+            <p:par>
+              <p:cTn id="12" fill="hold" nodeType="afterEffect">
+                <p:stCondLst>
+                  <p:cond delay="1510"/>
+                </p:stCondLst>
+                <p:childTnLst>
+                  <p:animEffect transition="in" filter="fade">
+                    <p:cBhvr>
+                      <p:cTn id="13" dur="360" fill="hold"/>
+                      <p:tgtEl>
+                        <p:spTgt spid="17"/>
+                      </p:tgtEl>
+                    </p:cBhvr>
+                  </p:animEffect>
+                </p:childTnLst>
+              </p:cTn>
+            </p:par>
+            <p:par>
+              <p:cTn id="14" fill="hold" nodeType="afterEffect">
+                <p:stCondLst>
+                  <p:cond delay="1770"/>
+                </p:stCondLst>
+                <p:childTnLst>
+                  <p:animEffect transition="in" filter="fade">
+                    <p:cBhvr>
+                      <p:cTn id="15" dur="360" fill="hold"/>
+                      <p:tgtEl>
+                        <p:spTgt spid="19"/>
+                      </p:tgtEl>
+                    </p:cBhvr>
+                  </p:animEffect>
+                </p:childTnLst>
+              </p:cTn>
+            </p:par>
+          </p:childTnLst>
+        </p:cTn>
+        <p:prevCondLst>
+          <p:cond evt="onPrev" delay="0">
+            <p:tgtEl>
+              <p:sldTgt/>
+            </p:tgtEl>
+          </p:cond>
+        </p:prevCondLst>
+        <p:nextCondLst>
+          <p:cond evt="onNext" delay="0">
+            <p:tgtEl>
+              <p:sldTgt/>
+            </p:tgtEl>
+          </p:cond>
+        </p:nextCondLst>
+      </p:seq>
+    </p:tnLst>
+  </p:timing>
 </p:sld>
 </file>
 
 <file path=ppt/slides/slide2.xml><?xml version="1.0" encoding="utf-8"?>
-<p:sld xmlns:a="http://schemas.openxmlformats.org/drawingml/2006/main" xmlns:p="http://schemas.openxmlformats.org/presentationml/2006/main" xmlns:r="http://schemas.openxmlformats.org/officeDocument/2006/relationships">
+<p:sld xmlns:a="http://schemas.openxmlformats.org/drawingml/2006/main" xmlns:p="http://schemas.openxmlformats.org/presentationml/2006/main" xmlns:r="http://schemas.openxmlformats.org/officeDocument/2006/relationships" xmlns:ns0="http://schemas.openxmlformats.org/markup-compatibility/2006" ns0:Ignorable="p14">
   <p:cSld>
     <p:bg>
       <p:bgPr>
@@ -9142,11 +10243,169 @@
   <p:clrMapOvr>
     <a:masterClrMapping/>
   </p:clrMapOvr>
+  <ns0:AlternateContent xmlns:p14="http://schemas.microsoft.com/office/powerpoint/2010/main">
+    <ns0:Choice Requires="p14">
+      <p:transition spd="med" p14:dur="700">
+        <p:fade/>
+      </p:transition>
+    </ns0:Choice>
+    <ns0:Fallback>
+      <p:transition spd="med">
+        <p:fade/>
+      </p:transition>
+    </ns0:Fallback>
+  </ns0:AlternateContent>
+  <p:timing>
+    <p:tnLst>
+      <p:seq concurrent="1" nextAc="seek">
+        <p:cTn id="1" dur="indefinite" nodeType="mainSeq">
+          <p:stCondLst>
+            <p:cond delay="0"/>
+          </p:stCondLst>
+          <p:childTnLst>
+            <p:par>
+              <p:cTn id="2" fill="hold" nodeType="afterEffect">
+                <p:stCondLst>
+                  <p:cond delay="0"/>
+                </p:stCondLst>
+                <p:childTnLst>
+                  <p:animEffect transition="in" filter="fade">
+                    <p:cBhvr>
+                      <p:cTn id="3" dur="500" fill="hold"/>
+                      <p:tgtEl>
+                        <p:spTgt spid="8"/>
+                      </p:tgtEl>
+                    </p:cBhvr>
+                  </p:animEffect>
+                </p:childTnLst>
+              </p:cTn>
+            </p:par>
+            <p:par>
+              <p:cTn id="4" fill="hold" nodeType="afterEffect">
+                <p:stCondLst>
+                  <p:cond delay="560"/>
+                </p:stCondLst>
+                <p:childTnLst>
+                  <p:animEffect transition="in" filter="fade">
+                    <p:cBhvr>
+                      <p:cTn id="5" dur="430" fill="hold"/>
+                      <p:tgtEl>
+                        <p:spTgt spid="11"/>
+                      </p:tgtEl>
+                    </p:cBhvr>
+                  </p:animEffect>
+                </p:childTnLst>
+              </p:cTn>
+            </p:par>
+            <p:par>
+              <p:cTn id="6" fill="hold" nodeType="withEffect">
+                <p:stCondLst>
+                  <p:cond delay="560"/>
+                </p:stCondLst>
+                <p:childTnLst>
+                  <p:animEffect transition="in" filter="fade">
+                    <p:cBhvr>
+                      <p:cTn id="7" dur="430" fill="hold"/>
+                      <p:tgtEl>
+                        <p:spTgt spid="12"/>
+                      </p:tgtEl>
+                    </p:cBhvr>
+                  </p:animEffect>
+                </p:childTnLst>
+              </p:cTn>
+            </p:par>
+            <p:par>
+              <p:cTn id="8" fill="hold" nodeType="afterEffect">
+                <p:stCondLst>
+                  <p:cond delay="830"/>
+                </p:stCondLst>
+                <p:childTnLst>
+                  <p:animEffect transition="in" filter="fade">
+                    <p:cBhvr>
+                      <p:cTn id="9" dur="430" fill="hold"/>
+                      <p:tgtEl>
+                        <p:spTgt spid="15"/>
+                      </p:tgtEl>
+                    </p:cBhvr>
+                  </p:animEffect>
+                </p:childTnLst>
+              </p:cTn>
+            </p:par>
+            <p:par>
+              <p:cTn id="10" fill="hold" nodeType="withEffect">
+                <p:stCondLst>
+                  <p:cond delay="830"/>
+                </p:stCondLst>
+                <p:childTnLst>
+                  <p:animEffect transition="in" filter="fade">
+                    <p:cBhvr>
+                      <p:cTn id="11" dur="430" fill="hold"/>
+                      <p:tgtEl>
+                        <p:spTgt spid="16"/>
+                      </p:tgtEl>
+                    </p:cBhvr>
+                  </p:animEffect>
+                </p:childTnLst>
+              </p:cTn>
+            </p:par>
+            <p:par>
+              <p:cTn id="12" fill="hold" nodeType="afterEffect">
+                <p:stCondLst>
+                  <p:cond delay="1100"/>
+                </p:stCondLst>
+                <p:childTnLst>
+                  <p:animEffect transition="in" filter="fade">
+                    <p:cBhvr>
+                      <p:cTn id="13" dur="430" fill="hold"/>
+                      <p:tgtEl>
+                        <p:spTgt spid="19"/>
+                      </p:tgtEl>
+                    </p:cBhvr>
+                  </p:animEffect>
+                </p:childTnLst>
+              </p:cTn>
+            </p:par>
+            <p:par>
+              <p:cTn id="14" fill="hold" nodeType="withEffect">
+                <p:stCondLst>
+                  <p:cond delay="1100"/>
+                </p:stCondLst>
+                <p:childTnLst>
+                  <p:animEffect transition="in" filter="fade">
+                    <p:cBhvr>
+                      <p:cTn id="15" dur="430" fill="hold"/>
+                      <p:tgtEl>
+                        <p:spTgt spid="20"/>
+                      </p:tgtEl>
+                    </p:cBhvr>
+                  </p:animEffect>
+                </p:childTnLst>
+              </p:cTn>
+            </p:par>
+          </p:childTnLst>
+        </p:cTn>
+        <p:prevCondLst>
+          <p:cond evt="onPrev" delay="0">
+            <p:tgtEl>
+              <p:sldTgt/>
+            </p:tgtEl>
+          </p:cond>
+        </p:prevCondLst>
+        <p:nextCondLst>
+          <p:cond evt="onNext" delay="0">
+            <p:tgtEl>
+              <p:sldTgt/>
+            </p:tgtEl>
+          </p:cond>
+        </p:nextCondLst>
+      </p:seq>
+    </p:tnLst>
+  </p:timing>
 </p:sld>
 </file>
 
 <file path=ppt/slides/slide3.xml><?xml version="1.0" encoding="utf-8"?>
-<p:sld xmlns:a="http://schemas.openxmlformats.org/drawingml/2006/main" xmlns:p="http://schemas.openxmlformats.org/presentationml/2006/main" xmlns:r="http://schemas.openxmlformats.org/officeDocument/2006/relationships">
+<p:sld xmlns:a="http://schemas.openxmlformats.org/drawingml/2006/main" xmlns:p="http://schemas.openxmlformats.org/presentationml/2006/main" xmlns:r="http://schemas.openxmlformats.org/officeDocument/2006/relationships" xmlns:ns0="http://schemas.openxmlformats.org/markup-compatibility/2006" ns0:Ignorable="p14">
   <p:cSld>
     <p:bg>
       <p:bgPr>
@@ -9700,11 +10959,171 @@
   <p:clrMapOvr>
     <a:masterClrMapping/>
   </p:clrMapOvr>
+  <ns0:AlternateContent xmlns:p14="http://schemas.microsoft.com/office/powerpoint/2010/main">
+    <ns0:Choice Requires="p14">
+      <p:transition spd="med" p14:dur="700">
+        <p:fade/>
+      </p:transition>
+    </ns0:Choice>
+    <ns0:Fallback>
+      <p:transition spd="med">
+        <p:fade/>
+      </p:transition>
+    </ns0:Fallback>
+  </ns0:AlternateContent>
+  <p:timing>
+    <p:tnLst>
+      <p:seq concurrent="1" nextAc="seek">
+        <p:cTn id="1" dur="indefinite" nodeType="mainSeq">
+          <p:stCondLst>
+            <p:cond delay="0"/>
+          </p:stCondLst>
+          <p:childTnLst>
+            <p:par>
+              <p:cTn id="2" fill="hold" nodeType="afterEffect">
+                <p:stCondLst>
+                  <p:cond delay="0"/>
+                </p:stCondLst>
+                <p:childTnLst>
+                  <p:animEffect transition="in" filter="fade">
+                    <p:cBhvr>
+                      <p:cTn id="3" dur="500" fill="hold"/>
+                      <p:tgtEl>
+                        <p:spTgt spid="8"/>
+                      </p:tgtEl>
+                    </p:cBhvr>
+                  </p:animEffect>
+                </p:childTnLst>
+              </p:cTn>
+            </p:par>
+            <p:par>
+              <p:cTn id="4" fill="hold" nodeType="afterEffect">
+                <p:stCondLst>
+                  <p:cond delay="560"/>
+                </p:stCondLst>
+                <p:childTnLst>
+                  <p:animEffect transition="in" filter="fade">
+                    <p:cBhvr>
+                      <p:cTn id="5" dur="450" fill="hold"/>
+                      <p:tgtEl>
+                        <p:spTgt spid="10"/>
+                      </p:tgtEl>
+                    </p:cBhvr>
+                  </p:animEffect>
+                </p:childTnLst>
+              </p:cTn>
+            </p:par>
+            <p:par>
+              <p:cTn id="6" fill="hold" nodeType="afterEffect">
+                <p:stCondLst>
+                  <p:cond delay="920"/>
+                </p:stCondLst>
+                <p:childTnLst>
+                  <p:animEffect transition="in" filter="fade">
+                    <p:cBhvr>
+                      <p:cTn id="7" dur="330" fill="hold"/>
+                      <p:tgtEl>
+                        <p:spTgt spid="11">
+                          <p:txEl>
+                            <p:pRg st="0" end="0"/>
+                          </p:txEl>
+                        </p:spTgt>
+                      </p:tgtEl>
+                    </p:cBhvr>
+                  </p:animEffect>
+                </p:childTnLst>
+              </p:cTn>
+            </p:par>
+            <p:par>
+              <p:cTn id="8" fill="hold" nodeType="afterEffect">
+                <p:stCondLst>
+                  <p:cond delay="1150"/>
+                </p:stCondLst>
+                <p:childTnLst>
+                  <p:animEffect transition="in" filter="fade">
+                    <p:cBhvr>
+                      <p:cTn id="9" dur="330" fill="hold"/>
+                      <p:tgtEl>
+                        <p:spTgt spid="11">
+                          <p:txEl>
+                            <p:pRg st="1" end="1"/>
+                          </p:txEl>
+                        </p:spTgt>
+                      </p:tgtEl>
+                    </p:cBhvr>
+                  </p:animEffect>
+                </p:childTnLst>
+              </p:cTn>
+            </p:par>
+            <p:par>
+              <p:cTn id="10" fill="hold" nodeType="afterEffect">
+                <p:stCondLst>
+                  <p:cond delay="1380"/>
+                </p:stCondLst>
+                <p:childTnLst>
+                  <p:animEffect transition="in" filter="fade">
+                    <p:cBhvr>
+                      <p:cTn id="11" dur="330" fill="hold"/>
+                      <p:tgtEl>
+                        <p:spTgt spid="11">
+                          <p:txEl>
+                            <p:pRg st="2" end="2"/>
+                          </p:txEl>
+                        </p:spTgt>
+                      </p:tgtEl>
+                    </p:cBhvr>
+                  </p:animEffect>
+                </p:childTnLst>
+              </p:cTn>
+            </p:par>
+            <p:par>
+              <p:cTn id="12" fill="hold" nodeType="afterEffect">
+                <p:stCondLst>
+                  <p:cond delay="1610"/>
+                </p:stCondLst>
+                <p:childTnLst>
+                  <p:animEffect transition="in" filter="fade">
+                    <p:cBhvr>
+                      <p:cTn id="13" dur="330" fill="hold"/>
+                      <p:tgtEl>
+                        <p:spTgt spid="11">
+                          <p:txEl>
+                            <p:pRg st="3" end="3"/>
+                          </p:txEl>
+                        </p:spTgt>
+                      </p:tgtEl>
+                    </p:cBhvr>
+                  </p:animEffect>
+                </p:childTnLst>
+              </p:cTn>
+            </p:par>
+          </p:childTnLst>
+        </p:cTn>
+        <p:prevCondLst>
+          <p:cond evt="onPrev" delay="0">
+            <p:tgtEl>
+              <p:sldTgt/>
+            </p:tgtEl>
+          </p:cond>
+        </p:prevCondLst>
+        <p:nextCondLst>
+          <p:cond evt="onNext" delay="0">
+            <p:tgtEl>
+              <p:sldTgt/>
+            </p:tgtEl>
+          </p:cond>
+        </p:nextCondLst>
+      </p:seq>
+    </p:tnLst>
+    <p:bldLst>
+      <p:bldP spid="11" grpId="0" build="p"/>
+    </p:bldLst>
+  </p:timing>
 </p:sld>
 </file>
 
 <file path=ppt/slides/slide4.xml><?xml version="1.0" encoding="utf-8"?>
-<p:sld xmlns:a="http://schemas.openxmlformats.org/drawingml/2006/main" xmlns:p="http://schemas.openxmlformats.org/presentationml/2006/main" xmlns:r="http://schemas.openxmlformats.org/officeDocument/2006/relationships">
+<p:sld xmlns:a="http://schemas.openxmlformats.org/drawingml/2006/main" xmlns:p="http://schemas.openxmlformats.org/presentationml/2006/main" xmlns:r="http://schemas.openxmlformats.org/officeDocument/2006/relationships" xmlns:ns0="http://schemas.openxmlformats.org/markup-compatibility/2006" ns0:Ignorable="p14">
   <p:cSld>
     <p:bg>
       <p:bgPr>
@@ -10583,11 +12002,169 @@
   <p:clrMapOvr>
     <a:masterClrMapping/>
   </p:clrMapOvr>
+  <ns0:AlternateContent xmlns:p14="http://schemas.microsoft.com/office/powerpoint/2010/main">
+    <ns0:Choice Requires="p14">
+      <p:transition spd="med" p14:dur="700">
+        <p:fade/>
+      </p:transition>
+    </ns0:Choice>
+    <ns0:Fallback>
+      <p:transition spd="med">
+        <p:fade/>
+      </p:transition>
+    </ns0:Fallback>
+  </ns0:AlternateContent>
+  <p:timing>
+    <p:tnLst>
+      <p:seq concurrent="1" nextAc="seek">
+        <p:cTn id="1" dur="indefinite" nodeType="mainSeq">
+          <p:stCondLst>
+            <p:cond delay="0"/>
+          </p:stCondLst>
+          <p:childTnLst>
+            <p:par>
+              <p:cTn id="2" fill="hold" nodeType="afterEffect">
+                <p:stCondLst>
+                  <p:cond delay="0"/>
+                </p:stCondLst>
+                <p:childTnLst>
+                  <p:animEffect transition="in" filter="fade">
+                    <p:cBhvr>
+                      <p:cTn id="3" dur="500" fill="hold"/>
+                      <p:tgtEl>
+                        <p:spTgt spid="8"/>
+                      </p:tgtEl>
+                    </p:cBhvr>
+                  </p:animEffect>
+                </p:childTnLst>
+              </p:cTn>
+            </p:par>
+            <p:par>
+              <p:cTn id="4" fill="hold" nodeType="afterEffect">
+                <p:stCondLst>
+                  <p:cond delay="560"/>
+                </p:stCondLst>
+                <p:childTnLst>
+                  <p:animEffect transition="in" filter="fade">
+                    <p:cBhvr>
+                      <p:cTn id="5" dur="430" fill="hold"/>
+                      <p:tgtEl>
+                        <p:spTgt spid="11"/>
+                      </p:tgtEl>
+                    </p:cBhvr>
+                  </p:animEffect>
+                </p:childTnLst>
+              </p:cTn>
+            </p:par>
+            <p:par>
+              <p:cTn id="6" fill="hold" nodeType="withEffect">
+                <p:stCondLst>
+                  <p:cond delay="560"/>
+                </p:stCondLst>
+                <p:childTnLst>
+                  <p:animEffect transition="in" filter="fade">
+                    <p:cBhvr>
+                      <p:cTn id="7" dur="430" fill="hold"/>
+                      <p:tgtEl>
+                        <p:spTgt spid="12"/>
+                      </p:tgtEl>
+                    </p:cBhvr>
+                  </p:animEffect>
+                </p:childTnLst>
+              </p:cTn>
+            </p:par>
+            <p:par>
+              <p:cTn id="8" fill="hold" nodeType="afterEffect">
+                <p:stCondLst>
+                  <p:cond delay="830"/>
+                </p:stCondLst>
+                <p:childTnLst>
+                  <p:animEffect transition="in" filter="fade">
+                    <p:cBhvr>
+                      <p:cTn id="9" dur="430" fill="hold"/>
+                      <p:tgtEl>
+                        <p:spTgt spid="15"/>
+                      </p:tgtEl>
+                    </p:cBhvr>
+                  </p:animEffect>
+                </p:childTnLst>
+              </p:cTn>
+            </p:par>
+            <p:par>
+              <p:cTn id="10" fill="hold" nodeType="withEffect">
+                <p:stCondLst>
+                  <p:cond delay="830"/>
+                </p:stCondLst>
+                <p:childTnLst>
+                  <p:animEffect transition="in" filter="fade">
+                    <p:cBhvr>
+                      <p:cTn id="11" dur="430" fill="hold"/>
+                      <p:tgtEl>
+                        <p:spTgt spid="16"/>
+                      </p:tgtEl>
+                    </p:cBhvr>
+                  </p:animEffect>
+                </p:childTnLst>
+              </p:cTn>
+            </p:par>
+            <p:par>
+              <p:cTn id="12" fill="hold" nodeType="afterEffect">
+                <p:stCondLst>
+                  <p:cond delay="1100"/>
+                </p:stCondLst>
+                <p:childTnLst>
+                  <p:animEffect transition="in" filter="fade">
+                    <p:cBhvr>
+                      <p:cTn id="13" dur="430" fill="hold"/>
+                      <p:tgtEl>
+                        <p:spTgt spid="19"/>
+                      </p:tgtEl>
+                    </p:cBhvr>
+                  </p:animEffect>
+                </p:childTnLst>
+              </p:cTn>
+            </p:par>
+            <p:par>
+              <p:cTn id="14" fill="hold" nodeType="withEffect">
+                <p:stCondLst>
+                  <p:cond delay="1100"/>
+                </p:stCondLst>
+                <p:childTnLst>
+                  <p:animEffect transition="in" filter="fade">
+                    <p:cBhvr>
+                      <p:cTn id="15" dur="430" fill="hold"/>
+                      <p:tgtEl>
+                        <p:spTgt spid="20"/>
+                      </p:tgtEl>
+                    </p:cBhvr>
+                  </p:animEffect>
+                </p:childTnLst>
+              </p:cTn>
+            </p:par>
+          </p:childTnLst>
+        </p:cTn>
+        <p:prevCondLst>
+          <p:cond evt="onPrev" delay="0">
+            <p:tgtEl>
+              <p:sldTgt/>
+            </p:tgtEl>
+          </p:cond>
+        </p:prevCondLst>
+        <p:nextCondLst>
+          <p:cond evt="onNext" delay="0">
+            <p:tgtEl>
+              <p:sldTgt/>
+            </p:tgtEl>
+          </p:cond>
+        </p:nextCondLst>
+      </p:seq>
+    </p:tnLst>
+  </p:timing>
 </p:sld>
 </file>
 
 <file path=ppt/slides/slide5.xml><?xml version="1.0" encoding="utf-8"?>
-<p:sld xmlns:a="http://schemas.openxmlformats.org/drawingml/2006/main" xmlns:p="http://schemas.openxmlformats.org/presentationml/2006/main" xmlns:r="http://schemas.openxmlformats.org/officeDocument/2006/relationships">
+<p:sld xmlns:a="http://schemas.openxmlformats.org/drawingml/2006/main" xmlns:p="http://schemas.openxmlformats.org/presentationml/2006/main" xmlns:r="http://schemas.openxmlformats.org/officeDocument/2006/relationships" xmlns:ns0="http://schemas.openxmlformats.org/markup-compatibility/2006" ns0:Ignorable="p14">
   <p:cSld>
     <p:bg>
       <p:bgPr>
@@ -11950,11 +13527,203 @@
   <p:clrMapOvr>
     <a:masterClrMapping/>
   </p:clrMapOvr>
+  <ns0:AlternateContent xmlns:p14="http://schemas.microsoft.com/office/powerpoint/2010/main">
+    <ns0:Choice Requires="p14">
+      <p:transition spd="med" p14:dur="700">
+        <p:fade/>
+      </p:transition>
+    </ns0:Choice>
+    <ns0:Fallback>
+      <p:transition spd="med">
+        <p:fade/>
+      </p:transition>
+    </ns0:Fallback>
+  </ns0:AlternateContent>
+  <p:timing>
+    <p:tnLst>
+      <p:seq concurrent="1" nextAc="seek">
+        <p:cTn id="1" dur="indefinite" nodeType="mainSeq">
+          <p:stCondLst>
+            <p:cond delay="0"/>
+          </p:stCondLst>
+          <p:childTnLst>
+            <p:par>
+              <p:cTn id="2" fill="hold" nodeType="afterEffect">
+                <p:stCondLst>
+                  <p:cond delay="0"/>
+                </p:stCondLst>
+                <p:childTnLst>
+                  <p:animEffect transition="in" filter="fade">
+                    <p:cBhvr>
+                      <p:cTn id="3" dur="500" fill="hold"/>
+                      <p:tgtEl>
+                        <p:spTgt spid="8"/>
+                      </p:tgtEl>
+                    </p:cBhvr>
+                  </p:animEffect>
+                </p:childTnLst>
+              </p:cTn>
+            </p:par>
+            <p:par>
+              <p:cTn id="4" fill="hold" nodeType="afterEffect">
+                <p:stCondLst>
+                  <p:cond delay="560"/>
+                </p:stCondLst>
+                <p:childTnLst>
+                  <p:animEffect transition="in" filter="fade">
+                    <p:cBhvr>
+                      <p:cTn id="5" dur="420" fill="hold"/>
+                      <p:tgtEl>
+                        <p:spTgt spid="13"/>
+                      </p:tgtEl>
+                    </p:cBhvr>
+                  </p:animEffect>
+                </p:childTnLst>
+              </p:cTn>
+            </p:par>
+            <p:par>
+              <p:cTn id="6" fill="hold" nodeType="withEffect">
+                <p:stCondLst>
+                  <p:cond delay="560"/>
+                </p:stCondLst>
+                <p:childTnLst>
+                  <p:animEffect transition="in" filter="fade">
+                    <p:cBhvr>
+                      <p:cTn id="7" dur="420" fill="hold"/>
+                      <p:tgtEl>
+                        <p:spTgt spid="14"/>
+                      </p:tgtEl>
+                    </p:cBhvr>
+                  </p:animEffect>
+                </p:childTnLst>
+              </p:cTn>
+            </p:par>
+            <p:par>
+              <p:cTn id="8" fill="hold" nodeType="afterEffect">
+                <p:stCondLst>
+                  <p:cond delay="840"/>
+                </p:stCondLst>
+                <p:childTnLst>
+                  <p:animEffect transition="in" filter="fade">
+                    <p:cBhvr>
+                      <p:cTn id="9" dur="420" fill="hold"/>
+                      <p:tgtEl>
+                        <p:spTgt spid="19"/>
+                      </p:tgtEl>
+                    </p:cBhvr>
+                  </p:animEffect>
+                </p:childTnLst>
+              </p:cTn>
+            </p:par>
+            <p:par>
+              <p:cTn id="10" fill="hold" nodeType="withEffect">
+                <p:stCondLst>
+                  <p:cond delay="840"/>
+                </p:stCondLst>
+                <p:childTnLst>
+                  <p:animEffect transition="in" filter="fade">
+                    <p:cBhvr>
+                      <p:cTn id="11" dur="420" fill="hold"/>
+                      <p:tgtEl>
+                        <p:spTgt spid="20"/>
+                      </p:tgtEl>
+                    </p:cBhvr>
+                  </p:animEffect>
+                </p:childTnLst>
+              </p:cTn>
+            </p:par>
+            <p:par>
+              <p:cTn id="12" fill="hold" nodeType="afterEffect">
+                <p:stCondLst>
+                  <p:cond delay="1120"/>
+                </p:stCondLst>
+                <p:childTnLst>
+                  <p:animEffect transition="in" filter="fade">
+                    <p:cBhvr>
+                      <p:cTn id="13" dur="420" fill="hold"/>
+                      <p:tgtEl>
+                        <p:spTgt spid="25"/>
+                      </p:tgtEl>
+                    </p:cBhvr>
+                  </p:animEffect>
+                </p:childTnLst>
+              </p:cTn>
+            </p:par>
+            <p:par>
+              <p:cTn id="14" fill="hold" nodeType="withEffect">
+                <p:stCondLst>
+                  <p:cond delay="1120"/>
+                </p:stCondLst>
+                <p:childTnLst>
+                  <p:animEffect transition="in" filter="fade">
+                    <p:cBhvr>
+                      <p:cTn id="15" dur="420" fill="hold"/>
+                      <p:tgtEl>
+                        <p:spTgt spid="26"/>
+                      </p:tgtEl>
+                    </p:cBhvr>
+                  </p:animEffect>
+                </p:childTnLst>
+              </p:cTn>
+            </p:par>
+            <p:par>
+              <p:cTn id="16" fill="hold" nodeType="afterEffect">
+                <p:stCondLst>
+                  <p:cond delay="1400"/>
+                </p:stCondLst>
+                <p:childTnLst>
+                  <p:animEffect transition="in" filter="fade">
+                    <p:cBhvr>
+                      <p:cTn id="17" dur="420" fill="hold"/>
+                      <p:tgtEl>
+                        <p:spTgt spid="31"/>
+                      </p:tgtEl>
+                    </p:cBhvr>
+                  </p:animEffect>
+                </p:childTnLst>
+              </p:cTn>
+            </p:par>
+            <p:par>
+              <p:cTn id="18" fill="hold" nodeType="withEffect">
+                <p:stCondLst>
+                  <p:cond delay="1400"/>
+                </p:stCondLst>
+                <p:childTnLst>
+                  <p:animEffect transition="in" filter="fade">
+                    <p:cBhvr>
+                      <p:cTn id="19" dur="420" fill="hold"/>
+                      <p:tgtEl>
+                        <p:spTgt spid="32"/>
+                      </p:tgtEl>
+                    </p:cBhvr>
+                  </p:animEffect>
+                </p:childTnLst>
+              </p:cTn>
+            </p:par>
+          </p:childTnLst>
+        </p:cTn>
+        <p:prevCondLst>
+          <p:cond evt="onPrev" delay="0">
+            <p:tgtEl>
+              <p:sldTgt/>
+            </p:tgtEl>
+          </p:cond>
+        </p:prevCondLst>
+        <p:nextCondLst>
+          <p:cond evt="onNext" delay="0">
+            <p:tgtEl>
+              <p:sldTgt/>
+            </p:tgtEl>
+          </p:cond>
+        </p:nextCondLst>
+      </p:seq>
+    </p:tnLst>
+  </p:timing>
 </p:sld>
 </file>
 
 <file path=ppt/slides/slide6.xml><?xml version="1.0" encoding="utf-8"?>
-<p:sld xmlns:a="http://schemas.openxmlformats.org/drawingml/2006/main" xmlns:p="http://schemas.openxmlformats.org/presentationml/2006/main" xmlns:r="http://schemas.openxmlformats.org/officeDocument/2006/relationships">
+<p:sld xmlns:a="http://schemas.openxmlformats.org/drawingml/2006/main" xmlns:p="http://schemas.openxmlformats.org/presentationml/2006/main" xmlns:r="http://schemas.openxmlformats.org/officeDocument/2006/relationships" xmlns:ns0="http://schemas.openxmlformats.org/markup-compatibility/2006" ns0:Ignorable="p14">
   <p:cSld>
     <p:bg>
       <p:bgPr>
@@ -13307,11 +15076,288 @@
   <p:clrMapOvr>
     <a:masterClrMapping/>
   </p:clrMapOvr>
+  <ns0:AlternateContent xmlns:p14="http://schemas.microsoft.com/office/powerpoint/2010/main">
+    <ns0:Choice Requires="p14">
+      <p:transition spd="med" p14:dur="700">
+        <p:fade/>
+      </p:transition>
+    </ns0:Choice>
+    <ns0:Fallback>
+      <p:transition spd="med">
+        <p:fade/>
+      </p:transition>
+    </ns0:Fallback>
+  </ns0:AlternateContent>
+  <p:timing>
+    <p:tnLst>
+      <p:seq concurrent="1" nextAc="seek">
+        <p:cTn id="1" dur="indefinite" nodeType="mainSeq">
+          <p:stCondLst>
+            <p:cond delay="0"/>
+          </p:stCondLst>
+          <p:childTnLst>
+            <p:par>
+              <p:cTn id="2" fill="hold" nodeType="afterEffect">
+                <p:stCondLst>
+                  <p:cond delay="0"/>
+                </p:stCondLst>
+                <p:childTnLst>
+                  <p:animEffect transition="in" filter="fade">
+                    <p:cBhvr>
+                      <p:cTn id="3" dur="500" fill="hold"/>
+                      <p:tgtEl>
+                        <p:spTgt spid="8"/>
+                      </p:tgtEl>
+                    </p:cBhvr>
+                  </p:animEffect>
+                </p:childTnLst>
+              </p:cTn>
+            </p:par>
+            <p:par>
+              <p:cTn id="4" fill="hold" nodeType="afterEffect">
+                <p:stCondLst>
+                  <p:cond delay="560"/>
+                </p:stCondLst>
+                <p:childTnLst>
+                  <p:animEffect transition="in" filter="fade">
+                    <p:cBhvr>
+                      <p:cTn id="5" dur="360" fill="hold"/>
+                      <p:tgtEl>
+                        <p:spTgt spid="9"/>
+                      </p:tgtEl>
+                    </p:cBhvr>
+                  </p:animEffect>
+                </p:childTnLst>
+              </p:cTn>
+            </p:par>
+            <p:par>
+              <p:cTn id="6" fill="hold" nodeType="withEffect">
+                <p:stCondLst>
+                  <p:cond delay="560"/>
+                </p:stCondLst>
+                <p:childTnLst>
+                  <p:animEffect transition="in" filter="fade">
+                    <p:cBhvr>
+                      <p:cTn id="7" dur="360" fill="hold"/>
+                      <p:tgtEl>
+                        <p:spTgt spid="11"/>
+                      </p:tgtEl>
+                    </p:cBhvr>
+                  </p:animEffect>
+                </p:childTnLst>
+              </p:cTn>
+            </p:par>
+            <p:par>
+              <p:cTn id="8" fill="hold" nodeType="afterEffect">
+                <p:stCondLst>
+                  <p:cond delay="790"/>
+                </p:stCondLst>
+                <p:childTnLst>
+                  <p:animEffect transition="in" filter="fade">
+                    <p:cBhvr>
+                      <p:cTn id="9" dur="360" fill="hold"/>
+                      <p:tgtEl>
+                        <p:spTgt spid="13"/>
+                      </p:tgtEl>
+                    </p:cBhvr>
+                  </p:animEffect>
+                </p:childTnLst>
+              </p:cTn>
+            </p:par>
+            <p:par>
+              <p:cTn id="10" fill="hold" nodeType="afterEffect">
+                <p:stCondLst>
+                  <p:cond delay="1020"/>
+                </p:stCondLst>
+                <p:childTnLst>
+                  <p:animEffect transition="in" filter="fade">
+                    <p:cBhvr>
+                      <p:cTn id="11" dur="360" fill="hold"/>
+                      <p:tgtEl>
+                        <p:spTgt spid="16"/>
+                      </p:tgtEl>
+                    </p:cBhvr>
+                  </p:animEffect>
+                </p:childTnLst>
+              </p:cTn>
+            </p:par>
+            <p:par>
+              <p:cTn id="12" fill="hold" nodeType="withEffect">
+                <p:stCondLst>
+                  <p:cond delay="1020"/>
+                </p:stCondLst>
+                <p:childTnLst>
+                  <p:animEffect transition="in" filter="fade">
+                    <p:cBhvr>
+                      <p:cTn id="13" dur="360" fill="hold"/>
+                      <p:tgtEl>
+                        <p:spTgt spid="17"/>
+                      </p:tgtEl>
+                    </p:cBhvr>
+                  </p:animEffect>
+                </p:childTnLst>
+              </p:cTn>
+            </p:par>
+            <p:par>
+              <p:cTn id="14" fill="hold" nodeType="afterEffect">
+                <p:stCondLst>
+                  <p:cond delay="1250"/>
+                </p:stCondLst>
+                <p:childTnLst>
+                  <p:animEffect transition="in" filter="fade">
+                    <p:cBhvr>
+                      <p:cTn id="15" dur="360" fill="hold"/>
+                      <p:tgtEl>
+                        <p:spTgt spid="20"/>
+                      </p:tgtEl>
+                    </p:cBhvr>
+                  </p:animEffect>
+                </p:childTnLst>
+              </p:cTn>
+            </p:par>
+            <p:par>
+              <p:cTn id="16" fill="hold" nodeType="withEffect">
+                <p:stCondLst>
+                  <p:cond delay="1250"/>
+                </p:stCondLst>
+                <p:childTnLst>
+                  <p:animEffect transition="in" filter="fade">
+                    <p:cBhvr>
+                      <p:cTn id="17" dur="360" fill="hold"/>
+                      <p:tgtEl>
+                        <p:spTgt spid="21"/>
+                      </p:tgtEl>
+                    </p:cBhvr>
+                  </p:animEffect>
+                </p:childTnLst>
+              </p:cTn>
+            </p:par>
+            <p:par>
+              <p:cTn id="18" fill="hold" nodeType="afterEffect">
+                <p:stCondLst>
+                  <p:cond delay="1480"/>
+                </p:stCondLst>
+                <p:childTnLst>
+                  <p:animEffect transition="in" filter="fade">
+                    <p:cBhvr>
+                      <p:cTn id="19" dur="360" fill="hold"/>
+                      <p:tgtEl>
+                        <p:spTgt spid="24"/>
+                      </p:tgtEl>
+                    </p:cBhvr>
+                  </p:animEffect>
+                </p:childTnLst>
+              </p:cTn>
+            </p:par>
+            <p:par>
+              <p:cTn id="20" fill="hold" nodeType="withEffect">
+                <p:stCondLst>
+                  <p:cond delay="1480"/>
+                </p:stCondLst>
+                <p:childTnLst>
+                  <p:animEffect transition="in" filter="fade">
+                    <p:cBhvr>
+                      <p:cTn id="21" dur="360" fill="hold"/>
+                      <p:tgtEl>
+                        <p:spTgt spid="25"/>
+                      </p:tgtEl>
+                    </p:cBhvr>
+                  </p:animEffect>
+                </p:childTnLst>
+              </p:cTn>
+            </p:par>
+            <p:par>
+              <p:cTn id="22" fill="hold" nodeType="afterEffect">
+                <p:stCondLst>
+                  <p:cond delay="1710"/>
+                </p:stCondLst>
+                <p:childTnLst>
+                  <p:animEffect transition="in" filter="fade">
+                    <p:cBhvr>
+                      <p:cTn id="23" dur="360" fill="hold"/>
+                      <p:tgtEl>
+                        <p:spTgt spid="28"/>
+                      </p:tgtEl>
+                    </p:cBhvr>
+                  </p:animEffect>
+                </p:childTnLst>
+              </p:cTn>
+            </p:par>
+            <p:par>
+              <p:cTn id="24" fill="hold" nodeType="withEffect">
+                <p:stCondLst>
+                  <p:cond delay="1710"/>
+                </p:stCondLst>
+                <p:childTnLst>
+                  <p:animEffect transition="in" filter="fade">
+                    <p:cBhvr>
+                      <p:cTn id="25" dur="360" fill="hold"/>
+                      <p:tgtEl>
+                        <p:spTgt spid="29"/>
+                      </p:tgtEl>
+                    </p:cBhvr>
+                  </p:animEffect>
+                </p:childTnLst>
+              </p:cTn>
+            </p:par>
+            <p:par>
+              <p:cTn id="26" fill="hold" nodeType="afterEffect">
+                <p:stCondLst>
+                  <p:cond delay="1940"/>
+                </p:stCondLst>
+                <p:childTnLst>
+                  <p:animEffect transition="in" filter="fade">
+                    <p:cBhvr>
+                      <p:cTn id="27" dur="360" fill="hold"/>
+                      <p:tgtEl>
+                        <p:spTgt spid="31"/>
+                      </p:tgtEl>
+                    </p:cBhvr>
+                  </p:animEffect>
+                </p:childTnLst>
+              </p:cTn>
+            </p:par>
+            <p:par>
+              <p:cTn id="28" fill="hold" nodeType="afterEffect">
+                <p:stCondLst>
+                  <p:cond delay="2170"/>
+                </p:stCondLst>
+                <p:childTnLst>
+                  <p:animEffect transition="in" filter="fade">
+                    <p:cBhvr>
+                      <p:cTn id="29" dur="360" fill="hold"/>
+                      <p:tgtEl>
+                        <p:spTgt spid="32"/>
+                      </p:tgtEl>
+                    </p:cBhvr>
+                  </p:animEffect>
+                </p:childTnLst>
+              </p:cTn>
+            </p:par>
+          </p:childTnLst>
+        </p:cTn>
+        <p:prevCondLst>
+          <p:cond evt="onPrev" delay="0">
+            <p:tgtEl>
+              <p:sldTgt/>
+            </p:tgtEl>
+          </p:cond>
+        </p:prevCondLst>
+        <p:nextCondLst>
+          <p:cond evt="onNext" delay="0">
+            <p:tgtEl>
+              <p:sldTgt/>
+            </p:tgtEl>
+          </p:cond>
+        </p:nextCondLst>
+      </p:seq>
+    </p:tnLst>
+  </p:timing>
 </p:sld>
 </file>
 
 <file path=ppt/slides/slide7.xml><?xml version="1.0" encoding="utf-8"?>
-<p:sld xmlns:a="http://schemas.openxmlformats.org/drawingml/2006/main" xmlns:p="http://schemas.openxmlformats.org/presentationml/2006/main" xmlns:r="http://schemas.openxmlformats.org/officeDocument/2006/relationships">
+<p:sld xmlns:a="http://schemas.openxmlformats.org/drawingml/2006/main" xmlns:p="http://schemas.openxmlformats.org/presentationml/2006/main" xmlns:r="http://schemas.openxmlformats.org/officeDocument/2006/relationships" xmlns:ns0="http://schemas.openxmlformats.org/markup-compatibility/2006" ns0:Ignorable="p14">
   <p:cSld>
     <p:bg>
       <p:bgPr>
@@ -14434,11 +16480,220 @@
   <p:clrMapOvr>
     <a:masterClrMapping/>
   </p:clrMapOvr>
+  <ns0:AlternateContent xmlns:p14="http://schemas.microsoft.com/office/powerpoint/2010/main">
+    <ns0:Choice Requires="p14">
+      <p:transition spd="med" p14:dur="700">
+        <p:fade/>
+      </p:transition>
+    </ns0:Choice>
+    <ns0:Fallback>
+      <p:transition spd="med">
+        <p:fade/>
+      </p:transition>
+    </ns0:Fallback>
+  </ns0:AlternateContent>
+  <p:timing>
+    <p:tnLst>
+      <p:seq concurrent="1" nextAc="seek">
+        <p:cTn id="1" dur="indefinite" nodeType="mainSeq">
+          <p:stCondLst>
+            <p:cond delay="0"/>
+          </p:stCondLst>
+          <p:childTnLst>
+            <p:par>
+              <p:cTn id="2" fill="hold" nodeType="afterEffect">
+                <p:stCondLst>
+                  <p:cond delay="0"/>
+                </p:stCondLst>
+                <p:childTnLst>
+                  <p:animEffect transition="in" filter="fade">
+                    <p:cBhvr>
+                      <p:cTn id="3" dur="500" fill="hold"/>
+                      <p:tgtEl>
+                        <p:spTgt spid="8"/>
+                      </p:tgtEl>
+                    </p:cBhvr>
+                  </p:animEffect>
+                </p:childTnLst>
+              </p:cTn>
+            </p:par>
+            <p:par>
+              <p:cTn id="4" fill="hold" nodeType="afterEffect">
+                <p:stCondLst>
+                  <p:cond delay="560"/>
+                </p:stCondLst>
+                <p:childTnLst>
+                  <p:animEffect transition="in" filter="fade">
+                    <p:cBhvr>
+                      <p:cTn id="5" dur="420" fill="hold"/>
+                      <p:tgtEl>
+                        <p:spTgt spid="10"/>
+                      </p:tgtEl>
+                    </p:cBhvr>
+                  </p:animEffect>
+                </p:childTnLst>
+              </p:cTn>
+            </p:par>
+            <p:par>
+              <p:cTn id="6" fill="hold" nodeType="afterEffect">
+                <p:stCondLst>
+                  <p:cond delay="860"/>
+                </p:stCondLst>
+                <p:childTnLst>
+                  <p:animEffect transition="in" filter="fade">
+                    <p:cBhvr>
+                      <p:cTn id="7" dur="380" fill="hold"/>
+                      <p:tgtEl>
+                        <p:spTgt spid="13"/>
+                      </p:tgtEl>
+                    </p:cBhvr>
+                  </p:animEffect>
+                </p:childTnLst>
+              </p:cTn>
+            </p:par>
+            <p:par>
+              <p:cTn id="8" fill="hold" nodeType="withEffect">
+                <p:stCondLst>
+                  <p:cond delay="860"/>
+                </p:stCondLst>
+                <p:childTnLst>
+                  <p:animEffect transition="in" filter="fade">
+                    <p:cBhvr>
+                      <p:cTn id="9" dur="380" fill="hold"/>
+                      <p:tgtEl>
+                        <p:spTgt spid="14"/>
+                      </p:tgtEl>
+                    </p:cBhvr>
+                  </p:animEffect>
+                </p:childTnLst>
+              </p:cTn>
+            </p:par>
+            <p:par>
+              <p:cTn id="10" fill="hold" nodeType="afterEffect">
+                <p:stCondLst>
+                  <p:cond delay="1120"/>
+                </p:stCondLst>
+                <p:childTnLst>
+                  <p:animEffect transition="in" filter="fade">
+                    <p:cBhvr>
+                      <p:cTn id="11" dur="380" fill="hold"/>
+                      <p:tgtEl>
+                        <p:spTgt spid="17"/>
+                      </p:tgtEl>
+                    </p:cBhvr>
+                  </p:animEffect>
+                </p:childTnLst>
+              </p:cTn>
+            </p:par>
+            <p:par>
+              <p:cTn id="12" fill="hold" nodeType="withEffect">
+                <p:stCondLst>
+                  <p:cond delay="1120"/>
+                </p:stCondLst>
+                <p:childTnLst>
+                  <p:animEffect transition="in" filter="fade">
+                    <p:cBhvr>
+                      <p:cTn id="13" dur="380" fill="hold"/>
+                      <p:tgtEl>
+                        <p:spTgt spid="18"/>
+                      </p:tgtEl>
+                    </p:cBhvr>
+                  </p:animEffect>
+                </p:childTnLst>
+              </p:cTn>
+            </p:par>
+            <p:par>
+              <p:cTn id="14" fill="hold" nodeType="afterEffect">
+                <p:stCondLst>
+                  <p:cond delay="1380"/>
+                </p:stCondLst>
+                <p:childTnLst>
+                  <p:animEffect transition="in" filter="fade">
+                    <p:cBhvr>
+                      <p:cTn id="15" dur="380" fill="hold"/>
+                      <p:tgtEl>
+                        <p:spTgt spid="21"/>
+                      </p:tgtEl>
+                    </p:cBhvr>
+                  </p:animEffect>
+                </p:childTnLst>
+              </p:cTn>
+            </p:par>
+            <p:par>
+              <p:cTn id="16" fill="hold" nodeType="withEffect">
+                <p:stCondLst>
+                  <p:cond delay="1380"/>
+                </p:stCondLst>
+                <p:childTnLst>
+                  <p:animEffect transition="in" filter="fade">
+                    <p:cBhvr>
+                      <p:cTn id="17" dur="380" fill="hold"/>
+                      <p:tgtEl>
+                        <p:spTgt spid="22"/>
+                      </p:tgtEl>
+                    </p:cBhvr>
+                  </p:animEffect>
+                </p:childTnLst>
+              </p:cTn>
+            </p:par>
+            <p:par>
+              <p:cTn id="18" fill="hold" nodeType="afterEffect">
+                <p:stCondLst>
+                  <p:cond delay="1640"/>
+                </p:stCondLst>
+                <p:childTnLst>
+                  <p:animEffect transition="in" filter="fade">
+                    <p:cBhvr>
+                      <p:cTn id="19" dur="380" fill="hold"/>
+                      <p:tgtEl>
+                        <p:spTgt spid="25"/>
+                      </p:tgtEl>
+                    </p:cBhvr>
+                  </p:animEffect>
+                </p:childTnLst>
+              </p:cTn>
+            </p:par>
+            <p:par>
+              <p:cTn id="20" fill="hold" nodeType="withEffect">
+                <p:stCondLst>
+                  <p:cond delay="1640"/>
+                </p:stCondLst>
+                <p:childTnLst>
+                  <p:animEffect transition="in" filter="fade">
+                    <p:cBhvr>
+                      <p:cTn id="21" dur="380" fill="hold"/>
+                      <p:tgtEl>
+                        <p:spTgt spid="26"/>
+                      </p:tgtEl>
+                    </p:cBhvr>
+                  </p:animEffect>
+                </p:childTnLst>
+              </p:cTn>
+            </p:par>
+          </p:childTnLst>
+        </p:cTn>
+        <p:prevCondLst>
+          <p:cond evt="onPrev" delay="0">
+            <p:tgtEl>
+              <p:sldTgt/>
+            </p:tgtEl>
+          </p:cond>
+        </p:prevCondLst>
+        <p:nextCondLst>
+          <p:cond evt="onNext" delay="0">
+            <p:tgtEl>
+              <p:sldTgt/>
+            </p:tgtEl>
+          </p:cond>
+        </p:nextCondLst>
+      </p:seq>
+    </p:tnLst>
+  </p:timing>
 </p:sld>
 </file>
 
 <file path=ppt/slides/slide8.xml><?xml version="1.0" encoding="utf-8"?>
-<p:sld xmlns:a="http://schemas.openxmlformats.org/drawingml/2006/main" xmlns:p="http://schemas.openxmlformats.org/presentationml/2006/main" xmlns:r="http://schemas.openxmlformats.org/officeDocument/2006/relationships">
+<p:sld xmlns:a="http://schemas.openxmlformats.org/drawingml/2006/main" xmlns:p="http://schemas.openxmlformats.org/presentationml/2006/main" xmlns:r="http://schemas.openxmlformats.org/officeDocument/2006/relationships" xmlns:ns0="http://schemas.openxmlformats.org/markup-compatibility/2006" ns0:Ignorable="p14">
   <p:cSld>
     <p:bg>
       <p:bgPr>
@@ -15720,11 +17975,305 @@
   <p:clrMapOvr>
     <a:masterClrMapping/>
   </p:clrMapOvr>
+  <ns0:AlternateContent xmlns:p14="http://schemas.microsoft.com/office/powerpoint/2010/main">
+    <ns0:Choice Requires="p14">
+      <p:transition spd="med" p14:dur="700">
+        <p:fade/>
+      </p:transition>
+    </ns0:Choice>
+    <ns0:Fallback>
+      <p:transition spd="med">
+        <p:fade/>
+      </p:transition>
+    </ns0:Fallback>
+  </ns0:AlternateContent>
+  <p:timing>
+    <p:tnLst>
+      <p:seq concurrent="1" nextAc="seek">
+        <p:cTn id="1" dur="indefinite" nodeType="mainSeq">
+          <p:stCondLst>
+            <p:cond delay="0"/>
+          </p:stCondLst>
+          <p:childTnLst>
+            <p:par>
+              <p:cTn id="2" fill="hold" nodeType="afterEffect">
+                <p:stCondLst>
+                  <p:cond delay="0"/>
+                </p:stCondLst>
+                <p:childTnLst>
+                  <p:animEffect transition="in" filter="fade">
+                    <p:cBhvr>
+                      <p:cTn id="3" dur="500" fill="hold"/>
+                      <p:tgtEl>
+                        <p:spTgt spid="8"/>
+                      </p:tgtEl>
+                    </p:cBhvr>
+                  </p:animEffect>
+                </p:childTnLst>
+              </p:cTn>
+            </p:par>
+            <p:par>
+              <p:cTn id="4" fill="hold" nodeType="afterEffect">
+                <p:stCondLst>
+                  <p:cond delay="560"/>
+                </p:stCondLst>
+                <p:childTnLst>
+                  <p:animEffect transition="in" filter="fade">
+                    <p:cBhvr>
+                      <p:cTn id="5" dur="450" fill="hold"/>
+                      <p:tgtEl>
+                        <p:spTgt spid="9"/>
+                      </p:tgtEl>
+                    </p:cBhvr>
+                  </p:animEffect>
+                </p:childTnLst>
+              </p:cTn>
+            </p:par>
+            <p:par>
+              <p:cTn id="6" fill="hold" nodeType="afterEffect">
+                <p:stCondLst>
+                  <p:cond delay="950"/>
+                </p:stCondLst>
+                <p:childTnLst>
+                  <p:animEffect transition="in" filter="fade">
+                    <p:cBhvr>
+                      <p:cTn id="7" dur="360" fill="hold"/>
+                      <p:tgtEl>
+                        <p:spTgt spid="12"/>
+                      </p:tgtEl>
+                    </p:cBhvr>
+                  </p:animEffect>
+                </p:childTnLst>
+              </p:cTn>
+            </p:par>
+            <p:par>
+              <p:cTn id="8" fill="hold" nodeType="withEffect">
+                <p:stCondLst>
+                  <p:cond delay="950"/>
+                </p:stCondLst>
+                <p:childTnLst>
+                  <p:animEffect transition="in" filter="fade">
+                    <p:cBhvr>
+                      <p:cTn id="9" dur="360" fill="hold"/>
+                      <p:tgtEl>
+                        <p:spTgt spid="13"/>
+                      </p:tgtEl>
+                    </p:cBhvr>
+                  </p:animEffect>
+                </p:childTnLst>
+              </p:cTn>
+            </p:par>
+            <p:par>
+              <p:cTn id="10" fill="hold" nodeType="withEffect">
+                <p:stCondLst>
+                  <p:cond delay="950"/>
+                </p:stCondLst>
+                <p:childTnLst>
+                  <p:animEffect transition="in" filter="fade">
+                    <p:cBhvr>
+                      <p:cTn id="11" dur="360" fill="hold"/>
+                      <p:tgtEl>
+                        <p:spTgt spid="14"/>
+                      </p:tgtEl>
+                    </p:cBhvr>
+                  </p:animEffect>
+                </p:childTnLst>
+              </p:cTn>
+            </p:par>
+            <p:par>
+              <p:cTn id="12" fill="hold" nodeType="afterEffect">
+                <p:stCondLst>
+                  <p:cond delay="1250"/>
+                </p:stCondLst>
+                <p:childTnLst>
+                  <p:animEffect transition="in" filter="fade">
+                    <p:cBhvr>
+                      <p:cTn id="13" dur="360" fill="hold"/>
+                      <p:tgtEl>
+                        <p:spTgt spid="17"/>
+                      </p:tgtEl>
+                    </p:cBhvr>
+                  </p:animEffect>
+                </p:childTnLst>
+              </p:cTn>
+            </p:par>
+            <p:par>
+              <p:cTn id="14" fill="hold" nodeType="withEffect">
+                <p:stCondLst>
+                  <p:cond delay="1250"/>
+                </p:stCondLst>
+                <p:childTnLst>
+                  <p:animEffect transition="in" filter="fade">
+                    <p:cBhvr>
+                      <p:cTn id="15" dur="360" fill="hold"/>
+                      <p:tgtEl>
+                        <p:spTgt spid="18"/>
+                      </p:tgtEl>
+                    </p:cBhvr>
+                  </p:animEffect>
+                </p:childTnLst>
+              </p:cTn>
+            </p:par>
+            <p:par>
+              <p:cTn id="16" fill="hold" nodeType="withEffect">
+                <p:stCondLst>
+                  <p:cond delay="1250"/>
+                </p:stCondLst>
+                <p:childTnLst>
+                  <p:animEffect transition="in" filter="fade">
+                    <p:cBhvr>
+                      <p:cTn id="17" dur="360" fill="hold"/>
+                      <p:tgtEl>
+                        <p:spTgt spid="19"/>
+                      </p:tgtEl>
+                    </p:cBhvr>
+                  </p:animEffect>
+                </p:childTnLst>
+              </p:cTn>
+            </p:par>
+            <p:par>
+              <p:cTn id="18" fill="hold" nodeType="afterEffect">
+                <p:stCondLst>
+                  <p:cond delay="1550"/>
+                </p:stCondLst>
+                <p:childTnLst>
+                  <p:animEffect transition="in" filter="fade">
+                    <p:cBhvr>
+                      <p:cTn id="19" dur="360" fill="hold"/>
+                      <p:tgtEl>
+                        <p:spTgt spid="22"/>
+                      </p:tgtEl>
+                    </p:cBhvr>
+                  </p:animEffect>
+                </p:childTnLst>
+              </p:cTn>
+            </p:par>
+            <p:par>
+              <p:cTn id="20" fill="hold" nodeType="withEffect">
+                <p:stCondLst>
+                  <p:cond delay="1550"/>
+                </p:stCondLst>
+                <p:childTnLst>
+                  <p:animEffect transition="in" filter="fade">
+                    <p:cBhvr>
+                      <p:cTn id="21" dur="360" fill="hold"/>
+                      <p:tgtEl>
+                        <p:spTgt spid="23"/>
+                      </p:tgtEl>
+                    </p:cBhvr>
+                  </p:animEffect>
+                </p:childTnLst>
+              </p:cTn>
+            </p:par>
+            <p:par>
+              <p:cTn id="22" fill="hold" nodeType="withEffect">
+                <p:stCondLst>
+                  <p:cond delay="1550"/>
+                </p:stCondLst>
+                <p:childTnLst>
+                  <p:animEffect transition="in" filter="fade">
+                    <p:cBhvr>
+                      <p:cTn id="23" dur="360" fill="hold"/>
+                      <p:tgtEl>
+                        <p:spTgt spid="24"/>
+                      </p:tgtEl>
+                    </p:cBhvr>
+                  </p:animEffect>
+                </p:childTnLst>
+              </p:cTn>
+            </p:par>
+            <p:par>
+              <p:cTn id="24" fill="hold" nodeType="afterEffect">
+                <p:stCondLst>
+                  <p:cond delay="1850"/>
+                </p:stCondLst>
+                <p:childTnLst>
+                  <p:animEffect transition="in" filter="fade">
+                    <p:cBhvr>
+                      <p:cTn id="25" dur="360" fill="hold"/>
+                      <p:tgtEl>
+                        <p:spTgt spid="27"/>
+                      </p:tgtEl>
+                    </p:cBhvr>
+                  </p:animEffect>
+                </p:childTnLst>
+              </p:cTn>
+            </p:par>
+            <p:par>
+              <p:cTn id="26" fill="hold" nodeType="withEffect">
+                <p:stCondLst>
+                  <p:cond delay="1850"/>
+                </p:stCondLst>
+                <p:childTnLst>
+                  <p:animEffect transition="in" filter="fade">
+                    <p:cBhvr>
+                      <p:cTn id="27" dur="360" fill="hold"/>
+                      <p:tgtEl>
+                        <p:spTgt spid="28"/>
+                      </p:tgtEl>
+                    </p:cBhvr>
+                  </p:animEffect>
+                </p:childTnLst>
+              </p:cTn>
+            </p:par>
+            <p:par>
+              <p:cTn id="28" fill="hold" nodeType="withEffect">
+                <p:stCondLst>
+                  <p:cond delay="1850"/>
+                </p:stCondLst>
+                <p:childTnLst>
+                  <p:animEffect transition="in" filter="fade">
+                    <p:cBhvr>
+                      <p:cTn id="29" dur="360" fill="hold"/>
+                      <p:tgtEl>
+                        <p:spTgt spid="29"/>
+                      </p:tgtEl>
+                    </p:cBhvr>
+                  </p:animEffect>
+                </p:childTnLst>
+              </p:cTn>
+            </p:par>
+            <p:par>
+              <p:cTn id="30" fill="hold" nodeType="afterEffect">
+                <p:stCondLst>
+                  <p:cond delay="2270"/>
+                </p:stCondLst>
+                <p:childTnLst>
+                  <p:animEffect transition="in" filter="fade">
+                    <p:cBhvr>
+                      <p:cTn id="31" dur="350" fill="hold"/>
+                      <p:tgtEl>
+                        <p:spTgt spid="31"/>
+                      </p:tgtEl>
+                    </p:cBhvr>
+                  </p:animEffect>
+                </p:childTnLst>
+              </p:cTn>
+            </p:par>
+          </p:childTnLst>
+        </p:cTn>
+        <p:prevCondLst>
+          <p:cond evt="onPrev" delay="0">
+            <p:tgtEl>
+              <p:sldTgt/>
+            </p:tgtEl>
+          </p:cond>
+        </p:prevCondLst>
+        <p:nextCondLst>
+          <p:cond evt="onNext" delay="0">
+            <p:tgtEl>
+              <p:sldTgt/>
+            </p:tgtEl>
+          </p:cond>
+        </p:nextCondLst>
+      </p:seq>
+    </p:tnLst>
+  </p:timing>
 </p:sld>
 </file>
 
 <file path=ppt/slides/slide9.xml><?xml version="1.0" encoding="utf-8"?>
-<p:sld xmlns:a="http://schemas.openxmlformats.org/drawingml/2006/main" xmlns:p="http://schemas.openxmlformats.org/presentationml/2006/main" xmlns:r="http://schemas.openxmlformats.org/officeDocument/2006/relationships">
+<p:sld xmlns:a="http://schemas.openxmlformats.org/drawingml/2006/main" xmlns:p="http://schemas.openxmlformats.org/presentationml/2006/main" xmlns:r="http://schemas.openxmlformats.org/officeDocument/2006/relationships" xmlns:ns0="http://schemas.openxmlformats.org/markup-compatibility/2006" ns0:Ignorable="p14">
   <p:cSld>
     <p:bg>
       <p:bgPr>
@@ -16445,6 +18994,268 @@
   <p:clrMapOvr>
     <a:masterClrMapping/>
   </p:clrMapOvr>
+  <ns0:AlternateContent xmlns:p14="http://schemas.microsoft.com/office/powerpoint/2010/main">
+    <ns0:Choice Requires="p14">
+      <p:transition spd="med" p14:dur="700">
+        <p:fade/>
+      </p:transition>
+    </ns0:Choice>
+    <ns0:Fallback>
+      <p:transition spd="med">
+        <p:fade/>
+      </p:transition>
+    </ns0:Fallback>
+  </ns0:AlternateContent>
+  <p:timing>
+    <p:tnLst>
+      <p:seq concurrent="1" nextAc="seek">
+        <p:cTn id="1" dur="indefinite" nodeType="mainSeq">
+          <p:stCondLst>
+            <p:cond delay="0"/>
+          </p:stCondLst>
+          <p:childTnLst>
+            <p:par>
+              <p:cTn id="2" fill="hold" nodeType="afterEffect">
+                <p:stCondLst>
+                  <p:cond delay="0"/>
+                </p:stCondLst>
+                <p:childTnLst>
+                  <p:animEffect transition="in" filter="fade">
+                    <p:cBhvr>
+                      <p:cTn id="3" dur="500" fill="hold"/>
+                      <p:tgtEl>
+                        <p:spTgt spid="8"/>
+                      </p:tgtEl>
+                    </p:cBhvr>
+                  </p:animEffect>
+                </p:childTnLst>
+              </p:cTn>
+            </p:par>
+            <p:par>
+              <p:cTn id="4" fill="hold" nodeType="afterEffect">
+                <p:stCondLst>
+                  <p:cond delay="560"/>
+                </p:stCondLst>
+                <p:childTnLst>
+                  <p:animEffect transition="in" filter="fade">
+                    <p:cBhvr>
+                      <p:cTn id="5" dur="350" fill="hold"/>
+                      <p:tgtEl>
+                        <p:spTgt spid="11"/>
+                      </p:tgtEl>
+                    </p:cBhvr>
+                  </p:animEffect>
+                </p:childTnLst>
+              </p:cTn>
+            </p:par>
+            <p:par>
+              <p:cTn id="6" fill="hold" nodeType="afterEffect">
+                <p:stCondLst>
+                  <p:cond delay="770"/>
+                </p:stCondLst>
+                <p:childTnLst>
+                  <p:animEffect transition="in" filter="fade">
+                    <p:cBhvr>
+                      <p:cTn id="7" dur="300" fill="hold"/>
+                      <p:tgtEl>
+                        <p:spTgt spid="12">
+                          <p:txEl>
+                            <p:pRg st="0" end="0"/>
+                          </p:txEl>
+                        </p:spTgt>
+                      </p:tgtEl>
+                    </p:cBhvr>
+                  </p:animEffect>
+                </p:childTnLst>
+              </p:cTn>
+            </p:par>
+            <p:par>
+              <p:cTn id="8" fill="hold" nodeType="afterEffect">
+                <p:stCondLst>
+                  <p:cond delay="940"/>
+                </p:stCondLst>
+                <p:childTnLst>
+                  <p:animEffect transition="in" filter="fade">
+                    <p:cBhvr>
+                      <p:cTn id="9" dur="300" fill="hold"/>
+                      <p:tgtEl>
+                        <p:spTgt spid="12">
+                          <p:txEl>
+                            <p:pRg st="1" end="1"/>
+                          </p:txEl>
+                        </p:spTgt>
+                      </p:tgtEl>
+                    </p:cBhvr>
+                  </p:animEffect>
+                </p:childTnLst>
+              </p:cTn>
+            </p:par>
+            <p:par>
+              <p:cTn id="10" fill="hold" nodeType="afterEffect">
+                <p:stCondLst>
+                  <p:cond delay="1110"/>
+                </p:stCondLst>
+                <p:childTnLst>
+                  <p:animEffect transition="in" filter="fade">
+                    <p:cBhvr>
+                      <p:cTn id="11" dur="300" fill="hold"/>
+                      <p:tgtEl>
+                        <p:spTgt spid="12">
+                          <p:txEl>
+                            <p:pRg st="2" end="2"/>
+                          </p:txEl>
+                        </p:spTgt>
+                      </p:tgtEl>
+                    </p:cBhvr>
+                  </p:animEffect>
+                </p:childTnLst>
+              </p:cTn>
+            </p:par>
+            <p:par>
+              <p:cTn id="12" fill="hold" nodeType="afterEffect">
+                <p:stCondLst>
+                  <p:cond delay="1280"/>
+                </p:stCondLst>
+                <p:childTnLst>
+                  <p:animEffect transition="in" filter="fade">
+                    <p:cBhvr>
+                      <p:cTn id="13" dur="300" fill="hold"/>
+                      <p:tgtEl>
+                        <p:spTgt spid="12">
+                          <p:txEl>
+                            <p:pRg st="3" end="3"/>
+                          </p:txEl>
+                        </p:spTgt>
+                      </p:tgtEl>
+                    </p:cBhvr>
+                  </p:animEffect>
+                </p:childTnLst>
+              </p:cTn>
+            </p:par>
+            <p:par>
+              <p:cTn id="14" fill="hold" nodeType="afterEffect">
+                <p:stCondLst>
+                  <p:cond delay="1450"/>
+                </p:stCondLst>
+                <p:childTnLst>
+                  <p:animEffect transition="in" filter="fade">
+                    <p:cBhvr>
+                      <p:cTn id="15" dur="350" fill="hold"/>
+                      <p:tgtEl>
+                        <p:spTgt spid="13"/>
+                      </p:tgtEl>
+                    </p:cBhvr>
+                  </p:animEffect>
+                </p:childTnLst>
+              </p:cTn>
+            </p:par>
+            <p:par>
+              <p:cTn id="16" fill="hold" nodeType="afterEffect">
+                <p:stCondLst>
+                  <p:cond delay="1660"/>
+                </p:stCondLst>
+                <p:childTnLst>
+                  <p:animEffect transition="in" filter="fade">
+                    <p:cBhvr>
+                      <p:cTn id="17" dur="300" fill="hold"/>
+                      <p:tgtEl>
+                        <p:spTgt spid="14">
+                          <p:txEl>
+                            <p:pRg st="0" end="0"/>
+                          </p:txEl>
+                        </p:spTgt>
+                      </p:tgtEl>
+                    </p:cBhvr>
+                  </p:animEffect>
+                </p:childTnLst>
+              </p:cTn>
+            </p:par>
+            <p:par>
+              <p:cTn id="18" fill="hold" nodeType="afterEffect">
+                <p:stCondLst>
+                  <p:cond delay="1830"/>
+                </p:stCondLst>
+                <p:childTnLst>
+                  <p:animEffect transition="in" filter="fade">
+                    <p:cBhvr>
+                      <p:cTn id="19" dur="300" fill="hold"/>
+                      <p:tgtEl>
+                        <p:spTgt spid="14">
+                          <p:txEl>
+                            <p:pRg st="1" end="1"/>
+                          </p:txEl>
+                        </p:spTgt>
+                      </p:tgtEl>
+                    </p:cBhvr>
+                  </p:animEffect>
+                </p:childTnLst>
+              </p:cTn>
+            </p:par>
+            <p:par>
+              <p:cTn id="20" fill="hold" nodeType="afterEffect">
+                <p:stCondLst>
+                  <p:cond delay="2000"/>
+                </p:stCondLst>
+                <p:childTnLst>
+                  <p:animEffect transition="in" filter="fade">
+                    <p:cBhvr>
+                      <p:cTn id="21" dur="300" fill="hold"/>
+                      <p:tgtEl>
+                        <p:spTgt spid="14">
+                          <p:txEl>
+                            <p:pRg st="2" end="2"/>
+                          </p:txEl>
+                        </p:spTgt>
+                      </p:tgtEl>
+                    </p:cBhvr>
+                  </p:animEffect>
+                </p:childTnLst>
+              </p:cTn>
+            </p:par>
+            <p:par>
+              <p:cTn id="22" fill="hold" nodeType="afterEffect">
+                <p:stCondLst>
+                  <p:cond delay="2170"/>
+                </p:stCondLst>
+                <p:childTnLst>
+                  <p:animEffect transition="in" filter="fade">
+                    <p:cBhvr>
+                      <p:cTn id="23" dur="300" fill="hold"/>
+                      <p:tgtEl>
+                        <p:spTgt spid="14">
+                          <p:txEl>
+                            <p:pRg st="3" end="3"/>
+                          </p:txEl>
+                        </p:spTgt>
+                      </p:tgtEl>
+                    </p:cBhvr>
+                  </p:animEffect>
+                </p:childTnLst>
+              </p:cTn>
+            </p:par>
+          </p:childTnLst>
+        </p:cTn>
+        <p:prevCondLst>
+          <p:cond evt="onPrev" delay="0">
+            <p:tgtEl>
+              <p:sldTgt/>
+            </p:tgtEl>
+          </p:cond>
+        </p:prevCondLst>
+        <p:nextCondLst>
+          <p:cond evt="onNext" delay="0">
+            <p:tgtEl>
+              <p:sldTgt/>
+            </p:tgtEl>
+          </p:cond>
+        </p:nextCondLst>
+      </p:seq>
+    </p:tnLst>
+    <p:bldLst>
+      <p:bldP spid="12" grpId="0" build="p"/>
+      <p:bldP spid="14" grpId="0" build="p"/>
+    </p:bldLst>
+  </p:timing>
 </p:sld>
 </file>
 

</xml_diff>

<commit_message>
Vary PowerPoint object animations
Co-authored-by: M0ntecia <M0ntecia@users.noreply.github.com>
</commit_message>
<xml_diff>
--- a/praesentation/schule_wohlbefinden_praesentation.pptx
+++ b/praesentation/schule_wohlbefinden_praesentation.pptx
@@ -3716,14 +3716,14 @@
               </p:cTn>
             </p:par>
             <p:par>
-              <p:cTn id="4" fill="hold" nodeType="afterEffect">
+              <p:cTn id="5" fill="hold" nodeType="afterEffect">
                 <p:stCondLst>
                   <p:cond delay="560"/>
                 </p:stCondLst>
                 <p:childTnLst>
-                  <p:animEffect transition="in" filter="fade">
+                  <p:animEffect transition="in" filter="wipe(fromLeft)">
                     <p:cBhvr>
-                      <p:cTn id="5" dur="450" fill="hold"/>
+                      <p:cTn id="6" dur="450" fill="hold"/>
                       <p:tgtEl>
                         <p:spTgt spid="11"/>
                       </p:tgtEl>
@@ -3733,14 +3733,14 @@
               </p:cTn>
             </p:par>
             <p:par>
-              <p:cTn id="6" fill="hold" nodeType="afterEffect">
+              <p:cTn id="8" fill="hold" nodeType="afterEffect">
                 <p:stCondLst>
                   <p:cond delay="840"/>
                 </p:stCondLst>
                 <p:childTnLst>
                   <p:animEffect transition="in" filter="fade">
                     <p:cBhvr>
-                      <p:cTn id="7" dur="450" fill="hold"/>
+                      <p:cTn id="9" dur="450" fill="hold"/>
                       <p:tgtEl>
                         <p:spTgt spid="12"/>
                       </p:tgtEl>
@@ -3750,14 +3750,14 @@
               </p:cTn>
             </p:par>
             <p:par>
-              <p:cTn id="8" fill="hold" nodeType="afterEffect">
+              <p:cTn id="11" fill="hold" nodeType="afterEffect">
                 <p:stCondLst>
                   <p:cond delay="1120"/>
                 </p:stCondLst>
                 <p:childTnLst>
                   <p:animEffect transition="in" filter="fade">
                     <p:cBhvr>
-                      <p:cTn id="9" dur="450" fill="hold"/>
+                      <p:cTn id="12" dur="450" fill="hold"/>
                       <p:tgtEl>
                         <p:spTgt spid="13"/>
                       </p:tgtEl>
@@ -4706,104 +4706,188 @@
               </p:cTn>
             </p:par>
             <p:par>
-              <p:cTn id="4" fill="hold" nodeType="afterEffect">
+              <p:cTn id="5" fill="hold" nodeType="afterEffect">
                 <p:stCondLst>
                   <p:cond delay="560"/>
                 </p:stCondLst>
                 <p:childTnLst>
                   <p:animEffect transition="in" filter="fade">
                     <p:cBhvr>
-                      <p:cTn id="5" dur="430" fill="hold"/>
+                      <p:cTn id="6" dur="430" fill="hold"/>
                       <p:tgtEl>
                         <p:spTgt spid="11"/>
                       </p:tgtEl>
                     </p:cBhvr>
                   </p:animEffect>
+                  <p:animScale>
+                    <p:cBhvr>
+                      <p:cTn id="7" dur="430" fill="hold"/>
+                      <p:tgtEl>
+                        <p:spTgt spid="11"/>
+                      </p:tgtEl>
+                      <p:attrNameLst>
+                        <p:attrName>ScaleX</p:attrName>
+                        <p:attrName>ScaleY</p:attrName>
+                      </p:attrNameLst>
+                    </p:cBhvr>
+                    <p:from x="96000" y="96000"/>
+                    <p:to x="100000" y="100000"/>
+                  </p:animScale>
                 </p:childTnLst>
               </p:cTn>
             </p:par>
             <p:par>
-              <p:cTn id="6" fill="hold" nodeType="withEffect">
+              <p:cTn id="8" fill="hold" nodeType="withEffect">
                 <p:stCondLst>
                   <p:cond delay="560"/>
                 </p:stCondLst>
                 <p:childTnLst>
                   <p:animEffect transition="in" filter="fade">
                     <p:cBhvr>
-                      <p:cTn id="7" dur="430" fill="hold"/>
+                      <p:cTn id="9" dur="430" fill="hold"/>
                       <p:tgtEl>
                         <p:spTgt spid="12"/>
                       </p:tgtEl>
                     </p:cBhvr>
                   </p:animEffect>
+                  <p:animScale>
+                    <p:cBhvr>
+                      <p:cTn id="10" dur="430" fill="hold"/>
+                      <p:tgtEl>
+                        <p:spTgt spid="12"/>
+                      </p:tgtEl>
+                      <p:attrNameLst>
+                        <p:attrName>ScaleX</p:attrName>
+                        <p:attrName>ScaleY</p:attrName>
+                      </p:attrNameLst>
+                    </p:cBhvr>
+                    <p:from x="96000" y="96000"/>
+                    <p:to x="100000" y="100000"/>
+                  </p:animScale>
                 </p:childTnLst>
               </p:cTn>
             </p:par>
             <p:par>
-              <p:cTn id="8" fill="hold" nodeType="afterEffect">
+              <p:cTn id="11" fill="hold" nodeType="afterEffect">
                 <p:stCondLst>
                   <p:cond delay="830"/>
                 </p:stCondLst>
                 <p:childTnLst>
                   <p:animEffect transition="in" filter="fade">
                     <p:cBhvr>
-                      <p:cTn id="9" dur="430" fill="hold"/>
+                      <p:cTn id="12" dur="430" fill="hold"/>
                       <p:tgtEl>
                         <p:spTgt spid="15"/>
                       </p:tgtEl>
                     </p:cBhvr>
                   </p:animEffect>
+                  <p:animScale>
+                    <p:cBhvr>
+                      <p:cTn id="13" dur="430" fill="hold"/>
+                      <p:tgtEl>
+                        <p:spTgt spid="15"/>
+                      </p:tgtEl>
+                      <p:attrNameLst>
+                        <p:attrName>ScaleX</p:attrName>
+                        <p:attrName>ScaleY</p:attrName>
+                      </p:attrNameLst>
+                    </p:cBhvr>
+                    <p:from x="96000" y="96000"/>
+                    <p:to x="100000" y="100000"/>
+                  </p:animScale>
                 </p:childTnLst>
               </p:cTn>
             </p:par>
             <p:par>
-              <p:cTn id="10" fill="hold" nodeType="withEffect">
+              <p:cTn id="14" fill="hold" nodeType="withEffect">
                 <p:stCondLst>
                   <p:cond delay="830"/>
                 </p:stCondLst>
                 <p:childTnLst>
                   <p:animEffect transition="in" filter="fade">
                     <p:cBhvr>
-                      <p:cTn id="11" dur="430" fill="hold"/>
+                      <p:cTn id="15" dur="430" fill="hold"/>
                       <p:tgtEl>
                         <p:spTgt spid="16"/>
                       </p:tgtEl>
                     </p:cBhvr>
                   </p:animEffect>
+                  <p:animScale>
+                    <p:cBhvr>
+                      <p:cTn id="16" dur="430" fill="hold"/>
+                      <p:tgtEl>
+                        <p:spTgt spid="16"/>
+                      </p:tgtEl>
+                      <p:attrNameLst>
+                        <p:attrName>ScaleX</p:attrName>
+                        <p:attrName>ScaleY</p:attrName>
+                      </p:attrNameLst>
+                    </p:cBhvr>
+                    <p:from x="96000" y="96000"/>
+                    <p:to x="100000" y="100000"/>
+                  </p:animScale>
                 </p:childTnLst>
               </p:cTn>
             </p:par>
             <p:par>
-              <p:cTn id="12" fill="hold" nodeType="afterEffect">
+              <p:cTn id="17" fill="hold" nodeType="afterEffect">
                 <p:stCondLst>
                   <p:cond delay="1100"/>
                 </p:stCondLst>
                 <p:childTnLst>
                   <p:animEffect transition="in" filter="fade">
                     <p:cBhvr>
-                      <p:cTn id="13" dur="430" fill="hold"/>
+                      <p:cTn id="18" dur="430" fill="hold"/>
                       <p:tgtEl>
                         <p:spTgt spid="19"/>
                       </p:tgtEl>
                     </p:cBhvr>
                   </p:animEffect>
+                  <p:animScale>
+                    <p:cBhvr>
+                      <p:cTn id="19" dur="430" fill="hold"/>
+                      <p:tgtEl>
+                        <p:spTgt spid="19"/>
+                      </p:tgtEl>
+                      <p:attrNameLst>
+                        <p:attrName>ScaleX</p:attrName>
+                        <p:attrName>ScaleY</p:attrName>
+                      </p:attrNameLst>
+                    </p:cBhvr>
+                    <p:from x="96000" y="96000"/>
+                    <p:to x="100000" y="100000"/>
+                  </p:animScale>
                 </p:childTnLst>
               </p:cTn>
             </p:par>
             <p:par>
-              <p:cTn id="14" fill="hold" nodeType="withEffect">
+              <p:cTn id="20" fill="hold" nodeType="withEffect">
                 <p:stCondLst>
                   <p:cond delay="1100"/>
                 </p:stCondLst>
                 <p:childTnLst>
                   <p:animEffect transition="in" filter="fade">
                     <p:cBhvr>
-                      <p:cTn id="15" dur="430" fill="hold"/>
+                      <p:cTn id="21" dur="430" fill="hold"/>
                       <p:tgtEl>
                         <p:spTgt spid="20"/>
                       </p:tgtEl>
                     </p:cBhvr>
                   </p:animEffect>
+                  <p:animScale>
+                    <p:cBhvr>
+                      <p:cTn id="22" dur="430" fill="hold"/>
+                      <p:tgtEl>
+                        <p:spTgt spid="20"/>
+                      </p:tgtEl>
+                      <p:attrNameLst>
+                        <p:attrName>ScaleX</p:attrName>
+                        <p:attrName>ScaleY</p:attrName>
+                      </p:attrNameLst>
+                    </p:cBhvr>
+                    <p:from x="96000" y="96000"/>
+                    <p:to x="100000" y="100000"/>
+                  </p:animScale>
                 </p:childTnLst>
               </p:cTn>
             </p:par>
@@ -5853,116 +5937,200 @@
               </p:cTn>
             </p:par>
             <p:par>
-              <p:cTn id="4" fill="hold" nodeType="afterEffect">
+              <p:cTn id="5" fill="hold" nodeType="afterEffect">
                 <p:stCondLst>
                   <p:cond delay="560"/>
                 </p:stCondLst>
                 <p:childTnLst>
                   <p:animEffect transition="in" filter="fade">
                     <p:cBhvr>
-                      <p:cTn id="5" dur="430" fill="hold"/>
+                      <p:cTn id="6" dur="430" fill="hold"/>
                       <p:tgtEl>
                         <p:spTgt spid="11"/>
                       </p:tgtEl>
                     </p:cBhvr>
                   </p:animEffect>
+                  <p:animScale>
+                    <p:cBhvr>
+                      <p:cTn id="7" dur="430" fill="hold"/>
+                      <p:tgtEl>
+                        <p:spTgt spid="11"/>
+                      </p:tgtEl>
+                      <p:attrNameLst>
+                        <p:attrName>ScaleX</p:attrName>
+                        <p:attrName>ScaleY</p:attrName>
+                      </p:attrNameLst>
+                    </p:cBhvr>
+                    <p:from x="96000" y="96000"/>
+                    <p:to x="100000" y="100000"/>
+                  </p:animScale>
                 </p:childTnLst>
               </p:cTn>
             </p:par>
             <p:par>
-              <p:cTn id="6" fill="hold" nodeType="withEffect">
+              <p:cTn id="8" fill="hold" nodeType="withEffect">
                 <p:stCondLst>
                   <p:cond delay="560"/>
                 </p:stCondLst>
                 <p:childTnLst>
                   <p:animEffect transition="in" filter="fade">
                     <p:cBhvr>
-                      <p:cTn id="7" dur="430" fill="hold"/>
+                      <p:cTn id="9" dur="430" fill="hold"/>
                       <p:tgtEl>
                         <p:spTgt spid="12"/>
                       </p:tgtEl>
                     </p:cBhvr>
                   </p:animEffect>
+                  <p:animScale>
+                    <p:cBhvr>
+                      <p:cTn id="10" dur="430" fill="hold"/>
+                      <p:tgtEl>
+                        <p:spTgt spid="12"/>
+                      </p:tgtEl>
+                      <p:attrNameLst>
+                        <p:attrName>ScaleX</p:attrName>
+                        <p:attrName>ScaleY</p:attrName>
+                      </p:attrNameLst>
+                    </p:cBhvr>
+                    <p:from x="96000" y="96000"/>
+                    <p:to x="100000" y="100000"/>
+                  </p:animScale>
                 </p:childTnLst>
               </p:cTn>
             </p:par>
             <p:par>
-              <p:cTn id="8" fill="hold" nodeType="afterEffect">
+              <p:cTn id="11" fill="hold" nodeType="afterEffect">
                 <p:stCondLst>
                   <p:cond delay="830"/>
                 </p:stCondLst>
                 <p:childTnLst>
                   <p:animEffect transition="in" filter="fade">
                     <p:cBhvr>
-                      <p:cTn id="9" dur="430" fill="hold"/>
+                      <p:cTn id="12" dur="430" fill="hold"/>
                       <p:tgtEl>
                         <p:spTgt spid="15"/>
                       </p:tgtEl>
                     </p:cBhvr>
                   </p:animEffect>
+                  <p:animScale>
+                    <p:cBhvr>
+                      <p:cTn id="13" dur="430" fill="hold"/>
+                      <p:tgtEl>
+                        <p:spTgt spid="15"/>
+                      </p:tgtEl>
+                      <p:attrNameLst>
+                        <p:attrName>ScaleX</p:attrName>
+                        <p:attrName>ScaleY</p:attrName>
+                      </p:attrNameLst>
+                    </p:cBhvr>
+                    <p:from x="96000" y="96000"/>
+                    <p:to x="100000" y="100000"/>
+                  </p:animScale>
                 </p:childTnLst>
               </p:cTn>
             </p:par>
             <p:par>
-              <p:cTn id="10" fill="hold" nodeType="withEffect">
+              <p:cTn id="14" fill="hold" nodeType="withEffect">
                 <p:stCondLst>
                   <p:cond delay="830"/>
                 </p:stCondLst>
                 <p:childTnLst>
                   <p:animEffect transition="in" filter="fade">
                     <p:cBhvr>
-                      <p:cTn id="11" dur="430" fill="hold"/>
+                      <p:cTn id="15" dur="430" fill="hold"/>
                       <p:tgtEl>
                         <p:spTgt spid="16"/>
                       </p:tgtEl>
                     </p:cBhvr>
                   </p:animEffect>
+                  <p:animScale>
+                    <p:cBhvr>
+                      <p:cTn id="16" dur="430" fill="hold"/>
+                      <p:tgtEl>
+                        <p:spTgt spid="16"/>
+                      </p:tgtEl>
+                      <p:attrNameLst>
+                        <p:attrName>ScaleX</p:attrName>
+                        <p:attrName>ScaleY</p:attrName>
+                      </p:attrNameLst>
+                    </p:cBhvr>
+                    <p:from x="96000" y="96000"/>
+                    <p:to x="100000" y="100000"/>
+                  </p:animScale>
                 </p:childTnLst>
               </p:cTn>
             </p:par>
             <p:par>
-              <p:cTn id="12" fill="hold" nodeType="afterEffect">
+              <p:cTn id="17" fill="hold" nodeType="afterEffect">
                 <p:stCondLst>
                   <p:cond delay="1100"/>
                 </p:stCondLst>
                 <p:childTnLst>
                   <p:animEffect transition="in" filter="fade">
                     <p:cBhvr>
-                      <p:cTn id="13" dur="430" fill="hold"/>
+                      <p:cTn id="18" dur="430" fill="hold"/>
                       <p:tgtEl>
                         <p:spTgt spid="19"/>
                       </p:tgtEl>
                     </p:cBhvr>
                   </p:animEffect>
+                  <p:animScale>
+                    <p:cBhvr>
+                      <p:cTn id="19" dur="430" fill="hold"/>
+                      <p:tgtEl>
+                        <p:spTgt spid="19"/>
+                      </p:tgtEl>
+                      <p:attrNameLst>
+                        <p:attrName>ScaleX</p:attrName>
+                        <p:attrName>ScaleY</p:attrName>
+                      </p:attrNameLst>
+                    </p:cBhvr>
+                    <p:from x="96000" y="96000"/>
+                    <p:to x="100000" y="100000"/>
+                  </p:animScale>
                 </p:childTnLst>
               </p:cTn>
             </p:par>
             <p:par>
-              <p:cTn id="14" fill="hold" nodeType="withEffect">
+              <p:cTn id="20" fill="hold" nodeType="withEffect">
                 <p:stCondLst>
                   <p:cond delay="1100"/>
                 </p:stCondLst>
                 <p:childTnLst>
                   <p:animEffect transition="in" filter="fade">
                     <p:cBhvr>
-                      <p:cTn id="15" dur="430" fill="hold"/>
+                      <p:cTn id="21" dur="430" fill="hold"/>
                       <p:tgtEl>
                         <p:spTgt spid="20"/>
                       </p:tgtEl>
                     </p:cBhvr>
                   </p:animEffect>
+                  <p:animScale>
+                    <p:cBhvr>
+                      <p:cTn id="22" dur="430" fill="hold"/>
+                      <p:tgtEl>
+                        <p:spTgt spid="20"/>
+                      </p:tgtEl>
+                      <p:attrNameLst>
+                        <p:attrName>ScaleX</p:attrName>
+                        <p:attrName>ScaleY</p:attrName>
+                      </p:attrNameLst>
+                    </p:cBhvr>
+                    <p:from x="96000" y="96000"/>
+                    <p:to x="100000" y="100000"/>
+                  </p:animScale>
                 </p:childTnLst>
               </p:cTn>
             </p:par>
             <p:par>
-              <p:cTn id="16" fill="hold" nodeType="afterEffect">
+              <p:cTn id="23" fill="hold" nodeType="afterEffect">
                 <p:stCondLst>
                   <p:cond delay="1380"/>
                 </p:stCondLst>
                 <p:childTnLst>
                   <p:animEffect transition="in" filter="fade">
                     <p:cBhvr>
-                      <p:cTn id="17" dur="340" fill="hold"/>
+                      <p:cTn id="24" dur="340" fill="hold"/>
                       <p:tgtEl>
                         <p:spTgt spid="21"/>
                       </p:tgtEl>
@@ -5972,14 +6140,14 @@
               </p:cTn>
             </p:par>
             <p:par>
-              <p:cTn id="18" fill="hold" nodeType="afterEffect">
+              <p:cTn id="26" fill="hold" nodeType="afterEffect">
                 <p:stCondLst>
                   <p:cond delay="1610"/>
                 </p:stCondLst>
                 <p:childTnLst>
-                  <p:animEffect transition="in" filter="fade">
+                  <p:animEffect transition="in" filter="wipe(fromLeft)">
                     <p:cBhvr>
-                      <p:cTn id="19" dur="300" fill="hold"/>
+                      <p:cTn id="27" dur="300" fill="hold"/>
                       <p:tgtEl>
                         <p:spTgt spid="22">
                           <p:txEl>
@@ -5993,14 +6161,14 @@
               </p:cTn>
             </p:par>
             <p:par>
-              <p:cTn id="20" fill="hold" nodeType="afterEffect">
+              <p:cTn id="29" fill="hold" nodeType="afterEffect">
                 <p:stCondLst>
                   <p:cond delay="1820"/>
                 </p:stCondLst>
                 <p:childTnLst>
-                  <p:animEffect transition="in" filter="fade">
+                  <p:animEffect transition="in" filter="wipe(fromLeft)">
                     <p:cBhvr>
-                      <p:cTn id="21" dur="300" fill="hold"/>
+                      <p:cTn id="30" dur="300" fill="hold"/>
                       <p:tgtEl>
                         <p:spTgt spid="22">
                           <p:txEl>
@@ -6014,14 +6182,14 @@
               </p:cTn>
             </p:par>
             <p:par>
-              <p:cTn id="22" fill="hold" nodeType="afterEffect">
+              <p:cTn id="32" fill="hold" nodeType="afterEffect">
                 <p:stCondLst>
                   <p:cond delay="2030"/>
                 </p:stCondLst>
                 <p:childTnLst>
-                  <p:animEffect transition="in" filter="fade">
+                  <p:animEffect transition="in" filter="wipe(fromLeft)">
                     <p:cBhvr>
-                      <p:cTn id="23" dur="300" fill="hold"/>
+                      <p:cTn id="33" dur="300" fill="hold"/>
                       <p:tgtEl>
                         <p:spTgt spid="22">
                           <p:txEl>
@@ -6819,14 +6987,14 @@
               </p:cTn>
             </p:par>
             <p:par>
-              <p:cTn id="4" fill="hold" nodeType="afterEffect">
+              <p:cTn id="5" fill="hold" nodeType="afterEffect">
                 <p:stCondLst>
                   <p:cond delay="560"/>
                 </p:stCondLst>
                 <p:childTnLst>
                   <p:animEffect transition="in" filter="fade">
                     <p:cBhvr>
-                      <p:cTn id="5" dur="340" fill="hold"/>
+                      <p:cTn id="6" dur="340" fill="hold"/>
                       <p:tgtEl>
                         <p:spTgt spid="11"/>
                       </p:tgtEl>
@@ -6836,14 +7004,14 @@
               </p:cTn>
             </p:par>
             <p:par>
-              <p:cTn id="6" fill="hold" nodeType="afterEffect">
+              <p:cTn id="8" fill="hold" nodeType="afterEffect">
                 <p:stCondLst>
                   <p:cond delay="750"/>
                 </p:stCondLst>
                 <p:childTnLst>
-                  <p:animEffect transition="in" filter="fade">
+                  <p:animEffect transition="in" filter="wipe(fromLeft)">
                     <p:cBhvr>
-                      <p:cTn id="7" dur="290" fill="hold"/>
+                      <p:cTn id="9" dur="290" fill="hold"/>
                       <p:tgtEl>
                         <p:spTgt spid="12">
                           <p:txEl>
@@ -6857,14 +7025,14 @@
               </p:cTn>
             </p:par>
             <p:par>
-              <p:cTn id="8" fill="hold" nodeType="afterEffect">
+              <p:cTn id="11" fill="hold" nodeType="afterEffect">
                 <p:stCondLst>
                   <p:cond delay="905"/>
                 </p:stCondLst>
                 <p:childTnLst>
-                  <p:animEffect transition="in" filter="fade">
+                  <p:animEffect transition="in" filter="wipe(fromLeft)">
                     <p:cBhvr>
-                      <p:cTn id="9" dur="290" fill="hold"/>
+                      <p:cTn id="12" dur="290" fill="hold"/>
                       <p:tgtEl>
                         <p:spTgt spid="12">
                           <p:txEl>
@@ -6878,14 +7046,14 @@
               </p:cTn>
             </p:par>
             <p:par>
-              <p:cTn id="10" fill="hold" nodeType="afterEffect">
+              <p:cTn id="14" fill="hold" nodeType="afterEffect">
                 <p:stCondLst>
                   <p:cond delay="1060"/>
                 </p:stCondLst>
                 <p:childTnLst>
-                  <p:animEffect transition="in" filter="fade">
+                  <p:animEffect transition="in" filter="wipe(fromLeft)">
                     <p:cBhvr>
-                      <p:cTn id="11" dur="290" fill="hold"/>
+                      <p:cTn id="15" dur="290" fill="hold"/>
                       <p:tgtEl>
                         <p:spTgt spid="12">
                           <p:txEl>
@@ -6899,14 +7067,14 @@
               </p:cTn>
             </p:par>
             <p:par>
-              <p:cTn id="12" fill="hold" nodeType="afterEffect">
+              <p:cTn id="17" fill="hold" nodeType="afterEffect">
                 <p:stCondLst>
                   <p:cond delay="1215"/>
                 </p:stCondLst>
                 <p:childTnLst>
-                  <p:animEffect transition="in" filter="fade">
+                  <p:animEffect transition="in" filter="wipe(fromLeft)">
                     <p:cBhvr>
-                      <p:cTn id="13" dur="290" fill="hold"/>
+                      <p:cTn id="18" dur="290" fill="hold"/>
                       <p:tgtEl>
                         <p:spTgt spid="12">
                           <p:txEl>
@@ -6920,14 +7088,14 @@
               </p:cTn>
             </p:par>
             <p:par>
-              <p:cTn id="14" fill="hold" nodeType="afterEffect">
+              <p:cTn id="20" fill="hold" nodeType="afterEffect">
                 <p:stCondLst>
                   <p:cond delay="1370"/>
                 </p:stCondLst>
                 <p:childTnLst>
                   <p:animEffect transition="in" filter="fade">
                     <p:cBhvr>
-                      <p:cTn id="15" dur="340" fill="hold"/>
+                      <p:cTn id="21" dur="340" fill="hold"/>
                       <p:tgtEl>
                         <p:spTgt spid="13"/>
                       </p:tgtEl>
@@ -6937,14 +7105,14 @@
               </p:cTn>
             </p:par>
             <p:par>
-              <p:cTn id="16" fill="hold" nodeType="afterEffect">
+              <p:cTn id="23" fill="hold" nodeType="afterEffect">
                 <p:stCondLst>
                   <p:cond delay="1560"/>
                 </p:stCondLst>
                 <p:childTnLst>
-                  <p:animEffect transition="in" filter="fade">
+                  <p:animEffect transition="in" filter="wipe(fromLeft)">
                     <p:cBhvr>
-                      <p:cTn id="17" dur="290" fill="hold"/>
+                      <p:cTn id="24" dur="290" fill="hold"/>
                       <p:tgtEl>
                         <p:spTgt spid="14">
                           <p:txEl>
@@ -6958,14 +7126,14 @@
               </p:cTn>
             </p:par>
             <p:par>
-              <p:cTn id="18" fill="hold" nodeType="afterEffect">
+              <p:cTn id="26" fill="hold" nodeType="afterEffect">
                 <p:stCondLst>
                   <p:cond delay="1715"/>
                 </p:stCondLst>
                 <p:childTnLst>
-                  <p:animEffect transition="in" filter="fade">
+                  <p:animEffect transition="in" filter="wipe(fromLeft)">
                     <p:cBhvr>
-                      <p:cTn id="19" dur="290" fill="hold"/>
+                      <p:cTn id="27" dur="290" fill="hold"/>
                       <p:tgtEl>
                         <p:spTgt spid="14">
                           <p:txEl>
@@ -6979,14 +7147,14 @@
               </p:cTn>
             </p:par>
             <p:par>
-              <p:cTn id="20" fill="hold" nodeType="afterEffect">
+              <p:cTn id="29" fill="hold" nodeType="afterEffect">
                 <p:stCondLst>
                   <p:cond delay="1870"/>
                 </p:stCondLst>
                 <p:childTnLst>
-                  <p:animEffect transition="in" filter="fade">
+                  <p:animEffect transition="in" filter="wipe(fromLeft)">
                     <p:cBhvr>
-                      <p:cTn id="21" dur="290" fill="hold"/>
+                      <p:cTn id="30" dur="290" fill="hold"/>
                       <p:tgtEl>
                         <p:spTgt spid="14">
                           <p:txEl>
@@ -7000,14 +7168,14 @@
               </p:cTn>
             </p:par>
             <p:par>
-              <p:cTn id="22" fill="hold" nodeType="afterEffect">
+              <p:cTn id="32" fill="hold" nodeType="afterEffect">
                 <p:stCondLst>
                   <p:cond delay="2025"/>
                 </p:stCondLst>
                 <p:childTnLst>
-                  <p:animEffect transition="in" filter="fade">
+                  <p:animEffect transition="in" filter="wipe(fromLeft)">
                     <p:cBhvr>
-                      <p:cTn id="23" dur="290" fill="hold"/>
+                      <p:cTn id="33" dur="290" fill="hold"/>
                       <p:tgtEl>
                         <p:spTgt spid="14">
                           <p:txEl>
@@ -8239,116 +8407,200 @@
               </p:cTn>
             </p:par>
             <p:par>
-              <p:cTn id="4" fill="hold" nodeType="afterEffect">
+              <p:cTn id="5" fill="hold" nodeType="afterEffect">
                 <p:stCondLst>
                   <p:cond delay="560"/>
                 </p:stCondLst>
                 <p:childTnLst>
                   <p:animEffect transition="in" filter="fade">
                     <p:cBhvr>
-                      <p:cTn id="5" dur="420" fill="hold"/>
+                      <p:cTn id="6" dur="420" fill="hold"/>
                       <p:tgtEl>
                         <p:spTgt spid="11"/>
                       </p:tgtEl>
                     </p:cBhvr>
                   </p:animEffect>
+                  <p:animScale>
+                    <p:cBhvr>
+                      <p:cTn id="7" dur="420" fill="hold"/>
+                      <p:tgtEl>
+                        <p:spTgt spid="11"/>
+                      </p:tgtEl>
+                      <p:attrNameLst>
+                        <p:attrName>ScaleX</p:attrName>
+                        <p:attrName>ScaleY</p:attrName>
+                      </p:attrNameLst>
+                    </p:cBhvr>
+                    <p:from x="96000" y="96000"/>
+                    <p:to x="100000" y="100000"/>
+                  </p:animScale>
                 </p:childTnLst>
               </p:cTn>
             </p:par>
             <p:par>
-              <p:cTn id="6" fill="hold" nodeType="withEffect">
+              <p:cTn id="8" fill="hold" nodeType="withEffect">
                 <p:stCondLst>
                   <p:cond delay="560"/>
                 </p:stCondLst>
                 <p:childTnLst>
                   <p:animEffect transition="in" filter="fade">
                     <p:cBhvr>
-                      <p:cTn id="7" dur="420" fill="hold"/>
+                      <p:cTn id="9" dur="420" fill="hold"/>
                       <p:tgtEl>
                         <p:spTgt spid="12"/>
                       </p:tgtEl>
                     </p:cBhvr>
                   </p:animEffect>
+                  <p:animScale>
+                    <p:cBhvr>
+                      <p:cTn id="10" dur="420" fill="hold"/>
+                      <p:tgtEl>
+                        <p:spTgt spid="12"/>
+                      </p:tgtEl>
+                      <p:attrNameLst>
+                        <p:attrName>ScaleX</p:attrName>
+                        <p:attrName>ScaleY</p:attrName>
+                      </p:attrNameLst>
+                    </p:cBhvr>
+                    <p:from x="96000" y="96000"/>
+                    <p:to x="100000" y="100000"/>
+                  </p:animScale>
                 </p:childTnLst>
               </p:cTn>
             </p:par>
             <p:par>
-              <p:cTn id="8" fill="hold" nodeType="afterEffect">
+              <p:cTn id="11" fill="hold" nodeType="afterEffect">
                 <p:stCondLst>
                   <p:cond delay="860"/>
                 </p:stCondLst>
                 <p:childTnLst>
                   <p:animEffect transition="in" filter="fade">
                     <p:cBhvr>
-                      <p:cTn id="9" dur="420" fill="hold"/>
+                      <p:cTn id="12" dur="420" fill="hold"/>
                       <p:tgtEl>
                         <p:spTgt spid="17"/>
                       </p:tgtEl>
                     </p:cBhvr>
                   </p:animEffect>
+                  <p:animScale>
+                    <p:cBhvr>
+                      <p:cTn id="13" dur="420" fill="hold"/>
+                      <p:tgtEl>
+                        <p:spTgt spid="17"/>
+                      </p:tgtEl>
+                      <p:attrNameLst>
+                        <p:attrName>ScaleX</p:attrName>
+                        <p:attrName>ScaleY</p:attrName>
+                      </p:attrNameLst>
+                    </p:cBhvr>
+                    <p:from x="96000" y="96000"/>
+                    <p:to x="100000" y="100000"/>
+                  </p:animScale>
                 </p:childTnLst>
               </p:cTn>
             </p:par>
             <p:par>
-              <p:cTn id="10" fill="hold" nodeType="withEffect">
+              <p:cTn id="14" fill="hold" nodeType="withEffect">
                 <p:stCondLst>
                   <p:cond delay="860"/>
                 </p:stCondLst>
                 <p:childTnLst>
                   <p:animEffect transition="in" filter="fade">
                     <p:cBhvr>
-                      <p:cTn id="11" dur="420" fill="hold"/>
+                      <p:cTn id="15" dur="420" fill="hold"/>
                       <p:tgtEl>
                         <p:spTgt spid="18"/>
                       </p:tgtEl>
                     </p:cBhvr>
                   </p:animEffect>
+                  <p:animScale>
+                    <p:cBhvr>
+                      <p:cTn id="16" dur="420" fill="hold"/>
+                      <p:tgtEl>
+                        <p:spTgt spid="18"/>
+                      </p:tgtEl>
+                      <p:attrNameLst>
+                        <p:attrName>ScaleX</p:attrName>
+                        <p:attrName>ScaleY</p:attrName>
+                      </p:attrNameLst>
+                    </p:cBhvr>
+                    <p:from x="96000" y="96000"/>
+                    <p:to x="100000" y="100000"/>
+                  </p:animScale>
                 </p:childTnLst>
               </p:cTn>
             </p:par>
             <p:par>
-              <p:cTn id="12" fill="hold" nodeType="afterEffect">
+              <p:cTn id="17" fill="hold" nodeType="afterEffect">
                 <p:stCondLst>
                   <p:cond delay="1160"/>
                 </p:stCondLst>
                 <p:childTnLst>
                   <p:animEffect transition="in" filter="fade">
                     <p:cBhvr>
-                      <p:cTn id="13" dur="420" fill="hold"/>
+                      <p:cTn id="18" dur="420" fill="hold"/>
                       <p:tgtEl>
                         <p:spTgt spid="23"/>
                       </p:tgtEl>
                     </p:cBhvr>
                   </p:animEffect>
+                  <p:animScale>
+                    <p:cBhvr>
+                      <p:cTn id="19" dur="420" fill="hold"/>
+                      <p:tgtEl>
+                        <p:spTgt spid="23"/>
+                      </p:tgtEl>
+                      <p:attrNameLst>
+                        <p:attrName>ScaleX</p:attrName>
+                        <p:attrName>ScaleY</p:attrName>
+                      </p:attrNameLst>
+                    </p:cBhvr>
+                    <p:from x="96000" y="96000"/>
+                    <p:to x="100000" y="100000"/>
+                  </p:animScale>
                 </p:childTnLst>
               </p:cTn>
             </p:par>
             <p:par>
-              <p:cTn id="14" fill="hold" nodeType="withEffect">
+              <p:cTn id="20" fill="hold" nodeType="withEffect">
                 <p:stCondLst>
                   <p:cond delay="1160"/>
                 </p:stCondLst>
                 <p:childTnLst>
                   <p:animEffect transition="in" filter="fade">
                     <p:cBhvr>
-                      <p:cTn id="15" dur="420" fill="hold"/>
+                      <p:cTn id="21" dur="420" fill="hold"/>
                       <p:tgtEl>
                         <p:spTgt spid="24"/>
                       </p:tgtEl>
                     </p:cBhvr>
                   </p:animEffect>
+                  <p:animScale>
+                    <p:cBhvr>
+                      <p:cTn id="22" dur="420" fill="hold"/>
+                      <p:tgtEl>
+                        <p:spTgt spid="24"/>
+                      </p:tgtEl>
+                      <p:attrNameLst>
+                        <p:attrName>ScaleX</p:attrName>
+                        <p:attrName>ScaleY</p:attrName>
+                      </p:attrNameLst>
+                    </p:cBhvr>
+                    <p:from x="96000" y="96000"/>
+                    <p:to x="100000" y="100000"/>
+                  </p:animScale>
                 </p:childTnLst>
               </p:cTn>
             </p:par>
             <p:par>
-              <p:cTn id="16" fill="hold" nodeType="afterEffect">
+              <p:cTn id="23" fill="hold" nodeType="afterEffect">
                 <p:stCondLst>
                   <p:cond delay="1560"/>
                 </p:stCondLst>
                 <p:childTnLst>
                   <p:animEffect transition="in" filter="fade">
                     <p:cBhvr>
-                      <p:cTn id="17" dur="380" fill="hold"/>
+                      <p:cTn id="24" dur="380" fill="hold"/>
                       <p:tgtEl>
                         <p:spTgt spid="27"/>
                       </p:tgtEl>
@@ -9240,14 +9492,14 @@
               </p:cTn>
             </p:par>
             <p:par>
-              <p:cTn id="4" fill="hold" nodeType="afterEffect">
+              <p:cTn id="5" fill="hold" nodeType="afterEffect">
                 <p:stCondLst>
                   <p:cond delay="560"/>
                 </p:stCondLst>
                 <p:childTnLst>
                   <p:animEffect transition="in" filter="fade">
                     <p:cBhvr>
-                      <p:cTn id="5" dur="500" fill="hold"/>
+                      <p:cTn id="6" dur="500" fill="hold"/>
                       <p:tgtEl>
                         <p:spTgt spid="9"/>
                       </p:tgtEl>
@@ -9257,14 +9509,14 @@
               </p:cTn>
             </p:par>
             <p:par>
-              <p:cTn id="6" fill="hold" nodeType="withEffect">
+              <p:cTn id="8" fill="hold" nodeType="withEffect">
                 <p:stCondLst>
                   <p:cond delay="560"/>
                 </p:stCondLst>
                 <p:childTnLst>
                   <p:animEffect transition="in" filter="fade">
                     <p:cBhvr>
-                      <p:cTn id="7" dur="500" fill="hold"/>
+                      <p:cTn id="9" dur="500" fill="hold"/>
                       <p:tgtEl>
                         <p:spTgt spid="11"/>
                       </p:tgtEl>
@@ -9274,14 +9526,14 @@
               </p:cTn>
             </p:par>
             <p:par>
-              <p:cTn id="8" fill="hold" nodeType="afterEffect">
+              <p:cTn id="11" fill="hold" nodeType="afterEffect">
                 <p:stCondLst>
                   <p:cond delay="990"/>
                 </p:stCondLst>
                 <p:childTnLst>
-                  <p:animEffect transition="in" filter="fade">
+                  <p:animEffect transition="in" filter="wipe(fromLeft)">
                     <p:cBhvr>
-                      <p:cTn id="9" dur="360" fill="hold"/>
+                      <p:cTn id="12" dur="360" fill="hold"/>
                       <p:tgtEl>
                         <p:spTgt spid="13"/>
                       </p:tgtEl>
@@ -9291,14 +9543,14 @@
               </p:cTn>
             </p:par>
             <p:par>
-              <p:cTn id="10" fill="hold" nodeType="afterEffect">
+              <p:cTn id="14" fill="hold" nodeType="afterEffect">
                 <p:stCondLst>
                   <p:cond delay="1250"/>
                 </p:stCondLst>
                 <p:childTnLst>
-                  <p:animEffect transition="in" filter="fade">
+                  <p:animEffect transition="in" filter="wipe(fromLeft)">
                     <p:cBhvr>
-                      <p:cTn id="11" dur="360" fill="hold"/>
+                      <p:cTn id="15" dur="360" fill="hold"/>
                       <p:tgtEl>
                         <p:spTgt spid="15"/>
                       </p:tgtEl>
@@ -9308,14 +9560,14 @@
               </p:cTn>
             </p:par>
             <p:par>
-              <p:cTn id="12" fill="hold" nodeType="afterEffect">
+              <p:cTn id="17" fill="hold" nodeType="afterEffect">
                 <p:stCondLst>
                   <p:cond delay="1510"/>
                 </p:stCondLst>
                 <p:childTnLst>
-                  <p:animEffect transition="in" filter="fade">
+                  <p:animEffect transition="in" filter="wipe(fromLeft)">
                     <p:cBhvr>
-                      <p:cTn id="13" dur="360" fill="hold"/>
+                      <p:cTn id="18" dur="360" fill="hold"/>
                       <p:tgtEl>
                         <p:spTgt spid="17"/>
                       </p:tgtEl>
@@ -9325,14 +9577,14 @@
               </p:cTn>
             </p:par>
             <p:par>
-              <p:cTn id="14" fill="hold" nodeType="afterEffect">
+              <p:cTn id="20" fill="hold" nodeType="afterEffect">
                 <p:stCondLst>
                   <p:cond delay="1770"/>
                 </p:stCondLst>
                 <p:childTnLst>
-                  <p:animEffect transition="in" filter="fade">
+                  <p:animEffect transition="in" filter="wipe(fromLeft)">
                     <p:cBhvr>
-                      <p:cTn id="15" dur="360" fill="hold"/>
+                      <p:cTn id="21" dur="360" fill="hold"/>
                       <p:tgtEl>
                         <p:spTgt spid="19"/>
                       </p:tgtEl>
@@ -10281,104 +10533,188 @@
               </p:cTn>
             </p:par>
             <p:par>
-              <p:cTn id="4" fill="hold" nodeType="afterEffect">
+              <p:cTn id="5" fill="hold" nodeType="afterEffect">
                 <p:stCondLst>
                   <p:cond delay="560"/>
                 </p:stCondLst>
                 <p:childTnLst>
                   <p:animEffect transition="in" filter="fade">
                     <p:cBhvr>
-                      <p:cTn id="5" dur="430" fill="hold"/>
+                      <p:cTn id="6" dur="430" fill="hold"/>
                       <p:tgtEl>
                         <p:spTgt spid="11"/>
                       </p:tgtEl>
                     </p:cBhvr>
                   </p:animEffect>
+                  <p:animScale>
+                    <p:cBhvr>
+                      <p:cTn id="7" dur="430" fill="hold"/>
+                      <p:tgtEl>
+                        <p:spTgt spid="11"/>
+                      </p:tgtEl>
+                      <p:attrNameLst>
+                        <p:attrName>ScaleX</p:attrName>
+                        <p:attrName>ScaleY</p:attrName>
+                      </p:attrNameLst>
+                    </p:cBhvr>
+                    <p:from x="96000" y="96000"/>
+                    <p:to x="100000" y="100000"/>
+                  </p:animScale>
                 </p:childTnLst>
               </p:cTn>
             </p:par>
             <p:par>
-              <p:cTn id="6" fill="hold" nodeType="withEffect">
+              <p:cTn id="8" fill="hold" nodeType="withEffect">
                 <p:stCondLst>
                   <p:cond delay="560"/>
                 </p:stCondLst>
                 <p:childTnLst>
                   <p:animEffect transition="in" filter="fade">
                     <p:cBhvr>
-                      <p:cTn id="7" dur="430" fill="hold"/>
+                      <p:cTn id="9" dur="430" fill="hold"/>
                       <p:tgtEl>
                         <p:spTgt spid="12"/>
                       </p:tgtEl>
                     </p:cBhvr>
                   </p:animEffect>
+                  <p:animScale>
+                    <p:cBhvr>
+                      <p:cTn id="10" dur="430" fill="hold"/>
+                      <p:tgtEl>
+                        <p:spTgt spid="12"/>
+                      </p:tgtEl>
+                      <p:attrNameLst>
+                        <p:attrName>ScaleX</p:attrName>
+                        <p:attrName>ScaleY</p:attrName>
+                      </p:attrNameLst>
+                    </p:cBhvr>
+                    <p:from x="96000" y="96000"/>
+                    <p:to x="100000" y="100000"/>
+                  </p:animScale>
                 </p:childTnLst>
               </p:cTn>
             </p:par>
             <p:par>
-              <p:cTn id="8" fill="hold" nodeType="afterEffect">
+              <p:cTn id="11" fill="hold" nodeType="afterEffect">
                 <p:stCondLst>
                   <p:cond delay="830"/>
                 </p:stCondLst>
                 <p:childTnLst>
                   <p:animEffect transition="in" filter="fade">
                     <p:cBhvr>
-                      <p:cTn id="9" dur="430" fill="hold"/>
+                      <p:cTn id="12" dur="430" fill="hold"/>
                       <p:tgtEl>
                         <p:spTgt spid="15"/>
                       </p:tgtEl>
                     </p:cBhvr>
                   </p:animEffect>
+                  <p:animScale>
+                    <p:cBhvr>
+                      <p:cTn id="13" dur="430" fill="hold"/>
+                      <p:tgtEl>
+                        <p:spTgt spid="15"/>
+                      </p:tgtEl>
+                      <p:attrNameLst>
+                        <p:attrName>ScaleX</p:attrName>
+                        <p:attrName>ScaleY</p:attrName>
+                      </p:attrNameLst>
+                    </p:cBhvr>
+                    <p:from x="96000" y="96000"/>
+                    <p:to x="100000" y="100000"/>
+                  </p:animScale>
                 </p:childTnLst>
               </p:cTn>
             </p:par>
             <p:par>
-              <p:cTn id="10" fill="hold" nodeType="withEffect">
+              <p:cTn id="14" fill="hold" nodeType="withEffect">
                 <p:stCondLst>
                   <p:cond delay="830"/>
                 </p:stCondLst>
                 <p:childTnLst>
                   <p:animEffect transition="in" filter="fade">
                     <p:cBhvr>
-                      <p:cTn id="11" dur="430" fill="hold"/>
+                      <p:cTn id="15" dur="430" fill="hold"/>
                       <p:tgtEl>
                         <p:spTgt spid="16"/>
                       </p:tgtEl>
                     </p:cBhvr>
                   </p:animEffect>
+                  <p:animScale>
+                    <p:cBhvr>
+                      <p:cTn id="16" dur="430" fill="hold"/>
+                      <p:tgtEl>
+                        <p:spTgt spid="16"/>
+                      </p:tgtEl>
+                      <p:attrNameLst>
+                        <p:attrName>ScaleX</p:attrName>
+                        <p:attrName>ScaleY</p:attrName>
+                      </p:attrNameLst>
+                    </p:cBhvr>
+                    <p:from x="96000" y="96000"/>
+                    <p:to x="100000" y="100000"/>
+                  </p:animScale>
                 </p:childTnLst>
               </p:cTn>
             </p:par>
             <p:par>
-              <p:cTn id="12" fill="hold" nodeType="afterEffect">
+              <p:cTn id="17" fill="hold" nodeType="afterEffect">
                 <p:stCondLst>
                   <p:cond delay="1100"/>
                 </p:stCondLst>
                 <p:childTnLst>
                   <p:animEffect transition="in" filter="fade">
                     <p:cBhvr>
-                      <p:cTn id="13" dur="430" fill="hold"/>
+                      <p:cTn id="18" dur="430" fill="hold"/>
                       <p:tgtEl>
                         <p:spTgt spid="19"/>
                       </p:tgtEl>
                     </p:cBhvr>
                   </p:animEffect>
+                  <p:animScale>
+                    <p:cBhvr>
+                      <p:cTn id="19" dur="430" fill="hold"/>
+                      <p:tgtEl>
+                        <p:spTgt spid="19"/>
+                      </p:tgtEl>
+                      <p:attrNameLst>
+                        <p:attrName>ScaleX</p:attrName>
+                        <p:attrName>ScaleY</p:attrName>
+                      </p:attrNameLst>
+                    </p:cBhvr>
+                    <p:from x="96000" y="96000"/>
+                    <p:to x="100000" y="100000"/>
+                  </p:animScale>
                 </p:childTnLst>
               </p:cTn>
             </p:par>
             <p:par>
-              <p:cTn id="14" fill="hold" nodeType="withEffect">
+              <p:cTn id="20" fill="hold" nodeType="withEffect">
                 <p:stCondLst>
                   <p:cond delay="1100"/>
                 </p:stCondLst>
                 <p:childTnLst>
                   <p:animEffect transition="in" filter="fade">
                     <p:cBhvr>
-                      <p:cTn id="15" dur="430" fill="hold"/>
+                      <p:cTn id="21" dur="430" fill="hold"/>
                       <p:tgtEl>
                         <p:spTgt spid="20"/>
                       </p:tgtEl>
                     </p:cBhvr>
                   </p:animEffect>
+                  <p:animScale>
+                    <p:cBhvr>
+                      <p:cTn id="22" dur="430" fill="hold"/>
+                      <p:tgtEl>
+                        <p:spTgt spid="20"/>
+                      </p:tgtEl>
+                      <p:attrNameLst>
+                        <p:attrName>ScaleX</p:attrName>
+                        <p:attrName>ScaleY</p:attrName>
+                      </p:attrNameLst>
+                    </p:cBhvr>
+                    <p:from x="96000" y="96000"/>
+                    <p:to x="100000" y="100000"/>
+                  </p:animScale>
                 </p:childTnLst>
               </p:cTn>
             </p:par>
@@ -10997,14 +11333,14 @@
               </p:cTn>
             </p:par>
             <p:par>
-              <p:cTn id="4" fill="hold" nodeType="afterEffect">
+              <p:cTn id="5" fill="hold" nodeType="afterEffect">
                 <p:stCondLst>
                   <p:cond delay="560"/>
                 </p:stCondLst>
                 <p:childTnLst>
                   <p:animEffect transition="in" filter="fade">
                     <p:cBhvr>
-                      <p:cTn id="5" dur="450" fill="hold"/>
+                      <p:cTn id="6" dur="450" fill="hold"/>
                       <p:tgtEl>
                         <p:spTgt spid="10"/>
                       </p:tgtEl>
@@ -11014,14 +11350,14 @@
               </p:cTn>
             </p:par>
             <p:par>
-              <p:cTn id="6" fill="hold" nodeType="afterEffect">
+              <p:cTn id="8" fill="hold" nodeType="afterEffect">
                 <p:stCondLst>
                   <p:cond delay="920"/>
                 </p:stCondLst>
                 <p:childTnLst>
-                  <p:animEffect transition="in" filter="fade">
+                  <p:animEffect transition="in" filter="wipe(fromLeft)">
                     <p:cBhvr>
-                      <p:cTn id="7" dur="330" fill="hold"/>
+                      <p:cTn id="9" dur="330" fill="hold"/>
                       <p:tgtEl>
                         <p:spTgt spid="11">
                           <p:txEl>
@@ -11035,14 +11371,14 @@
               </p:cTn>
             </p:par>
             <p:par>
-              <p:cTn id="8" fill="hold" nodeType="afterEffect">
+              <p:cTn id="11" fill="hold" nodeType="afterEffect">
                 <p:stCondLst>
                   <p:cond delay="1150"/>
                 </p:stCondLst>
                 <p:childTnLst>
-                  <p:animEffect transition="in" filter="fade">
+                  <p:animEffect transition="in" filter="wipe(fromLeft)">
                     <p:cBhvr>
-                      <p:cTn id="9" dur="330" fill="hold"/>
+                      <p:cTn id="12" dur="330" fill="hold"/>
                       <p:tgtEl>
                         <p:spTgt spid="11">
                           <p:txEl>
@@ -11056,14 +11392,14 @@
               </p:cTn>
             </p:par>
             <p:par>
-              <p:cTn id="10" fill="hold" nodeType="afterEffect">
+              <p:cTn id="14" fill="hold" nodeType="afterEffect">
                 <p:stCondLst>
                   <p:cond delay="1380"/>
                 </p:stCondLst>
                 <p:childTnLst>
-                  <p:animEffect transition="in" filter="fade">
+                  <p:animEffect transition="in" filter="wipe(fromLeft)">
                     <p:cBhvr>
-                      <p:cTn id="11" dur="330" fill="hold"/>
+                      <p:cTn id="15" dur="330" fill="hold"/>
                       <p:tgtEl>
                         <p:spTgt spid="11">
                           <p:txEl>
@@ -11077,14 +11413,14 @@
               </p:cTn>
             </p:par>
             <p:par>
-              <p:cTn id="12" fill="hold" nodeType="afterEffect">
+              <p:cTn id="17" fill="hold" nodeType="afterEffect">
                 <p:stCondLst>
                   <p:cond delay="1610"/>
                 </p:stCondLst>
                 <p:childTnLst>
-                  <p:animEffect transition="in" filter="fade">
+                  <p:animEffect transition="in" filter="wipe(fromLeft)">
                     <p:cBhvr>
-                      <p:cTn id="13" dur="330" fill="hold"/>
+                      <p:cTn id="18" dur="330" fill="hold"/>
                       <p:tgtEl>
                         <p:spTgt spid="11">
                           <p:txEl>
@@ -12040,104 +12376,188 @@
               </p:cTn>
             </p:par>
             <p:par>
-              <p:cTn id="4" fill="hold" nodeType="afterEffect">
+              <p:cTn id="5" fill="hold" nodeType="afterEffect">
                 <p:stCondLst>
                   <p:cond delay="560"/>
                 </p:stCondLst>
                 <p:childTnLst>
                   <p:animEffect transition="in" filter="fade">
                     <p:cBhvr>
-                      <p:cTn id="5" dur="430" fill="hold"/>
+                      <p:cTn id="6" dur="430" fill="hold"/>
                       <p:tgtEl>
                         <p:spTgt spid="11"/>
                       </p:tgtEl>
                     </p:cBhvr>
                   </p:animEffect>
+                  <p:animScale>
+                    <p:cBhvr>
+                      <p:cTn id="7" dur="430" fill="hold"/>
+                      <p:tgtEl>
+                        <p:spTgt spid="11"/>
+                      </p:tgtEl>
+                      <p:attrNameLst>
+                        <p:attrName>ScaleX</p:attrName>
+                        <p:attrName>ScaleY</p:attrName>
+                      </p:attrNameLst>
+                    </p:cBhvr>
+                    <p:from x="96000" y="96000"/>
+                    <p:to x="100000" y="100000"/>
+                  </p:animScale>
                 </p:childTnLst>
               </p:cTn>
             </p:par>
             <p:par>
-              <p:cTn id="6" fill="hold" nodeType="withEffect">
+              <p:cTn id="8" fill="hold" nodeType="withEffect">
                 <p:stCondLst>
                   <p:cond delay="560"/>
                 </p:stCondLst>
                 <p:childTnLst>
                   <p:animEffect transition="in" filter="fade">
                     <p:cBhvr>
-                      <p:cTn id="7" dur="430" fill="hold"/>
+                      <p:cTn id="9" dur="430" fill="hold"/>
                       <p:tgtEl>
                         <p:spTgt spid="12"/>
                       </p:tgtEl>
                     </p:cBhvr>
                   </p:animEffect>
+                  <p:animScale>
+                    <p:cBhvr>
+                      <p:cTn id="10" dur="430" fill="hold"/>
+                      <p:tgtEl>
+                        <p:spTgt spid="12"/>
+                      </p:tgtEl>
+                      <p:attrNameLst>
+                        <p:attrName>ScaleX</p:attrName>
+                        <p:attrName>ScaleY</p:attrName>
+                      </p:attrNameLst>
+                    </p:cBhvr>
+                    <p:from x="96000" y="96000"/>
+                    <p:to x="100000" y="100000"/>
+                  </p:animScale>
                 </p:childTnLst>
               </p:cTn>
             </p:par>
             <p:par>
-              <p:cTn id="8" fill="hold" nodeType="afterEffect">
+              <p:cTn id="11" fill="hold" nodeType="afterEffect">
                 <p:stCondLst>
                   <p:cond delay="830"/>
                 </p:stCondLst>
                 <p:childTnLst>
                   <p:animEffect transition="in" filter="fade">
                     <p:cBhvr>
-                      <p:cTn id="9" dur="430" fill="hold"/>
+                      <p:cTn id="12" dur="430" fill="hold"/>
                       <p:tgtEl>
                         <p:spTgt spid="15"/>
                       </p:tgtEl>
                     </p:cBhvr>
                   </p:animEffect>
+                  <p:animScale>
+                    <p:cBhvr>
+                      <p:cTn id="13" dur="430" fill="hold"/>
+                      <p:tgtEl>
+                        <p:spTgt spid="15"/>
+                      </p:tgtEl>
+                      <p:attrNameLst>
+                        <p:attrName>ScaleX</p:attrName>
+                        <p:attrName>ScaleY</p:attrName>
+                      </p:attrNameLst>
+                    </p:cBhvr>
+                    <p:from x="96000" y="96000"/>
+                    <p:to x="100000" y="100000"/>
+                  </p:animScale>
                 </p:childTnLst>
               </p:cTn>
             </p:par>
             <p:par>
-              <p:cTn id="10" fill="hold" nodeType="withEffect">
+              <p:cTn id="14" fill="hold" nodeType="withEffect">
                 <p:stCondLst>
                   <p:cond delay="830"/>
                 </p:stCondLst>
                 <p:childTnLst>
                   <p:animEffect transition="in" filter="fade">
                     <p:cBhvr>
-                      <p:cTn id="11" dur="430" fill="hold"/>
+                      <p:cTn id="15" dur="430" fill="hold"/>
                       <p:tgtEl>
                         <p:spTgt spid="16"/>
                       </p:tgtEl>
                     </p:cBhvr>
                   </p:animEffect>
+                  <p:animScale>
+                    <p:cBhvr>
+                      <p:cTn id="16" dur="430" fill="hold"/>
+                      <p:tgtEl>
+                        <p:spTgt spid="16"/>
+                      </p:tgtEl>
+                      <p:attrNameLst>
+                        <p:attrName>ScaleX</p:attrName>
+                        <p:attrName>ScaleY</p:attrName>
+                      </p:attrNameLst>
+                    </p:cBhvr>
+                    <p:from x="96000" y="96000"/>
+                    <p:to x="100000" y="100000"/>
+                  </p:animScale>
                 </p:childTnLst>
               </p:cTn>
             </p:par>
             <p:par>
-              <p:cTn id="12" fill="hold" nodeType="afterEffect">
+              <p:cTn id="17" fill="hold" nodeType="afterEffect">
                 <p:stCondLst>
                   <p:cond delay="1100"/>
                 </p:stCondLst>
                 <p:childTnLst>
                   <p:animEffect transition="in" filter="fade">
                     <p:cBhvr>
-                      <p:cTn id="13" dur="430" fill="hold"/>
+                      <p:cTn id="18" dur="430" fill="hold"/>
                       <p:tgtEl>
                         <p:spTgt spid="19"/>
                       </p:tgtEl>
                     </p:cBhvr>
                   </p:animEffect>
+                  <p:animScale>
+                    <p:cBhvr>
+                      <p:cTn id="19" dur="430" fill="hold"/>
+                      <p:tgtEl>
+                        <p:spTgt spid="19"/>
+                      </p:tgtEl>
+                      <p:attrNameLst>
+                        <p:attrName>ScaleX</p:attrName>
+                        <p:attrName>ScaleY</p:attrName>
+                      </p:attrNameLst>
+                    </p:cBhvr>
+                    <p:from x="96000" y="96000"/>
+                    <p:to x="100000" y="100000"/>
+                  </p:animScale>
                 </p:childTnLst>
               </p:cTn>
             </p:par>
             <p:par>
-              <p:cTn id="14" fill="hold" nodeType="withEffect">
+              <p:cTn id="20" fill="hold" nodeType="withEffect">
                 <p:stCondLst>
                   <p:cond delay="1100"/>
                 </p:stCondLst>
                 <p:childTnLst>
                   <p:animEffect transition="in" filter="fade">
                     <p:cBhvr>
-                      <p:cTn id="15" dur="430" fill="hold"/>
+                      <p:cTn id="21" dur="430" fill="hold"/>
                       <p:tgtEl>
                         <p:spTgt spid="20"/>
                       </p:tgtEl>
                     </p:cBhvr>
                   </p:animEffect>
+                  <p:animScale>
+                    <p:cBhvr>
+                      <p:cTn id="22" dur="430" fill="hold"/>
+                      <p:tgtEl>
+                        <p:spTgt spid="20"/>
+                      </p:tgtEl>
+                      <p:attrNameLst>
+                        <p:attrName>ScaleX</p:attrName>
+                        <p:attrName>ScaleY</p:attrName>
+                      </p:attrNameLst>
+                    </p:cBhvr>
+                    <p:from x="96000" y="96000"/>
+                    <p:to x="100000" y="100000"/>
+                  </p:animScale>
                 </p:childTnLst>
               </p:cTn>
             </p:par>
@@ -13565,138 +13985,250 @@
               </p:cTn>
             </p:par>
             <p:par>
-              <p:cTn id="4" fill="hold" nodeType="afterEffect">
+              <p:cTn id="5" fill="hold" nodeType="afterEffect">
                 <p:stCondLst>
                   <p:cond delay="560"/>
                 </p:stCondLst>
                 <p:childTnLst>
                   <p:animEffect transition="in" filter="fade">
                     <p:cBhvr>
-                      <p:cTn id="5" dur="420" fill="hold"/>
+                      <p:cTn id="6" dur="420" fill="hold"/>
                       <p:tgtEl>
                         <p:spTgt spid="13"/>
                       </p:tgtEl>
                     </p:cBhvr>
                   </p:animEffect>
+                  <p:animScale>
+                    <p:cBhvr>
+                      <p:cTn id="7" dur="420" fill="hold"/>
+                      <p:tgtEl>
+                        <p:spTgt spid="13"/>
+                      </p:tgtEl>
+                      <p:attrNameLst>
+                        <p:attrName>ScaleX</p:attrName>
+                        <p:attrName>ScaleY</p:attrName>
+                      </p:attrNameLst>
+                    </p:cBhvr>
+                    <p:from x="96000" y="96000"/>
+                    <p:to x="100000" y="100000"/>
+                  </p:animScale>
                 </p:childTnLst>
               </p:cTn>
             </p:par>
             <p:par>
-              <p:cTn id="6" fill="hold" nodeType="withEffect">
+              <p:cTn id="8" fill="hold" nodeType="withEffect">
                 <p:stCondLst>
                   <p:cond delay="560"/>
                 </p:stCondLst>
                 <p:childTnLst>
                   <p:animEffect transition="in" filter="fade">
                     <p:cBhvr>
-                      <p:cTn id="7" dur="420" fill="hold"/>
+                      <p:cTn id="9" dur="420" fill="hold"/>
                       <p:tgtEl>
                         <p:spTgt spid="14"/>
                       </p:tgtEl>
                     </p:cBhvr>
                   </p:animEffect>
+                  <p:animScale>
+                    <p:cBhvr>
+                      <p:cTn id="10" dur="420" fill="hold"/>
+                      <p:tgtEl>
+                        <p:spTgt spid="14"/>
+                      </p:tgtEl>
+                      <p:attrNameLst>
+                        <p:attrName>ScaleX</p:attrName>
+                        <p:attrName>ScaleY</p:attrName>
+                      </p:attrNameLst>
+                    </p:cBhvr>
+                    <p:from x="96000" y="96000"/>
+                    <p:to x="100000" y="100000"/>
+                  </p:animScale>
                 </p:childTnLst>
               </p:cTn>
             </p:par>
             <p:par>
-              <p:cTn id="8" fill="hold" nodeType="afterEffect">
+              <p:cTn id="11" fill="hold" nodeType="afterEffect">
                 <p:stCondLst>
                   <p:cond delay="840"/>
                 </p:stCondLst>
                 <p:childTnLst>
                   <p:animEffect transition="in" filter="fade">
                     <p:cBhvr>
-                      <p:cTn id="9" dur="420" fill="hold"/>
+                      <p:cTn id="12" dur="420" fill="hold"/>
                       <p:tgtEl>
                         <p:spTgt spid="19"/>
                       </p:tgtEl>
                     </p:cBhvr>
                   </p:animEffect>
+                  <p:animScale>
+                    <p:cBhvr>
+                      <p:cTn id="13" dur="420" fill="hold"/>
+                      <p:tgtEl>
+                        <p:spTgt spid="19"/>
+                      </p:tgtEl>
+                      <p:attrNameLst>
+                        <p:attrName>ScaleX</p:attrName>
+                        <p:attrName>ScaleY</p:attrName>
+                      </p:attrNameLst>
+                    </p:cBhvr>
+                    <p:from x="96000" y="96000"/>
+                    <p:to x="100000" y="100000"/>
+                  </p:animScale>
                 </p:childTnLst>
               </p:cTn>
             </p:par>
             <p:par>
-              <p:cTn id="10" fill="hold" nodeType="withEffect">
+              <p:cTn id="14" fill="hold" nodeType="withEffect">
                 <p:stCondLst>
                   <p:cond delay="840"/>
                 </p:stCondLst>
                 <p:childTnLst>
                   <p:animEffect transition="in" filter="fade">
                     <p:cBhvr>
-                      <p:cTn id="11" dur="420" fill="hold"/>
+                      <p:cTn id="15" dur="420" fill="hold"/>
                       <p:tgtEl>
                         <p:spTgt spid="20"/>
                       </p:tgtEl>
                     </p:cBhvr>
                   </p:animEffect>
+                  <p:animScale>
+                    <p:cBhvr>
+                      <p:cTn id="16" dur="420" fill="hold"/>
+                      <p:tgtEl>
+                        <p:spTgt spid="20"/>
+                      </p:tgtEl>
+                      <p:attrNameLst>
+                        <p:attrName>ScaleX</p:attrName>
+                        <p:attrName>ScaleY</p:attrName>
+                      </p:attrNameLst>
+                    </p:cBhvr>
+                    <p:from x="96000" y="96000"/>
+                    <p:to x="100000" y="100000"/>
+                  </p:animScale>
                 </p:childTnLst>
               </p:cTn>
             </p:par>
             <p:par>
-              <p:cTn id="12" fill="hold" nodeType="afterEffect">
+              <p:cTn id="17" fill="hold" nodeType="afterEffect">
                 <p:stCondLst>
                   <p:cond delay="1120"/>
                 </p:stCondLst>
                 <p:childTnLst>
                   <p:animEffect transition="in" filter="fade">
                     <p:cBhvr>
-                      <p:cTn id="13" dur="420" fill="hold"/>
+                      <p:cTn id="18" dur="420" fill="hold"/>
                       <p:tgtEl>
                         <p:spTgt spid="25"/>
                       </p:tgtEl>
                     </p:cBhvr>
                   </p:animEffect>
+                  <p:animScale>
+                    <p:cBhvr>
+                      <p:cTn id="19" dur="420" fill="hold"/>
+                      <p:tgtEl>
+                        <p:spTgt spid="25"/>
+                      </p:tgtEl>
+                      <p:attrNameLst>
+                        <p:attrName>ScaleX</p:attrName>
+                        <p:attrName>ScaleY</p:attrName>
+                      </p:attrNameLst>
+                    </p:cBhvr>
+                    <p:from x="96000" y="96000"/>
+                    <p:to x="100000" y="100000"/>
+                  </p:animScale>
                 </p:childTnLst>
               </p:cTn>
             </p:par>
             <p:par>
-              <p:cTn id="14" fill="hold" nodeType="withEffect">
+              <p:cTn id="20" fill="hold" nodeType="withEffect">
                 <p:stCondLst>
                   <p:cond delay="1120"/>
                 </p:stCondLst>
                 <p:childTnLst>
                   <p:animEffect transition="in" filter="fade">
                     <p:cBhvr>
-                      <p:cTn id="15" dur="420" fill="hold"/>
+                      <p:cTn id="21" dur="420" fill="hold"/>
                       <p:tgtEl>
                         <p:spTgt spid="26"/>
                       </p:tgtEl>
                     </p:cBhvr>
                   </p:animEffect>
+                  <p:animScale>
+                    <p:cBhvr>
+                      <p:cTn id="22" dur="420" fill="hold"/>
+                      <p:tgtEl>
+                        <p:spTgt spid="26"/>
+                      </p:tgtEl>
+                      <p:attrNameLst>
+                        <p:attrName>ScaleX</p:attrName>
+                        <p:attrName>ScaleY</p:attrName>
+                      </p:attrNameLst>
+                    </p:cBhvr>
+                    <p:from x="96000" y="96000"/>
+                    <p:to x="100000" y="100000"/>
+                  </p:animScale>
                 </p:childTnLst>
               </p:cTn>
             </p:par>
             <p:par>
-              <p:cTn id="16" fill="hold" nodeType="afterEffect">
+              <p:cTn id="23" fill="hold" nodeType="afterEffect">
                 <p:stCondLst>
                   <p:cond delay="1400"/>
                 </p:stCondLst>
                 <p:childTnLst>
                   <p:animEffect transition="in" filter="fade">
                     <p:cBhvr>
-                      <p:cTn id="17" dur="420" fill="hold"/>
+                      <p:cTn id="24" dur="420" fill="hold"/>
                       <p:tgtEl>
                         <p:spTgt spid="31"/>
                       </p:tgtEl>
                     </p:cBhvr>
                   </p:animEffect>
+                  <p:animScale>
+                    <p:cBhvr>
+                      <p:cTn id="25" dur="420" fill="hold"/>
+                      <p:tgtEl>
+                        <p:spTgt spid="31"/>
+                      </p:tgtEl>
+                      <p:attrNameLst>
+                        <p:attrName>ScaleX</p:attrName>
+                        <p:attrName>ScaleY</p:attrName>
+                      </p:attrNameLst>
+                    </p:cBhvr>
+                    <p:from x="96000" y="96000"/>
+                    <p:to x="100000" y="100000"/>
+                  </p:animScale>
                 </p:childTnLst>
               </p:cTn>
             </p:par>
             <p:par>
-              <p:cTn id="18" fill="hold" nodeType="withEffect">
+              <p:cTn id="26" fill="hold" nodeType="withEffect">
                 <p:stCondLst>
                   <p:cond delay="1400"/>
                 </p:stCondLst>
                 <p:childTnLst>
                   <p:animEffect transition="in" filter="fade">
                     <p:cBhvr>
-                      <p:cTn id="19" dur="420" fill="hold"/>
+                      <p:cTn id="27" dur="420" fill="hold"/>
                       <p:tgtEl>
                         <p:spTgt spid="32"/>
                       </p:tgtEl>
                     </p:cBhvr>
                   </p:animEffect>
+                  <p:animScale>
+                    <p:cBhvr>
+                      <p:cTn id="28" dur="420" fill="hold"/>
+                      <p:tgtEl>
+                        <p:spTgt spid="32"/>
+                      </p:tgtEl>
+                      <p:attrNameLst>
+                        <p:attrName>ScaleX</p:attrName>
+                        <p:attrName>ScaleY</p:attrName>
+                      </p:attrNameLst>
+                    </p:cBhvr>
+                    <p:from x="96000" y="96000"/>
+                    <p:to x="100000" y="100000"/>
+                  </p:animScale>
                 </p:childTnLst>
               </p:cTn>
             </p:par>
@@ -15114,48 +15646,76 @@
               </p:cTn>
             </p:par>
             <p:par>
-              <p:cTn id="4" fill="hold" nodeType="afterEffect">
+              <p:cTn id="5" fill="hold" nodeType="afterEffect">
                 <p:stCondLst>
                   <p:cond delay="560"/>
                 </p:stCondLst>
                 <p:childTnLst>
                   <p:animEffect transition="in" filter="fade">
                     <p:cBhvr>
-                      <p:cTn id="5" dur="360" fill="hold"/>
+                      <p:cTn id="6" dur="360" fill="hold"/>
                       <p:tgtEl>
                         <p:spTgt spid="9"/>
                       </p:tgtEl>
                     </p:cBhvr>
                   </p:animEffect>
+                  <p:animScale>
+                    <p:cBhvr>
+                      <p:cTn id="7" dur="360" fill="hold"/>
+                      <p:tgtEl>
+                        <p:spTgt spid="9"/>
+                      </p:tgtEl>
+                      <p:attrNameLst>
+                        <p:attrName>ScaleX</p:attrName>
+                        <p:attrName>ScaleY</p:attrName>
+                      </p:attrNameLst>
+                    </p:cBhvr>
+                    <p:from x="96000" y="96000"/>
+                    <p:to x="100000" y="100000"/>
+                  </p:animScale>
                 </p:childTnLst>
               </p:cTn>
             </p:par>
             <p:par>
-              <p:cTn id="6" fill="hold" nodeType="withEffect">
+              <p:cTn id="8" fill="hold" nodeType="withEffect">
                 <p:stCondLst>
                   <p:cond delay="560"/>
                 </p:stCondLst>
                 <p:childTnLst>
                   <p:animEffect transition="in" filter="fade">
                     <p:cBhvr>
-                      <p:cTn id="7" dur="360" fill="hold"/>
+                      <p:cTn id="9" dur="360" fill="hold"/>
                       <p:tgtEl>
                         <p:spTgt spid="11"/>
                       </p:tgtEl>
                     </p:cBhvr>
                   </p:animEffect>
+                  <p:animScale>
+                    <p:cBhvr>
+                      <p:cTn id="10" dur="360" fill="hold"/>
+                      <p:tgtEl>
+                        <p:spTgt spid="11"/>
+                      </p:tgtEl>
+                      <p:attrNameLst>
+                        <p:attrName>ScaleX</p:attrName>
+                        <p:attrName>ScaleY</p:attrName>
+                      </p:attrNameLst>
+                    </p:cBhvr>
+                    <p:from x="96000" y="96000"/>
+                    <p:to x="100000" y="100000"/>
+                  </p:animScale>
                 </p:childTnLst>
               </p:cTn>
             </p:par>
             <p:par>
-              <p:cTn id="8" fill="hold" nodeType="afterEffect">
+              <p:cTn id="11" fill="hold" nodeType="afterEffect">
                 <p:stCondLst>
                   <p:cond delay="790"/>
                 </p:stCondLst>
                 <p:childTnLst>
-                  <p:animEffect transition="in" filter="fade">
+                  <p:animEffect transition="in" filter="wipe(fromLeft)">
                     <p:cBhvr>
-                      <p:cTn id="9" dur="360" fill="hold"/>
+                      <p:cTn id="12" dur="360" fill="hold"/>
                       <p:tgtEl>
                         <p:spTgt spid="13"/>
                       </p:tgtEl>
@@ -15165,150 +15725,262 @@
               </p:cTn>
             </p:par>
             <p:par>
-              <p:cTn id="10" fill="hold" nodeType="afterEffect">
+              <p:cTn id="14" fill="hold" nodeType="afterEffect">
                 <p:stCondLst>
                   <p:cond delay="1020"/>
                 </p:stCondLst>
                 <p:childTnLst>
                   <p:animEffect transition="in" filter="fade">
                     <p:cBhvr>
-                      <p:cTn id="11" dur="360" fill="hold"/>
+                      <p:cTn id="15" dur="360" fill="hold"/>
                       <p:tgtEl>
                         <p:spTgt spid="16"/>
                       </p:tgtEl>
                     </p:cBhvr>
                   </p:animEffect>
+                  <p:animScale>
+                    <p:cBhvr>
+                      <p:cTn id="16" dur="360" fill="hold"/>
+                      <p:tgtEl>
+                        <p:spTgt spid="16"/>
+                      </p:tgtEl>
+                      <p:attrNameLst>
+                        <p:attrName>ScaleX</p:attrName>
+                        <p:attrName>ScaleY</p:attrName>
+                      </p:attrNameLst>
+                    </p:cBhvr>
+                    <p:from x="96000" y="96000"/>
+                    <p:to x="100000" y="100000"/>
+                  </p:animScale>
                 </p:childTnLst>
               </p:cTn>
             </p:par>
             <p:par>
-              <p:cTn id="12" fill="hold" nodeType="withEffect">
+              <p:cTn id="17" fill="hold" nodeType="withEffect">
                 <p:stCondLst>
                   <p:cond delay="1020"/>
                 </p:stCondLst>
                 <p:childTnLst>
                   <p:animEffect transition="in" filter="fade">
                     <p:cBhvr>
-                      <p:cTn id="13" dur="360" fill="hold"/>
+                      <p:cTn id="18" dur="360" fill="hold"/>
                       <p:tgtEl>
                         <p:spTgt spid="17"/>
                       </p:tgtEl>
                     </p:cBhvr>
                   </p:animEffect>
+                  <p:animScale>
+                    <p:cBhvr>
+                      <p:cTn id="19" dur="360" fill="hold"/>
+                      <p:tgtEl>
+                        <p:spTgt spid="17"/>
+                      </p:tgtEl>
+                      <p:attrNameLst>
+                        <p:attrName>ScaleX</p:attrName>
+                        <p:attrName>ScaleY</p:attrName>
+                      </p:attrNameLst>
+                    </p:cBhvr>
+                    <p:from x="96000" y="96000"/>
+                    <p:to x="100000" y="100000"/>
+                  </p:animScale>
                 </p:childTnLst>
               </p:cTn>
             </p:par>
             <p:par>
-              <p:cTn id="14" fill="hold" nodeType="afterEffect">
+              <p:cTn id="20" fill="hold" nodeType="afterEffect">
                 <p:stCondLst>
                   <p:cond delay="1250"/>
                 </p:stCondLst>
                 <p:childTnLst>
                   <p:animEffect transition="in" filter="fade">
                     <p:cBhvr>
-                      <p:cTn id="15" dur="360" fill="hold"/>
+                      <p:cTn id="21" dur="360" fill="hold"/>
                       <p:tgtEl>
                         <p:spTgt spid="20"/>
                       </p:tgtEl>
                     </p:cBhvr>
                   </p:animEffect>
+                  <p:animScale>
+                    <p:cBhvr>
+                      <p:cTn id="22" dur="360" fill="hold"/>
+                      <p:tgtEl>
+                        <p:spTgt spid="20"/>
+                      </p:tgtEl>
+                      <p:attrNameLst>
+                        <p:attrName>ScaleX</p:attrName>
+                        <p:attrName>ScaleY</p:attrName>
+                      </p:attrNameLst>
+                    </p:cBhvr>
+                    <p:from x="96000" y="96000"/>
+                    <p:to x="100000" y="100000"/>
+                  </p:animScale>
                 </p:childTnLst>
               </p:cTn>
             </p:par>
             <p:par>
-              <p:cTn id="16" fill="hold" nodeType="withEffect">
+              <p:cTn id="23" fill="hold" nodeType="withEffect">
                 <p:stCondLst>
                   <p:cond delay="1250"/>
                 </p:stCondLst>
                 <p:childTnLst>
                   <p:animEffect transition="in" filter="fade">
                     <p:cBhvr>
-                      <p:cTn id="17" dur="360" fill="hold"/>
+                      <p:cTn id="24" dur="360" fill="hold"/>
                       <p:tgtEl>
                         <p:spTgt spid="21"/>
                       </p:tgtEl>
                     </p:cBhvr>
                   </p:animEffect>
+                  <p:animScale>
+                    <p:cBhvr>
+                      <p:cTn id="25" dur="360" fill="hold"/>
+                      <p:tgtEl>
+                        <p:spTgt spid="21"/>
+                      </p:tgtEl>
+                      <p:attrNameLst>
+                        <p:attrName>ScaleX</p:attrName>
+                        <p:attrName>ScaleY</p:attrName>
+                      </p:attrNameLst>
+                    </p:cBhvr>
+                    <p:from x="96000" y="96000"/>
+                    <p:to x="100000" y="100000"/>
+                  </p:animScale>
                 </p:childTnLst>
               </p:cTn>
             </p:par>
             <p:par>
-              <p:cTn id="18" fill="hold" nodeType="afterEffect">
+              <p:cTn id="26" fill="hold" nodeType="afterEffect">
                 <p:stCondLst>
                   <p:cond delay="1480"/>
                 </p:stCondLst>
                 <p:childTnLst>
                   <p:animEffect transition="in" filter="fade">
                     <p:cBhvr>
-                      <p:cTn id="19" dur="360" fill="hold"/>
+                      <p:cTn id="27" dur="360" fill="hold"/>
                       <p:tgtEl>
                         <p:spTgt spid="24"/>
                       </p:tgtEl>
                     </p:cBhvr>
                   </p:animEffect>
+                  <p:animScale>
+                    <p:cBhvr>
+                      <p:cTn id="28" dur="360" fill="hold"/>
+                      <p:tgtEl>
+                        <p:spTgt spid="24"/>
+                      </p:tgtEl>
+                      <p:attrNameLst>
+                        <p:attrName>ScaleX</p:attrName>
+                        <p:attrName>ScaleY</p:attrName>
+                      </p:attrNameLst>
+                    </p:cBhvr>
+                    <p:from x="96000" y="96000"/>
+                    <p:to x="100000" y="100000"/>
+                  </p:animScale>
                 </p:childTnLst>
               </p:cTn>
             </p:par>
             <p:par>
-              <p:cTn id="20" fill="hold" nodeType="withEffect">
+              <p:cTn id="29" fill="hold" nodeType="withEffect">
                 <p:stCondLst>
                   <p:cond delay="1480"/>
                 </p:stCondLst>
                 <p:childTnLst>
                   <p:animEffect transition="in" filter="fade">
                     <p:cBhvr>
-                      <p:cTn id="21" dur="360" fill="hold"/>
+                      <p:cTn id="30" dur="360" fill="hold"/>
                       <p:tgtEl>
                         <p:spTgt spid="25"/>
                       </p:tgtEl>
                     </p:cBhvr>
                   </p:animEffect>
+                  <p:animScale>
+                    <p:cBhvr>
+                      <p:cTn id="31" dur="360" fill="hold"/>
+                      <p:tgtEl>
+                        <p:spTgt spid="25"/>
+                      </p:tgtEl>
+                      <p:attrNameLst>
+                        <p:attrName>ScaleX</p:attrName>
+                        <p:attrName>ScaleY</p:attrName>
+                      </p:attrNameLst>
+                    </p:cBhvr>
+                    <p:from x="96000" y="96000"/>
+                    <p:to x="100000" y="100000"/>
+                  </p:animScale>
                 </p:childTnLst>
               </p:cTn>
             </p:par>
             <p:par>
-              <p:cTn id="22" fill="hold" nodeType="afterEffect">
+              <p:cTn id="32" fill="hold" nodeType="afterEffect">
                 <p:stCondLst>
                   <p:cond delay="1710"/>
                 </p:stCondLst>
                 <p:childTnLst>
                   <p:animEffect transition="in" filter="fade">
                     <p:cBhvr>
-                      <p:cTn id="23" dur="360" fill="hold"/>
+                      <p:cTn id="33" dur="360" fill="hold"/>
                       <p:tgtEl>
                         <p:spTgt spid="28"/>
                       </p:tgtEl>
                     </p:cBhvr>
                   </p:animEffect>
+                  <p:animScale>
+                    <p:cBhvr>
+                      <p:cTn id="34" dur="360" fill="hold"/>
+                      <p:tgtEl>
+                        <p:spTgt spid="28"/>
+                      </p:tgtEl>
+                      <p:attrNameLst>
+                        <p:attrName>ScaleX</p:attrName>
+                        <p:attrName>ScaleY</p:attrName>
+                      </p:attrNameLst>
+                    </p:cBhvr>
+                    <p:from x="96000" y="96000"/>
+                    <p:to x="100000" y="100000"/>
+                  </p:animScale>
                 </p:childTnLst>
               </p:cTn>
             </p:par>
             <p:par>
-              <p:cTn id="24" fill="hold" nodeType="withEffect">
+              <p:cTn id="35" fill="hold" nodeType="withEffect">
                 <p:stCondLst>
                   <p:cond delay="1710"/>
                 </p:stCondLst>
                 <p:childTnLst>
                   <p:animEffect transition="in" filter="fade">
                     <p:cBhvr>
-                      <p:cTn id="25" dur="360" fill="hold"/>
+                      <p:cTn id="36" dur="360" fill="hold"/>
                       <p:tgtEl>
                         <p:spTgt spid="29"/>
                       </p:tgtEl>
                     </p:cBhvr>
                   </p:animEffect>
+                  <p:animScale>
+                    <p:cBhvr>
+                      <p:cTn id="37" dur="360" fill="hold"/>
+                      <p:tgtEl>
+                        <p:spTgt spid="29"/>
+                      </p:tgtEl>
+                      <p:attrNameLst>
+                        <p:attrName>ScaleX</p:attrName>
+                        <p:attrName>ScaleY</p:attrName>
+                      </p:attrNameLst>
+                    </p:cBhvr>
+                    <p:from x="96000" y="96000"/>
+                    <p:to x="100000" y="100000"/>
+                  </p:animScale>
                 </p:childTnLst>
               </p:cTn>
             </p:par>
             <p:par>
-              <p:cTn id="26" fill="hold" nodeType="afterEffect">
+              <p:cTn id="38" fill="hold" nodeType="afterEffect">
                 <p:stCondLst>
                   <p:cond delay="1940"/>
                 </p:stCondLst>
                 <p:childTnLst>
-                  <p:animEffect transition="in" filter="fade">
+                  <p:animEffect transition="in" filter="wipe(fromLeft)">
                     <p:cBhvr>
-                      <p:cTn id="27" dur="360" fill="hold"/>
+                      <p:cTn id="39" dur="360" fill="hold"/>
                       <p:tgtEl>
                         <p:spTgt spid="31"/>
                       </p:tgtEl>
@@ -15318,14 +15990,14 @@
               </p:cTn>
             </p:par>
             <p:par>
-              <p:cTn id="28" fill="hold" nodeType="afterEffect">
+              <p:cTn id="41" fill="hold" nodeType="afterEffect">
                 <p:stCondLst>
                   <p:cond delay="2170"/>
                 </p:stCondLst>
                 <p:childTnLst>
-                  <p:animEffect transition="in" filter="fade">
+                  <p:animEffect transition="in" filter="wipe(fromLeft)">
                     <p:cBhvr>
-                      <p:cTn id="29" dur="360" fill="hold"/>
+                      <p:cTn id="42" dur="360" fill="hold"/>
                       <p:tgtEl>
                         <p:spTgt spid="32"/>
                       </p:tgtEl>
@@ -16518,41 +17190,38 @@
               </p:cTn>
             </p:par>
             <p:par>
-              <p:cTn id="4" fill="hold" nodeType="afterEffect">
+              <p:cTn id="5" fill="hold" nodeType="afterEffect">
                 <p:stCondLst>
                   <p:cond delay="560"/>
                 </p:stCondLst>
                 <p:childTnLst>
                   <p:animEffect transition="in" filter="fade">
                     <p:cBhvr>
-                      <p:cTn id="5" dur="420" fill="hold"/>
+                      <p:cTn id="6" dur="420" fill="hold"/>
                       <p:tgtEl>
                         <p:spTgt spid="10"/>
                       </p:tgtEl>
                     </p:cBhvr>
                   </p:animEffect>
+                  <p:animScale>
+                    <p:cBhvr>
+                      <p:cTn id="7" dur="420" fill="hold"/>
+                      <p:tgtEl>
+                        <p:spTgt spid="10"/>
+                      </p:tgtEl>
+                      <p:attrNameLst>
+                        <p:attrName>ScaleX</p:attrName>
+                        <p:attrName>ScaleY</p:attrName>
+                      </p:attrNameLst>
+                    </p:cBhvr>
+                    <p:from x="96000" y="96000"/>
+                    <p:to x="100000" y="100000"/>
+                  </p:animScale>
                 </p:childTnLst>
               </p:cTn>
             </p:par>
             <p:par>
-              <p:cTn id="6" fill="hold" nodeType="afterEffect">
-                <p:stCondLst>
-                  <p:cond delay="860"/>
-                </p:stCondLst>
-                <p:childTnLst>
-                  <p:animEffect transition="in" filter="fade">
-                    <p:cBhvr>
-                      <p:cTn id="7" dur="380" fill="hold"/>
-                      <p:tgtEl>
-                        <p:spTgt spid="13"/>
-                      </p:tgtEl>
-                    </p:cBhvr>
-                  </p:animEffect>
-                </p:childTnLst>
-              </p:cTn>
-            </p:par>
-            <p:par>
-              <p:cTn id="8" fill="hold" nodeType="withEffect">
+              <p:cTn id="8" fill="hold" nodeType="afterEffect">
                 <p:stCondLst>
                   <p:cond delay="860"/>
                 </p:stCondLst>
@@ -16561,112 +17230,241 @@
                     <p:cBhvr>
                       <p:cTn id="9" dur="380" fill="hold"/>
                       <p:tgtEl>
+                        <p:spTgt spid="13"/>
+                      </p:tgtEl>
+                    </p:cBhvr>
+                  </p:animEffect>
+                  <p:animScale>
+                    <p:cBhvr>
+                      <p:cTn id="10" dur="380" fill="hold"/>
+                      <p:tgtEl>
+                        <p:spTgt spid="13"/>
+                      </p:tgtEl>
+                      <p:attrNameLst>
+                        <p:attrName>ScaleX</p:attrName>
+                        <p:attrName>ScaleY</p:attrName>
+                      </p:attrNameLst>
+                    </p:cBhvr>
+                    <p:from x="96000" y="96000"/>
+                    <p:to x="100000" y="100000"/>
+                  </p:animScale>
+                </p:childTnLst>
+              </p:cTn>
+            </p:par>
+            <p:par>
+              <p:cTn id="11" fill="hold" nodeType="withEffect">
+                <p:stCondLst>
+                  <p:cond delay="860"/>
+                </p:stCondLst>
+                <p:childTnLst>
+                  <p:animEffect transition="in" filter="fade">
+                    <p:cBhvr>
+                      <p:cTn id="12" dur="380" fill="hold"/>
+                      <p:tgtEl>
                         <p:spTgt spid="14"/>
                       </p:tgtEl>
                     </p:cBhvr>
                   </p:animEffect>
+                  <p:animScale>
+                    <p:cBhvr>
+                      <p:cTn id="13" dur="380" fill="hold"/>
+                      <p:tgtEl>
+                        <p:spTgt spid="14"/>
+                      </p:tgtEl>
+                      <p:attrNameLst>
+                        <p:attrName>ScaleX</p:attrName>
+                        <p:attrName>ScaleY</p:attrName>
+                      </p:attrNameLst>
+                    </p:cBhvr>
+                    <p:from x="96000" y="96000"/>
+                    <p:to x="100000" y="100000"/>
+                  </p:animScale>
                 </p:childTnLst>
               </p:cTn>
             </p:par>
             <p:par>
-              <p:cTn id="10" fill="hold" nodeType="afterEffect">
+              <p:cTn id="14" fill="hold" nodeType="afterEffect">
                 <p:stCondLst>
                   <p:cond delay="1120"/>
                 </p:stCondLst>
                 <p:childTnLst>
                   <p:animEffect transition="in" filter="fade">
                     <p:cBhvr>
-                      <p:cTn id="11" dur="380" fill="hold"/>
+                      <p:cTn id="15" dur="380" fill="hold"/>
                       <p:tgtEl>
                         <p:spTgt spid="17"/>
                       </p:tgtEl>
                     </p:cBhvr>
                   </p:animEffect>
+                  <p:animScale>
+                    <p:cBhvr>
+                      <p:cTn id="16" dur="380" fill="hold"/>
+                      <p:tgtEl>
+                        <p:spTgt spid="17"/>
+                      </p:tgtEl>
+                      <p:attrNameLst>
+                        <p:attrName>ScaleX</p:attrName>
+                        <p:attrName>ScaleY</p:attrName>
+                      </p:attrNameLst>
+                    </p:cBhvr>
+                    <p:from x="96000" y="96000"/>
+                    <p:to x="100000" y="100000"/>
+                  </p:animScale>
                 </p:childTnLst>
               </p:cTn>
             </p:par>
             <p:par>
-              <p:cTn id="12" fill="hold" nodeType="withEffect">
+              <p:cTn id="17" fill="hold" nodeType="withEffect">
                 <p:stCondLst>
                   <p:cond delay="1120"/>
                 </p:stCondLst>
                 <p:childTnLst>
                   <p:animEffect transition="in" filter="fade">
                     <p:cBhvr>
-                      <p:cTn id="13" dur="380" fill="hold"/>
+                      <p:cTn id="18" dur="380" fill="hold"/>
                       <p:tgtEl>
                         <p:spTgt spid="18"/>
                       </p:tgtEl>
                     </p:cBhvr>
                   </p:animEffect>
+                  <p:animScale>
+                    <p:cBhvr>
+                      <p:cTn id="19" dur="380" fill="hold"/>
+                      <p:tgtEl>
+                        <p:spTgt spid="18"/>
+                      </p:tgtEl>
+                      <p:attrNameLst>
+                        <p:attrName>ScaleX</p:attrName>
+                        <p:attrName>ScaleY</p:attrName>
+                      </p:attrNameLst>
+                    </p:cBhvr>
+                    <p:from x="96000" y="96000"/>
+                    <p:to x="100000" y="100000"/>
+                  </p:animScale>
                 </p:childTnLst>
               </p:cTn>
             </p:par>
             <p:par>
-              <p:cTn id="14" fill="hold" nodeType="afterEffect">
+              <p:cTn id="20" fill="hold" nodeType="afterEffect">
                 <p:stCondLst>
                   <p:cond delay="1380"/>
                 </p:stCondLst>
                 <p:childTnLst>
                   <p:animEffect transition="in" filter="fade">
                     <p:cBhvr>
-                      <p:cTn id="15" dur="380" fill="hold"/>
+                      <p:cTn id="21" dur="380" fill="hold"/>
                       <p:tgtEl>
                         <p:spTgt spid="21"/>
                       </p:tgtEl>
                     </p:cBhvr>
                   </p:animEffect>
+                  <p:animScale>
+                    <p:cBhvr>
+                      <p:cTn id="22" dur="380" fill="hold"/>
+                      <p:tgtEl>
+                        <p:spTgt spid="21"/>
+                      </p:tgtEl>
+                      <p:attrNameLst>
+                        <p:attrName>ScaleX</p:attrName>
+                        <p:attrName>ScaleY</p:attrName>
+                      </p:attrNameLst>
+                    </p:cBhvr>
+                    <p:from x="96000" y="96000"/>
+                    <p:to x="100000" y="100000"/>
+                  </p:animScale>
                 </p:childTnLst>
               </p:cTn>
             </p:par>
             <p:par>
-              <p:cTn id="16" fill="hold" nodeType="withEffect">
+              <p:cTn id="23" fill="hold" nodeType="withEffect">
                 <p:stCondLst>
                   <p:cond delay="1380"/>
                 </p:stCondLst>
                 <p:childTnLst>
                   <p:animEffect transition="in" filter="fade">
                     <p:cBhvr>
-                      <p:cTn id="17" dur="380" fill="hold"/>
+                      <p:cTn id="24" dur="380" fill="hold"/>
                       <p:tgtEl>
                         <p:spTgt spid="22"/>
                       </p:tgtEl>
                     </p:cBhvr>
                   </p:animEffect>
+                  <p:animScale>
+                    <p:cBhvr>
+                      <p:cTn id="25" dur="380" fill="hold"/>
+                      <p:tgtEl>
+                        <p:spTgt spid="22"/>
+                      </p:tgtEl>
+                      <p:attrNameLst>
+                        <p:attrName>ScaleX</p:attrName>
+                        <p:attrName>ScaleY</p:attrName>
+                      </p:attrNameLst>
+                    </p:cBhvr>
+                    <p:from x="96000" y="96000"/>
+                    <p:to x="100000" y="100000"/>
+                  </p:animScale>
                 </p:childTnLst>
               </p:cTn>
             </p:par>
             <p:par>
-              <p:cTn id="18" fill="hold" nodeType="afterEffect">
+              <p:cTn id="26" fill="hold" nodeType="afterEffect">
                 <p:stCondLst>
                   <p:cond delay="1640"/>
                 </p:stCondLst>
                 <p:childTnLst>
                   <p:animEffect transition="in" filter="fade">
                     <p:cBhvr>
-                      <p:cTn id="19" dur="380" fill="hold"/>
+                      <p:cTn id="27" dur="380" fill="hold"/>
                       <p:tgtEl>
                         <p:spTgt spid="25"/>
                       </p:tgtEl>
                     </p:cBhvr>
                   </p:animEffect>
+                  <p:animScale>
+                    <p:cBhvr>
+                      <p:cTn id="28" dur="380" fill="hold"/>
+                      <p:tgtEl>
+                        <p:spTgt spid="25"/>
+                      </p:tgtEl>
+                      <p:attrNameLst>
+                        <p:attrName>ScaleX</p:attrName>
+                        <p:attrName>ScaleY</p:attrName>
+                      </p:attrNameLst>
+                    </p:cBhvr>
+                    <p:from x="96000" y="96000"/>
+                    <p:to x="100000" y="100000"/>
+                  </p:animScale>
                 </p:childTnLst>
               </p:cTn>
             </p:par>
             <p:par>
-              <p:cTn id="20" fill="hold" nodeType="withEffect">
+              <p:cTn id="29" fill="hold" nodeType="withEffect">
                 <p:stCondLst>
                   <p:cond delay="1640"/>
                 </p:stCondLst>
                 <p:childTnLst>
                   <p:animEffect transition="in" filter="fade">
                     <p:cBhvr>
-                      <p:cTn id="21" dur="380" fill="hold"/>
+                      <p:cTn id="30" dur="380" fill="hold"/>
                       <p:tgtEl>
                         <p:spTgt spid="26"/>
                       </p:tgtEl>
                     </p:cBhvr>
                   </p:animEffect>
+                  <p:animScale>
+                    <p:cBhvr>
+                      <p:cTn id="31" dur="380" fill="hold"/>
+                      <p:tgtEl>
+                        <p:spTgt spid="26"/>
+                      </p:tgtEl>
+                      <p:attrNameLst>
+                        <p:attrName>ScaleX</p:attrName>
+                        <p:attrName>ScaleY</p:attrName>
+                      </p:attrNameLst>
+                    </p:cBhvr>
+                    <p:from x="96000" y="96000"/>
+                    <p:to x="100000" y="100000"/>
+                  </p:animScale>
                 </p:childTnLst>
               </p:cTn>
             </p:par>
@@ -18013,14 +18811,14 @@
               </p:cTn>
             </p:par>
             <p:par>
-              <p:cTn id="4" fill="hold" nodeType="afterEffect">
+              <p:cTn id="5" fill="hold" nodeType="afterEffect">
                 <p:stCondLst>
                   <p:cond delay="560"/>
                 </p:stCondLst>
                 <p:childTnLst>
-                  <p:animEffect transition="in" filter="fade">
+                  <p:animEffect transition="in" filter="wipe(fromLeft)">
                     <p:cBhvr>
-                      <p:cTn id="5" dur="450" fill="hold"/>
+                      <p:cTn id="6" dur="450" fill="hold"/>
                       <p:tgtEl>
                         <p:spTgt spid="9"/>
                       </p:tgtEl>
@@ -18030,24 +18828,7 @@
               </p:cTn>
             </p:par>
             <p:par>
-              <p:cTn id="6" fill="hold" nodeType="afterEffect">
-                <p:stCondLst>
-                  <p:cond delay="950"/>
-                </p:stCondLst>
-                <p:childTnLst>
-                  <p:animEffect transition="in" filter="fade">
-                    <p:cBhvr>
-                      <p:cTn id="7" dur="360" fill="hold"/>
-                      <p:tgtEl>
-                        <p:spTgt spid="12"/>
-                      </p:tgtEl>
-                    </p:cBhvr>
-                  </p:animEffect>
-                </p:childTnLst>
-              </p:cTn>
-            </p:par>
-            <p:par>
-              <p:cTn id="8" fill="hold" nodeType="withEffect">
+              <p:cTn id="8" fill="hold" nodeType="afterEffect">
                 <p:stCondLst>
                   <p:cond delay="950"/>
                 </p:stCondLst>
@@ -18056,192 +18837,377 @@
                     <p:cBhvr>
                       <p:cTn id="9" dur="360" fill="hold"/>
                       <p:tgtEl>
-                        <p:spTgt spid="13"/>
+                        <p:spTgt spid="12"/>
                       </p:tgtEl>
                     </p:cBhvr>
                   </p:animEffect>
+                  <p:animScale>
+                    <p:cBhvr>
+                      <p:cTn id="10" dur="360" fill="hold"/>
+                      <p:tgtEl>
+                        <p:spTgt spid="12"/>
+                      </p:tgtEl>
+                      <p:attrNameLst>
+                        <p:attrName>ScaleX</p:attrName>
+                        <p:attrName>ScaleY</p:attrName>
+                      </p:attrNameLst>
+                    </p:cBhvr>
+                    <p:from x="96000" y="96000"/>
+                    <p:to x="100000" y="100000"/>
+                  </p:animScale>
                 </p:childTnLst>
               </p:cTn>
             </p:par>
             <p:par>
-              <p:cTn id="10" fill="hold" nodeType="withEffect">
+              <p:cTn id="11" fill="hold" nodeType="withEffect">
                 <p:stCondLst>
                   <p:cond delay="950"/>
                 </p:stCondLst>
                 <p:childTnLst>
                   <p:animEffect transition="in" filter="fade">
                     <p:cBhvr>
-                      <p:cTn id="11" dur="360" fill="hold"/>
+                      <p:cTn id="12" dur="360" fill="hold"/>
+                      <p:tgtEl>
+                        <p:spTgt spid="13"/>
+                      </p:tgtEl>
+                    </p:cBhvr>
+                  </p:animEffect>
+                  <p:animScale>
+                    <p:cBhvr>
+                      <p:cTn id="13" dur="360" fill="hold"/>
+                      <p:tgtEl>
+                        <p:spTgt spid="13"/>
+                      </p:tgtEl>
+                      <p:attrNameLst>
+                        <p:attrName>ScaleX</p:attrName>
+                        <p:attrName>ScaleY</p:attrName>
+                      </p:attrNameLst>
+                    </p:cBhvr>
+                    <p:from x="96000" y="96000"/>
+                    <p:to x="100000" y="100000"/>
+                  </p:animScale>
+                </p:childTnLst>
+              </p:cTn>
+            </p:par>
+            <p:par>
+              <p:cTn id="14" fill="hold" nodeType="withEffect">
+                <p:stCondLst>
+                  <p:cond delay="950"/>
+                </p:stCondLst>
+                <p:childTnLst>
+                  <p:animEffect transition="in" filter="fade">
+                    <p:cBhvr>
+                      <p:cTn id="15" dur="360" fill="hold"/>
                       <p:tgtEl>
                         <p:spTgt spid="14"/>
                       </p:tgtEl>
                     </p:cBhvr>
                   </p:animEffect>
+                  <p:animScale>
+                    <p:cBhvr>
+                      <p:cTn id="16" dur="360" fill="hold"/>
+                      <p:tgtEl>
+                        <p:spTgt spid="14"/>
+                      </p:tgtEl>
+                      <p:attrNameLst>
+                        <p:attrName>ScaleX</p:attrName>
+                        <p:attrName>ScaleY</p:attrName>
+                      </p:attrNameLst>
+                    </p:cBhvr>
+                    <p:from x="96000" y="96000"/>
+                    <p:to x="100000" y="100000"/>
+                  </p:animScale>
                 </p:childTnLst>
               </p:cTn>
             </p:par>
             <p:par>
-              <p:cTn id="12" fill="hold" nodeType="afterEffect">
+              <p:cTn id="17" fill="hold" nodeType="afterEffect">
                 <p:stCondLst>
                   <p:cond delay="1250"/>
                 </p:stCondLst>
                 <p:childTnLst>
                   <p:animEffect transition="in" filter="fade">
                     <p:cBhvr>
-                      <p:cTn id="13" dur="360" fill="hold"/>
+                      <p:cTn id="18" dur="360" fill="hold"/>
                       <p:tgtEl>
                         <p:spTgt spid="17"/>
                       </p:tgtEl>
                     </p:cBhvr>
                   </p:animEffect>
+                  <p:animScale>
+                    <p:cBhvr>
+                      <p:cTn id="19" dur="360" fill="hold"/>
+                      <p:tgtEl>
+                        <p:spTgt spid="17"/>
+                      </p:tgtEl>
+                      <p:attrNameLst>
+                        <p:attrName>ScaleX</p:attrName>
+                        <p:attrName>ScaleY</p:attrName>
+                      </p:attrNameLst>
+                    </p:cBhvr>
+                    <p:from x="96000" y="96000"/>
+                    <p:to x="100000" y="100000"/>
+                  </p:animScale>
                 </p:childTnLst>
               </p:cTn>
             </p:par>
             <p:par>
-              <p:cTn id="14" fill="hold" nodeType="withEffect">
+              <p:cTn id="20" fill="hold" nodeType="withEffect">
                 <p:stCondLst>
                   <p:cond delay="1250"/>
                 </p:stCondLst>
                 <p:childTnLst>
                   <p:animEffect transition="in" filter="fade">
                     <p:cBhvr>
-                      <p:cTn id="15" dur="360" fill="hold"/>
+                      <p:cTn id="21" dur="360" fill="hold"/>
                       <p:tgtEl>
                         <p:spTgt spid="18"/>
                       </p:tgtEl>
                     </p:cBhvr>
                   </p:animEffect>
+                  <p:animScale>
+                    <p:cBhvr>
+                      <p:cTn id="22" dur="360" fill="hold"/>
+                      <p:tgtEl>
+                        <p:spTgt spid="18"/>
+                      </p:tgtEl>
+                      <p:attrNameLst>
+                        <p:attrName>ScaleX</p:attrName>
+                        <p:attrName>ScaleY</p:attrName>
+                      </p:attrNameLst>
+                    </p:cBhvr>
+                    <p:from x="96000" y="96000"/>
+                    <p:to x="100000" y="100000"/>
+                  </p:animScale>
                 </p:childTnLst>
               </p:cTn>
             </p:par>
             <p:par>
-              <p:cTn id="16" fill="hold" nodeType="withEffect">
+              <p:cTn id="23" fill="hold" nodeType="withEffect">
                 <p:stCondLst>
                   <p:cond delay="1250"/>
                 </p:stCondLst>
                 <p:childTnLst>
                   <p:animEffect transition="in" filter="fade">
                     <p:cBhvr>
-                      <p:cTn id="17" dur="360" fill="hold"/>
+                      <p:cTn id="24" dur="360" fill="hold"/>
                       <p:tgtEl>
                         <p:spTgt spid="19"/>
                       </p:tgtEl>
                     </p:cBhvr>
                   </p:animEffect>
+                  <p:animScale>
+                    <p:cBhvr>
+                      <p:cTn id="25" dur="360" fill="hold"/>
+                      <p:tgtEl>
+                        <p:spTgt spid="19"/>
+                      </p:tgtEl>
+                      <p:attrNameLst>
+                        <p:attrName>ScaleX</p:attrName>
+                        <p:attrName>ScaleY</p:attrName>
+                      </p:attrNameLst>
+                    </p:cBhvr>
+                    <p:from x="96000" y="96000"/>
+                    <p:to x="100000" y="100000"/>
+                  </p:animScale>
                 </p:childTnLst>
               </p:cTn>
             </p:par>
             <p:par>
-              <p:cTn id="18" fill="hold" nodeType="afterEffect">
+              <p:cTn id="26" fill="hold" nodeType="afterEffect">
                 <p:stCondLst>
                   <p:cond delay="1550"/>
                 </p:stCondLst>
                 <p:childTnLst>
                   <p:animEffect transition="in" filter="fade">
                     <p:cBhvr>
-                      <p:cTn id="19" dur="360" fill="hold"/>
+                      <p:cTn id="27" dur="360" fill="hold"/>
                       <p:tgtEl>
                         <p:spTgt spid="22"/>
                       </p:tgtEl>
                     </p:cBhvr>
                   </p:animEffect>
+                  <p:animScale>
+                    <p:cBhvr>
+                      <p:cTn id="28" dur="360" fill="hold"/>
+                      <p:tgtEl>
+                        <p:spTgt spid="22"/>
+                      </p:tgtEl>
+                      <p:attrNameLst>
+                        <p:attrName>ScaleX</p:attrName>
+                        <p:attrName>ScaleY</p:attrName>
+                      </p:attrNameLst>
+                    </p:cBhvr>
+                    <p:from x="96000" y="96000"/>
+                    <p:to x="100000" y="100000"/>
+                  </p:animScale>
                 </p:childTnLst>
               </p:cTn>
             </p:par>
             <p:par>
-              <p:cTn id="20" fill="hold" nodeType="withEffect">
+              <p:cTn id="29" fill="hold" nodeType="withEffect">
                 <p:stCondLst>
                   <p:cond delay="1550"/>
                 </p:stCondLst>
                 <p:childTnLst>
                   <p:animEffect transition="in" filter="fade">
                     <p:cBhvr>
-                      <p:cTn id="21" dur="360" fill="hold"/>
+                      <p:cTn id="30" dur="360" fill="hold"/>
                       <p:tgtEl>
                         <p:spTgt spid="23"/>
                       </p:tgtEl>
                     </p:cBhvr>
                   </p:animEffect>
+                  <p:animScale>
+                    <p:cBhvr>
+                      <p:cTn id="31" dur="360" fill="hold"/>
+                      <p:tgtEl>
+                        <p:spTgt spid="23"/>
+                      </p:tgtEl>
+                      <p:attrNameLst>
+                        <p:attrName>ScaleX</p:attrName>
+                        <p:attrName>ScaleY</p:attrName>
+                      </p:attrNameLst>
+                    </p:cBhvr>
+                    <p:from x="96000" y="96000"/>
+                    <p:to x="100000" y="100000"/>
+                  </p:animScale>
                 </p:childTnLst>
               </p:cTn>
             </p:par>
             <p:par>
-              <p:cTn id="22" fill="hold" nodeType="withEffect">
+              <p:cTn id="32" fill="hold" nodeType="withEffect">
                 <p:stCondLst>
                   <p:cond delay="1550"/>
                 </p:stCondLst>
                 <p:childTnLst>
                   <p:animEffect transition="in" filter="fade">
                     <p:cBhvr>
-                      <p:cTn id="23" dur="360" fill="hold"/>
+                      <p:cTn id="33" dur="360" fill="hold"/>
                       <p:tgtEl>
                         <p:spTgt spid="24"/>
                       </p:tgtEl>
                     </p:cBhvr>
                   </p:animEffect>
+                  <p:animScale>
+                    <p:cBhvr>
+                      <p:cTn id="34" dur="360" fill="hold"/>
+                      <p:tgtEl>
+                        <p:spTgt spid="24"/>
+                      </p:tgtEl>
+                      <p:attrNameLst>
+                        <p:attrName>ScaleX</p:attrName>
+                        <p:attrName>ScaleY</p:attrName>
+                      </p:attrNameLst>
+                    </p:cBhvr>
+                    <p:from x="96000" y="96000"/>
+                    <p:to x="100000" y="100000"/>
+                  </p:animScale>
                 </p:childTnLst>
               </p:cTn>
             </p:par>
             <p:par>
-              <p:cTn id="24" fill="hold" nodeType="afterEffect">
+              <p:cTn id="35" fill="hold" nodeType="afterEffect">
                 <p:stCondLst>
                   <p:cond delay="1850"/>
                 </p:stCondLst>
                 <p:childTnLst>
                   <p:animEffect transition="in" filter="fade">
                     <p:cBhvr>
-                      <p:cTn id="25" dur="360" fill="hold"/>
+                      <p:cTn id="36" dur="360" fill="hold"/>
                       <p:tgtEl>
                         <p:spTgt spid="27"/>
                       </p:tgtEl>
                     </p:cBhvr>
                   </p:animEffect>
+                  <p:animScale>
+                    <p:cBhvr>
+                      <p:cTn id="37" dur="360" fill="hold"/>
+                      <p:tgtEl>
+                        <p:spTgt spid="27"/>
+                      </p:tgtEl>
+                      <p:attrNameLst>
+                        <p:attrName>ScaleX</p:attrName>
+                        <p:attrName>ScaleY</p:attrName>
+                      </p:attrNameLst>
+                    </p:cBhvr>
+                    <p:from x="96000" y="96000"/>
+                    <p:to x="100000" y="100000"/>
+                  </p:animScale>
                 </p:childTnLst>
               </p:cTn>
             </p:par>
             <p:par>
-              <p:cTn id="26" fill="hold" nodeType="withEffect">
+              <p:cTn id="38" fill="hold" nodeType="withEffect">
                 <p:stCondLst>
                   <p:cond delay="1850"/>
                 </p:stCondLst>
                 <p:childTnLst>
                   <p:animEffect transition="in" filter="fade">
                     <p:cBhvr>
-                      <p:cTn id="27" dur="360" fill="hold"/>
+                      <p:cTn id="39" dur="360" fill="hold"/>
                       <p:tgtEl>
                         <p:spTgt spid="28"/>
                       </p:tgtEl>
                     </p:cBhvr>
                   </p:animEffect>
+                  <p:animScale>
+                    <p:cBhvr>
+                      <p:cTn id="40" dur="360" fill="hold"/>
+                      <p:tgtEl>
+                        <p:spTgt spid="28"/>
+                      </p:tgtEl>
+                      <p:attrNameLst>
+                        <p:attrName>ScaleX</p:attrName>
+                        <p:attrName>ScaleY</p:attrName>
+                      </p:attrNameLst>
+                    </p:cBhvr>
+                    <p:from x="96000" y="96000"/>
+                    <p:to x="100000" y="100000"/>
+                  </p:animScale>
                 </p:childTnLst>
               </p:cTn>
             </p:par>
             <p:par>
-              <p:cTn id="28" fill="hold" nodeType="withEffect">
+              <p:cTn id="41" fill="hold" nodeType="withEffect">
                 <p:stCondLst>
                   <p:cond delay="1850"/>
                 </p:stCondLst>
                 <p:childTnLst>
                   <p:animEffect transition="in" filter="fade">
                     <p:cBhvr>
-                      <p:cTn id="29" dur="360" fill="hold"/>
+                      <p:cTn id="42" dur="360" fill="hold"/>
                       <p:tgtEl>
                         <p:spTgt spid="29"/>
                       </p:tgtEl>
                     </p:cBhvr>
                   </p:animEffect>
+                  <p:animScale>
+                    <p:cBhvr>
+                      <p:cTn id="43" dur="360" fill="hold"/>
+                      <p:tgtEl>
+                        <p:spTgt spid="29"/>
+                      </p:tgtEl>
+                      <p:attrNameLst>
+                        <p:attrName>ScaleX</p:attrName>
+                        <p:attrName>ScaleY</p:attrName>
+                      </p:attrNameLst>
+                    </p:cBhvr>
+                    <p:from x="96000" y="96000"/>
+                    <p:to x="100000" y="100000"/>
+                  </p:animScale>
                 </p:childTnLst>
               </p:cTn>
             </p:par>
             <p:par>
-              <p:cTn id="30" fill="hold" nodeType="afterEffect">
+              <p:cTn id="44" fill="hold" nodeType="afterEffect">
                 <p:stCondLst>
                   <p:cond delay="2270"/>
                 </p:stCondLst>
                 <p:childTnLst>
                   <p:animEffect transition="in" filter="fade">
                     <p:cBhvr>
-                      <p:cTn id="31" dur="350" fill="hold"/>
+                      <p:cTn id="45" dur="350" fill="hold"/>
                       <p:tgtEl>
                         <p:spTgt spid="31"/>
                       </p:tgtEl>
@@ -19032,14 +19998,14 @@
               </p:cTn>
             </p:par>
             <p:par>
-              <p:cTn id="4" fill="hold" nodeType="afterEffect">
+              <p:cTn id="5" fill="hold" nodeType="afterEffect">
                 <p:stCondLst>
                   <p:cond delay="560"/>
                 </p:stCondLst>
                 <p:childTnLst>
                   <p:animEffect transition="in" filter="fade">
                     <p:cBhvr>
-                      <p:cTn id="5" dur="350" fill="hold"/>
+                      <p:cTn id="6" dur="350" fill="hold"/>
                       <p:tgtEl>
                         <p:spTgt spid="11"/>
                       </p:tgtEl>
@@ -19049,14 +20015,14 @@
               </p:cTn>
             </p:par>
             <p:par>
-              <p:cTn id="6" fill="hold" nodeType="afterEffect">
+              <p:cTn id="8" fill="hold" nodeType="afterEffect">
                 <p:stCondLst>
                   <p:cond delay="770"/>
                 </p:stCondLst>
                 <p:childTnLst>
-                  <p:animEffect transition="in" filter="fade">
+                  <p:animEffect transition="in" filter="wipe(fromLeft)">
                     <p:cBhvr>
-                      <p:cTn id="7" dur="300" fill="hold"/>
+                      <p:cTn id="9" dur="300" fill="hold"/>
                       <p:tgtEl>
                         <p:spTgt spid="12">
                           <p:txEl>
@@ -19070,14 +20036,14 @@
               </p:cTn>
             </p:par>
             <p:par>
-              <p:cTn id="8" fill="hold" nodeType="afterEffect">
+              <p:cTn id="11" fill="hold" nodeType="afterEffect">
                 <p:stCondLst>
                   <p:cond delay="940"/>
                 </p:stCondLst>
                 <p:childTnLst>
-                  <p:animEffect transition="in" filter="fade">
+                  <p:animEffect transition="in" filter="wipe(fromLeft)">
                     <p:cBhvr>
-                      <p:cTn id="9" dur="300" fill="hold"/>
+                      <p:cTn id="12" dur="300" fill="hold"/>
                       <p:tgtEl>
                         <p:spTgt spid="12">
                           <p:txEl>
@@ -19091,14 +20057,14 @@
               </p:cTn>
             </p:par>
             <p:par>
-              <p:cTn id="10" fill="hold" nodeType="afterEffect">
+              <p:cTn id="14" fill="hold" nodeType="afterEffect">
                 <p:stCondLst>
                   <p:cond delay="1110"/>
                 </p:stCondLst>
                 <p:childTnLst>
-                  <p:animEffect transition="in" filter="fade">
+                  <p:animEffect transition="in" filter="wipe(fromLeft)">
                     <p:cBhvr>
-                      <p:cTn id="11" dur="300" fill="hold"/>
+                      <p:cTn id="15" dur="300" fill="hold"/>
                       <p:tgtEl>
                         <p:spTgt spid="12">
                           <p:txEl>
@@ -19112,14 +20078,14 @@
               </p:cTn>
             </p:par>
             <p:par>
-              <p:cTn id="12" fill="hold" nodeType="afterEffect">
+              <p:cTn id="17" fill="hold" nodeType="afterEffect">
                 <p:stCondLst>
                   <p:cond delay="1280"/>
                 </p:stCondLst>
                 <p:childTnLst>
-                  <p:animEffect transition="in" filter="fade">
+                  <p:animEffect transition="in" filter="wipe(fromLeft)">
                     <p:cBhvr>
-                      <p:cTn id="13" dur="300" fill="hold"/>
+                      <p:cTn id="18" dur="300" fill="hold"/>
                       <p:tgtEl>
                         <p:spTgt spid="12">
                           <p:txEl>
@@ -19133,14 +20099,14 @@
               </p:cTn>
             </p:par>
             <p:par>
-              <p:cTn id="14" fill="hold" nodeType="afterEffect">
+              <p:cTn id="20" fill="hold" nodeType="afterEffect">
                 <p:stCondLst>
                   <p:cond delay="1450"/>
                 </p:stCondLst>
                 <p:childTnLst>
                   <p:animEffect transition="in" filter="fade">
                     <p:cBhvr>
-                      <p:cTn id="15" dur="350" fill="hold"/>
+                      <p:cTn id="21" dur="350" fill="hold"/>
                       <p:tgtEl>
                         <p:spTgt spid="13"/>
                       </p:tgtEl>
@@ -19150,14 +20116,14 @@
               </p:cTn>
             </p:par>
             <p:par>
-              <p:cTn id="16" fill="hold" nodeType="afterEffect">
+              <p:cTn id="23" fill="hold" nodeType="afterEffect">
                 <p:stCondLst>
                   <p:cond delay="1660"/>
                 </p:stCondLst>
                 <p:childTnLst>
-                  <p:animEffect transition="in" filter="fade">
+                  <p:animEffect transition="in" filter="wipe(fromLeft)">
                     <p:cBhvr>
-                      <p:cTn id="17" dur="300" fill="hold"/>
+                      <p:cTn id="24" dur="300" fill="hold"/>
                       <p:tgtEl>
                         <p:spTgt spid="14">
                           <p:txEl>
@@ -19171,14 +20137,14 @@
               </p:cTn>
             </p:par>
             <p:par>
-              <p:cTn id="18" fill="hold" nodeType="afterEffect">
+              <p:cTn id="26" fill="hold" nodeType="afterEffect">
                 <p:stCondLst>
                   <p:cond delay="1830"/>
                 </p:stCondLst>
                 <p:childTnLst>
-                  <p:animEffect transition="in" filter="fade">
+                  <p:animEffect transition="in" filter="wipe(fromLeft)">
                     <p:cBhvr>
-                      <p:cTn id="19" dur="300" fill="hold"/>
+                      <p:cTn id="27" dur="300" fill="hold"/>
                       <p:tgtEl>
                         <p:spTgt spid="14">
                           <p:txEl>
@@ -19192,14 +20158,14 @@
               </p:cTn>
             </p:par>
             <p:par>
-              <p:cTn id="20" fill="hold" nodeType="afterEffect">
+              <p:cTn id="29" fill="hold" nodeType="afterEffect">
                 <p:stCondLst>
                   <p:cond delay="2000"/>
                 </p:stCondLst>
                 <p:childTnLst>
-                  <p:animEffect transition="in" filter="fade">
+                  <p:animEffect transition="in" filter="wipe(fromLeft)">
                     <p:cBhvr>
-                      <p:cTn id="21" dur="300" fill="hold"/>
+                      <p:cTn id="30" dur="300" fill="hold"/>
                       <p:tgtEl>
                         <p:spTgt spid="14">
                           <p:txEl>
@@ -19213,14 +20179,14 @@
               </p:cTn>
             </p:par>
             <p:par>
-              <p:cTn id="22" fill="hold" nodeType="afterEffect">
+              <p:cTn id="32" fill="hold" nodeType="afterEffect">
                 <p:stCondLst>
                   <p:cond delay="2170"/>
                 </p:stCondLst>
                 <p:childTnLst>
-                  <p:animEffect transition="in" filter="fade">
+                  <p:animEffect transition="in" filter="wipe(fromLeft)">
                     <p:cBhvr>
-                      <p:cTn id="23" dur="300" fill="hold"/>
+                      <p:cTn id="33" dur="300" fill="hold"/>
                       <p:tgtEl>
                         <p:spTgt spid="14">
                           <p:txEl>

</xml_diff>

<commit_message>
Add Keynote-friendly presentation variant
Co-authored-by: M0ntecia <M0ntecia@users.noreply.github.com>
</commit_message>
<xml_diff>
--- a/praesentation/schule_wohlbefinden_praesentation.pptx
+++ b/praesentation/schule_wohlbefinden_praesentation.pptx
@@ -3699,14 +3699,28 @@
           </p:stCondLst>
           <p:childTnLst>
             <p:par>
-              <p:cTn id="2" fill="hold" nodeType="afterEffect">
+              <p:cTn id="2" fill="hold" nodeType="afterEffect" presetID="10" presetClass="entr" presetSubtype="0">
                 <p:stCondLst>
                   <p:cond delay="0"/>
                 </p:stCondLst>
                 <p:childTnLst>
+                  <p:set>
+                    <p:cBhvr>
+                      <p:cTn id="3" dur="1" fill="hold"/>
+                      <p:tgtEl>
+                        <p:spTgt spid="10"/>
+                      </p:tgtEl>
+                      <p:attrNameLst>
+                        <p:attrName>style.visibility</p:attrName>
+                      </p:attrNameLst>
+                    </p:cBhvr>
+                    <p:to>
+                      <p:strVal val="visible"/>
+                    </p:to>
+                  </p:set>
                   <p:animEffect transition="in" filter="fade">
                     <p:cBhvr>
-                      <p:cTn id="3" dur="500" fill="hold"/>
+                      <p:cTn id="4" dur="500" fill="hold"/>
                       <p:tgtEl>
                         <p:spTgt spid="10"/>
                       </p:tgtEl>
@@ -3716,14 +3730,28 @@
               </p:cTn>
             </p:par>
             <p:par>
-              <p:cTn id="5" fill="hold" nodeType="afterEffect">
+              <p:cTn id="6" fill="hold" nodeType="afterEffect" presetID="2819" presetClass="entr" presetSubtype="0">
                 <p:stCondLst>
                   <p:cond delay="560"/>
                 </p:stCondLst>
                 <p:childTnLst>
-                  <p:animEffect transition="in" filter="wipe(fromLeft)">
-                    <p:cBhvr>
-                      <p:cTn id="6" dur="450" fill="hold"/>
+                  <p:set>
+                    <p:cBhvr>
+                      <p:cTn id="7" dur="1" fill="hold"/>
+                      <p:tgtEl>
+                        <p:spTgt spid="11"/>
+                      </p:tgtEl>
+                      <p:attrNameLst>
+                        <p:attrName>style.visibility</p:attrName>
+                      </p:attrNameLst>
+                    </p:cBhvr>
+                    <p:to>
+                      <p:strVal val="visible"/>
+                    </p:to>
+                  </p:set>
+                  <p:animEffect transition="in" filter="wipe(right)">
+                    <p:cBhvr>
+                      <p:cTn id="8" dur="450" fill="hold"/>
                       <p:tgtEl>
                         <p:spTgt spid="11"/>
                       </p:tgtEl>
@@ -3733,14 +3761,28 @@
               </p:cTn>
             </p:par>
             <p:par>
-              <p:cTn id="8" fill="hold" nodeType="afterEffect">
+              <p:cTn id="10" fill="hold" nodeType="afterEffect" presetID="10" presetClass="entr" presetSubtype="0">
                 <p:stCondLst>
                   <p:cond delay="840"/>
                 </p:stCondLst>
                 <p:childTnLst>
+                  <p:set>
+                    <p:cBhvr>
+                      <p:cTn id="11" dur="1" fill="hold"/>
+                      <p:tgtEl>
+                        <p:spTgt spid="12"/>
+                      </p:tgtEl>
+                      <p:attrNameLst>
+                        <p:attrName>style.visibility</p:attrName>
+                      </p:attrNameLst>
+                    </p:cBhvr>
+                    <p:to>
+                      <p:strVal val="visible"/>
+                    </p:to>
+                  </p:set>
                   <p:animEffect transition="in" filter="fade">
                     <p:cBhvr>
-                      <p:cTn id="9" dur="450" fill="hold"/>
+                      <p:cTn id="12" dur="450" fill="hold"/>
                       <p:tgtEl>
                         <p:spTgt spid="12"/>
                       </p:tgtEl>
@@ -3750,14 +3792,28 @@
               </p:cTn>
             </p:par>
             <p:par>
-              <p:cTn id="11" fill="hold" nodeType="afterEffect">
+              <p:cTn id="14" fill="hold" nodeType="afterEffect" presetID="10" presetClass="entr" presetSubtype="0">
                 <p:stCondLst>
                   <p:cond delay="1120"/>
                 </p:stCondLst>
                 <p:childTnLst>
+                  <p:set>
+                    <p:cBhvr>
+                      <p:cTn id="15" dur="1" fill="hold"/>
+                      <p:tgtEl>
+                        <p:spTgt spid="13"/>
+                      </p:tgtEl>
+                      <p:attrNameLst>
+                        <p:attrName>style.visibility</p:attrName>
+                      </p:attrNameLst>
+                    </p:cBhvr>
+                    <p:to>
+                      <p:strVal val="visible"/>
+                    </p:to>
+                  </p:set>
                   <p:animEffect transition="in" filter="fade">
                     <p:cBhvr>
-                      <p:cTn id="12" dur="450" fill="hold"/>
+                      <p:cTn id="16" dur="450" fill="hold"/>
                       <p:tgtEl>
                         <p:spTgt spid="13"/>
                       </p:tgtEl>
@@ -4689,14 +4745,28 @@
           </p:stCondLst>
           <p:childTnLst>
             <p:par>
-              <p:cTn id="2" fill="hold" nodeType="afterEffect">
+              <p:cTn id="2" fill="hold" nodeType="afterEffect" presetID="10" presetClass="entr" presetSubtype="0">
                 <p:stCondLst>
                   <p:cond delay="0"/>
                 </p:stCondLst>
                 <p:childTnLst>
+                  <p:set>
+                    <p:cBhvr>
+                      <p:cTn id="3" dur="1" fill="hold"/>
+                      <p:tgtEl>
+                        <p:spTgt spid="8"/>
+                      </p:tgtEl>
+                      <p:attrNameLst>
+                        <p:attrName>style.visibility</p:attrName>
+                      </p:attrNameLst>
+                    </p:cBhvr>
+                    <p:to>
+                      <p:strVal val="visible"/>
+                    </p:to>
+                  </p:set>
                   <p:animEffect transition="in" filter="fade">
                     <p:cBhvr>
-                      <p:cTn id="3" dur="500" fill="hold"/>
+                      <p:cTn id="4" dur="500" fill="hold"/>
                       <p:tgtEl>
                         <p:spTgt spid="8"/>
                       </p:tgtEl>
@@ -4706,14 +4776,28 @@
               </p:cTn>
             </p:par>
             <p:par>
-              <p:cTn id="5" fill="hold" nodeType="afterEffect">
+              <p:cTn id="6" fill="hold" nodeType="afterEffect" presetID="22" presetClass="entr" presetSubtype="0">
                 <p:stCondLst>
                   <p:cond delay="560"/>
                 </p:stCondLst>
                 <p:childTnLst>
+                  <p:set>
+                    <p:cBhvr>
+                      <p:cTn id="7" dur="1" fill="hold"/>
+                      <p:tgtEl>
+                        <p:spTgt spid="11"/>
+                      </p:tgtEl>
+                      <p:attrNameLst>
+                        <p:attrName>style.visibility</p:attrName>
+                      </p:attrNameLst>
+                    </p:cBhvr>
+                    <p:to>
+                      <p:strVal val="visible"/>
+                    </p:to>
+                  </p:set>
                   <p:animEffect transition="in" filter="fade">
                     <p:cBhvr>
-                      <p:cTn id="6" dur="430" fill="hold"/>
+                      <p:cTn id="8" dur="430" fill="hold"/>
                       <p:tgtEl>
                         <p:spTgt spid="11"/>
                       </p:tgtEl>
@@ -4721,7 +4805,7 @@
                   </p:animEffect>
                   <p:animScale>
                     <p:cBhvr>
-                      <p:cTn id="7" dur="430" fill="hold"/>
+                      <p:cTn id="9" dur="430" fill="hold"/>
                       <p:tgtEl>
                         <p:spTgt spid="11"/>
                       </p:tgtEl>
@@ -4737,14 +4821,28 @@
               </p:cTn>
             </p:par>
             <p:par>
-              <p:cTn id="8" fill="hold" nodeType="withEffect">
+              <p:cTn id="10" fill="hold" nodeType="withEffect" presetID="22" presetClass="entr" presetSubtype="0">
                 <p:stCondLst>
                   <p:cond delay="560"/>
                 </p:stCondLst>
                 <p:childTnLst>
+                  <p:set>
+                    <p:cBhvr>
+                      <p:cTn id="11" dur="1" fill="hold"/>
+                      <p:tgtEl>
+                        <p:spTgt spid="12"/>
+                      </p:tgtEl>
+                      <p:attrNameLst>
+                        <p:attrName>style.visibility</p:attrName>
+                      </p:attrNameLst>
+                    </p:cBhvr>
+                    <p:to>
+                      <p:strVal val="visible"/>
+                    </p:to>
+                  </p:set>
                   <p:animEffect transition="in" filter="fade">
                     <p:cBhvr>
-                      <p:cTn id="9" dur="430" fill="hold"/>
+                      <p:cTn id="12" dur="430" fill="hold"/>
                       <p:tgtEl>
                         <p:spTgt spid="12"/>
                       </p:tgtEl>
@@ -4752,7 +4850,7 @@
                   </p:animEffect>
                   <p:animScale>
                     <p:cBhvr>
-                      <p:cTn id="10" dur="430" fill="hold"/>
+                      <p:cTn id="13" dur="430" fill="hold"/>
                       <p:tgtEl>
                         <p:spTgt spid="12"/>
                       </p:tgtEl>
@@ -4768,14 +4866,28 @@
               </p:cTn>
             </p:par>
             <p:par>
-              <p:cTn id="11" fill="hold" nodeType="afterEffect">
+              <p:cTn id="14" fill="hold" nodeType="afterEffect" presetID="22" presetClass="entr" presetSubtype="0">
                 <p:stCondLst>
                   <p:cond delay="830"/>
                 </p:stCondLst>
                 <p:childTnLst>
+                  <p:set>
+                    <p:cBhvr>
+                      <p:cTn id="15" dur="1" fill="hold"/>
+                      <p:tgtEl>
+                        <p:spTgt spid="15"/>
+                      </p:tgtEl>
+                      <p:attrNameLst>
+                        <p:attrName>style.visibility</p:attrName>
+                      </p:attrNameLst>
+                    </p:cBhvr>
+                    <p:to>
+                      <p:strVal val="visible"/>
+                    </p:to>
+                  </p:set>
                   <p:animEffect transition="in" filter="fade">
                     <p:cBhvr>
-                      <p:cTn id="12" dur="430" fill="hold"/>
+                      <p:cTn id="16" dur="430" fill="hold"/>
                       <p:tgtEl>
                         <p:spTgt spid="15"/>
                       </p:tgtEl>
@@ -4783,7 +4895,7 @@
                   </p:animEffect>
                   <p:animScale>
                     <p:cBhvr>
-                      <p:cTn id="13" dur="430" fill="hold"/>
+                      <p:cTn id="17" dur="430" fill="hold"/>
                       <p:tgtEl>
                         <p:spTgt spid="15"/>
                       </p:tgtEl>
@@ -4799,14 +4911,28 @@
               </p:cTn>
             </p:par>
             <p:par>
-              <p:cTn id="14" fill="hold" nodeType="withEffect">
+              <p:cTn id="18" fill="hold" nodeType="withEffect" presetID="22" presetClass="entr" presetSubtype="0">
                 <p:stCondLst>
                   <p:cond delay="830"/>
                 </p:stCondLst>
                 <p:childTnLst>
+                  <p:set>
+                    <p:cBhvr>
+                      <p:cTn id="19" dur="1" fill="hold"/>
+                      <p:tgtEl>
+                        <p:spTgt spid="16"/>
+                      </p:tgtEl>
+                      <p:attrNameLst>
+                        <p:attrName>style.visibility</p:attrName>
+                      </p:attrNameLst>
+                    </p:cBhvr>
+                    <p:to>
+                      <p:strVal val="visible"/>
+                    </p:to>
+                  </p:set>
                   <p:animEffect transition="in" filter="fade">
                     <p:cBhvr>
-                      <p:cTn id="15" dur="430" fill="hold"/>
+                      <p:cTn id="20" dur="430" fill="hold"/>
                       <p:tgtEl>
                         <p:spTgt spid="16"/>
                       </p:tgtEl>
@@ -4814,7 +4940,7 @@
                   </p:animEffect>
                   <p:animScale>
                     <p:cBhvr>
-                      <p:cTn id="16" dur="430" fill="hold"/>
+                      <p:cTn id="21" dur="430" fill="hold"/>
                       <p:tgtEl>
                         <p:spTgt spid="16"/>
                       </p:tgtEl>
@@ -4830,14 +4956,28 @@
               </p:cTn>
             </p:par>
             <p:par>
-              <p:cTn id="17" fill="hold" nodeType="afterEffect">
+              <p:cTn id="22" fill="hold" nodeType="afterEffect" presetID="22" presetClass="entr" presetSubtype="0">
                 <p:stCondLst>
                   <p:cond delay="1100"/>
                 </p:stCondLst>
                 <p:childTnLst>
+                  <p:set>
+                    <p:cBhvr>
+                      <p:cTn id="23" dur="1" fill="hold"/>
+                      <p:tgtEl>
+                        <p:spTgt spid="19"/>
+                      </p:tgtEl>
+                      <p:attrNameLst>
+                        <p:attrName>style.visibility</p:attrName>
+                      </p:attrNameLst>
+                    </p:cBhvr>
+                    <p:to>
+                      <p:strVal val="visible"/>
+                    </p:to>
+                  </p:set>
                   <p:animEffect transition="in" filter="fade">
                     <p:cBhvr>
-                      <p:cTn id="18" dur="430" fill="hold"/>
+                      <p:cTn id="24" dur="430" fill="hold"/>
                       <p:tgtEl>
                         <p:spTgt spid="19"/>
                       </p:tgtEl>
@@ -4845,7 +4985,7 @@
                   </p:animEffect>
                   <p:animScale>
                     <p:cBhvr>
-                      <p:cTn id="19" dur="430" fill="hold"/>
+                      <p:cTn id="25" dur="430" fill="hold"/>
                       <p:tgtEl>
                         <p:spTgt spid="19"/>
                       </p:tgtEl>
@@ -4861,14 +5001,28 @@
               </p:cTn>
             </p:par>
             <p:par>
-              <p:cTn id="20" fill="hold" nodeType="withEffect">
+              <p:cTn id="26" fill="hold" nodeType="withEffect" presetID="22" presetClass="entr" presetSubtype="0">
                 <p:stCondLst>
                   <p:cond delay="1100"/>
                 </p:stCondLst>
                 <p:childTnLst>
+                  <p:set>
+                    <p:cBhvr>
+                      <p:cTn id="27" dur="1" fill="hold"/>
+                      <p:tgtEl>
+                        <p:spTgt spid="20"/>
+                      </p:tgtEl>
+                      <p:attrNameLst>
+                        <p:attrName>style.visibility</p:attrName>
+                      </p:attrNameLst>
+                    </p:cBhvr>
+                    <p:to>
+                      <p:strVal val="visible"/>
+                    </p:to>
+                  </p:set>
                   <p:animEffect transition="in" filter="fade">
                     <p:cBhvr>
-                      <p:cTn id="21" dur="430" fill="hold"/>
+                      <p:cTn id="28" dur="430" fill="hold"/>
                       <p:tgtEl>
                         <p:spTgt spid="20"/>
                       </p:tgtEl>
@@ -4876,7 +5030,7 @@
                   </p:animEffect>
                   <p:animScale>
                     <p:cBhvr>
-                      <p:cTn id="22" dur="430" fill="hold"/>
+                      <p:cTn id="29" dur="430" fill="hold"/>
                       <p:tgtEl>
                         <p:spTgt spid="20"/>
                       </p:tgtEl>
@@ -5920,14 +6074,28 @@
           </p:stCondLst>
           <p:childTnLst>
             <p:par>
-              <p:cTn id="2" fill="hold" nodeType="afterEffect">
+              <p:cTn id="2" fill="hold" nodeType="afterEffect" presetID="10" presetClass="entr" presetSubtype="0">
                 <p:stCondLst>
                   <p:cond delay="0"/>
                 </p:stCondLst>
                 <p:childTnLst>
+                  <p:set>
+                    <p:cBhvr>
+                      <p:cTn id="3" dur="1" fill="hold"/>
+                      <p:tgtEl>
+                        <p:spTgt spid="8"/>
+                      </p:tgtEl>
+                      <p:attrNameLst>
+                        <p:attrName>style.visibility</p:attrName>
+                      </p:attrNameLst>
+                    </p:cBhvr>
+                    <p:to>
+                      <p:strVal val="visible"/>
+                    </p:to>
+                  </p:set>
                   <p:animEffect transition="in" filter="fade">
                     <p:cBhvr>
-                      <p:cTn id="3" dur="500" fill="hold"/>
+                      <p:cTn id="4" dur="500" fill="hold"/>
                       <p:tgtEl>
                         <p:spTgt spid="8"/>
                       </p:tgtEl>
@@ -5937,14 +6105,28 @@
               </p:cTn>
             </p:par>
             <p:par>
-              <p:cTn id="5" fill="hold" nodeType="afterEffect">
+              <p:cTn id="6" fill="hold" nodeType="afterEffect" presetID="22" presetClass="entr" presetSubtype="0">
                 <p:stCondLst>
                   <p:cond delay="560"/>
                 </p:stCondLst>
                 <p:childTnLst>
+                  <p:set>
+                    <p:cBhvr>
+                      <p:cTn id="7" dur="1" fill="hold"/>
+                      <p:tgtEl>
+                        <p:spTgt spid="11"/>
+                      </p:tgtEl>
+                      <p:attrNameLst>
+                        <p:attrName>style.visibility</p:attrName>
+                      </p:attrNameLst>
+                    </p:cBhvr>
+                    <p:to>
+                      <p:strVal val="visible"/>
+                    </p:to>
+                  </p:set>
                   <p:animEffect transition="in" filter="fade">
                     <p:cBhvr>
-                      <p:cTn id="6" dur="430" fill="hold"/>
+                      <p:cTn id="8" dur="430" fill="hold"/>
                       <p:tgtEl>
                         <p:spTgt spid="11"/>
                       </p:tgtEl>
@@ -5952,7 +6134,7 @@
                   </p:animEffect>
                   <p:animScale>
                     <p:cBhvr>
-                      <p:cTn id="7" dur="430" fill="hold"/>
+                      <p:cTn id="9" dur="430" fill="hold"/>
                       <p:tgtEl>
                         <p:spTgt spid="11"/>
                       </p:tgtEl>
@@ -5968,14 +6150,28 @@
               </p:cTn>
             </p:par>
             <p:par>
-              <p:cTn id="8" fill="hold" nodeType="withEffect">
+              <p:cTn id="10" fill="hold" nodeType="withEffect" presetID="22" presetClass="entr" presetSubtype="0">
                 <p:stCondLst>
                   <p:cond delay="560"/>
                 </p:stCondLst>
                 <p:childTnLst>
+                  <p:set>
+                    <p:cBhvr>
+                      <p:cTn id="11" dur="1" fill="hold"/>
+                      <p:tgtEl>
+                        <p:spTgt spid="12"/>
+                      </p:tgtEl>
+                      <p:attrNameLst>
+                        <p:attrName>style.visibility</p:attrName>
+                      </p:attrNameLst>
+                    </p:cBhvr>
+                    <p:to>
+                      <p:strVal val="visible"/>
+                    </p:to>
+                  </p:set>
                   <p:animEffect transition="in" filter="fade">
                     <p:cBhvr>
-                      <p:cTn id="9" dur="430" fill="hold"/>
+                      <p:cTn id="12" dur="430" fill="hold"/>
                       <p:tgtEl>
                         <p:spTgt spid="12"/>
                       </p:tgtEl>
@@ -5983,7 +6179,7 @@
                   </p:animEffect>
                   <p:animScale>
                     <p:cBhvr>
-                      <p:cTn id="10" dur="430" fill="hold"/>
+                      <p:cTn id="13" dur="430" fill="hold"/>
                       <p:tgtEl>
                         <p:spTgt spid="12"/>
                       </p:tgtEl>
@@ -5999,14 +6195,28 @@
               </p:cTn>
             </p:par>
             <p:par>
-              <p:cTn id="11" fill="hold" nodeType="afterEffect">
+              <p:cTn id="14" fill="hold" nodeType="afterEffect" presetID="22" presetClass="entr" presetSubtype="0">
                 <p:stCondLst>
                   <p:cond delay="830"/>
                 </p:stCondLst>
                 <p:childTnLst>
+                  <p:set>
+                    <p:cBhvr>
+                      <p:cTn id="15" dur="1" fill="hold"/>
+                      <p:tgtEl>
+                        <p:spTgt spid="15"/>
+                      </p:tgtEl>
+                      <p:attrNameLst>
+                        <p:attrName>style.visibility</p:attrName>
+                      </p:attrNameLst>
+                    </p:cBhvr>
+                    <p:to>
+                      <p:strVal val="visible"/>
+                    </p:to>
+                  </p:set>
                   <p:animEffect transition="in" filter="fade">
                     <p:cBhvr>
-                      <p:cTn id="12" dur="430" fill="hold"/>
+                      <p:cTn id="16" dur="430" fill="hold"/>
                       <p:tgtEl>
                         <p:spTgt spid="15"/>
                       </p:tgtEl>
@@ -6014,7 +6224,7 @@
                   </p:animEffect>
                   <p:animScale>
                     <p:cBhvr>
-                      <p:cTn id="13" dur="430" fill="hold"/>
+                      <p:cTn id="17" dur="430" fill="hold"/>
                       <p:tgtEl>
                         <p:spTgt spid="15"/>
                       </p:tgtEl>
@@ -6030,14 +6240,28 @@
               </p:cTn>
             </p:par>
             <p:par>
-              <p:cTn id="14" fill="hold" nodeType="withEffect">
+              <p:cTn id="18" fill="hold" nodeType="withEffect" presetID="22" presetClass="entr" presetSubtype="0">
                 <p:stCondLst>
                   <p:cond delay="830"/>
                 </p:stCondLst>
                 <p:childTnLst>
+                  <p:set>
+                    <p:cBhvr>
+                      <p:cTn id="19" dur="1" fill="hold"/>
+                      <p:tgtEl>
+                        <p:spTgt spid="16"/>
+                      </p:tgtEl>
+                      <p:attrNameLst>
+                        <p:attrName>style.visibility</p:attrName>
+                      </p:attrNameLst>
+                    </p:cBhvr>
+                    <p:to>
+                      <p:strVal val="visible"/>
+                    </p:to>
+                  </p:set>
                   <p:animEffect transition="in" filter="fade">
                     <p:cBhvr>
-                      <p:cTn id="15" dur="430" fill="hold"/>
+                      <p:cTn id="20" dur="430" fill="hold"/>
                       <p:tgtEl>
                         <p:spTgt spid="16"/>
                       </p:tgtEl>
@@ -6045,7 +6269,7 @@
                   </p:animEffect>
                   <p:animScale>
                     <p:cBhvr>
-                      <p:cTn id="16" dur="430" fill="hold"/>
+                      <p:cTn id="21" dur="430" fill="hold"/>
                       <p:tgtEl>
                         <p:spTgt spid="16"/>
                       </p:tgtEl>
@@ -6061,14 +6285,28 @@
               </p:cTn>
             </p:par>
             <p:par>
-              <p:cTn id="17" fill="hold" nodeType="afterEffect">
+              <p:cTn id="22" fill="hold" nodeType="afterEffect" presetID="22" presetClass="entr" presetSubtype="0">
                 <p:stCondLst>
                   <p:cond delay="1100"/>
                 </p:stCondLst>
                 <p:childTnLst>
+                  <p:set>
+                    <p:cBhvr>
+                      <p:cTn id="23" dur="1" fill="hold"/>
+                      <p:tgtEl>
+                        <p:spTgt spid="19"/>
+                      </p:tgtEl>
+                      <p:attrNameLst>
+                        <p:attrName>style.visibility</p:attrName>
+                      </p:attrNameLst>
+                    </p:cBhvr>
+                    <p:to>
+                      <p:strVal val="visible"/>
+                    </p:to>
+                  </p:set>
                   <p:animEffect transition="in" filter="fade">
                     <p:cBhvr>
-                      <p:cTn id="18" dur="430" fill="hold"/>
+                      <p:cTn id="24" dur="430" fill="hold"/>
                       <p:tgtEl>
                         <p:spTgt spid="19"/>
                       </p:tgtEl>
@@ -6076,7 +6314,7 @@
                   </p:animEffect>
                   <p:animScale>
                     <p:cBhvr>
-                      <p:cTn id="19" dur="430" fill="hold"/>
+                      <p:cTn id="25" dur="430" fill="hold"/>
                       <p:tgtEl>
                         <p:spTgt spid="19"/>
                       </p:tgtEl>
@@ -6092,14 +6330,28 @@
               </p:cTn>
             </p:par>
             <p:par>
-              <p:cTn id="20" fill="hold" nodeType="withEffect">
+              <p:cTn id="26" fill="hold" nodeType="withEffect" presetID="22" presetClass="entr" presetSubtype="0">
                 <p:stCondLst>
                   <p:cond delay="1100"/>
                 </p:stCondLst>
                 <p:childTnLst>
+                  <p:set>
+                    <p:cBhvr>
+                      <p:cTn id="27" dur="1" fill="hold"/>
+                      <p:tgtEl>
+                        <p:spTgt spid="20"/>
+                      </p:tgtEl>
+                      <p:attrNameLst>
+                        <p:attrName>style.visibility</p:attrName>
+                      </p:attrNameLst>
+                    </p:cBhvr>
+                    <p:to>
+                      <p:strVal val="visible"/>
+                    </p:to>
+                  </p:set>
                   <p:animEffect transition="in" filter="fade">
                     <p:cBhvr>
-                      <p:cTn id="21" dur="430" fill="hold"/>
+                      <p:cTn id="28" dur="430" fill="hold"/>
                       <p:tgtEl>
                         <p:spTgt spid="20"/>
                       </p:tgtEl>
@@ -6107,7 +6359,7 @@
                   </p:animEffect>
                   <p:animScale>
                     <p:cBhvr>
-                      <p:cTn id="22" dur="430" fill="hold"/>
+                      <p:cTn id="29" dur="430" fill="hold"/>
                       <p:tgtEl>
                         <p:spTgt spid="20"/>
                       </p:tgtEl>
@@ -6123,14 +6375,28 @@
               </p:cTn>
             </p:par>
             <p:par>
-              <p:cTn id="23" fill="hold" nodeType="afterEffect">
+              <p:cTn id="30" fill="hold" nodeType="afterEffect" presetID="10" presetClass="entr" presetSubtype="0">
                 <p:stCondLst>
                   <p:cond delay="1380"/>
                 </p:stCondLst>
                 <p:childTnLst>
+                  <p:set>
+                    <p:cBhvr>
+                      <p:cTn id="31" dur="1" fill="hold"/>
+                      <p:tgtEl>
+                        <p:spTgt spid="21"/>
+                      </p:tgtEl>
+                      <p:attrNameLst>
+                        <p:attrName>style.visibility</p:attrName>
+                      </p:attrNameLst>
+                    </p:cBhvr>
+                    <p:to>
+                      <p:strVal val="visible"/>
+                    </p:to>
+                  </p:set>
                   <p:animEffect transition="in" filter="fade">
                     <p:cBhvr>
-                      <p:cTn id="24" dur="340" fill="hold"/>
+                      <p:cTn id="32" dur="340" fill="hold"/>
                       <p:tgtEl>
                         <p:spTgt spid="21"/>
                       </p:tgtEl>
@@ -6140,14 +6406,14 @@
               </p:cTn>
             </p:par>
             <p:par>
-              <p:cTn id="26" fill="hold" nodeType="afterEffect">
+              <p:cTn id="34" fill="hold" nodeType="afterEffect" presetID="2819" presetClass="entr" presetSubtype="0">
                 <p:stCondLst>
                   <p:cond delay="1610"/>
                 </p:stCondLst>
                 <p:childTnLst>
-                  <p:animEffect transition="in" filter="wipe(fromLeft)">
-                    <p:cBhvr>
-                      <p:cTn id="27" dur="300" fill="hold"/>
+                  <p:set>
+                    <p:cBhvr>
+                      <p:cTn id="35" dur="1" fill="hold"/>
                       <p:tgtEl>
                         <p:spTgt spid="22">
                           <p:txEl>
@@ -6155,20 +6421,38 @@
                           </p:txEl>
                         </p:spTgt>
                       </p:tgtEl>
+                      <p:attrNameLst>
+                        <p:attrName>style.visibility</p:attrName>
+                      </p:attrNameLst>
+                    </p:cBhvr>
+                    <p:to>
+                      <p:strVal val="visible"/>
+                    </p:to>
+                  </p:set>
+                  <p:animEffect transition="in" filter="wipe(right)">
+                    <p:cBhvr>
+                      <p:cTn id="36" dur="300" fill="hold"/>
+                      <p:tgtEl>
+                        <p:spTgt spid="22">
+                          <p:txEl>
+                            <p:pRg st="0" end="0"/>
+                          </p:txEl>
+                        </p:spTgt>
+                      </p:tgtEl>
                     </p:cBhvr>
                   </p:animEffect>
                 </p:childTnLst>
               </p:cTn>
             </p:par>
             <p:par>
-              <p:cTn id="29" fill="hold" nodeType="afterEffect">
+              <p:cTn id="38" fill="hold" nodeType="afterEffect" presetID="2819" presetClass="entr" presetSubtype="0">
                 <p:stCondLst>
                   <p:cond delay="1820"/>
                 </p:stCondLst>
                 <p:childTnLst>
-                  <p:animEffect transition="in" filter="wipe(fromLeft)">
-                    <p:cBhvr>
-                      <p:cTn id="30" dur="300" fill="hold"/>
+                  <p:set>
+                    <p:cBhvr>
+                      <p:cTn id="39" dur="1" fill="hold"/>
                       <p:tgtEl>
                         <p:spTgt spid="22">
                           <p:txEl>
@@ -6176,20 +6460,56 @@
                           </p:txEl>
                         </p:spTgt>
                       </p:tgtEl>
+                      <p:attrNameLst>
+                        <p:attrName>style.visibility</p:attrName>
+                      </p:attrNameLst>
+                    </p:cBhvr>
+                    <p:to>
+                      <p:strVal val="visible"/>
+                    </p:to>
+                  </p:set>
+                  <p:animEffect transition="in" filter="wipe(right)">
+                    <p:cBhvr>
+                      <p:cTn id="40" dur="300" fill="hold"/>
+                      <p:tgtEl>
+                        <p:spTgt spid="22">
+                          <p:txEl>
+                            <p:pRg st="1" end="1"/>
+                          </p:txEl>
+                        </p:spTgt>
+                      </p:tgtEl>
                     </p:cBhvr>
                   </p:animEffect>
                 </p:childTnLst>
               </p:cTn>
             </p:par>
             <p:par>
-              <p:cTn id="32" fill="hold" nodeType="afterEffect">
+              <p:cTn id="42" fill="hold" nodeType="afterEffect" presetID="2819" presetClass="entr" presetSubtype="0">
                 <p:stCondLst>
                   <p:cond delay="2030"/>
                 </p:stCondLst>
                 <p:childTnLst>
-                  <p:animEffect transition="in" filter="wipe(fromLeft)">
-                    <p:cBhvr>
-                      <p:cTn id="33" dur="300" fill="hold"/>
+                  <p:set>
+                    <p:cBhvr>
+                      <p:cTn id="43" dur="1" fill="hold"/>
+                      <p:tgtEl>
+                        <p:spTgt spid="22">
+                          <p:txEl>
+                            <p:pRg st="2" end="2"/>
+                          </p:txEl>
+                        </p:spTgt>
+                      </p:tgtEl>
+                      <p:attrNameLst>
+                        <p:attrName>style.visibility</p:attrName>
+                      </p:attrNameLst>
+                    </p:cBhvr>
+                    <p:to>
+                      <p:strVal val="visible"/>
+                    </p:to>
+                  </p:set>
+                  <p:animEffect transition="in" filter="wipe(right)">
+                    <p:cBhvr>
+                      <p:cTn id="44" dur="300" fill="hold"/>
                       <p:tgtEl>
                         <p:spTgt spid="22">
                           <p:txEl>
@@ -6970,14 +7290,28 @@
           </p:stCondLst>
           <p:childTnLst>
             <p:par>
-              <p:cTn id="2" fill="hold" nodeType="afterEffect">
+              <p:cTn id="2" fill="hold" nodeType="afterEffect" presetID="10" presetClass="entr" presetSubtype="0">
                 <p:stCondLst>
                   <p:cond delay="0"/>
                 </p:stCondLst>
                 <p:childTnLst>
+                  <p:set>
+                    <p:cBhvr>
+                      <p:cTn id="3" dur="1" fill="hold"/>
+                      <p:tgtEl>
+                        <p:spTgt spid="8"/>
+                      </p:tgtEl>
+                      <p:attrNameLst>
+                        <p:attrName>style.visibility</p:attrName>
+                      </p:attrNameLst>
+                    </p:cBhvr>
+                    <p:to>
+                      <p:strVal val="visible"/>
+                    </p:to>
+                  </p:set>
                   <p:animEffect transition="in" filter="fade">
                     <p:cBhvr>
-                      <p:cTn id="3" dur="500" fill="hold"/>
+                      <p:cTn id="4" dur="500" fill="hold"/>
                       <p:tgtEl>
                         <p:spTgt spid="8"/>
                       </p:tgtEl>
@@ -6987,14 +7321,28 @@
               </p:cTn>
             </p:par>
             <p:par>
-              <p:cTn id="5" fill="hold" nodeType="afterEffect">
+              <p:cTn id="6" fill="hold" nodeType="afterEffect" presetID="10" presetClass="entr" presetSubtype="0">
                 <p:stCondLst>
                   <p:cond delay="560"/>
                 </p:stCondLst>
                 <p:childTnLst>
+                  <p:set>
+                    <p:cBhvr>
+                      <p:cTn id="7" dur="1" fill="hold"/>
+                      <p:tgtEl>
+                        <p:spTgt spid="11"/>
+                      </p:tgtEl>
+                      <p:attrNameLst>
+                        <p:attrName>style.visibility</p:attrName>
+                      </p:attrNameLst>
+                    </p:cBhvr>
+                    <p:to>
+                      <p:strVal val="visible"/>
+                    </p:to>
+                  </p:set>
                   <p:animEffect transition="in" filter="fade">
                     <p:cBhvr>
-                      <p:cTn id="6" dur="340" fill="hold"/>
+                      <p:cTn id="8" dur="340" fill="hold"/>
                       <p:tgtEl>
                         <p:spTgt spid="11"/>
                       </p:tgtEl>
@@ -7004,14 +7352,14 @@
               </p:cTn>
             </p:par>
             <p:par>
-              <p:cTn id="8" fill="hold" nodeType="afterEffect">
+              <p:cTn id="10" fill="hold" nodeType="afterEffect" presetID="2819" presetClass="entr" presetSubtype="0">
                 <p:stCondLst>
                   <p:cond delay="750"/>
                 </p:stCondLst>
                 <p:childTnLst>
-                  <p:animEffect transition="in" filter="wipe(fromLeft)">
-                    <p:cBhvr>
-                      <p:cTn id="9" dur="290" fill="hold"/>
+                  <p:set>
+                    <p:cBhvr>
+                      <p:cTn id="11" dur="1" fill="hold"/>
                       <p:tgtEl>
                         <p:spTgt spid="12">
                           <p:txEl>
@@ -7019,20 +7367,38 @@
                           </p:txEl>
                         </p:spTgt>
                       </p:tgtEl>
+                      <p:attrNameLst>
+                        <p:attrName>style.visibility</p:attrName>
+                      </p:attrNameLst>
+                    </p:cBhvr>
+                    <p:to>
+                      <p:strVal val="visible"/>
+                    </p:to>
+                  </p:set>
+                  <p:animEffect transition="in" filter="wipe(right)">
+                    <p:cBhvr>
+                      <p:cTn id="12" dur="290" fill="hold"/>
+                      <p:tgtEl>
+                        <p:spTgt spid="12">
+                          <p:txEl>
+                            <p:pRg st="0" end="0"/>
+                          </p:txEl>
+                        </p:spTgt>
+                      </p:tgtEl>
                     </p:cBhvr>
                   </p:animEffect>
                 </p:childTnLst>
               </p:cTn>
             </p:par>
             <p:par>
-              <p:cTn id="11" fill="hold" nodeType="afterEffect">
+              <p:cTn id="14" fill="hold" nodeType="afterEffect" presetID="2819" presetClass="entr" presetSubtype="0">
                 <p:stCondLst>
                   <p:cond delay="905"/>
                 </p:stCondLst>
                 <p:childTnLst>
-                  <p:animEffect transition="in" filter="wipe(fromLeft)">
-                    <p:cBhvr>
-                      <p:cTn id="12" dur="290" fill="hold"/>
+                  <p:set>
+                    <p:cBhvr>
+                      <p:cTn id="15" dur="1" fill="hold"/>
                       <p:tgtEl>
                         <p:spTgt spid="12">
                           <p:txEl>
@@ -7040,20 +7406,38 @@
                           </p:txEl>
                         </p:spTgt>
                       </p:tgtEl>
+                      <p:attrNameLst>
+                        <p:attrName>style.visibility</p:attrName>
+                      </p:attrNameLst>
+                    </p:cBhvr>
+                    <p:to>
+                      <p:strVal val="visible"/>
+                    </p:to>
+                  </p:set>
+                  <p:animEffect transition="in" filter="wipe(right)">
+                    <p:cBhvr>
+                      <p:cTn id="16" dur="290" fill="hold"/>
+                      <p:tgtEl>
+                        <p:spTgt spid="12">
+                          <p:txEl>
+                            <p:pRg st="1" end="1"/>
+                          </p:txEl>
+                        </p:spTgt>
+                      </p:tgtEl>
                     </p:cBhvr>
                   </p:animEffect>
                 </p:childTnLst>
               </p:cTn>
             </p:par>
             <p:par>
-              <p:cTn id="14" fill="hold" nodeType="afterEffect">
+              <p:cTn id="18" fill="hold" nodeType="afterEffect" presetID="2819" presetClass="entr" presetSubtype="0">
                 <p:stCondLst>
                   <p:cond delay="1060"/>
                 </p:stCondLst>
                 <p:childTnLst>
-                  <p:animEffect transition="in" filter="wipe(fromLeft)">
-                    <p:cBhvr>
-                      <p:cTn id="15" dur="290" fill="hold"/>
+                  <p:set>
+                    <p:cBhvr>
+                      <p:cTn id="19" dur="1" fill="hold"/>
                       <p:tgtEl>
                         <p:spTgt spid="12">
                           <p:txEl>
@@ -7061,20 +7445,38 @@
                           </p:txEl>
                         </p:spTgt>
                       </p:tgtEl>
+                      <p:attrNameLst>
+                        <p:attrName>style.visibility</p:attrName>
+                      </p:attrNameLst>
+                    </p:cBhvr>
+                    <p:to>
+                      <p:strVal val="visible"/>
+                    </p:to>
+                  </p:set>
+                  <p:animEffect transition="in" filter="wipe(right)">
+                    <p:cBhvr>
+                      <p:cTn id="20" dur="290" fill="hold"/>
+                      <p:tgtEl>
+                        <p:spTgt spid="12">
+                          <p:txEl>
+                            <p:pRg st="2" end="2"/>
+                          </p:txEl>
+                        </p:spTgt>
+                      </p:tgtEl>
                     </p:cBhvr>
                   </p:animEffect>
                 </p:childTnLst>
               </p:cTn>
             </p:par>
             <p:par>
-              <p:cTn id="17" fill="hold" nodeType="afterEffect">
+              <p:cTn id="22" fill="hold" nodeType="afterEffect" presetID="2819" presetClass="entr" presetSubtype="0">
                 <p:stCondLst>
                   <p:cond delay="1215"/>
                 </p:stCondLst>
                 <p:childTnLst>
-                  <p:animEffect transition="in" filter="wipe(fromLeft)">
-                    <p:cBhvr>
-                      <p:cTn id="18" dur="290" fill="hold"/>
+                  <p:set>
+                    <p:cBhvr>
+                      <p:cTn id="23" dur="1" fill="hold"/>
                       <p:tgtEl>
                         <p:spTgt spid="12">
                           <p:txEl>
@@ -7082,20 +7484,52 @@
                           </p:txEl>
                         </p:spTgt>
                       </p:tgtEl>
+                      <p:attrNameLst>
+                        <p:attrName>style.visibility</p:attrName>
+                      </p:attrNameLst>
+                    </p:cBhvr>
+                    <p:to>
+                      <p:strVal val="visible"/>
+                    </p:to>
+                  </p:set>
+                  <p:animEffect transition="in" filter="wipe(right)">
+                    <p:cBhvr>
+                      <p:cTn id="24" dur="290" fill="hold"/>
+                      <p:tgtEl>
+                        <p:spTgt spid="12">
+                          <p:txEl>
+                            <p:pRg st="3" end="3"/>
+                          </p:txEl>
+                        </p:spTgt>
+                      </p:tgtEl>
                     </p:cBhvr>
                   </p:animEffect>
                 </p:childTnLst>
               </p:cTn>
             </p:par>
             <p:par>
-              <p:cTn id="20" fill="hold" nodeType="afterEffect">
+              <p:cTn id="26" fill="hold" nodeType="afterEffect" presetID="10" presetClass="entr" presetSubtype="0">
                 <p:stCondLst>
                   <p:cond delay="1370"/>
                 </p:stCondLst>
                 <p:childTnLst>
+                  <p:set>
+                    <p:cBhvr>
+                      <p:cTn id="27" dur="1" fill="hold"/>
+                      <p:tgtEl>
+                        <p:spTgt spid="13"/>
+                      </p:tgtEl>
+                      <p:attrNameLst>
+                        <p:attrName>style.visibility</p:attrName>
+                      </p:attrNameLst>
+                    </p:cBhvr>
+                    <p:to>
+                      <p:strVal val="visible"/>
+                    </p:to>
+                  </p:set>
                   <p:animEffect transition="in" filter="fade">
                     <p:cBhvr>
-                      <p:cTn id="21" dur="340" fill="hold"/>
+                      <p:cTn id="28" dur="340" fill="hold"/>
                       <p:tgtEl>
                         <p:spTgt spid="13"/>
                       </p:tgtEl>
@@ -7105,14 +7539,14 @@
               </p:cTn>
             </p:par>
             <p:par>
-              <p:cTn id="23" fill="hold" nodeType="afterEffect">
+              <p:cTn id="30" fill="hold" nodeType="afterEffect" presetID="2819" presetClass="entr" presetSubtype="0">
                 <p:stCondLst>
                   <p:cond delay="1560"/>
                 </p:stCondLst>
                 <p:childTnLst>
-                  <p:animEffect transition="in" filter="wipe(fromLeft)">
-                    <p:cBhvr>
-                      <p:cTn id="24" dur="290" fill="hold"/>
+                  <p:set>
+                    <p:cBhvr>
+                      <p:cTn id="31" dur="1" fill="hold"/>
                       <p:tgtEl>
                         <p:spTgt spid="14">
                           <p:txEl>
@@ -7120,20 +7554,38 @@
                           </p:txEl>
                         </p:spTgt>
                       </p:tgtEl>
+                      <p:attrNameLst>
+                        <p:attrName>style.visibility</p:attrName>
+                      </p:attrNameLst>
+                    </p:cBhvr>
+                    <p:to>
+                      <p:strVal val="visible"/>
+                    </p:to>
+                  </p:set>
+                  <p:animEffect transition="in" filter="wipe(right)">
+                    <p:cBhvr>
+                      <p:cTn id="32" dur="290" fill="hold"/>
+                      <p:tgtEl>
+                        <p:spTgt spid="14">
+                          <p:txEl>
+                            <p:pRg st="0" end="0"/>
+                          </p:txEl>
+                        </p:spTgt>
+                      </p:tgtEl>
                     </p:cBhvr>
                   </p:animEffect>
                 </p:childTnLst>
               </p:cTn>
             </p:par>
             <p:par>
-              <p:cTn id="26" fill="hold" nodeType="afterEffect">
+              <p:cTn id="34" fill="hold" nodeType="afterEffect" presetID="2819" presetClass="entr" presetSubtype="0">
                 <p:stCondLst>
                   <p:cond delay="1715"/>
                 </p:stCondLst>
                 <p:childTnLst>
-                  <p:animEffect transition="in" filter="wipe(fromLeft)">
-                    <p:cBhvr>
-                      <p:cTn id="27" dur="290" fill="hold"/>
+                  <p:set>
+                    <p:cBhvr>
+                      <p:cTn id="35" dur="1" fill="hold"/>
                       <p:tgtEl>
                         <p:spTgt spid="14">
                           <p:txEl>
@@ -7141,20 +7593,38 @@
                           </p:txEl>
                         </p:spTgt>
                       </p:tgtEl>
+                      <p:attrNameLst>
+                        <p:attrName>style.visibility</p:attrName>
+                      </p:attrNameLst>
+                    </p:cBhvr>
+                    <p:to>
+                      <p:strVal val="visible"/>
+                    </p:to>
+                  </p:set>
+                  <p:animEffect transition="in" filter="wipe(right)">
+                    <p:cBhvr>
+                      <p:cTn id="36" dur="290" fill="hold"/>
+                      <p:tgtEl>
+                        <p:spTgt spid="14">
+                          <p:txEl>
+                            <p:pRg st="1" end="1"/>
+                          </p:txEl>
+                        </p:spTgt>
+                      </p:tgtEl>
                     </p:cBhvr>
                   </p:animEffect>
                 </p:childTnLst>
               </p:cTn>
             </p:par>
             <p:par>
-              <p:cTn id="29" fill="hold" nodeType="afterEffect">
+              <p:cTn id="38" fill="hold" nodeType="afterEffect" presetID="2819" presetClass="entr" presetSubtype="0">
                 <p:stCondLst>
                   <p:cond delay="1870"/>
                 </p:stCondLst>
                 <p:childTnLst>
-                  <p:animEffect transition="in" filter="wipe(fromLeft)">
-                    <p:cBhvr>
-                      <p:cTn id="30" dur="290" fill="hold"/>
+                  <p:set>
+                    <p:cBhvr>
+                      <p:cTn id="39" dur="1" fill="hold"/>
                       <p:tgtEl>
                         <p:spTgt spid="14">
                           <p:txEl>
@@ -7162,20 +7632,56 @@
                           </p:txEl>
                         </p:spTgt>
                       </p:tgtEl>
+                      <p:attrNameLst>
+                        <p:attrName>style.visibility</p:attrName>
+                      </p:attrNameLst>
+                    </p:cBhvr>
+                    <p:to>
+                      <p:strVal val="visible"/>
+                    </p:to>
+                  </p:set>
+                  <p:animEffect transition="in" filter="wipe(right)">
+                    <p:cBhvr>
+                      <p:cTn id="40" dur="290" fill="hold"/>
+                      <p:tgtEl>
+                        <p:spTgt spid="14">
+                          <p:txEl>
+                            <p:pRg st="2" end="2"/>
+                          </p:txEl>
+                        </p:spTgt>
+                      </p:tgtEl>
                     </p:cBhvr>
                   </p:animEffect>
                 </p:childTnLst>
               </p:cTn>
             </p:par>
             <p:par>
-              <p:cTn id="32" fill="hold" nodeType="afterEffect">
+              <p:cTn id="42" fill="hold" nodeType="afterEffect" presetID="2819" presetClass="entr" presetSubtype="0">
                 <p:stCondLst>
                   <p:cond delay="2025"/>
                 </p:stCondLst>
                 <p:childTnLst>
-                  <p:animEffect transition="in" filter="wipe(fromLeft)">
-                    <p:cBhvr>
-                      <p:cTn id="33" dur="290" fill="hold"/>
+                  <p:set>
+                    <p:cBhvr>
+                      <p:cTn id="43" dur="1" fill="hold"/>
+                      <p:tgtEl>
+                        <p:spTgt spid="14">
+                          <p:txEl>
+                            <p:pRg st="3" end="3"/>
+                          </p:txEl>
+                        </p:spTgt>
+                      </p:tgtEl>
+                      <p:attrNameLst>
+                        <p:attrName>style.visibility</p:attrName>
+                      </p:attrNameLst>
+                    </p:cBhvr>
+                    <p:to>
+                      <p:strVal val="visible"/>
+                    </p:to>
+                  </p:set>
+                  <p:animEffect transition="in" filter="wipe(right)">
+                    <p:cBhvr>
+                      <p:cTn id="44" dur="290" fill="hold"/>
                       <p:tgtEl>
                         <p:spTgt spid="14">
                           <p:txEl>
@@ -8390,14 +8896,28 @@
           </p:stCondLst>
           <p:childTnLst>
             <p:par>
-              <p:cTn id="2" fill="hold" nodeType="afterEffect">
+              <p:cTn id="2" fill="hold" nodeType="afterEffect" presetID="10" presetClass="entr" presetSubtype="0">
                 <p:stCondLst>
                   <p:cond delay="0"/>
                 </p:stCondLst>
                 <p:childTnLst>
+                  <p:set>
+                    <p:cBhvr>
+                      <p:cTn id="3" dur="1" fill="hold"/>
+                      <p:tgtEl>
+                        <p:spTgt spid="8"/>
+                      </p:tgtEl>
+                      <p:attrNameLst>
+                        <p:attrName>style.visibility</p:attrName>
+                      </p:attrNameLst>
+                    </p:cBhvr>
+                    <p:to>
+                      <p:strVal val="visible"/>
+                    </p:to>
+                  </p:set>
                   <p:animEffect transition="in" filter="fade">
                     <p:cBhvr>
-                      <p:cTn id="3" dur="500" fill="hold"/>
+                      <p:cTn id="4" dur="500" fill="hold"/>
                       <p:tgtEl>
                         <p:spTgt spid="8"/>
                       </p:tgtEl>
@@ -8407,14 +8927,28 @@
               </p:cTn>
             </p:par>
             <p:par>
-              <p:cTn id="5" fill="hold" nodeType="afterEffect">
+              <p:cTn id="6" fill="hold" nodeType="afterEffect" presetID="22" presetClass="entr" presetSubtype="0">
                 <p:stCondLst>
                   <p:cond delay="560"/>
                 </p:stCondLst>
                 <p:childTnLst>
+                  <p:set>
+                    <p:cBhvr>
+                      <p:cTn id="7" dur="1" fill="hold"/>
+                      <p:tgtEl>
+                        <p:spTgt spid="11"/>
+                      </p:tgtEl>
+                      <p:attrNameLst>
+                        <p:attrName>style.visibility</p:attrName>
+                      </p:attrNameLst>
+                    </p:cBhvr>
+                    <p:to>
+                      <p:strVal val="visible"/>
+                    </p:to>
+                  </p:set>
                   <p:animEffect transition="in" filter="fade">
                     <p:cBhvr>
-                      <p:cTn id="6" dur="420" fill="hold"/>
+                      <p:cTn id="8" dur="420" fill="hold"/>
                       <p:tgtEl>
                         <p:spTgt spid="11"/>
                       </p:tgtEl>
@@ -8422,7 +8956,7 @@
                   </p:animEffect>
                   <p:animScale>
                     <p:cBhvr>
-                      <p:cTn id="7" dur="420" fill="hold"/>
+                      <p:cTn id="9" dur="420" fill="hold"/>
                       <p:tgtEl>
                         <p:spTgt spid="11"/>
                       </p:tgtEl>
@@ -8438,14 +8972,28 @@
               </p:cTn>
             </p:par>
             <p:par>
-              <p:cTn id="8" fill="hold" nodeType="withEffect">
+              <p:cTn id="10" fill="hold" nodeType="withEffect" presetID="22" presetClass="entr" presetSubtype="0">
                 <p:stCondLst>
                   <p:cond delay="560"/>
                 </p:stCondLst>
                 <p:childTnLst>
+                  <p:set>
+                    <p:cBhvr>
+                      <p:cTn id="11" dur="1" fill="hold"/>
+                      <p:tgtEl>
+                        <p:spTgt spid="12"/>
+                      </p:tgtEl>
+                      <p:attrNameLst>
+                        <p:attrName>style.visibility</p:attrName>
+                      </p:attrNameLst>
+                    </p:cBhvr>
+                    <p:to>
+                      <p:strVal val="visible"/>
+                    </p:to>
+                  </p:set>
                   <p:animEffect transition="in" filter="fade">
                     <p:cBhvr>
-                      <p:cTn id="9" dur="420" fill="hold"/>
+                      <p:cTn id="12" dur="420" fill="hold"/>
                       <p:tgtEl>
                         <p:spTgt spid="12"/>
                       </p:tgtEl>
@@ -8453,7 +9001,7 @@
                   </p:animEffect>
                   <p:animScale>
                     <p:cBhvr>
-                      <p:cTn id="10" dur="420" fill="hold"/>
+                      <p:cTn id="13" dur="420" fill="hold"/>
                       <p:tgtEl>
                         <p:spTgt spid="12"/>
                       </p:tgtEl>
@@ -8469,14 +9017,28 @@
               </p:cTn>
             </p:par>
             <p:par>
-              <p:cTn id="11" fill="hold" nodeType="afterEffect">
+              <p:cTn id="14" fill="hold" nodeType="afterEffect" presetID="22" presetClass="entr" presetSubtype="0">
                 <p:stCondLst>
                   <p:cond delay="860"/>
                 </p:stCondLst>
                 <p:childTnLst>
+                  <p:set>
+                    <p:cBhvr>
+                      <p:cTn id="15" dur="1" fill="hold"/>
+                      <p:tgtEl>
+                        <p:spTgt spid="17"/>
+                      </p:tgtEl>
+                      <p:attrNameLst>
+                        <p:attrName>style.visibility</p:attrName>
+                      </p:attrNameLst>
+                    </p:cBhvr>
+                    <p:to>
+                      <p:strVal val="visible"/>
+                    </p:to>
+                  </p:set>
                   <p:animEffect transition="in" filter="fade">
                     <p:cBhvr>
-                      <p:cTn id="12" dur="420" fill="hold"/>
+                      <p:cTn id="16" dur="420" fill="hold"/>
                       <p:tgtEl>
                         <p:spTgt spid="17"/>
                       </p:tgtEl>
@@ -8484,7 +9046,7 @@
                   </p:animEffect>
                   <p:animScale>
                     <p:cBhvr>
-                      <p:cTn id="13" dur="420" fill="hold"/>
+                      <p:cTn id="17" dur="420" fill="hold"/>
                       <p:tgtEl>
                         <p:spTgt spid="17"/>
                       </p:tgtEl>
@@ -8500,14 +9062,28 @@
               </p:cTn>
             </p:par>
             <p:par>
-              <p:cTn id="14" fill="hold" nodeType="withEffect">
+              <p:cTn id="18" fill="hold" nodeType="withEffect" presetID="22" presetClass="entr" presetSubtype="0">
                 <p:stCondLst>
                   <p:cond delay="860"/>
                 </p:stCondLst>
                 <p:childTnLst>
+                  <p:set>
+                    <p:cBhvr>
+                      <p:cTn id="19" dur="1" fill="hold"/>
+                      <p:tgtEl>
+                        <p:spTgt spid="18"/>
+                      </p:tgtEl>
+                      <p:attrNameLst>
+                        <p:attrName>style.visibility</p:attrName>
+                      </p:attrNameLst>
+                    </p:cBhvr>
+                    <p:to>
+                      <p:strVal val="visible"/>
+                    </p:to>
+                  </p:set>
                   <p:animEffect transition="in" filter="fade">
                     <p:cBhvr>
-                      <p:cTn id="15" dur="420" fill="hold"/>
+                      <p:cTn id="20" dur="420" fill="hold"/>
                       <p:tgtEl>
                         <p:spTgt spid="18"/>
                       </p:tgtEl>
@@ -8515,7 +9091,7 @@
                   </p:animEffect>
                   <p:animScale>
                     <p:cBhvr>
-                      <p:cTn id="16" dur="420" fill="hold"/>
+                      <p:cTn id="21" dur="420" fill="hold"/>
                       <p:tgtEl>
                         <p:spTgt spid="18"/>
                       </p:tgtEl>
@@ -8531,14 +9107,28 @@
               </p:cTn>
             </p:par>
             <p:par>
-              <p:cTn id="17" fill="hold" nodeType="afterEffect">
+              <p:cTn id="22" fill="hold" nodeType="afterEffect" presetID="22" presetClass="entr" presetSubtype="0">
                 <p:stCondLst>
                   <p:cond delay="1160"/>
                 </p:stCondLst>
                 <p:childTnLst>
+                  <p:set>
+                    <p:cBhvr>
+                      <p:cTn id="23" dur="1" fill="hold"/>
+                      <p:tgtEl>
+                        <p:spTgt spid="23"/>
+                      </p:tgtEl>
+                      <p:attrNameLst>
+                        <p:attrName>style.visibility</p:attrName>
+                      </p:attrNameLst>
+                    </p:cBhvr>
+                    <p:to>
+                      <p:strVal val="visible"/>
+                    </p:to>
+                  </p:set>
                   <p:animEffect transition="in" filter="fade">
                     <p:cBhvr>
-                      <p:cTn id="18" dur="420" fill="hold"/>
+                      <p:cTn id="24" dur="420" fill="hold"/>
                       <p:tgtEl>
                         <p:spTgt spid="23"/>
                       </p:tgtEl>
@@ -8546,7 +9136,7 @@
                   </p:animEffect>
                   <p:animScale>
                     <p:cBhvr>
-                      <p:cTn id="19" dur="420" fill="hold"/>
+                      <p:cTn id="25" dur="420" fill="hold"/>
                       <p:tgtEl>
                         <p:spTgt spid="23"/>
                       </p:tgtEl>
@@ -8562,14 +9152,28 @@
               </p:cTn>
             </p:par>
             <p:par>
-              <p:cTn id="20" fill="hold" nodeType="withEffect">
+              <p:cTn id="26" fill="hold" nodeType="withEffect" presetID="22" presetClass="entr" presetSubtype="0">
                 <p:stCondLst>
                   <p:cond delay="1160"/>
                 </p:stCondLst>
                 <p:childTnLst>
+                  <p:set>
+                    <p:cBhvr>
+                      <p:cTn id="27" dur="1" fill="hold"/>
+                      <p:tgtEl>
+                        <p:spTgt spid="24"/>
+                      </p:tgtEl>
+                      <p:attrNameLst>
+                        <p:attrName>style.visibility</p:attrName>
+                      </p:attrNameLst>
+                    </p:cBhvr>
+                    <p:to>
+                      <p:strVal val="visible"/>
+                    </p:to>
+                  </p:set>
                   <p:animEffect transition="in" filter="fade">
                     <p:cBhvr>
-                      <p:cTn id="21" dur="420" fill="hold"/>
+                      <p:cTn id="28" dur="420" fill="hold"/>
                       <p:tgtEl>
                         <p:spTgt spid="24"/>
                       </p:tgtEl>
@@ -8577,7 +9181,7 @@
                   </p:animEffect>
                   <p:animScale>
                     <p:cBhvr>
-                      <p:cTn id="22" dur="420" fill="hold"/>
+                      <p:cTn id="29" dur="420" fill="hold"/>
                       <p:tgtEl>
                         <p:spTgt spid="24"/>
                       </p:tgtEl>
@@ -8593,14 +9197,28 @@
               </p:cTn>
             </p:par>
             <p:par>
-              <p:cTn id="23" fill="hold" nodeType="afterEffect">
+              <p:cTn id="30" fill="hold" nodeType="afterEffect" presetID="10" presetClass="entr" presetSubtype="0">
                 <p:stCondLst>
                   <p:cond delay="1560"/>
                 </p:stCondLst>
                 <p:childTnLst>
+                  <p:set>
+                    <p:cBhvr>
+                      <p:cTn id="31" dur="1" fill="hold"/>
+                      <p:tgtEl>
+                        <p:spTgt spid="27"/>
+                      </p:tgtEl>
+                      <p:attrNameLst>
+                        <p:attrName>style.visibility</p:attrName>
+                      </p:attrNameLst>
+                    </p:cBhvr>
+                    <p:to>
+                      <p:strVal val="visible"/>
+                    </p:to>
+                  </p:set>
                   <p:animEffect transition="in" filter="fade">
                     <p:cBhvr>
-                      <p:cTn id="24" dur="380" fill="hold"/>
+                      <p:cTn id="32" dur="380" fill="hold"/>
                       <p:tgtEl>
                         <p:spTgt spid="27"/>
                       </p:tgtEl>
@@ -9475,14 +10093,28 @@
           </p:stCondLst>
           <p:childTnLst>
             <p:par>
-              <p:cTn id="2" fill="hold" nodeType="afterEffect">
+              <p:cTn id="2" fill="hold" nodeType="afterEffect" presetID="10" presetClass="entr" presetSubtype="0">
                 <p:stCondLst>
                   <p:cond delay="0"/>
                 </p:stCondLst>
                 <p:childTnLst>
+                  <p:set>
+                    <p:cBhvr>
+                      <p:cTn id="3" dur="1" fill="hold"/>
+                      <p:tgtEl>
+                        <p:spTgt spid="8"/>
+                      </p:tgtEl>
+                      <p:attrNameLst>
+                        <p:attrName>style.visibility</p:attrName>
+                      </p:attrNameLst>
+                    </p:cBhvr>
+                    <p:to>
+                      <p:strVal val="visible"/>
+                    </p:to>
+                  </p:set>
                   <p:animEffect transition="in" filter="fade">
                     <p:cBhvr>
-                      <p:cTn id="3" dur="500" fill="hold"/>
+                      <p:cTn id="4" dur="500" fill="hold"/>
                       <p:tgtEl>
                         <p:spTgt spid="8"/>
                       </p:tgtEl>
@@ -9492,14 +10124,28 @@
               </p:cTn>
             </p:par>
             <p:par>
-              <p:cTn id="5" fill="hold" nodeType="afterEffect">
+              <p:cTn id="6" fill="hold" nodeType="afterEffect" presetID="10" presetClass="entr" presetSubtype="0">
                 <p:stCondLst>
                   <p:cond delay="560"/>
                 </p:stCondLst>
                 <p:childTnLst>
+                  <p:set>
+                    <p:cBhvr>
+                      <p:cTn id="7" dur="1" fill="hold"/>
+                      <p:tgtEl>
+                        <p:spTgt spid="9"/>
+                      </p:tgtEl>
+                      <p:attrNameLst>
+                        <p:attrName>style.visibility</p:attrName>
+                      </p:attrNameLst>
+                    </p:cBhvr>
+                    <p:to>
+                      <p:strVal val="visible"/>
+                    </p:to>
+                  </p:set>
                   <p:animEffect transition="in" filter="fade">
                     <p:cBhvr>
-                      <p:cTn id="6" dur="500" fill="hold"/>
+                      <p:cTn id="8" dur="500" fill="hold"/>
                       <p:tgtEl>
                         <p:spTgt spid="9"/>
                       </p:tgtEl>
@@ -9509,14 +10155,28 @@
               </p:cTn>
             </p:par>
             <p:par>
-              <p:cTn id="8" fill="hold" nodeType="withEffect">
+              <p:cTn id="10" fill="hold" nodeType="withEffect" presetID="10" presetClass="entr" presetSubtype="0">
                 <p:stCondLst>
                   <p:cond delay="560"/>
                 </p:stCondLst>
                 <p:childTnLst>
+                  <p:set>
+                    <p:cBhvr>
+                      <p:cTn id="11" dur="1" fill="hold"/>
+                      <p:tgtEl>
+                        <p:spTgt spid="11"/>
+                      </p:tgtEl>
+                      <p:attrNameLst>
+                        <p:attrName>style.visibility</p:attrName>
+                      </p:attrNameLst>
+                    </p:cBhvr>
+                    <p:to>
+                      <p:strVal val="visible"/>
+                    </p:to>
+                  </p:set>
                   <p:animEffect transition="in" filter="fade">
                     <p:cBhvr>
-                      <p:cTn id="9" dur="500" fill="hold"/>
+                      <p:cTn id="12" dur="500" fill="hold"/>
                       <p:tgtEl>
                         <p:spTgt spid="11"/>
                       </p:tgtEl>
@@ -9526,14 +10186,28 @@
               </p:cTn>
             </p:par>
             <p:par>
-              <p:cTn id="11" fill="hold" nodeType="afterEffect">
+              <p:cTn id="14" fill="hold" nodeType="afterEffect" presetID="2819" presetClass="entr" presetSubtype="0">
                 <p:stCondLst>
                   <p:cond delay="990"/>
                 </p:stCondLst>
                 <p:childTnLst>
-                  <p:animEffect transition="in" filter="wipe(fromLeft)">
-                    <p:cBhvr>
-                      <p:cTn id="12" dur="360" fill="hold"/>
+                  <p:set>
+                    <p:cBhvr>
+                      <p:cTn id="15" dur="1" fill="hold"/>
+                      <p:tgtEl>
+                        <p:spTgt spid="13"/>
+                      </p:tgtEl>
+                      <p:attrNameLst>
+                        <p:attrName>style.visibility</p:attrName>
+                      </p:attrNameLst>
+                    </p:cBhvr>
+                    <p:to>
+                      <p:strVal val="visible"/>
+                    </p:to>
+                  </p:set>
+                  <p:animEffect transition="in" filter="wipe(right)">
+                    <p:cBhvr>
+                      <p:cTn id="16" dur="360" fill="hold"/>
                       <p:tgtEl>
                         <p:spTgt spid="13"/>
                       </p:tgtEl>
@@ -9543,14 +10217,28 @@
               </p:cTn>
             </p:par>
             <p:par>
-              <p:cTn id="14" fill="hold" nodeType="afterEffect">
+              <p:cTn id="18" fill="hold" nodeType="afterEffect" presetID="2819" presetClass="entr" presetSubtype="0">
                 <p:stCondLst>
                   <p:cond delay="1250"/>
                 </p:stCondLst>
                 <p:childTnLst>
-                  <p:animEffect transition="in" filter="wipe(fromLeft)">
-                    <p:cBhvr>
-                      <p:cTn id="15" dur="360" fill="hold"/>
+                  <p:set>
+                    <p:cBhvr>
+                      <p:cTn id="19" dur="1" fill="hold"/>
+                      <p:tgtEl>
+                        <p:spTgt spid="15"/>
+                      </p:tgtEl>
+                      <p:attrNameLst>
+                        <p:attrName>style.visibility</p:attrName>
+                      </p:attrNameLst>
+                    </p:cBhvr>
+                    <p:to>
+                      <p:strVal val="visible"/>
+                    </p:to>
+                  </p:set>
+                  <p:animEffect transition="in" filter="wipe(right)">
+                    <p:cBhvr>
+                      <p:cTn id="20" dur="360" fill="hold"/>
                       <p:tgtEl>
                         <p:spTgt spid="15"/>
                       </p:tgtEl>
@@ -9560,14 +10248,28 @@
               </p:cTn>
             </p:par>
             <p:par>
-              <p:cTn id="17" fill="hold" nodeType="afterEffect">
+              <p:cTn id="22" fill="hold" nodeType="afterEffect" presetID="2819" presetClass="entr" presetSubtype="0">
                 <p:stCondLst>
                   <p:cond delay="1510"/>
                 </p:stCondLst>
                 <p:childTnLst>
-                  <p:animEffect transition="in" filter="wipe(fromLeft)">
-                    <p:cBhvr>
-                      <p:cTn id="18" dur="360" fill="hold"/>
+                  <p:set>
+                    <p:cBhvr>
+                      <p:cTn id="23" dur="1" fill="hold"/>
+                      <p:tgtEl>
+                        <p:spTgt spid="17"/>
+                      </p:tgtEl>
+                      <p:attrNameLst>
+                        <p:attrName>style.visibility</p:attrName>
+                      </p:attrNameLst>
+                    </p:cBhvr>
+                    <p:to>
+                      <p:strVal val="visible"/>
+                    </p:to>
+                  </p:set>
+                  <p:animEffect transition="in" filter="wipe(right)">
+                    <p:cBhvr>
+                      <p:cTn id="24" dur="360" fill="hold"/>
                       <p:tgtEl>
                         <p:spTgt spid="17"/>
                       </p:tgtEl>
@@ -9577,14 +10279,28 @@
               </p:cTn>
             </p:par>
             <p:par>
-              <p:cTn id="20" fill="hold" nodeType="afterEffect">
+              <p:cTn id="26" fill="hold" nodeType="afterEffect" presetID="2819" presetClass="entr" presetSubtype="0">
                 <p:stCondLst>
                   <p:cond delay="1770"/>
                 </p:stCondLst>
                 <p:childTnLst>
-                  <p:animEffect transition="in" filter="wipe(fromLeft)">
-                    <p:cBhvr>
-                      <p:cTn id="21" dur="360" fill="hold"/>
+                  <p:set>
+                    <p:cBhvr>
+                      <p:cTn id="27" dur="1" fill="hold"/>
+                      <p:tgtEl>
+                        <p:spTgt spid="19"/>
+                      </p:tgtEl>
+                      <p:attrNameLst>
+                        <p:attrName>style.visibility</p:attrName>
+                      </p:attrNameLst>
+                    </p:cBhvr>
+                    <p:to>
+                      <p:strVal val="visible"/>
+                    </p:to>
+                  </p:set>
+                  <p:animEffect transition="in" filter="wipe(right)">
+                    <p:cBhvr>
+                      <p:cTn id="28" dur="360" fill="hold"/>
                       <p:tgtEl>
                         <p:spTgt spid="19"/>
                       </p:tgtEl>
@@ -10516,14 +11232,28 @@
           </p:stCondLst>
           <p:childTnLst>
             <p:par>
-              <p:cTn id="2" fill="hold" nodeType="afterEffect">
+              <p:cTn id="2" fill="hold" nodeType="afterEffect" presetID="10" presetClass="entr" presetSubtype="0">
                 <p:stCondLst>
                   <p:cond delay="0"/>
                 </p:stCondLst>
                 <p:childTnLst>
+                  <p:set>
+                    <p:cBhvr>
+                      <p:cTn id="3" dur="1" fill="hold"/>
+                      <p:tgtEl>
+                        <p:spTgt spid="8"/>
+                      </p:tgtEl>
+                      <p:attrNameLst>
+                        <p:attrName>style.visibility</p:attrName>
+                      </p:attrNameLst>
+                    </p:cBhvr>
+                    <p:to>
+                      <p:strVal val="visible"/>
+                    </p:to>
+                  </p:set>
                   <p:animEffect transition="in" filter="fade">
                     <p:cBhvr>
-                      <p:cTn id="3" dur="500" fill="hold"/>
+                      <p:cTn id="4" dur="500" fill="hold"/>
                       <p:tgtEl>
                         <p:spTgt spid="8"/>
                       </p:tgtEl>
@@ -10533,14 +11263,28 @@
               </p:cTn>
             </p:par>
             <p:par>
-              <p:cTn id="5" fill="hold" nodeType="afterEffect">
+              <p:cTn id="6" fill="hold" nodeType="afterEffect" presetID="22" presetClass="entr" presetSubtype="0">
                 <p:stCondLst>
                   <p:cond delay="560"/>
                 </p:stCondLst>
                 <p:childTnLst>
+                  <p:set>
+                    <p:cBhvr>
+                      <p:cTn id="7" dur="1" fill="hold"/>
+                      <p:tgtEl>
+                        <p:spTgt spid="11"/>
+                      </p:tgtEl>
+                      <p:attrNameLst>
+                        <p:attrName>style.visibility</p:attrName>
+                      </p:attrNameLst>
+                    </p:cBhvr>
+                    <p:to>
+                      <p:strVal val="visible"/>
+                    </p:to>
+                  </p:set>
                   <p:animEffect transition="in" filter="fade">
                     <p:cBhvr>
-                      <p:cTn id="6" dur="430" fill="hold"/>
+                      <p:cTn id="8" dur="430" fill="hold"/>
                       <p:tgtEl>
                         <p:spTgt spid="11"/>
                       </p:tgtEl>
@@ -10548,7 +11292,7 @@
                   </p:animEffect>
                   <p:animScale>
                     <p:cBhvr>
-                      <p:cTn id="7" dur="430" fill="hold"/>
+                      <p:cTn id="9" dur="430" fill="hold"/>
                       <p:tgtEl>
                         <p:spTgt spid="11"/>
                       </p:tgtEl>
@@ -10564,14 +11308,28 @@
               </p:cTn>
             </p:par>
             <p:par>
-              <p:cTn id="8" fill="hold" nodeType="withEffect">
+              <p:cTn id="10" fill="hold" nodeType="withEffect" presetID="22" presetClass="entr" presetSubtype="0">
                 <p:stCondLst>
                   <p:cond delay="560"/>
                 </p:stCondLst>
                 <p:childTnLst>
+                  <p:set>
+                    <p:cBhvr>
+                      <p:cTn id="11" dur="1" fill="hold"/>
+                      <p:tgtEl>
+                        <p:spTgt spid="12"/>
+                      </p:tgtEl>
+                      <p:attrNameLst>
+                        <p:attrName>style.visibility</p:attrName>
+                      </p:attrNameLst>
+                    </p:cBhvr>
+                    <p:to>
+                      <p:strVal val="visible"/>
+                    </p:to>
+                  </p:set>
                   <p:animEffect transition="in" filter="fade">
                     <p:cBhvr>
-                      <p:cTn id="9" dur="430" fill="hold"/>
+                      <p:cTn id="12" dur="430" fill="hold"/>
                       <p:tgtEl>
                         <p:spTgt spid="12"/>
                       </p:tgtEl>
@@ -10579,7 +11337,7 @@
                   </p:animEffect>
                   <p:animScale>
                     <p:cBhvr>
-                      <p:cTn id="10" dur="430" fill="hold"/>
+                      <p:cTn id="13" dur="430" fill="hold"/>
                       <p:tgtEl>
                         <p:spTgt spid="12"/>
                       </p:tgtEl>
@@ -10595,14 +11353,28 @@
               </p:cTn>
             </p:par>
             <p:par>
-              <p:cTn id="11" fill="hold" nodeType="afterEffect">
+              <p:cTn id="14" fill="hold" nodeType="afterEffect" presetID="22" presetClass="entr" presetSubtype="0">
                 <p:stCondLst>
                   <p:cond delay="830"/>
                 </p:stCondLst>
                 <p:childTnLst>
+                  <p:set>
+                    <p:cBhvr>
+                      <p:cTn id="15" dur="1" fill="hold"/>
+                      <p:tgtEl>
+                        <p:spTgt spid="15"/>
+                      </p:tgtEl>
+                      <p:attrNameLst>
+                        <p:attrName>style.visibility</p:attrName>
+                      </p:attrNameLst>
+                    </p:cBhvr>
+                    <p:to>
+                      <p:strVal val="visible"/>
+                    </p:to>
+                  </p:set>
                   <p:animEffect transition="in" filter="fade">
                     <p:cBhvr>
-                      <p:cTn id="12" dur="430" fill="hold"/>
+                      <p:cTn id="16" dur="430" fill="hold"/>
                       <p:tgtEl>
                         <p:spTgt spid="15"/>
                       </p:tgtEl>
@@ -10610,7 +11382,7 @@
                   </p:animEffect>
                   <p:animScale>
                     <p:cBhvr>
-                      <p:cTn id="13" dur="430" fill="hold"/>
+                      <p:cTn id="17" dur="430" fill="hold"/>
                       <p:tgtEl>
                         <p:spTgt spid="15"/>
                       </p:tgtEl>
@@ -10626,14 +11398,28 @@
               </p:cTn>
             </p:par>
             <p:par>
-              <p:cTn id="14" fill="hold" nodeType="withEffect">
+              <p:cTn id="18" fill="hold" nodeType="withEffect" presetID="22" presetClass="entr" presetSubtype="0">
                 <p:stCondLst>
                   <p:cond delay="830"/>
                 </p:stCondLst>
                 <p:childTnLst>
+                  <p:set>
+                    <p:cBhvr>
+                      <p:cTn id="19" dur="1" fill="hold"/>
+                      <p:tgtEl>
+                        <p:spTgt spid="16"/>
+                      </p:tgtEl>
+                      <p:attrNameLst>
+                        <p:attrName>style.visibility</p:attrName>
+                      </p:attrNameLst>
+                    </p:cBhvr>
+                    <p:to>
+                      <p:strVal val="visible"/>
+                    </p:to>
+                  </p:set>
                   <p:animEffect transition="in" filter="fade">
                     <p:cBhvr>
-                      <p:cTn id="15" dur="430" fill="hold"/>
+                      <p:cTn id="20" dur="430" fill="hold"/>
                       <p:tgtEl>
                         <p:spTgt spid="16"/>
                       </p:tgtEl>
@@ -10641,7 +11427,7 @@
                   </p:animEffect>
                   <p:animScale>
                     <p:cBhvr>
-                      <p:cTn id="16" dur="430" fill="hold"/>
+                      <p:cTn id="21" dur="430" fill="hold"/>
                       <p:tgtEl>
                         <p:spTgt spid="16"/>
                       </p:tgtEl>
@@ -10657,14 +11443,28 @@
               </p:cTn>
             </p:par>
             <p:par>
-              <p:cTn id="17" fill="hold" nodeType="afterEffect">
+              <p:cTn id="22" fill="hold" nodeType="afterEffect" presetID="22" presetClass="entr" presetSubtype="0">
                 <p:stCondLst>
                   <p:cond delay="1100"/>
                 </p:stCondLst>
                 <p:childTnLst>
+                  <p:set>
+                    <p:cBhvr>
+                      <p:cTn id="23" dur="1" fill="hold"/>
+                      <p:tgtEl>
+                        <p:spTgt spid="19"/>
+                      </p:tgtEl>
+                      <p:attrNameLst>
+                        <p:attrName>style.visibility</p:attrName>
+                      </p:attrNameLst>
+                    </p:cBhvr>
+                    <p:to>
+                      <p:strVal val="visible"/>
+                    </p:to>
+                  </p:set>
                   <p:animEffect transition="in" filter="fade">
                     <p:cBhvr>
-                      <p:cTn id="18" dur="430" fill="hold"/>
+                      <p:cTn id="24" dur="430" fill="hold"/>
                       <p:tgtEl>
                         <p:spTgt spid="19"/>
                       </p:tgtEl>
@@ -10672,7 +11472,7 @@
                   </p:animEffect>
                   <p:animScale>
                     <p:cBhvr>
-                      <p:cTn id="19" dur="430" fill="hold"/>
+                      <p:cTn id="25" dur="430" fill="hold"/>
                       <p:tgtEl>
                         <p:spTgt spid="19"/>
                       </p:tgtEl>
@@ -10688,14 +11488,28 @@
               </p:cTn>
             </p:par>
             <p:par>
-              <p:cTn id="20" fill="hold" nodeType="withEffect">
+              <p:cTn id="26" fill="hold" nodeType="withEffect" presetID="22" presetClass="entr" presetSubtype="0">
                 <p:stCondLst>
                   <p:cond delay="1100"/>
                 </p:stCondLst>
                 <p:childTnLst>
+                  <p:set>
+                    <p:cBhvr>
+                      <p:cTn id="27" dur="1" fill="hold"/>
+                      <p:tgtEl>
+                        <p:spTgt spid="20"/>
+                      </p:tgtEl>
+                      <p:attrNameLst>
+                        <p:attrName>style.visibility</p:attrName>
+                      </p:attrNameLst>
+                    </p:cBhvr>
+                    <p:to>
+                      <p:strVal val="visible"/>
+                    </p:to>
+                  </p:set>
                   <p:animEffect transition="in" filter="fade">
                     <p:cBhvr>
-                      <p:cTn id="21" dur="430" fill="hold"/>
+                      <p:cTn id="28" dur="430" fill="hold"/>
                       <p:tgtEl>
                         <p:spTgt spid="20"/>
                       </p:tgtEl>
@@ -10703,7 +11517,7 @@
                   </p:animEffect>
                   <p:animScale>
                     <p:cBhvr>
-                      <p:cTn id="22" dur="430" fill="hold"/>
+                      <p:cTn id="29" dur="430" fill="hold"/>
                       <p:tgtEl>
                         <p:spTgt spid="20"/>
                       </p:tgtEl>
@@ -11316,14 +12130,28 @@
           </p:stCondLst>
           <p:childTnLst>
             <p:par>
-              <p:cTn id="2" fill="hold" nodeType="afterEffect">
+              <p:cTn id="2" fill="hold" nodeType="afterEffect" presetID="10" presetClass="entr" presetSubtype="0">
                 <p:stCondLst>
                   <p:cond delay="0"/>
                 </p:stCondLst>
                 <p:childTnLst>
+                  <p:set>
+                    <p:cBhvr>
+                      <p:cTn id="3" dur="1" fill="hold"/>
+                      <p:tgtEl>
+                        <p:spTgt spid="8"/>
+                      </p:tgtEl>
+                      <p:attrNameLst>
+                        <p:attrName>style.visibility</p:attrName>
+                      </p:attrNameLst>
+                    </p:cBhvr>
+                    <p:to>
+                      <p:strVal val="visible"/>
+                    </p:to>
+                  </p:set>
                   <p:animEffect transition="in" filter="fade">
                     <p:cBhvr>
-                      <p:cTn id="3" dur="500" fill="hold"/>
+                      <p:cTn id="4" dur="500" fill="hold"/>
                       <p:tgtEl>
                         <p:spTgt spid="8"/>
                       </p:tgtEl>
@@ -11333,14 +12161,28 @@
               </p:cTn>
             </p:par>
             <p:par>
-              <p:cTn id="5" fill="hold" nodeType="afterEffect">
+              <p:cTn id="6" fill="hold" nodeType="afterEffect" presetID="10" presetClass="entr" presetSubtype="0">
                 <p:stCondLst>
                   <p:cond delay="560"/>
                 </p:stCondLst>
                 <p:childTnLst>
+                  <p:set>
+                    <p:cBhvr>
+                      <p:cTn id="7" dur="1" fill="hold"/>
+                      <p:tgtEl>
+                        <p:spTgt spid="10"/>
+                      </p:tgtEl>
+                      <p:attrNameLst>
+                        <p:attrName>style.visibility</p:attrName>
+                      </p:attrNameLst>
+                    </p:cBhvr>
+                    <p:to>
+                      <p:strVal val="visible"/>
+                    </p:to>
+                  </p:set>
                   <p:animEffect transition="in" filter="fade">
                     <p:cBhvr>
-                      <p:cTn id="6" dur="450" fill="hold"/>
+                      <p:cTn id="8" dur="450" fill="hold"/>
                       <p:tgtEl>
                         <p:spTgt spid="10"/>
                       </p:tgtEl>
@@ -11350,14 +12192,14 @@
               </p:cTn>
             </p:par>
             <p:par>
-              <p:cTn id="8" fill="hold" nodeType="afterEffect">
+              <p:cTn id="10" fill="hold" nodeType="afterEffect" presetID="2819" presetClass="entr" presetSubtype="0">
                 <p:stCondLst>
                   <p:cond delay="920"/>
                 </p:stCondLst>
                 <p:childTnLst>
-                  <p:animEffect transition="in" filter="wipe(fromLeft)">
-                    <p:cBhvr>
-                      <p:cTn id="9" dur="330" fill="hold"/>
+                  <p:set>
+                    <p:cBhvr>
+                      <p:cTn id="11" dur="1" fill="hold"/>
                       <p:tgtEl>
                         <p:spTgt spid="11">
                           <p:txEl>
@@ -11365,20 +12207,38 @@
                           </p:txEl>
                         </p:spTgt>
                       </p:tgtEl>
+                      <p:attrNameLst>
+                        <p:attrName>style.visibility</p:attrName>
+                      </p:attrNameLst>
+                    </p:cBhvr>
+                    <p:to>
+                      <p:strVal val="visible"/>
+                    </p:to>
+                  </p:set>
+                  <p:animEffect transition="in" filter="wipe(right)">
+                    <p:cBhvr>
+                      <p:cTn id="12" dur="330" fill="hold"/>
+                      <p:tgtEl>
+                        <p:spTgt spid="11">
+                          <p:txEl>
+                            <p:pRg st="0" end="0"/>
+                          </p:txEl>
+                        </p:spTgt>
+                      </p:tgtEl>
                     </p:cBhvr>
                   </p:animEffect>
                 </p:childTnLst>
               </p:cTn>
             </p:par>
             <p:par>
-              <p:cTn id="11" fill="hold" nodeType="afterEffect">
+              <p:cTn id="14" fill="hold" nodeType="afterEffect" presetID="2819" presetClass="entr" presetSubtype="0">
                 <p:stCondLst>
                   <p:cond delay="1150"/>
                 </p:stCondLst>
                 <p:childTnLst>
-                  <p:animEffect transition="in" filter="wipe(fromLeft)">
-                    <p:cBhvr>
-                      <p:cTn id="12" dur="330" fill="hold"/>
+                  <p:set>
+                    <p:cBhvr>
+                      <p:cTn id="15" dur="1" fill="hold"/>
                       <p:tgtEl>
                         <p:spTgt spid="11">
                           <p:txEl>
@@ -11386,20 +12246,38 @@
                           </p:txEl>
                         </p:spTgt>
                       </p:tgtEl>
+                      <p:attrNameLst>
+                        <p:attrName>style.visibility</p:attrName>
+                      </p:attrNameLst>
+                    </p:cBhvr>
+                    <p:to>
+                      <p:strVal val="visible"/>
+                    </p:to>
+                  </p:set>
+                  <p:animEffect transition="in" filter="wipe(right)">
+                    <p:cBhvr>
+                      <p:cTn id="16" dur="330" fill="hold"/>
+                      <p:tgtEl>
+                        <p:spTgt spid="11">
+                          <p:txEl>
+                            <p:pRg st="1" end="1"/>
+                          </p:txEl>
+                        </p:spTgt>
+                      </p:tgtEl>
                     </p:cBhvr>
                   </p:animEffect>
                 </p:childTnLst>
               </p:cTn>
             </p:par>
             <p:par>
-              <p:cTn id="14" fill="hold" nodeType="afterEffect">
+              <p:cTn id="18" fill="hold" nodeType="afterEffect" presetID="2819" presetClass="entr" presetSubtype="0">
                 <p:stCondLst>
                   <p:cond delay="1380"/>
                 </p:stCondLst>
                 <p:childTnLst>
-                  <p:animEffect transition="in" filter="wipe(fromLeft)">
-                    <p:cBhvr>
-                      <p:cTn id="15" dur="330" fill="hold"/>
+                  <p:set>
+                    <p:cBhvr>
+                      <p:cTn id="19" dur="1" fill="hold"/>
                       <p:tgtEl>
                         <p:spTgt spid="11">
                           <p:txEl>
@@ -11407,20 +12285,56 @@
                           </p:txEl>
                         </p:spTgt>
                       </p:tgtEl>
+                      <p:attrNameLst>
+                        <p:attrName>style.visibility</p:attrName>
+                      </p:attrNameLst>
+                    </p:cBhvr>
+                    <p:to>
+                      <p:strVal val="visible"/>
+                    </p:to>
+                  </p:set>
+                  <p:animEffect transition="in" filter="wipe(right)">
+                    <p:cBhvr>
+                      <p:cTn id="20" dur="330" fill="hold"/>
+                      <p:tgtEl>
+                        <p:spTgt spid="11">
+                          <p:txEl>
+                            <p:pRg st="2" end="2"/>
+                          </p:txEl>
+                        </p:spTgt>
+                      </p:tgtEl>
                     </p:cBhvr>
                   </p:animEffect>
                 </p:childTnLst>
               </p:cTn>
             </p:par>
             <p:par>
-              <p:cTn id="17" fill="hold" nodeType="afterEffect">
+              <p:cTn id="22" fill="hold" nodeType="afterEffect" presetID="2819" presetClass="entr" presetSubtype="0">
                 <p:stCondLst>
                   <p:cond delay="1610"/>
                 </p:stCondLst>
                 <p:childTnLst>
-                  <p:animEffect transition="in" filter="wipe(fromLeft)">
-                    <p:cBhvr>
-                      <p:cTn id="18" dur="330" fill="hold"/>
+                  <p:set>
+                    <p:cBhvr>
+                      <p:cTn id="23" dur="1" fill="hold"/>
+                      <p:tgtEl>
+                        <p:spTgt spid="11">
+                          <p:txEl>
+                            <p:pRg st="3" end="3"/>
+                          </p:txEl>
+                        </p:spTgt>
+                      </p:tgtEl>
+                      <p:attrNameLst>
+                        <p:attrName>style.visibility</p:attrName>
+                      </p:attrNameLst>
+                    </p:cBhvr>
+                    <p:to>
+                      <p:strVal val="visible"/>
+                    </p:to>
+                  </p:set>
+                  <p:animEffect transition="in" filter="wipe(right)">
+                    <p:cBhvr>
+                      <p:cTn id="24" dur="330" fill="hold"/>
                       <p:tgtEl>
                         <p:spTgt spid="11">
                           <p:txEl>
@@ -12359,14 +13273,28 @@
           </p:stCondLst>
           <p:childTnLst>
             <p:par>
-              <p:cTn id="2" fill="hold" nodeType="afterEffect">
+              <p:cTn id="2" fill="hold" nodeType="afterEffect" presetID="10" presetClass="entr" presetSubtype="0">
                 <p:stCondLst>
                   <p:cond delay="0"/>
                 </p:stCondLst>
                 <p:childTnLst>
+                  <p:set>
+                    <p:cBhvr>
+                      <p:cTn id="3" dur="1" fill="hold"/>
+                      <p:tgtEl>
+                        <p:spTgt spid="8"/>
+                      </p:tgtEl>
+                      <p:attrNameLst>
+                        <p:attrName>style.visibility</p:attrName>
+                      </p:attrNameLst>
+                    </p:cBhvr>
+                    <p:to>
+                      <p:strVal val="visible"/>
+                    </p:to>
+                  </p:set>
                   <p:animEffect transition="in" filter="fade">
                     <p:cBhvr>
-                      <p:cTn id="3" dur="500" fill="hold"/>
+                      <p:cTn id="4" dur="500" fill="hold"/>
                       <p:tgtEl>
                         <p:spTgt spid="8"/>
                       </p:tgtEl>
@@ -12376,14 +13304,28 @@
               </p:cTn>
             </p:par>
             <p:par>
-              <p:cTn id="5" fill="hold" nodeType="afterEffect">
+              <p:cTn id="6" fill="hold" nodeType="afterEffect" presetID="22" presetClass="entr" presetSubtype="0">
                 <p:stCondLst>
                   <p:cond delay="560"/>
                 </p:stCondLst>
                 <p:childTnLst>
+                  <p:set>
+                    <p:cBhvr>
+                      <p:cTn id="7" dur="1" fill="hold"/>
+                      <p:tgtEl>
+                        <p:spTgt spid="11"/>
+                      </p:tgtEl>
+                      <p:attrNameLst>
+                        <p:attrName>style.visibility</p:attrName>
+                      </p:attrNameLst>
+                    </p:cBhvr>
+                    <p:to>
+                      <p:strVal val="visible"/>
+                    </p:to>
+                  </p:set>
                   <p:animEffect transition="in" filter="fade">
                     <p:cBhvr>
-                      <p:cTn id="6" dur="430" fill="hold"/>
+                      <p:cTn id="8" dur="430" fill="hold"/>
                       <p:tgtEl>
                         <p:spTgt spid="11"/>
                       </p:tgtEl>
@@ -12391,7 +13333,7 @@
                   </p:animEffect>
                   <p:animScale>
                     <p:cBhvr>
-                      <p:cTn id="7" dur="430" fill="hold"/>
+                      <p:cTn id="9" dur="430" fill="hold"/>
                       <p:tgtEl>
                         <p:spTgt spid="11"/>
                       </p:tgtEl>
@@ -12407,14 +13349,28 @@
               </p:cTn>
             </p:par>
             <p:par>
-              <p:cTn id="8" fill="hold" nodeType="withEffect">
+              <p:cTn id="10" fill="hold" nodeType="withEffect" presetID="22" presetClass="entr" presetSubtype="0">
                 <p:stCondLst>
                   <p:cond delay="560"/>
                 </p:stCondLst>
                 <p:childTnLst>
+                  <p:set>
+                    <p:cBhvr>
+                      <p:cTn id="11" dur="1" fill="hold"/>
+                      <p:tgtEl>
+                        <p:spTgt spid="12"/>
+                      </p:tgtEl>
+                      <p:attrNameLst>
+                        <p:attrName>style.visibility</p:attrName>
+                      </p:attrNameLst>
+                    </p:cBhvr>
+                    <p:to>
+                      <p:strVal val="visible"/>
+                    </p:to>
+                  </p:set>
                   <p:animEffect transition="in" filter="fade">
                     <p:cBhvr>
-                      <p:cTn id="9" dur="430" fill="hold"/>
+                      <p:cTn id="12" dur="430" fill="hold"/>
                       <p:tgtEl>
                         <p:spTgt spid="12"/>
                       </p:tgtEl>
@@ -12422,7 +13378,7 @@
                   </p:animEffect>
                   <p:animScale>
                     <p:cBhvr>
-                      <p:cTn id="10" dur="430" fill="hold"/>
+                      <p:cTn id="13" dur="430" fill="hold"/>
                       <p:tgtEl>
                         <p:spTgt spid="12"/>
                       </p:tgtEl>
@@ -12438,14 +13394,28 @@
               </p:cTn>
             </p:par>
             <p:par>
-              <p:cTn id="11" fill="hold" nodeType="afterEffect">
+              <p:cTn id="14" fill="hold" nodeType="afterEffect" presetID="22" presetClass="entr" presetSubtype="0">
                 <p:stCondLst>
                   <p:cond delay="830"/>
                 </p:stCondLst>
                 <p:childTnLst>
+                  <p:set>
+                    <p:cBhvr>
+                      <p:cTn id="15" dur="1" fill="hold"/>
+                      <p:tgtEl>
+                        <p:spTgt spid="15"/>
+                      </p:tgtEl>
+                      <p:attrNameLst>
+                        <p:attrName>style.visibility</p:attrName>
+                      </p:attrNameLst>
+                    </p:cBhvr>
+                    <p:to>
+                      <p:strVal val="visible"/>
+                    </p:to>
+                  </p:set>
                   <p:animEffect transition="in" filter="fade">
                     <p:cBhvr>
-                      <p:cTn id="12" dur="430" fill="hold"/>
+                      <p:cTn id="16" dur="430" fill="hold"/>
                       <p:tgtEl>
                         <p:spTgt spid="15"/>
                       </p:tgtEl>
@@ -12453,7 +13423,7 @@
                   </p:animEffect>
                   <p:animScale>
                     <p:cBhvr>
-                      <p:cTn id="13" dur="430" fill="hold"/>
+                      <p:cTn id="17" dur="430" fill="hold"/>
                       <p:tgtEl>
                         <p:spTgt spid="15"/>
                       </p:tgtEl>
@@ -12469,14 +13439,28 @@
               </p:cTn>
             </p:par>
             <p:par>
-              <p:cTn id="14" fill="hold" nodeType="withEffect">
+              <p:cTn id="18" fill="hold" nodeType="withEffect" presetID="22" presetClass="entr" presetSubtype="0">
                 <p:stCondLst>
                   <p:cond delay="830"/>
                 </p:stCondLst>
                 <p:childTnLst>
+                  <p:set>
+                    <p:cBhvr>
+                      <p:cTn id="19" dur="1" fill="hold"/>
+                      <p:tgtEl>
+                        <p:spTgt spid="16"/>
+                      </p:tgtEl>
+                      <p:attrNameLst>
+                        <p:attrName>style.visibility</p:attrName>
+                      </p:attrNameLst>
+                    </p:cBhvr>
+                    <p:to>
+                      <p:strVal val="visible"/>
+                    </p:to>
+                  </p:set>
                   <p:animEffect transition="in" filter="fade">
                     <p:cBhvr>
-                      <p:cTn id="15" dur="430" fill="hold"/>
+                      <p:cTn id="20" dur="430" fill="hold"/>
                       <p:tgtEl>
                         <p:spTgt spid="16"/>
                       </p:tgtEl>
@@ -12484,7 +13468,7 @@
                   </p:animEffect>
                   <p:animScale>
                     <p:cBhvr>
-                      <p:cTn id="16" dur="430" fill="hold"/>
+                      <p:cTn id="21" dur="430" fill="hold"/>
                       <p:tgtEl>
                         <p:spTgt spid="16"/>
                       </p:tgtEl>
@@ -12500,14 +13484,28 @@
               </p:cTn>
             </p:par>
             <p:par>
-              <p:cTn id="17" fill="hold" nodeType="afterEffect">
+              <p:cTn id="22" fill="hold" nodeType="afterEffect" presetID="22" presetClass="entr" presetSubtype="0">
                 <p:stCondLst>
                   <p:cond delay="1100"/>
                 </p:stCondLst>
                 <p:childTnLst>
+                  <p:set>
+                    <p:cBhvr>
+                      <p:cTn id="23" dur="1" fill="hold"/>
+                      <p:tgtEl>
+                        <p:spTgt spid="19"/>
+                      </p:tgtEl>
+                      <p:attrNameLst>
+                        <p:attrName>style.visibility</p:attrName>
+                      </p:attrNameLst>
+                    </p:cBhvr>
+                    <p:to>
+                      <p:strVal val="visible"/>
+                    </p:to>
+                  </p:set>
                   <p:animEffect transition="in" filter="fade">
                     <p:cBhvr>
-                      <p:cTn id="18" dur="430" fill="hold"/>
+                      <p:cTn id="24" dur="430" fill="hold"/>
                       <p:tgtEl>
                         <p:spTgt spid="19"/>
                       </p:tgtEl>
@@ -12515,7 +13513,7 @@
                   </p:animEffect>
                   <p:animScale>
                     <p:cBhvr>
-                      <p:cTn id="19" dur="430" fill="hold"/>
+                      <p:cTn id="25" dur="430" fill="hold"/>
                       <p:tgtEl>
                         <p:spTgt spid="19"/>
                       </p:tgtEl>
@@ -12531,14 +13529,28 @@
               </p:cTn>
             </p:par>
             <p:par>
-              <p:cTn id="20" fill="hold" nodeType="withEffect">
+              <p:cTn id="26" fill="hold" nodeType="withEffect" presetID="22" presetClass="entr" presetSubtype="0">
                 <p:stCondLst>
                   <p:cond delay="1100"/>
                 </p:stCondLst>
                 <p:childTnLst>
+                  <p:set>
+                    <p:cBhvr>
+                      <p:cTn id="27" dur="1" fill="hold"/>
+                      <p:tgtEl>
+                        <p:spTgt spid="20"/>
+                      </p:tgtEl>
+                      <p:attrNameLst>
+                        <p:attrName>style.visibility</p:attrName>
+                      </p:attrNameLst>
+                    </p:cBhvr>
+                    <p:to>
+                      <p:strVal val="visible"/>
+                    </p:to>
+                  </p:set>
                   <p:animEffect transition="in" filter="fade">
                     <p:cBhvr>
-                      <p:cTn id="21" dur="430" fill="hold"/>
+                      <p:cTn id="28" dur="430" fill="hold"/>
                       <p:tgtEl>
                         <p:spTgt spid="20"/>
                       </p:tgtEl>
@@ -12546,7 +13558,7 @@
                   </p:animEffect>
                   <p:animScale>
                     <p:cBhvr>
-                      <p:cTn id="22" dur="430" fill="hold"/>
+                      <p:cTn id="29" dur="430" fill="hold"/>
                       <p:tgtEl>
                         <p:spTgt spid="20"/>
                       </p:tgtEl>
@@ -13968,14 +14980,28 @@
           </p:stCondLst>
           <p:childTnLst>
             <p:par>
-              <p:cTn id="2" fill="hold" nodeType="afterEffect">
+              <p:cTn id="2" fill="hold" nodeType="afterEffect" presetID="10" presetClass="entr" presetSubtype="0">
                 <p:stCondLst>
                   <p:cond delay="0"/>
                 </p:stCondLst>
                 <p:childTnLst>
+                  <p:set>
+                    <p:cBhvr>
+                      <p:cTn id="3" dur="1" fill="hold"/>
+                      <p:tgtEl>
+                        <p:spTgt spid="8"/>
+                      </p:tgtEl>
+                      <p:attrNameLst>
+                        <p:attrName>style.visibility</p:attrName>
+                      </p:attrNameLst>
+                    </p:cBhvr>
+                    <p:to>
+                      <p:strVal val="visible"/>
+                    </p:to>
+                  </p:set>
                   <p:animEffect transition="in" filter="fade">
                     <p:cBhvr>
-                      <p:cTn id="3" dur="500" fill="hold"/>
+                      <p:cTn id="4" dur="500" fill="hold"/>
                       <p:tgtEl>
                         <p:spTgt spid="8"/>
                       </p:tgtEl>
@@ -13985,14 +15011,28 @@
               </p:cTn>
             </p:par>
             <p:par>
-              <p:cTn id="5" fill="hold" nodeType="afterEffect">
+              <p:cTn id="6" fill="hold" nodeType="afterEffect" presetID="22" presetClass="entr" presetSubtype="0">
                 <p:stCondLst>
                   <p:cond delay="560"/>
                 </p:stCondLst>
                 <p:childTnLst>
+                  <p:set>
+                    <p:cBhvr>
+                      <p:cTn id="7" dur="1" fill="hold"/>
+                      <p:tgtEl>
+                        <p:spTgt spid="13"/>
+                      </p:tgtEl>
+                      <p:attrNameLst>
+                        <p:attrName>style.visibility</p:attrName>
+                      </p:attrNameLst>
+                    </p:cBhvr>
+                    <p:to>
+                      <p:strVal val="visible"/>
+                    </p:to>
+                  </p:set>
                   <p:animEffect transition="in" filter="fade">
                     <p:cBhvr>
-                      <p:cTn id="6" dur="420" fill="hold"/>
+                      <p:cTn id="8" dur="420" fill="hold"/>
                       <p:tgtEl>
                         <p:spTgt spid="13"/>
                       </p:tgtEl>
@@ -14000,7 +15040,7 @@
                   </p:animEffect>
                   <p:animScale>
                     <p:cBhvr>
-                      <p:cTn id="7" dur="420" fill="hold"/>
+                      <p:cTn id="9" dur="420" fill="hold"/>
                       <p:tgtEl>
                         <p:spTgt spid="13"/>
                       </p:tgtEl>
@@ -14016,14 +15056,28 @@
               </p:cTn>
             </p:par>
             <p:par>
-              <p:cTn id="8" fill="hold" nodeType="withEffect">
+              <p:cTn id="10" fill="hold" nodeType="withEffect" presetID="22" presetClass="entr" presetSubtype="0">
                 <p:stCondLst>
                   <p:cond delay="560"/>
                 </p:stCondLst>
                 <p:childTnLst>
+                  <p:set>
+                    <p:cBhvr>
+                      <p:cTn id="11" dur="1" fill="hold"/>
+                      <p:tgtEl>
+                        <p:spTgt spid="14"/>
+                      </p:tgtEl>
+                      <p:attrNameLst>
+                        <p:attrName>style.visibility</p:attrName>
+                      </p:attrNameLst>
+                    </p:cBhvr>
+                    <p:to>
+                      <p:strVal val="visible"/>
+                    </p:to>
+                  </p:set>
                   <p:animEffect transition="in" filter="fade">
                     <p:cBhvr>
-                      <p:cTn id="9" dur="420" fill="hold"/>
+                      <p:cTn id="12" dur="420" fill="hold"/>
                       <p:tgtEl>
                         <p:spTgt spid="14"/>
                       </p:tgtEl>
@@ -14031,7 +15085,7 @@
                   </p:animEffect>
                   <p:animScale>
                     <p:cBhvr>
-                      <p:cTn id="10" dur="420" fill="hold"/>
+                      <p:cTn id="13" dur="420" fill="hold"/>
                       <p:tgtEl>
                         <p:spTgt spid="14"/>
                       </p:tgtEl>
@@ -14047,14 +15101,28 @@
               </p:cTn>
             </p:par>
             <p:par>
-              <p:cTn id="11" fill="hold" nodeType="afterEffect">
+              <p:cTn id="14" fill="hold" nodeType="afterEffect" presetID="22" presetClass="entr" presetSubtype="0">
                 <p:stCondLst>
                   <p:cond delay="840"/>
                 </p:stCondLst>
                 <p:childTnLst>
+                  <p:set>
+                    <p:cBhvr>
+                      <p:cTn id="15" dur="1" fill="hold"/>
+                      <p:tgtEl>
+                        <p:spTgt spid="19"/>
+                      </p:tgtEl>
+                      <p:attrNameLst>
+                        <p:attrName>style.visibility</p:attrName>
+                      </p:attrNameLst>
+                    </p:cBhvr>
+                    <p:to>
+                      <p:strVal val="visible"/>
+                    </p:to>
+                  </p:set>
                   <p:animEffect transition="in" filter="fade">
                     <p:cBhvr>
-                      <p:cTn id="12" dur="420" fill="hold"/>
+                      <p:cTn id="16" dur="420" fill="hold"/>
                       <p:tgtEl>
                         <p:spTgt spid="19"/>
                       </p:tgtEl>
@@ -14062,7 +15130,7 @@
                   </p:animEffect>
                   <p:animScale>
                     <p:cBhvr>
-                      <p:cTn id="13" dur="420" fill="hold"/>
+                      <p:cTn id="17" dur="420" fill="hold"/>
                       <p:tgtEl>
                         <p:spTgt spid="19"/>
                       </p:tgtEl>
@@ -14078,14 +15146,28 @@
               </p:cTn>
             </p:par>
             <p:par>
-              <p:cTn id="14" fill="hold" nodeType="withEffect">
+              <p:cTn id="18" fill="hold" nodeType="withEffect" presetID="22" presetClass="entr" presetSubtype="0">
                 <p:stCondLst>
                   <p:cond delay="840"/>
                 </p:stCondLst>
                 <p:childTnLst>
+                  <p:set>
+                    <p:cBhvr>
+                      <p:cTn id="19" dur="1" fill="hold"/>
+                      <p:tgtEl>
+                        <p:spTgt spid="20"/>
+                      </p:tgtEl>
+                      <p:attrNameLst>
+                        <p:attrName>style.visibility</p:attrName>
+                      </p:attrNameLst>
+                    </p:cBhvr>
+                    <p:to>
+                      <p:strVal val="visible"/>
+                    </p:to>
+                  </p:set>
                   <p:animEffect transition="in" filter="fade">
                     <p:cBhvr>
-                      <p:cTn id="15" dur="420" fill="hold"/>
+                      <p:cTn id="20" dur="420" fill="hold"/>
                       <p:tgtEl>
                         <p:spTgt spid="20"/>
                       </p:tgtEl>
@@ -14093,7 +15175,7 @@
                   </p:animEffect>
                   <p:animScale>
                     <p:cBhvr>
-                      <p:cTn id="16" dur="420" fill="hold"/>
+                      <p:cTn id="21" dur="420" fill="hold"/>
                       <p:tgtEl>
                         <p:spTgt spid="20"/>
                       </p:tgtEl>
@@ -14109,14 +15191,28 @@
               </p:cTn>
             </p:par>
             <p:par>
-              <p:cTn id="17" fill="hold" nodeType="afterEffect">
+              <p:cTn id="22" fill="hold" nodeType="afterEffect" presetID="22" presetClass="entr" presetSubtype="0">
                 <p:stCondLst>
                   <p:cond delay="1120"/>
                 </p:stCondLst>
                 <p:childTnLst>
+                  <p:set>
+                    <p:cBhvr>
+                      <p:cTn id="23" dur="1" fill="hold"/>
+                      <p:tgtEl>
+                        <p:spTgt spid="25"/>
+                      </p:tgtEl>
+                      <p:attrNameLst>
+                        <p:attrName>style.visibility</p:attrName>
+                      </p:attrNameLst>
+                    </p:cBhvr>
+                    <p:to>
+                      <p:strVal val="visible"/>
+                    </p:to>
+                  </p:set>
                   <p:animEffect transition="in" filter="fade">
                     <p:cBhvr>
-                      <p:cTn id="18" dur="420" fill="hold"/>
+                      <p:cTn id="24" dur="420" fill="hold"/>
                       <p:tgtEl>
                         <p:spTgt spid="25"/>
                       </p:tgtEl>
@@ -14124,7 +15220,7 @@
                   </p:animEffect>
                   <p:animScale>
                     <p:cBhvr>
-                      <p:cTn id="19" dur="420" fill="hold"/>
+                      <p:cTn id="25" dur="420" fill="hold"/>
                       <p:tgtEl>
                         <p:spTgt spid="25"/>
                       </p:tgtEl>
@@ -14140,14 +15236,28 @@
               </p:cTn>
             </p:par>
             <p:par>
-              <p:cTn id="20" fill="hold" nodeType="withEffect">
+              <p:cTn id="26" fill="hold" nodeType="withEffect" presetID="22" presetClass="entr" presetSubtype="0">
                 <p:stCondLst>
                   <p:cond delay="1120"/>
                 </p:stCondLst>
                 <p:childTnLst>
+                  <p:set>
+                    <p:cBhvr>
+                      <p:cTn id="27" dur="1" fill="hold"/>
+                      <p:tgtEl>
+                        <p:spTgt spid="26"/>
+                      </p:tgtEl>
+                      <p:attrNameLst>
+                        <p:attrName>style.visibility</p:attrName>
+                      </p:attrNameLst>
+                    </p:cBhvr>
+                    <p:to>
+                      <p:strVal val="visible"/>
+                    </p:to>
+                  </p:set>
                   <p:animEffect transition="in" filter="fade">
                     <p:cBhvr>
-                      <p:cTn id="21" dur="420" fill="hold"/>
+                      <p:cTn id="28" dur="420" fill="hold"/>
                       <p:tgtEl>
                         <p:spTgt spid="26"/>
                       </p:tgtEl>
@@ -14155,7 +15265,7 @@
                   </p:animEffect>
                   <p:animScale>
                     <p:cBhvr>
-                      <p:cTn id="22" dur="420" fill="hold"/>
+                      <p:cTn id="29" dur="420" fill="hold"/>
                       <p:tgtEl>
                         <p:spTgt spid="26"/>
                       </p:tgtEl>
@@ -14171,14 +15281,28 @@
               </p:cTn>
             </p:par>
             <p:par>
-              <p:cTn id="23" fill="hold" nodeType="afterEffect">
+              <p:cTn id="30" fill="hold" nodeType="afterEffect" presetID="22" presetClass="entr" presetSubtype="0">
                 <p:stCondLst>
                   <p:cond delay="1400"/>
                 </p:stCondLst>
                 <p:childTnLst>
+                  <p:set>
+                    <p:cBhvr>
+                      <p:cTn id="31" dur="1" fill="hold"/>
+                      <p:tgtEl>
+                        <p:spTgt spid="31"/>
+                      </p:tgtEl>
+                      <p:attrNameLst>
+                        <p:attrName>style.visibility</p:attrName>
+                      </p:attrNameLst>
+                    </p:cBhvr>
+                    <p:to>
+                      <p:strVal val="visible"/>
+                    </p:to>
+                  </p:set>
                   <p:animEffect transition="in" filter="fade">
                     <p:cBhvr>
-                      <p:cTn id="24" dur="420" fill="hold"/>
+                      <p:cTn id="32" dur="420" fill="hold"/>
                       <p:tgtEl>
                         <p:spTgt spid="31"/>
                       </p:tgtEl>
@@ -14186,7 +15310,7 @@
                   </p:animEffect>
                   <p:animScale>
                     <p:cBhvr>
-                      <p:cTn id="25" dur="420" fill="hold"/>
+                      <p:cTn id="33" dur="420" fill="hold"/>
                       <p:tgtEl>
                         <p:spTgt spid="31"/>
                       </p:tgtEl>
@@ -14202,14 +15326,28 @@
               </p:cTn>
             </p:par>
             <p:par>
-              <p:cTn id="26" fill="hold" nodeType="withEffect">
+              <p:cTn id="34" fill="hold" nodeType="withEffect" presetID="22" presetClass="entr" presetSubtype="0">
                 <p:stCondLst>
                   <p:cond delay="1400"/>
                 </p:stCondLst>
                 <p:childTnLst>
+                  <p:set>
+                    <p:cBhvr>
+                      <p:cTn id="35" dur="1" fill="hold"/>
+                      <p:tgtEl>
+                        <p:spTgt spid="32"/>
+                      </p:tgtEl>
+                      <p:attrNameLst>
+                        <p:attrName>style.visibility</p:attrName>
+                      </p:attrNameLst>
+                    </p:cBhvr>
+                    <p:to>
+                      <p:strVal val="visible"/>
+                    </p:to>
+                  </p:set>
                   <p:animEffect transition="in" filter="fade">
                     <p:cBhvr>
-                      <p:cTn id="27" dur="420" fill="hold"/>
+                      <p:cTn id="36" dur="420" fill="hold"/>
                       <p:tgtEl>
                         <p:spTgt spid="32"/>
                       </p:tgtEl>
@@ -14217,7 +15355,7 @@
                   </p:animEffect>
                   <p:animScale>
                     <p:cBhvr>
-                      <p:cTn id="28" dur="420" fill="hold"/>
+                      <p:cTn id="37" dur="420" fill="hold"/>
                       <p:tgtEl>
                         <p:spTgt spid="32"/>
                       </p:tgtEl>
@@ -15629,14 +16767,28 @@
           </p:stCondLst>
           <p:childTnLst>
             <p:par>
-              <p:cTn id="2" fill="hold" nodeType="afterEffect">
+              <p:cTn id="2" fill="hold" nodeType="afterEffect" presetID="10" presetClass="entr" presetSubtype="0">
                 <p:stCondLst>
                   <p:cond delay="0"/>
                 </p:stCondLst>
                 <p:childTnLst>
+                  <p:set>
+                    <p:cBhvr>
+                      <p:cTn id="3" dur="1" fill="hold"/>
+                      <p:tgtEl>
+                        <p:spTgt spid="8"/>
+                      </p:tgtEl>
+                      <p:attrNameLst>
+                        <p:attrName>style.visibility</p:attrName>
+                      </p:attrNameLst>
+                    </p:cBhvr>
+                    <p:to>
+                      <p:strVal val="visible"/>
+                    </p:to>
+                  </p:set>
                   <p:animEffect transition="in" filter="fade">
                     <p:cBhvr>
-                      <p:cTn id="3" dur="500" fill="hold"/>
+                      <p:cTn id="4" dur="500" fill="hold"/>
                       <p:tgtEl>
                         <p:spTgt spid="8"/>
                       </p:tgtEl>
@@ -15646,14 +16798,28 @@
               </p:cTn>
             </p:par>
             <p:par>
-              <p:cTn id="5" fill="hold" nodeType="afterEffect">
+              <p:cTn id="6" fill="hold" nodeType="afterEffect" presetID="22" presetClass="entr" presetSubtype="0">
                 <p:stCondLst>
                   <p:cond delay="560"/>
                 </p:stCondLst>
                 <p:childTnLst>
+                  <p:set>
+                    <p:cBhvr>
+                      <p:cTn id="7" dur="1" fill="hold"/>
+                      <p:tgtEl>
+                        <p:spTgt spid="9"/>
+                      </p:tgtEl>
+                      <p:attrNameLst>
+                        <p:attrName>style.visibility</p:attrName>
+                      </p:attrNameLst>
+                    </p:cBhvr>
+                    <p:to>
+                      <p:strVal val="visible"/>
+                    </p:to>
+                  </p:set>
                   <p:animEffect transition="in" filter="fade">
                     <p:cBhvr>
-                      <p:cTn id="6" dur="360" fill="hold"/>
+                      <p:cTn id="8" dur="360" fill="hold"/>
                       <p:tgtEl>
                         <p:spTgt spid="9"/>
                       </p:tgtEl>
@@ -15661,7 +16827,7 @@
                   </p:animEffect>
                   <p:animScale>
                     <p:cBhvr>
-                      <p:cTn id="7" dur="360" fill="hold"/>
+                      <p:cTn id="9" dur="360" fill="hold"/>
                       <p:tgtEl>
                         <p:spTgt spid="9"/>
                       </p:tgtEl>
@@ -15677,14 +16843,28 @@
               </p:cTn>
             </p:par>
             <p:par>
-              <p:cTn id="8" fill="hold" nodeType="withEffect">
+              <p:cTn id="10" fill="hold" nodeType="withEffect" presetID="22" presetClass="entr" presetSubtype="0">
                 <p:stCondLst>
                   <p:cond delay="560"/>
                 </p:stCondLst>
                 <p:childTnLst>
+                  <p:set>
+                    <p:cBhvr>
+                      <p:cTn id="11" dur="1" fill="hold"/>
+                      <p:tgtEl>
+                        <p:spTgt spid="11"/>
+                      </p:tgtEl>
+                      <p:attrNameLst>
+                        <p:attrName>style.visibility</p:attrName>
+                      </p:attrNameLst>
+                    </p:cBhvr>
+                    <p:to>
+                      <p:strVal val="visible"/>
+                    </p:to>
+                  </p:set>
                   <p:animEffect transition="in" filter="fade">
                     <p:cBhvr>
-                      <p:cTn id="9" dur="360" fill="hold"/>
+                      <p:cTn id="12" dur="360" fill="hold"/>
                       <p:tgtEl>
                         <p:spTgt spid="11"/>
                       </p:tgtEl>
@@ -15692,7 +16872,7 @@
                   </p:animEffect>
                   <p:animScale>
                     <p:cBhvr>
-                      <p:cTn id="10" dur="360" fill="hold"/>
+                      <p:cTn id="13" dur="360" fill="hold"/>
                       <p:tgtEl>
                         <p:spTgt spid="11"/>
                       </p:tgtEl>
@@ -15708,14 +16888,28 @@
               </p:cTn>
             </p:par>
             <p:par>
-              <p:cTn id="11" fill="hold" nodeType="afterEffect">
+              <p:cTn id="14" fill="hold" nodeType="afterEffect" presetID="2819" presetClass="entr" presetSubtype="0">
                 <p:stCondLst>
                   <p:cond delay="790"/>
                 </p:stCondLst>
                 <p:childTnLst>
-                  <p:animEffect transition="in" filter="wipe(fromLeft)">
-                    <p:cBhvr>
-                      <p:cTn id="12" dur="360" fill="hold"/>
+                  <p:set>
+                    <p:cBhvr>
+                      <p:cTn id="15" dur="1" fill="hold"/>
+                      <p:tgtEl>
+                        <p:spTgt spid="13"/>
+                      </p:tgtEl>
+                      <p:attrNameLst>
+                        <p:attrName>style.visibility</p:attrName>
+                      </p:attrNameLst>
+                    </p:cBhvr>
+                    <p:to>
+                      <p:strVal val="visible"/>
+                    </p:to>
+                  </p:set>
+                  <p:animEffect transition="in" filter="wipe(right)">
+                    <p:cBhvr>
+                      <p:cTn id="16" dur="360" fill="hold"/>
                       <p:tgtEl>
                         <p:spTgt spid="13"/>
                       </p:tgtEl>
@@ -15725,14 +16919,28 @@
               </p:cTn>
             </p:par>
             <p:par>
-              <p:cTn id="14" fill="hold" nodeType="afterEffect">
+              <p:cTn id="18" fill="hold" nodeType="afterEffect" presetID="22" presetClass="entr" presetSubtype="0">
                 <p:stCondLst>
                   <p:cond delay="1020"/>
                 </p:stCondLst>
                 <p:childTnLst>
+                  <p:set>
+                    <p:cBhvr>
+                      <p:cTn id="19" dur="1" fill="hold"/>
+                      <p:tgtEl>
+                        <p:spTgt spid="16"/>
+                      </p:tgtEl>
+                      <p:attrNameLst>
+                        <p:attrName>style.visibility</p:attrName>
+                      </p:attrNameLst>
+                    </p:cBhvr>
+                    <p:to>
+                      <p:strVal val="visible"/>
+                    </p:to>
+                  </p:set>
                   <p:animEffect transition="in" filter="fade">
                     <p:cBhvr>
-                      <p:cTn id="15" dur="360" fill="hold"/>
+                      <p:cTn id="20" dur="360" fill="hold"/>
                       <p:tgtEl>
                         <p:spTgt spid="16"/>
                       </p:tgtEl>
@@ -15740,7 +16948,7 @@
                   </p:animEffect>
                   <p:animScale>
                     <p:cBhvr>
-                      <p:cTn id="16" dur="360" fill="hold"/>
+                      <p:cTn id="21" dur="360" fill="hold"/>
                       <p:tgtEl>
                         <p:spTgt spid="16"/>
                       </p:tgtEl>
@@ -15756,14 +16964,28 @@
               </p:cTn>
             </p:par>
             <p:par>
-              <p:cTn id="17" fill="hold" nodeType="withEffect">
+              <p:cTn id="22" fill="hold" nodeType="withEffect" presetID="22" presetClass="entr" presetSubtype="0">
                 <p:stCondLst>
                   <p:cond delay="1020"/>
                 </p:stCondLst>
                 <p:childTnLst>
+                  <p:set>
+                    <p:cBhvr>
+                      <p:cTn id="23" dur="1" fill="hold"/>
+                      <p:tgtEl>
+                        <p:spTgt spid="17"/>
+                      </p:tgtEl>
+                      <p:attrNameLst>
+                        <p:attrName>style.visibility</p:attrName>
+                      </p:attrNameLst>
+                    </p:cBhvr>
+                    <p:to>
+                      <p:strVal val="visible"/>
+                    </p:to>
+                  </p:set>
                   <p:animEffect transition="in" filter="fade">
                     <p:cBhvr>
-                      <p:cTn id="18" dur="360" fill="hold"/>
+                      <p:cTn id="24" dur="360" fill="hold"/>
                       <p:tgtEl>
                         <p:spTgt spid="17"/>
                       </p:tgtEl>
@@ -15771,7 +16993,7 @@
                   </p:animEffect>
                   <p:animScale>
                     <p:cBhvr>
-                      <p:cTn id="19" dur="360" fill="hold"/>
+                      <p:cTn id="25" dur="360" fill="hold"/>
                       <p:tgtEl>
                         <p:spTgt spid="17"/>
                       </p:tgtEl>
@@ -15787,14 +17009,28 @@
               </p:cTn>
             </p:par>
             <p:par>
-              <p:cTn id="20" fill="hold" nodeType="afterEffect">
+              <p:cTn id="26" fill="hold" nodeType="afterEffect" presetID="22" presetClass="entr" presetSubtype="0">
                 <p:stCondLst>
                   <p:cond delay="1250"/>
                 </p:stCondLst>
                 <p:childTnLst>
+                  <p:set>
+                    <p:cBhvr>
+                      <p:cTn id="27" dur="1" fill="hold"/>
+                      <p:tgtEl>
+                        <p:spTgt spid="20"/>
+                      </p:tgtEl>
+                      <p:attrNameLst>
+                        <p:attrName>style.visibility</p:attrName>
+                      </p:attrNameLst>
+                    </p:cBhvr>
+                    <p:to>
+                      <p:strVal val="visible"/>
+                    </p:to>
+                  </p:set>
                   <p:animEffect transition="in" filter="fade">
                     <p:cBhvr>
-                      <p:cTn id="21" dur="360" fill="hold"/>
+                      <p:cTn id="28" dur="360" fill="hold"/>
                       <p:tgtEl>
                         <p:spTgt spid="20"/>
                       </p:tgtEl>
@@ -15802,7 +17038,7 @@
                   </p:animEffect>
                   <p:animScale>
                     <p:cBhvr>
-                      <p:cTn id="22" dur="360" fill="hold"/>
+                      <p:cTn id="29" dur="360" fill="hold"/>
                       <p:tgtEl>
                         <p:spTgt spid="20"/>
                       </p:tgtEl>
@@ -15818,14 +17054,28 @@
               </p:cTn>
             </p:par>
             <p:par>
-              <p:cTn id="23" fill="hold" nodeType="withEffect">
+              <p:cTn id="30" fill="hold" nodeType="withEffect" presetID="22" presetClass="entr" presetSubtype="0">
                 <p:stCondLst>
                   <p:cond delay="1250"/>
                 </p:stCondLst>
                 <p:childTnLst>
+                  <p:set>
+                    <p:cBhvr>
+                      <p:cTn id="31" dur="1" fill="hold"/>
+                      <p:tgtEl>
+                        <p:spTgt spid="21"/>
+                      </p:tgtEl>
+                      <p:attrNameLst>
+                        <p:attrName>style.visibility</p:attrName>
+                      </p:attrNameLst>
+                    </p:cBhvr>
+                    <p:to>
+                      <p:strVal val="visible"/>
+                    </p:to>
+                  </p:set>
                   <p:animEffect transition="in" filter="fade">
                     <p:cBhvr>
-                      <p:cTn id="24" dur="360" fill="hold"/>
+                      <p:cTn id="32" dur="360" fill="hold"/>
                       <p:tgtEl>
                         <p:spTgt spid="21"/>
                       </p:tgtEl>
@@ -15833,7 +17083,7 @@
                   </p:animEffect>
                   <p:animScale>
                     <p:cBhvr>
-                      <p:cTn id="25" dur="360" fill="hold"/>
+                      <p:cTn id="33" dur="360" fill="hold"/>
                       <p:tgtEl>
                         <p:spTgt spid="21"/>
                       </p:tgtEl>
@@ -15849,14 +17099,28 @@
               </p:cTn>
             </p:par>
             <p:par>
-              <p:cTn id="26" fill="hold" nodeType="afterEffect">
+              <p:cTn id="34" fill="hold" nodeType="afterEffect" presetID="22" presetClass="entr" presetSubtype="0">
                 <p:stCondLst>
                   <p:cond delay="1480"/>
                 </p:stCondLst>
                 <p:childTnLst>
+                  <p:set>
+                    <p:cBhvr>
+                      <p:cTn id="35" dur="1" fill="hold"/>
+                      <p:tgtEl>
+                        <p:spTgt spid="24"/>
+                      </p:tgtEl>
+                      <p:attrNameLst>
+                        <p:attrName>style.visibility</p:attrName>
+                      </p:attrNameLst>
+                    </p:cBhvr>
+                    <p:to>
+                      <p:strVal val="visible"/>
+                    </p:to>
+                  </p:set>
                   <p:animEffect transition="in" filter="fade">
                     <p:cBhvr>
-                      <p:cTn id="27" dur="360" fill="hold"/>
+                      <p:cTn id="36" dur="360" fill="hold"/>
                       <p:tgtEl>
                         <p:spTgt spid="24"/>
                       </p:tgtEl>
@@ -15864,7 +17128,7 @@
                   </p:animEffect>
                   <p:animScale>
                     <p:cBhvr>
-                      <p:cTn id="28" dur="360" fill="hold"/>
+                      <p:cTn id="37" dur="360" fill="hold"/>
                       <p:tgtEl>
                         <p:spTgt spid="24"/>
                       </p:tgtEl>
@@ -15880,14 +17144,28 @@
               </p:cTn>
             </p:par>
             <p:par>
-              <p:cTn id="29" fill="hold" nodeType="withEffect">
+              <p:cTn id="38" fill="hold" nodeType="withEffect" presetID="22" presetClass="entr" presetSubtype="0">
                 <p:stCondLst>
                   <p:cond delay="1480"/>
                 </p:stCondLst>
                 <p:childTnLst>
+                  <p:set>
+                    <p:cBhvr>
+                      <p:cTn id="39" dur="1" fill="hold"/>
+                      <p:tgtEl>
+                        <p:spTgt spid="25"/>
+                      </p:tgtEl>
+                      <p:attrNameLst>
+                        <p:attrName>style.visibility</p:attrName>
+                      </p:attrNameLst>
+                    </p:cBhvr>
+                    <p:to>
+                      <p:strVal val="visible"/>
+                    </p:to>
+                  </p:set>
                   <p:animEffect transition="in" filter="fade">
                     <p:cBhvr>
-                      <p:cTn id="30" dur="360" fill="hold"/>
+                      <p:cTn id="40" dur="360" fill="hold"/>
                       <p:tgtEl>
                         <p:spTgt spid="25"/>
                       </p:tgtEl>
@@ -15895,7 +17173,7 @@
                   </p:animEffect>
                   <p:animScale>
                     <p:cBhvr>
-                      <p:cTn id="31" dur="360" fill="hold"/>
+                      <p:cTn id="41" dur="360" fill="hold"/>
                       <p:tgtEl>
                         <p:spTgt spid="25"/>
                       </p:tgtEl>
@@ -15911,14 +17189,28 @@
               </p:cTn>
             </p:par>
             <p:par>
-              <p:cTn id="32" fill="hold" nodeType="afterEffect">
+              <p:cTn id="42" fill="hold" nodeType="afterEffect" presetID="22" presetClass="entr" presetSubtype="0">
                 <p:stCondLst>
                   <p:cond delay="1710"/>
                 </p:stCondLst>
                 <p:childTnLst>
+                  <p:set>
+                    <p:cBhvr>
+                      <p:cTn id="43" dur="1" fill="hold"/>
+                      <p:tgtEl>
+                        <p:spTgt spid="28"/>
+                      </p:tgtEl>
+                      <p:attrNameLst>
+                        <p:attrName>style.visibility</p:attrName>
+                      </p:attrNameLst>
+                    </p:cBhvr>
+                    <p:to>
+                      <p:strVal val="visible"/>
+                    </p:to>
+                  </p:set>
                   <p:animEffect transition="in" filter="fade">
                     <p:cBhvr>
-                      <p:cTn id="33" dur="360" fill="hold"/>
+                      <p:cTn id="44" dur="360" fill="hold"/>
                       <p:tgtEl>
                         <p:spTgt spid="28"/>
                       </p:tgtEl>
@@ -15926,7 +17218,7 @@
                   </p:animEffect>
                   <p:animScale>
                     <p:cBhvr>
-                      <p:cTn id="34" dur="360" fill="hold"/>
+                      <p:cTn id="45" dur="360" fill="hold"/>
                       <p:tgtEl>
                         <p:spTgt spid="28"/>
                       </p:tgtEl>
@@ -15942,14 +17234,28 @@
               </p:cTn>
             </p:par>
             <p:par>
-              <p:cTn id="35" fill="hold" nodeType="withEffect">
+              <p:cTn id="46" fill="hold" nodeType="withEffect" presetID="22" presetClass="entr" presetSubtype="0">
                 <p:stCondLst>
                   <p:cond delay="1710"/>
                 </p:stCondLst>
                 <p:childTnLst>
+                  <p:set>
+                    <p:cBhvr>
+                      <p:cTn id="47" dur="1" fill="hold"/>
+                      <p:tgtEl>
+                        <p:spTgt spid="29"/>
+                      </p:tgtEl>
+                      <p:attrNameLst>
+                        <p:attrName>style.visibility</p:attrName>
+                      </p:attrNameLst>
+                    </p:cBhvr>
+                    <p:to>
+                      <p:strVal val="visible"/>
+                    </p:to>
+                  </p:set>
                   <p:animEffect transition="in" filter="fade">
                     <p:cBhvr>
-                      <p:cTn id="36" dur="360" fill="hold"/>
+                      <p:cTn id="48" dur="360" fill="hold"/>
                       <p:tgtEl>
                         <p:spTgt spid="29"/>
                       </p:tgtEl>
@@ -15957,7 +17263,7 @@
                   </p:animEffect>
                   <p:animScale>
                     <p:cBhvr>
-                      <p:cTn id="37" dur="360" fill="hold"/>
+                      <p:cTn id="49" dur="360" fill="hold"/>
                       <p:tgtEl>
                         <p:spTgt spid="29"/>
                       </p:tgtEl>
@@ -15973,14 +17279,28 @@
               </p:cTn>
             </p:par>
             <p:par>
-              <p:cTn id="38" fill="hold" nodeType="afterEffect">
+              <p:cTn id="50" fill="hold" nodeType="afterEffect" presetID="2819" presetClass="entr" presetSubtype="0">
                 <p:stCondLst>
                   <p:cond delay="1940"/>
                 </p:stCondLst>
                 <p:childTnLst>
-                  <p:animEffect transition="in" filter="wipe(fromLeft)">
-                    <p:cBhvr>
-                      <p:cTn id="39" dur="360" fill="hold"/>
+                  <p:set>
+                    <p:cBhvr>
+                      <p:cTn id="51" dur="1" fill="hold"/>
+                      <p:tgtEl>
+                        <p:spTgt spid="31"/>
+                      </p:tgtEl>
+                      <p:attrNameLst>
+                        <p:attrName>style.visibility</p:attrName>
+                      </p:attrNameLst>
+                    </p:cBhvr>
+                    <p:to>
+                      <p:strVal val="visible"/>
+                    </p:to>
+                  </p:set>
+                  <p:animEffect transition="in" filter="wipe(right)">
+                    <p:cBhvr>
+                      <p:cTn id="52" dur="360" fill="hold"/>
                       <p:tgtEl>
                         <p:spTgt spid="31"/>
                       </p:tgtEl>
@@ -15990,14 +17310,28 @@
               </p:cTn>
             </p:par>
             <p:par>
-              <p:cTn id="41" fill="hold" nodeType="afterEffect">
+              <p:cTn id="54" fill="hold" nodeType="afterEffect" presetID="2819" presetClass="entr" presetSubtype="0">
                 <p:stCondLst>
                   <p:cond delay="2170"/>
                 </p:stCondLst>
                 <p:childTnLst>
-                  <p:animEffect transition="in" filter="wipe(fromLeft)">
-                    <p:cBhvr>
-                      <p:cTn id="42" dur="360" fill="hold"/>
+                  <p:set>
+                    <p:cBhvr>
+                      <p:cTn id="55" dur="1" fill="hold"/>
+                      <p:tgtEl>
+                        <p:spTgt spid="32"/>
+                      </p:tgtEl>
+                      <p:attrNameLst>
+                        <p:attrName>style.visibility</p:attrName>
+                      </p:attrNameLst>
+                    </p:cBhvr>
+                    <p:to>
+                      <p:strVal val="visible"/>
+                    </p:to>
+                  </p:set>
+                  <p:animEffect transition="in" filter="wipe(right)">
+                    <p:cBhvr>
+                      <p:cTn id="56" dur="360" fill="hold"/>
                       <p:tgtEl>
                         <p:spTgt spid="32"/>
                       </p:tgtEl>
@@ -17173,14 +18507,28 @@
           </p:stCondLst>
           <p:childTnLst>
             <p:par>
-              <p:cTn id="2" fill="hold" nodeType="afterEffect">
+              <p:cTn id="2" fill="hold" nodeType="afterEffect" presetID="10" presetClass="entr" presetSubtype="0">
                 <p:stCondLst>
                   <p:cond delay="0"/>
                 </p:stCondLst>
                 <p:childTnLst>
+                  <p:set>
+                    <p:cBhvr>
+                      <p:cTn id="3" dur="1" fill="hold"/>
+                      <p:tgtEl>
+                        <p:spTgt spid="8"/>
+                      </p:tgtEl>
+                      <p:attrNameLst>
+                        <p:attrName>style.visibility</p:attrName>
+                      </p:attrNameLst>
+                    </p:cBhvr>
+                    <p:to>
+                      <p:strVal val="visible"/>
+                    </p:to>
+                  </p:set>
                   <p:animEffect transition="in" filter="fade">
                     <p:cBhvr>
-                      <p:cTn id="3" dur="500" fill="hold"/>
+                      <p:cTn id="4" dur="500" fill="hold"/>
                       <p:tgtEl>
                         <p:spTgt spid="8"/>
                       </p:tgtEl>
@@ -17190,14 +18538,28 @@
               </p:cTn>
             </p:par>
             <p:par>
-              <p:cTn id="5" fill="hold" nodeType="afterEffect">
+              <p:cTn id="6" fill="hold" nodeType="afterEffect" presetID="22" presetClass="entr" presetSubtype="0">
                 <p:stCondLst>
                   <p:cond delay="560"/>
                 </p:stCondLst>
                 <p:childTnLst>
+                  <p:set>
+                    <p:cBhvr>
+                      <p:cTn id="7" dur="1" fill="hold"/>
+                      <p:tgtEl>
+                        <p:spTgt spid="10"/>
+                      </p:tgtEl>
+                      <p:attrNameLst>
+                        <p:attrName>style.visibility</p:attrName>
+                      </p:attrNameLst>
+                    </p:cBhvr>
+                    <p:to>
+                      <p:strVal val="visible"/>
+                    </p:to>
+                  </p:set>
                   <p:animEffect transition="in" filter="fade">
                     <p:cBhvr>
-                      <p:cTn id="6" dur="420" fill="hold"/>
+                      <p:cTn id="8" dur="420" fill="hold"/>
                       <p:tgtEl>
                         <p:spTgt spid="10"/>
                       </p:tgtEl>
@@ -17205,7 +18567,7 @@
                   </p:animEffect>
                   <p:animScale>
                     <p:cBhvr>
-                      <p:cTn id="7" dur="420" fill="hold"/>
+                      <p:cTn id="9" dur="420" fill="hold"/>
                       <p:tgtEl>
                         <p:spTgt spid="10"/>
                       </p:tgtEl>
@@ -17221,14 +18583,28 @@
               </p:cTn>
             </p:par>
             <p:par>
-              <p:cTn id="8" fill="hold" nodeType="afterEffect">
+              <p:cTn id="10" fill="hold" nodeType="afterEffect" presetID="22" presetClass="entr" presetSubtype="0">
                 <p:stCondLst>
                   <p:cond delay="860"/>
                 </p:stCondLst>
                 <p:childTnLst>
+                  <p:set>
+                    <p:cBhvr>
+                      <p:cTn id="11" dur="1" fill="hold"/>
+                      <p:tgtEl>
+                        <p:spTgt spid="13"/>
+                      </p:tgtEl>
+                      <p:attrNameLst>
+                        <p:attrName>style.visibility</p:attrName>
+                      </p:attrNameLst>
+                    </p:cBhvr>
+                    <p:to>
+                      <p:strVal val="visible"/>
+                    </p:to>
+                  </p:set>
                   <p:animEffect transition="in" filter="fade">
                     <p:cBhvr>
-                      <p:cTn id="9" dur="380" fill="hold"/>
+                      <p:cTn id="12" dur="380" fill="hold"/>
                       <p:tgtEl>
                         <p:spTgt spid="13"/>
                       </p:tgtEl>
@@ -17236,7 +18612,7 @@
                   </p:animEffect>
                   <p:animScale>
                     <p:cBhvr>
-                      <p:cTn id="10" dur="380" fill="hold"/>
+                      <p:cTn id="13" dur="380" fill="hold"/>
                       <p:tgtEl>
                         <p:spTgt spid="13"/>
                       </p:tgtEl>
@@ -17252,14 +18628,28 @@
               </p:cTn>
             </p:par>
             <p:par>
-              <p:cTn id="11" fill="hold" nodeType="withEffect">
+              <p:cTn id="14" fill="hold" nodeType="withEffect" presetID="22" presetClass="entr" presetSubtype="0">
                 <p:stCondLst>
                   <p:cond delay="860"/>
                 </p:stCondLst>
                 <p:childTnLst>
+                  <p:set>
+                    <p:cBhvr>
+                      <p:cTn id="15" dur="1" fill="hold"/>
+                      <p:tgtEl>
+                        <p:spTgt spid="14"/>
+                      </p:tgtEl>
+                      <p:attrNameLst>
+                        <p:attrName>style.visibility</p:attrName>
+                      </p:attrNameLst>
+                    </p:cBhvr>
+                    <p:to>
+                      <p:strVal val="visible"/>
+                    </p:to>
+                  </p:set>
                   <p:animEffect transition="in" filter="fade">
                     <p:cBhvr>
-                      <p:cTn id="12" dur="380" fill="hold"/>
+                      <p:cTn id="16" dur="380" fill="hold"/>
                       <p:tgtEl>
                         <p:spTgt spid="14"/>
                       </p:tgtEl>
@@ -17267,7 +18657,7 @@
                   </p:animEffect>
                   <p:animScale>
                     <p:cBhvr>
-                      <p:cTn id="13" dur="380" fill="hold"/>
+                      <p:cTn id="17" dur="380" fill="hold"/>
                       <p:tgtEl>
                         <p:spTgt spid="14"/>
                       </p:tgtEl>
@@ -17283,14 +18673,28 @@
               </p:cTn>
             </p:par>
             <p:par>
-              <p:cTn id="14" fill="hold" nodeType="afterEffect">
+              <p:cTn id="18" fill="hold" nodeType="afterEffect" presetID="22" presetClass="entr" presetSubtype="0">
                 <p:stCondLst>
                   <p:cond delay="1120"/>
                 </p:stCondLst>
                 <p:childTnLst>
+                  <p:set>
+                    <p:cBhvr>
+                      <p:cTn id="19" dur="1" fill="hold"/>
+                      <p:tgtEl>
+                        <p:spTgt spid="17"/>
+                      </p:tgtEl>
+                      <p:attrNameLst>
+                        <p:attrName>style.visibility</p:attrName>
+                      </p:attrNameLst>
+                    </p:cBhvr>
+                    <p:to>
+                      <p:strVal val="visible"/>
+                    </p:to>
+                  </p:set>
                   <p:animEffect transition="in" filter="fade">
                     <p:cBhvr>
-                      <p:cTn id="15" dur="380" fill="hold"/>
+                      <p:cTn id="20" dur="380" fill="hold"/>
                       <p:tgtEl>
                         <p:spTgt spid="17"/>
                       </p:tgtEl>
@@ -17298,7 +18702,7 @@
                   </p:animEffect>
                   <p:animScale>
                     <p:cBhvr>
-                      <p:cTn id="16" dur="380" fill="hold"/>
+                      <p:cTn id="21" dur="380" fill="hold"/>
                       <p:tgtEl>
                         <p:spTgt spid="17"/>
                       </p:tgtEl>
@@ -17314,14 +18718,28 @@
               </p:cTn>
             </p:par>
             <p:par>
-              <p:cTn id="17" fill="hold" nodeType="withEffect">
+              <p:cTn id="22" fill="hold" nodeType="withEffect" presetID="22" presetClass="entr" presetSubtype="0">
                 <p:stCondLst>
                   <p:cond delay="1120"/>
                 </p:stCondLst>
                 <p:childTnLst>
+                  <p:set>
+                    <p:cBhvr>
+                      <p:cTn id="23" dur="1" fill="hold"/>
+                      <p:tgtEl>
+                        <p:spTgt spid="18"/>
+                      </p:tgtEl>
+                      <p:attrNameLst>
+                        <p:attrName>style.visibility</p:attrName>
+                      </p:attrNameLst>
+                    </p:cBhvr>
+                    <p:to>
+                      <p:strVal val="visible"/>
+                    </p:to>
+                  </p:set>
                   <p:animEffect transition="in" filter="fade">
                     <p:cBhvr>
-                      <p:cTn id="18" dur="380" fill="hold"/>
+                      <p:cTn id="24" dur="380" fill="hold"/>
                       <p:tgtEl>
                         <p:spTgt spid="18"/>
                       </p:tgtEl>
@@ -17329,7 +18747,7 @@
                   </p:animEffect>
                   <p:animScale>
                     <p:cBhvr>
-                      <p:cTn id="19" dur="380" fill="hold"/>
+                      <p:cTn id="25" dur="380" fill="hold"/>
                       <p:tgtEl>
                         <p:spTgt spid="18"/>
                       </p:tgtEl>
@@ -17345,14 +18763,28 @@
               </p:cTn>
             </p:par>
             <p:par>
-              <p:cTn id="20" fill="hold" nodeType="afterEffect">
+              <p:cTn id="26" fill="hold" nodeType="afterEffect" presetID="22" presetClass="entr" presetSubtype="0">
                 <p:stCondLst>
                   <p:cond delay="1380"/>
                 </p:stCondLst>
                 <p:childTnLst>
+                  <p:set>
+                    <p:cBhvr>
+                      <p:cTn id="27" dur="1" fill="hold"/>
+                      <p:tgtEl>
+                        <p:spTgt spid="21"/>
+                      </p:tgtEl>
+                      <p:attrNameLst>
+                        <p:attrName>style.visibility</p:attrName>
+                      </p:attrNameLst>
+                    </p:cBhvr>
+                    <p:to>
+                      <p:strVal val="visible"/>
+                    </p:to>
+                  </p:set>
                   <p:animEffect transition="in" filter="fade">
                     <p:cBhvr>
-                      <p:cTn id="21" dur="380" fill="hold"/>
+                      <p:cTn id="28" dur="380" fill="hold"/>
                       <p:tgtEl>
                         <p:spTgt spid="21"/>
                       </p:tgtEl>
@@ -17360,7 +18792,7 @@
                   </p:animEffect>
                   <p:animScale>
                     <p:cBhvr>
-                      <p:cTn id="22" dur="380" fill="hold"/>
+                      <p:cTn id="29" dur="380" fill="hold"/>
                       <p:tgtEl>
                         <p:spTgt spid="21"/>
                       </p:tgtEl>
@@ -17376,14 +18808,28 @@
               </p:cTn>
             </p:par>
             <p:par>
-              <p:cTn id="23" fill="hold" nodeType="withEffect">
+              <p:cTn id="30" fill="hold" nodeType="withEffect" presetID="22" presetClass="entr" presetSubtype="0">
                 <p:stCondLst>
                   <p:cond delay="1380"/>
                 </p:stCondLst>
                 <p:childTnLst>
+                  <p:set>
+                    <p:cBhvr>
+                      <p:cTn id="31" dur="1" fill="hold"/>
+                      <p:tgtEl>
+                        <p:spTgt spid="22"/>
+                      </p:tgtEl>
+                      <p:attrNameLst>
+                        <p:attrName>style.visibility</p:attrName>
+                      </p:attrNameLst>
+                    </p:cBhvr>
+                    <p:to>
+                      <p:strVal val="visible"/>
+                    </p:to>
+                  </p:set>
                   <p:animEffect transition="in" filter="fade">
                     <p:cBhvr>
-                      <p:cTn id="24" dur="380" fill="hold"/>
+                      <p:cTn id="32" dur="380" fill="hold"/>
                       <p:tgtEl>
                         <p:spTgt spid="22"/>
                       </p:tgtEl>
@@ -17391,7 +18837,7 @@
                   </p:animEffect>
                   <p:animScale>
                     <p:cBhvr>
-                      <p:cTn id="25" dur="380" fill="hold"/>
+                      <p:cTn id="33" dur="380" fill="hold"/>
                       <p:tgtEl>
                         <p:spTgt spid="22"/>
                       </p:tgtEl>
@@ -17407,14 +18853,28 @@
               </p:cTn>
             </p:par>
             <p:par>
-              <p:cTn id="26" fill="hold" nodeType="afterEffect">
+              <p:cTn id="34" fill="hold" nodeType="afterEffect" presetID="22" presetClass="entr" presetSubtype="0">
                 <p:stCondLst>
                   <p:cond delay="1640"/>
                 </p:stCondLst>
                 <p:childTnLst>
+                  <p:set>
+                    <p:cBhvr>
+                      <p:cTn id="35" dur="1" fill="hold"/>
+                      <p:tgtEl>
+                        <p:spTgt spid="25"/>
+                      </p:tgtEl>
+                      <p:attrNameLst>
+                        <p:attrName>style.visibility</p:attrName>
+                      </p:attrNameLst>
+                    </p:cBhvr>
+                    <p:to>
+                      <p:strVal val="visible"/>
+                    </p:to>
+                  </p:set>
                   <p:animEffect transition="in" filter="fade">
                     <p:cBhvr>
-                      <p:cTn id="27" dur="380" fill="hold"/>
+                      <p:cTn id="36" dur="380" fill="hold"/>
                       <p:tgtEl>
                         <p:spTgt spid="25"/>
                       </p:tgtEl>
@@ -17422,7 +18882,7 @@
                   </p:animEffect>
                   <p:animScale>
                     <p:cBhvr>
-                      <p:cTn id="28" dur="380" fill="hold"/>
+                      <p:cTn id="37" dur="380" fill="hold"/>
                       <p:tgtEl>
                         <p:spTgt spid="25"/>
                       </p:tgtEl>
@@ -17438,14 +18898,28 @@
               </p:cTn>
             </p:par>
             <p:par>
-              <p:cTn id="29" fill="hold" nodeType="withEffect">
+              <p:cTn id="38" fill="hold" nodeType="withEffect" presetID="22" presetClass="entr" presetSubtype="0">
                 <p:stCondLst>
                   <p:cond delay="1640"/>
                 </p:stCondLst>
                 <p:childTnLst>
+                  <p:set>
+                    <p:cBhvr>
+                      <p:cTn id="39" dur="1" fill="hold"/>
+                      <p:tgtEl>
+                        <p:spTgt spid="26"/>
+                      </p:tgtEl>
+                      <p:attrNameLst>
+                        <p:attrName>style.visibility</p:attrName>
+                      </p:attrNameLst>
+                    </p:cBhvr>
+                    <p:to>
+                      <p:strVal val="visible"/>
+                    </p:to>
+                  </p:set>
                   <p:animEffect transition="in" filter="fade">
                     <p:cBhvr>
-                      <p:cTn id="30" dur="380" fill="hold"/>
+                      <p:cTn id="40" dur="380" fill="hold"/>
                       <p:tgtEl>
                         <p:spTgt spid="26"/>
                       </p:tgtEl>
@@ -17453,7 +18927,7 @@
                   </p:animEffect>
                   <p:animScale>
                     <p:cBhvr>
-                      <p:cTn id="31" dur="380" fill="hold"/>
+                      <p:cTn id="41" dur="380" fill="hold"/>
                       <p:tgtEl>
                         <p:spTgt spid="26"/>
                       </p:tgtEl>
@@ -18794,14 +20268,28 @@
           </p:stCondLst>
           <p:childTnLst>
             <p:par>
-              <p:cTn id="2" fill="hold" nodeType="afterEffect">
+              <p:cTn id="2" fill="hold" nodeType="afterEffect" presetID="10" presetClass="entr" presetSubtype="0">
                 <p:stCondLst>
                   <p:cond delay="0"/>
                 </p:stCondLst>
                 <p:childTnLst>
+                  <p:set>
+                    <p:cBhvr>
+                      <p:cTn id="3" dur="1" fill="hold"/>
+                      <p:tgtEl>
+                        <p:spTgt spid="8"/>
+                      </p:tgtEl>
+                      <p:attrNameLst>
+                        <p:attrName>style.visibility</p:attrName>
+                      </p:attrNameLst>
+                    </p:cBhvr>
+                    <p:to>
+                      <p:strVal val="visible"/>
+                    </p:to>
+                  </p:set>
                   <p:animEffect transition="in" filter="fade">
                     <p:cBhvr>
-                      <p:cTn id="3" dur="500" fill="hold"/>
+                      <p:cTn id="4" dur="500" fill="hold"/>
                       <p:tgtEl>
                         <p:spTgt spid="8"/>
                       </p:tgtEl>
@@ -18811,14 +20299,28 @@
               </p:cTn>
             </p:par>
             <p:par>
-              <p:cTn id="5" fill="hold" nodeType="afterEffect">
+              <p:cTn id="6" fill="hold" nodeType="afterEffect" presetID="2819" presetClass="entr" presetSubtype="0">
                 <p:stCondLst>
                   <p:cond delay="560"/>
                 </p:stCondLst>
                 <p:childTnLst>
-                  <p:animEffect transition="in" filter="wipe(fromLeft)">
-                    <p:cBhvr>
-                      <p:cTn id="6" dur="450" fill="hold"/>
+                  <p:set>
+                    <p:cBhvr>
+                      <p:cTn id="7" dur="1" fill="hold"/>
+                      <p:tgtEl>
+                        <p:spTgt spid="9"/>
+                      </p:tgtEl>
+                      <p:attrNameLst>
+                        <p:attrName>style.visibility</p:attrName>
+                      </p:attrNameLst>
+                    </p:cBhvr>
+                    <p:to>
+                      <p:strVal val="visible"/>
+                    </p:to>
+                  </p:set>
+                  <p:animEffect transition="in" filter="wipe(right)">
+                    <p:cBhvr>
+                      <p:cTn id="8" dur="450" fill="hold"/>
                       <p:tgtEl>
                         <p:spTgt spid="9"/>
                       </p:tgtEl>
@@ -18828,14 +20330,28 @@
               </p:cTn>
             </p:par>
             <p:par>
-              <p:cTn id="8" fill="hold" nodeType="afterEffect">
+              <p:cTn id="10" fill="hold" nodeType="afterEffect" presetID="22" presetClass="entr" presetSubtype="0">
                 <p:stCondLst>
                   <p:cond delay="950"/>
                 </p:stCondLst>
                 <p:childTnLst>
+                  <p:set>
+                    <p:cBhvr>
+                      <p:cTn id="11" dur="1" fill="hold"/>
+                      <p:tgtEl>
+                        <p:spTgt spid="12"/>
+                      </p:tgtEl>
+                      <p:attrNameLst>
+                        <p:attrName>style.visibility</p:attrName>
+                      </p:attrNameLst>
+                    </p:cBhvr>
+                    <p:to>
+                      <p:strVal val="visible"/>
+                    </p:to>
+                  </p:set>
                   <p:animEffect transition="in" filter="fade">
                     <p:cBhvr>
-                      <p:cTn id="9" dur="360" fill="hold"/>
+                      <p:cTn id="12" dur="360" fill="hold"/>
                       <p:tgtEl>
                         <p:spTgt spid="12"/>
                       </p:tgtEl>
@@ -18843,7 +20359,7 @@
                   </p:animEffect>
                   <p:animScale>
                     <p:cBhvr>
-                      <p:cTn id="10" dur="360" fill="hold"/>
+                      <p:cTn id="13" dur="360" fill="hold"/>
                       <p:tgtEl>
                         <p:spTgt spid="12"/>
                       </p:tgtEl>
@@ -18859,14 +20375,28 @@
               </p:cTn>
             </p:par>
             <p:par>
-              <p:cTn id="11" fill="hold" nodeType="withEffect">
+              <p:cTn id="14" fill="hold" nodeType="withEffect" presetID="22" presetClass="entr" presetSubtype="0">
                 <p:stCondLst>
                   <p:cond delay="950"/>
                 </p:stCondLst>
                 <p:childTnLst>
+                  <p:set>
+                    <p:cBhvr>
+                      <p:cTn id="15" dur="1" fill="hold"/>
+                      <p:tgtEl>
+                        <p:spTgt spid="13"/>
+                      </p:tgtEl>
+                      <p:attrNameLst>
+                        <p:attrName>style.visibility</p:attrName>
+                      </p:attrNameLst>
+                    </p:cBhvr>
+                    <p:to>
+                      <p:strVal val="visible"/>
+                    </p:to>
+                  </p:set>
                   <p:animEffect transition="in" filter="fade">
                     <p:cBhvr>
-                      <p:cTn id="12" dur="360" fill="hold"/>
+                      <p:cTn id="16" dur="360" fill="hold"/>
                       <p:tgtEl>
                         <p:spTgt spid="13"/>
                       </p:tgtEl>
@@ -18874,7 +20404,7 @@
                   </p:animEffect>
                   <p:animScale>
                     <p:cBhvr>
-                      <p:cTn id="13" dur="360" fill="hold"/>
+                      <p:cTn id="17" dur="360" fill="hold"/>
                       <p:tgtEl>
                         <p:spTgt spid="13"/>
                       </p:tgtEl>
@@ -18890,14 +20420,28 @@
               </p:cTn>
             </p:par>
             <p:par>
-              <p:cTn id="14" fill="hold" nodeType="withEffect">
+              <p:cTn id="18" fill="hold" nodeType="withEffect" presetID="22" presetClass="entr" presetSubtype="0">
                 <p:stCondLst>
                   <p:cond delay="950"/>
                 </p:stCondLst>
                 <p:childTnLst>
+                  <p:set>
+                    <p:cBhvr>
+                      <p:cTn id="19" dur="1" fill="hold"/>
+                      <p:tgtEl>
+                        <p:spTgt spid="14"/>
+                      </p:tgtEl>
+                      <p:attrNameLst>
+                        <p:attrName>style.visibility</p:attrName>
+                      </p:attrNameLst>
+                    </p:cBhvr>
+                    <p:to>
+                      <p:strVal val="visible"/>
+                    </p:to>
+                  </p:set>
                   <p:animEffect transition="in" filter="fade">
                     <p:cBhvr>
-                      <p:cTn id="15" dur="360" fill="hold"/>
+                      <p:cTn id="20" dur="360" fill="hold"/>
                       <p:tgtEl>
                         <p:spTgt spid="14"/>
                       </p:tgtEl>
@@ -18905,7 +20449,7 @@
                   </p:animEffect>
                   <p:animScale>
                     <p:cBhvr>
-                      <p:cTn id="16" dur="360" fill="hold"/>
+                      <p:cTn id="21" dur="360" fill="hold"/>
                       <p:tgtEl>
                         <p:spTgt spid="14"/>
                       </p:tgtEl>
@@ -18921,14 +20465,28 @@
               </p:cTn>
             </p:par>
             <p:par>
-              <p:cTn id="17" fill="hold" nodeType="afterEffect">
+              <p:cTn id="22" fill="hold" nodeType="afterEffect" presetID="22" presetClass="entr" presetSubtype="0">
                 <p:stCondLst>
                   <p:cond delay="1250"/>
                 </p:stCondLst>
                 <p:childTnLst>
+                  <p:set>
+                    <p:cBhvr>
+                      <p:cTn id="23" dur="1" fill="hold"/>
+                      <p:tgtEl>
+                        <p:spTgt spid="17"/>
+                      </p:tgtEl>
+                      <p:attrNameLst>
+                        <p:attrName>style.visibility</p:attrName>
+                      </p:attrNameLst>
+                    </p:cBhvr>
+                    <p:to>
+                      <p:strVal val="visible"/>
+                    </p:to>
+                  </p:set>
                   <p:animEffect transition="in" filter="fade">
                     <p:cBhvr>
-                      <p:cTn id="18" dur="360" fill="hold"/>
+                      <p:cTn id="24" dur="360" fill="hold"/>
                       <p:tgtEl>
                         <p:spTgt spid="17"/>
                       </p:tgtEl>
@@ -18936,7 +20494,7 @@
                   </p:animEffect>
                   <p:animScale>
                     <p:cBhvr>
-                      <p:cTn id="19" dur="360" fill="hold"/>
+                      <p:cTn id="25" dur="360" fill="hold"/>
                       <p:tgtEl>
                         <p:spTgt spid="17"/>
                       </p:tgtEl>
@@ -18952,14 +20510,28 @@
               </p:cTn>
             </p:par>
             <p:par>
-              <p:cTn id="20" fill="hold" nodeType="withEffect">
+              <p:cTn id="26" fill="hold" nodeType="withEffect" presetID="22" presetClass="entr" presetSubtype="0">
                 <p:stCondLst>
                   <p:cond delay="1250"/>
                 </p:stCondLst>
                 <p:childTnLst>
+                  <p:set>
+                    <p:cBhvr>
+                      <p:cTn id="27" dur="1" fill="hold"/>
+                      <p:tgtEl>
+                        <p:spTgt spid="18"/>
+                      </p:tgtEl>
+                      <p:attrNameLst>
+                        <p:attrName>style.visibility</p:attrName>
+                      </p:attrNameLst>
+                    </p:cBhvr>
+                    <p:to>
+                      <p:strVal val="visible"/>
+                    </p:to>
+                  </p:set>
                   <p:animEffect transition="in" filter="fade">
                     <p:cBhvr>
-                      <p:cTn id="21" dur="360" fill="hold"/>
+                      <p:cTn id="28" dur="360" fill="hold"/>
                       <p:tgtEl>
                         <p:spTgt spid="18"/>
                       </p:tgtEl>
@@ -18967,7 +20539,7 @@
                   </p:animEffect>
                   <p:animScale>
                     <p:cBhvr>
-                      <p:cTn id="22" dur="360" fill="hold"/>
+                      <p:cTn id="29" dur="360" fill="hold"/>
                       <p:tgtEl>
                         <p:spTgt spid="18"/>
                       </p:tgtEl>
@@ -18983,14 +20555,28 @@
               </p:cTn>
             </p:par>
             <p:par>
-              <p:cTn id="23" fill="hold" nodeType="withEffect">
+              <p:cTn id="30" fill="hold" nodeType="withEffect" presetID="22" presetClass="entr" presetSubtype="0">
                 <p:stCondLst>
                   <p:cond delay="1250"/>
                 </p:stCondLst>
                 <p:childTnLst>
+                  <p:set>
+                    <p:cBhvr>
+                      <p:cTn id="31" dur="1" fill="hold"/>
+                      <p:tgtEl>
+                        <p:spTgt spid="19"/>
+                      </p:tgtEl>
+                      <p:attrNameLst>
+                        <p:attrName>style.visibility</p:attrName>
+                      </p:attrNameLst>
+                    </p:cBhvr>
+                    <p:to>
+                      <p:strVal val="visible"/>
+                    </p:to>
+                  </p:set>
                   <p:animEffect transition="in" filter="fade">
                     <p:cBhvr>
-                      <p:cTn id="24" dur="360" fill="hold"/>
+                      <p:cTn id="32" dur="360" fill="hold"/>
                       <p:tgtEl>
                         <p:spTgt spid="19"/>
                       </p:tgtEl>
@@ -18998,7 +20584,7 @@
                   </p:animEffect>
                   <p:animScale>
                     <p:cBhvr>
-                      <p:cTn id="25" dur="360" fill="hold"/>
+                      <p:cTn id="33" dur="360" fill="hold"/>
                       <p:tgtEl>
                         <p:spTgt spid="19"/>
                       </p:tgtEl>
@@ -19014,14 +20600,28 @@
               </p:cTn>
             </p:par>
             <p:par>
-              <p:cTn id="26" fill="hold" nodeType="afterEffect">
+              <p:cTn id="34" fill="hold" nodeType="afterEffect" presetID="22" presetClass="entr" presetSubtype="0">
                 <p:stCondLst>
                   <p:cond delay="1550"/>
                 </p:stCondLst>
                 <p:childTnLst>
+                  <p:set>
+                    <p:cBhvr>
+                      <p:cTn id="35" dur="1" fill="hold"/>
+                      <p:tgtEl>
+                        <p:spTgt spid="22"/>
+                      </p:tgtEl>
+                      <p:attrNameLst>
+                        <p:attrName>style.visibility</p:attrName>
+                      </p:attrNameLst>
+                    </p:cBhvr>
+                    <p:to>
+                      <p:strVal val="visible"/>
+                    </p:to>
+                  </p:set>
                   <p:animEffect transition="in" filter="fade">
                     <p:cBhvr>
-                      <p:cTn id="27" dur="360" fill="hold"/>
+                      <p:cTn id="36" dur="360" fill="hold"/>
                       <p:tgtEl>
                         <p:spTgt spid="22"/>
                       </p:tgtEl>
@@ -19029,7 +20629,7 @@
                   </p:animEffect>
                   <p:animScale>
                     <p:cBhvr>
-                      <p:cTn id="28" dur="360" fill="hold"/>
+                      <p:cTn id="37" dur="360" fill="hold"/>
                       <p:tgtEl>
                         <p:spTgt spid="22"/>
                       </p:tgtEl>
@@ -19045,14 +20645,28 @@
               </p:cTn>
             </p:par>
             <p:par>
-              <p:cTn id="29" fill="hold" nodeType="withEffect">
+              <p:cTn id="38" fill="hold" nodeType="withEffect" presetID="22" presetClass="entr" presetSubtype="0">
                 <p:stCondLst>
                   <p:cond delay="1550"/>
                 </p:stCondLst>
                 <p:childTnLst>
+                  <p:set>
+                    <p:cBhvr>
+                      <p:cTn id="39" dur="1" fill="hold"/>
+                      <p:tgtEl>
+                        <p:spTgt spid="23"/>
+                      </p:tgtEl>
+                      <p:attrNameLst>
+                        <p:attrName>style.visibility</p:attrName>
+                      </p:attrNameLst>
+                    </p:cBhvr>
+                    <p:to>
+                      <p:strVal val="visible"/>
+                    </p:to>
+                  </p:set>
                   <p:animEffect transition="in" filter="fade">
                     <p:cBhvr>
-                      <p:cTn id="30" dur="360" fill="hold"/>
+                      <p:cTn id="40" dur="360" fill="hold"/>
                       <p:tgtEl>
                         <p:spTgt spid="23"/>
                       </p:tgtEl>
@@ -19060,7 +20674,7 @@
                   </p:animEffect>
                   <p:animScale>
                     <p:cBhvr>
-                      <p:cTn id="31" dur="360" fill="hold"/>
+                      <p:cTn id="41" dur="360" fill="hold"/>
                       <p:tgtEl>
                         <p:spTgt spid="23"/>
                       </p:tgtEl>
@@ -19076,14 +20690,28 @@
               </p:cTn>
             </p:par>
             <p:par>
-              <p:cTn id="32" fill="hold" nodeType="withEffect">
+              <p:cTn id="42" fill="hold" nodeType="withEffect" presetID="22" presetClass="entr" presetSubtype="0">
                 <p:stCondLst>
                   <p:cond delay="1550"/>
                 </p:stCondLst>
                 <p:childTnLst>
+                  <p:set>
+                    <p:cBhvr>
+                      <p:cTn id="43" dur="1" fill="hold"/>
+                      <p:tgtEl>
+                        <p:spTgt spid="24"/>
+                      </p:tgtEl>
+                      <p:attrNameLst>
+                        <p:attrName>style.visibility</p:attrName>
+                      </p:attrNameLst>
+                    </p:cBhvr>
+                    <p:to>
+                      <p:strVal val="visible"/>
+                    </p:to>
+                  </p:set>
                   <p:animEffect transition="in" filter="fade">
                     <p:cBhvr>
-                      <p:cTn id="33" dur="360" fill="hold"/>
+                      <p:cTn id="44" dur="360" fill="hold"/>
                       <p:tgtEl>
                         <p:spTgt spid="24"/>
                       </p:tgtEl>
@@ -19091,7 +20719,7 @@
                   </p:animEffect>
                   <p:animScale>
                     <p:cBhvr>
-                      <p:cTn id="34" dur="360" fill="hold"/>
+                      <p:cTn id="45" dur="360" fill="hold"/>
                       <p:tgtEl>
                         <p:spTgt spid="24"/>
                       </p:tgtEl>
@@ -19107,14 +20735,28 @@
               </p:cTn>
             </p:par>
             <p:par>
-              <p:cTn id="35" fill="hold" nodeType="afterEffect">
+              <p:cTn id="46" fill="hold" nodeType="afterEffect" presetID="22" presetClass="entr" presetSubtype="0">
                 <p:stCondLst>
                   <p:cond delay="1850"/>
                 </p:stCondLst>
                 <p:childTnLst>
+                  <p:set>
+                    <p:cBhvr>
+                      <p:cTn id="47" dur="1" fill="hold"/>
+                      <p:tgtEl>
+                        <p:spTgt spid="27"/>
+                      </p:tgtEl>
+                      <p:attrNameLst>
+                        <p:attrName>style.visibility</p:attrName>
+                      </p:attrNameLst>
+                    </p:cBhvr>
+                    <p:to>
+                      <p:strVal val="visible"/>
+                    </p:to>
+                  </p:set>
                   <p:animEffect transition="in" filter="fade">
                     <p:cBhvr>
-                      <p:cTn id="36" dur="360" fill="hold"/>
+                      <p:cTn id="48" dur="360" fill="hold"/>
                       <p:tgtEl>
                         <p:spTgt spid="27"/>
                       </p:tgtEl>
@@ -19122,7 +20764,7 @@
                   </p:animEffect>
                   <p:animScale>
                     <p:cBhvr>
-                      <p:cTn id="37" dur="360" fill="hold"/>
+                      <p:cTn id="49" dur="360" fill="hold"/>
                       <p:tgtEl>
                         <p:spTgt spid="27"/>
                       </p:tgtEl>
@@ -19138,14 +20780,28 @@
               </p:cTn>
             </p:par>
             <p:par>
-              <p:cTn id="38" fill="hold" nodeType="withEffect">
+              <p:cTn id="50" fill="hold" nodeType="withEffect" presetID="22" presetClass="entr" presetSubtype="0">
                 <p:stCondLst>
                   <p:cond delay="1850"/>
                 </p:stCondLst>
                 <p:childTnLst>
+                  <p:set>
+                    <p:cBhvr>
+                      <p:cTn id="51" dur="1" fill="hold"/>
+                      <p:tgtEl>
+                        <p:spTgt spid="28"/>
+                      </p:tgtEl>
+                      <p:attrNameLst>
+                        <p:attrName>style.visibility</p:attrName>
+                      </p:attrNameLst>
+                    </p:cBhvr>
+                    <p:to>
+                      <p:strVal val="visible"/>
+                    </p:to>
+                  </p:set>
                   <p:animEffect transition="in" filter="fade">
                     <p:cBhvr>
-                      <p:cTn id="39" dur="360" fill="hold"/>
+                      <p:cTn id="52" dur="360" fill="hold"/>
                       <p:tgtEl>
                         <p:spTgt spid="28"/>
                       </p:tgtEl>
@@ -19153,7 +20809,7 @@
                   </p:animEffect>
                   <p:animScale>
                     <p:cBhvr>
-                      <p:cTn id="40" dur="360" fill="hold"/>
+                      <p:cTn id="53" dur="360" fill="hold"/>
                       <p:tgtEl>
                         <p:spTgt spid="28"/>
                       </p:tgtEl>
@@ -19169,14 +20825,28 @@
               </p:cTn>
             </p:par>
             <p:par>
-              <p:cTn id="41" fill="hold" nodeType="withEffect">
+              <p:cTn id="54" fill="hold" nodeType="withEffect" presetID="22" presetClass="entr" presetSubtype="0">
                 <p:stCondLst>
                   <p:cond delay="1850"/>
                 </p:stCondLst>
                 <p:childTnLst>
+                  <p:set>
+                    <p:cBhvr>
+                      <p:cTn id="55" dur="1" fill="hold"/>
+                      <p:tgtEl>
+                        <p:spTgt spid="29"/>
+                      </p:tgtEl>
+                      <p:attrNameLst>
+                        <p:attrName>style.visibility</p:attrName>
+                      </p:attrNameLst>
+                    </p:cBhvr>
+                    <p:to>
+                      <p:strVal val="visible"/>
+                    </p:to>
+                  </p:set>
                   <p:animEffect transition="in" filter="fade">
                     <p:cBhvr>
-                      <p:cTn id="42" dur="360" fill="hold"/>
+                      <p:cTn id="56" dur="360" fill="hold"/>
                       <p:tgtEl>
                         <p:spTgt spid="29"/>
                       </p:tgtEl>
@@ -19184,7 +20854,7 @@
                   </p:animEffect>
                   <p:animScale>
                     <p:cBhvr>
-                      <p:cTn id="43" dur="360" fill="hold"/>
+                      <p:cTn id="57" dur="360" fill="hold"/>
                       <p:tgtEl>
                         <p:spTgt spid="29"/>
                       </p:tgtEl>
@@ -19200,14 +20870,28 @@
               </p:cTn>
             </p:par>
             <p:par>
-              <p:cTn id="44" fill="hold" nodeType="afterEffect">
+              <p:cTn id="58" fill="hold" nodeType="afterEffect" presetID="10" presetClass="entr" presetSubtype="0">
                 <p:stCondLst>
                   <p:cond delay="2270"/>
                 </p:stCondLst>
                 <p:childTnLst>
+                  <p:set>
+                    <p:cBhvr>
+                      <p:cTn id="59" dur="1" fill="hold"/>
+                      <p:tgtEl>
+                        <p:spTgt spid="31"/>
+                      </p:tgtEl>
+                      <p:attrNameLst>
+                        <p:attrName>style.visibility</p:attrName>
+                      </p:attrNameLst>
+                    </p:cBhvr>
+                    <p:to>
+                      <p:strVal val="visible"/>
+                    </p:to>
+                  </p:set>
                   <p:animEffect transition="in" filter="fade">
                     <p:cBhvr>
-                      <p:cTn id="45" dur="350" fill="hold"/>
+                      <p:cTn id="60" dur="350" fill="hold"/>
                       <p:tgtEl>
                         <p:spTgt spid="31"/>
                       </p:tgtEl>
@@ -19981,14 +21665,28 @@
           </p:stCondLst>
           <p:childTnLst>
             <p:par>
-              <p:cTn id="2" fill="hold" nodeType="afterEffect">
+              <p:cTn id="2" fill="hold" nodeType="afterEffect" presetID="10" presetClass="entr" presetSubtype="0">
                 <p:stCondLst>
                   <p:cond delay="0"/>
                 </p:stCondLst>
                 <p:childTnLst>
+                  <p:set>
+                    <p:cBhvr>
+                      <p:cTn id="3" dur="1" fill="hold"/>
+                      <p:tgtEl>
+                        <p:spTgt spid="8"/>
+                      </p:tgtEl>
+                      <p:attrNameLst>
+                        <p:attrName>style.visibility</p:attrName>
+                      </p:attrNameLst>
+                    </p:cBhvr>
+                    <p:to>
+                      <p:strVal val="visible"/>
+                    </p:to>
+                  </p:set>
                   <p:animEffect transition="in" filter="fade">
                     <p:cBhvr>
-                      <p:cTn id="3" dur="500" fill="hold"/>
+                      <p:cTn id="4" dur="500" fill="hold"/>
                       <p:tgtEl>
                         <p:spTgt spid="8"/>
                       </p:tgtEl>
@@ -19998,14 +21696,28 @@
               </p:cTn>
             </p:par>
             <p:par>
-              <p:cTn id="5" fill="hold" nodeType="afterEffect">
+              <p:cTn id="6" fill="hold" nodeType="afterEffect" presetID="10" presetClass="entr" presetSubtype="0">
                 <p:stCondLst>
                   <p:cond delay="560"/>
                 </p:stCondLst>
                 <p:childTnLst>
+                  <p:set>
+                    <p:cBhvr>
+                      <p:cTn id="7" dur="1" fill="hold"/>
+                      <p:tgtEl>
+                        <p:spTgt spid="11"/>
+                      </p:tgtEl>
+                      <p:attrNameLst>
+                        <p:attrName>style.visibility</p:attrName>
+                      </p:attrNameLst>
+                    </p:cBhvr>
+                    <p:to>
+                      <p:strVal val="visible"/>
+                    </p:to>
+                  </p:set>
                   <p:animEffect transition="in" filter="fade">
                     <p:cBhvr>
-                      <p:cTn id="6" dur="350" fill="hold"/>
+                      <p:cTn id="8" dur="350" fill="hold"/>
                       <p:tgtEl>
                         <p:spTgt spid="11"/>
                       </p:tgtEl>
@@ -20015,14 +21727,14 @@
               </p:cTn>
             </p:par>
             <p:par>
-              <p:cTn id="8" fill="hold" nodeType="afterEffect">
+              <p:cTn id="10" fill="hold" nodeType="afterEffect" presetID="2819" presetClass="entr" presetSubtype="0">
                 <p:stCondLst>
                   <p:cond delay="770"/>
                 </p:stCondLst>
                 <p:childTnLst>
-                  <p:animEffect transition="in" filter="wipe(fromLeft)">
-                    <p:cBhvr>
-                      <p:cTn id="9" dur="300" fill="hold"/>
+                  <p:set>
+                    <p:cBhvr>
+                      <p:cTn id="11" dur="1" fill="hold"/>
                       <p:tgtEl>
                         <p:spTgt spid="12">
                           <p:txEl>
@@ -20030,20 +21742,38 @@
                           </p:txEl>
                         </p:spTgt>
                       </p:tgtEl>
+                      <p:attrNameLst>
+                        <p:attrName>style.visibility</p:attrName>
+                      </p:attrNameLst>
+                    </p:cBhvr>
+                    <p:to>
+                      <p:strVal val="visible"/>
+                    </p:to>
+                  </p:set>
+                  <p:animEffect transition="in" filter="wipe(right)">
+                    <p:cBhvr>
+                      <p:cTn id="12" dur="300" fill="hold"/>
+                      <p:tgtEl>
+                        <p:spTgt spid="12">
+                          <p:txEl>
+                            <p:pRg st="0" end="0"/>
+                          </p:txEl>
+                        </p:spTgt>
+                      </p:tgtEl>
                     </p:cBhvr>
                   </p:animEffect>
                 </p:childTnLst>
               </p:cTn>
             </p:par>
             <p:par>
-              <p:cTn id="11" fill="hold" nodeType="afterEffect">
+              <p:cTn id="14" fill="hold" nodeType="afterEffect" presetID="2819" presetClass="entr" presetSubtype="0">
                 <p:stCondLst>
                   <p:cond delay="940"/>
                 </p:stCondLst>
                 <p:childTnLst>
-                  <p:animEffect transition="in" filter="wipe(fromLeft)">
-                    <p:cBhvr>
-                      <p:cTn id="12" dur="300" fill="hold"/>
+                  <p:set>
+                    <p:cBhvr>
+                      <p:cTn id="15" dur="1" fill="hold"/>
                       <p:tgtEl>
                         <p:spTgt spid="12">
                           <p:txEl>
@@ -20051,20 +21781,38 @@
                           </p:txEl>
                         </p:spTgt>
                       </p:tgtEl>
+                      <p:attrNameLst>
+                        <p:attrName>style.visibility</p:attrName>
+                      </p:attrNameLst>
+                    </p:cBhvr>
+                    <p:to>
+                      <p:strVal val="visible"/>
+                    </p:to>
+                  </p:set>
+                  <p:animEffect transition="in" filter="wipe(right)">
+                    <p:cBhvr>
+                      <p:cTn id="16" dur="300" fill="hold"/>
+                      <p:tgtEl>
+                        <p:spTgt spid="12">
+                          <p:txEl>
+                            <p:pRg st="1" end="1"/>
+                          </p:txEl>
+                        </p:spTgt>
+                      </p:tgtEl>
                     </p:cBhvr>
                   </p:animEffect>
                 </p:childTnLst>
               </p:cTn>
             </p:par>
             <p:par>
-              <p:cTn id="14" fill="hold" nodeType="afterEffect">
+              <p:cTn id="18" fill="hold" nodeType="afterEffect" presetID="2819" presetClass="entr" presetSubtype="0">
                 <p:stCondLst>
                   <p:cond delay="1110"/>
                 </p:stCondLst>
                 <p:childTnLst>
-                  <p:animEffect transition="in" filter="wipe(fromLeft)">
-                    <p:cBhvr>
-                      <p:cTn id="15" dur="300" fill="hold"/>
+                  <p:set>
+                    <p:cBhvr>
+                      <p:cTn id="19" dur="1" fill="hold"/>
                       <p:tgtEl>
                         <p:spTgt spid="12">
                           <p:txEl>
@@ -20072,20 +21820,38 @@
                           </p:txEl>
                         </p:spTgt>
                       </p:tgtEl>
+                      <p:attrNameLst>
+                        <p:attrName>style.visibility</p:attrName>
+                      </p:attrNameLst>
+                    </p:cBhvr>
+                    <p:to>
+                      <p:strVal val="visible"/>
+                    </p:to>
+                  </p:set>
+                  <p:animEffect transition="in" filter="wipe(right)">
+                    <p:cBhvr>
+                      <p:cTn id="20" dur="300" fill="hold"/>
+                      <p:tgtEl>
+                        <p:spTgt spid="12">
+                          <p:txEl>
+                            <p:pRg st="2" end="2"/>
+                          </p:txEl>
+                        </p:spTgt>
+                      </p:tgtEl>
                     </p:cBhvr>
                   </p:animEffect>
                 </p:childTnLst>
               </p:cTn>
             </p:par>
             <p:par>
-              <p:cTn id="17" fill="hold" nodeType="afterEffect">
+              <p:cTn id="22" fill="hold" nodeType="afterEffect" presetID="2819" presetClass="entr" presetSubtype="0">
                 <p:stCondLst>
                   <p:cond delay="1280"/>
                 </p:stCondLst>
                 <p:childTnLst>
-                  <p:animEffect transition="in" filter="wipe(fromLeft)">
-                    <p:cBhvr>
-                      <p:cTn id="18" dur="300" fill="hold"/>
+                  <p:set>
+                    <p:cBhvr>
+                      <p:cTn id="23" dur="1" fill="hold"/>
                       <p:tgtEl>
                         <p:spTgt spid="12">
                           <p:txEl>
@@ -20093,20 +21859,52 @@
                           </p:txEl>
                         </p:spTgt>
                       </p:tgtEl>
+                      <p:attrNameLst>
+                        <p:attrName>style.visibility</p:attrName>
+                      </p:attrNameLst>
+                    </p:cBhvr>
+                    <p:to>
+                      <p:strVal val="visible"/>
+                    </p:to>
+                  </p:set>
+                  <p:animEffect transition="in" filter="wipe(right)">
+                    <p:cBhvr>
+                      <p:cTn id="24" dur="300" fill="hold"/>
+                      <p:tgtEl>
+                        <p:spTgt spid="12">
+                          <p:txEl>
+                            <p:pRg st="3" end="3"/>
+                          </p:txEl>
+                        </p:spTgt>
+                      </p:tgtEl>
                     </p:cBhvr>
                   </p:animEffect>
                 </p:childTnLst>
               </p:cTn>
             </p:par>
             <p:par>
-              <p:cTn id="20" fill="hold" nodeType="afterEffect">
+              <p:cTn id="26" fill="hold" nodeType="afterEffect" presetID="10" presetClass="entr" presetSubtype="0">
                 <p:stCondLst>
                   <p:cond delay="1450"/>
                 </p:stCondLst>
                 <p:childTnLst>
+                  <p:set>
+                    <p:cBhvr>
+                      <p:cTn id="27" dur="1" fill="hold"/>
+                      <p:tgtEl>
+                        <p:spTgt spid="13"/>
+                      </p:tgtEl>
+                      <p:attrNameLst>
+                        <p:attrName>style.visibility</p:attrName>
+                      </p:attrNameLst>
+                    </p:cBhvr>
+                    <p:to>
+                      <p:strVal val="visible"/>
+                    </p:to>
+                  </p:set>
                   <p:animEffect transition="in" filter="fade">
                     <p:cBhvr>
-                      <p:cTn id="21" dur="350" fill="hold"/>
+                      <p:cTn id="28" dur="350" fill="hold"/>
                       <p:tgtEl>
                         <p:spTgt spid="13"/>
                       </p:tgtEl>
@@ -20116,14 +21914,14 @@
               </p:cTn>
             </p:par>
             <p:par>
-              <p:cTn id="23" fill="hold" nodeType="afterEffect">
+              <p:cTn id="30" fill="hold" nodeType="afterEffect" presetID="2819" presetClass="entr" presetSubtype="0">
                 <p:stCondLst>
                   <p:cond delay="1660"/>
                 </p:stCondLst>
                 <p:childTnLst>
-                  <p:animEffect transition="in" filter="wipe(fromLeft)">
-                    <p:cBhvr>
-                      <p:cTn id="24" dur="300" fill="hold"/>
+                  <p:set>
+                    <p:cBhvr>
+                      <p:cTn id="31" dur="1" fill="hold"/>
                       <p:tgtEl>
                         <p:spTgt spid="14">
                           <p:txEl>
@@ -20131,20 +21929,38 @@
                           </p:txEl>
                         </p:spTgt>
                       </p:tgtEl>
+                      <p:attrNameLst>
+                        <p:attrName>style.visibility</p:attrName>
+                      </p:attrNameLst>
+                    </p:cBhvr>
+                    <p:to>
+                      <p:strVal val="visible"/>
+                    </p:to>
+                  </p:set>
+                  <p:animEffect transition="in" filter="wipe(right)">
+                    <p:cBhvr>
+                      <p:cTn id="32" dur="300" fill="hold"/>
+                      <p:tgtEl>
+                        <p:spTgt spid="14">
+                          <p:txEl>
+                            <p:pRg st="0" end="0"/>
+                          </p:txEl>
+                        </p:spTgt>
+                      </p:tgtEl>
                     </p:cBhvr>
                   </p:animEffect>
                 </p:childTnLst>
               </p:cTn>
             </p:par>
             <p:par>
-              <p:cTn id="26" fill="hold" nodeType="afterEffect">
+              <p:cTn id="34" fill="hold" nodeType="afterEffect" presetID="2819" presetClass="entr" presetSubtype="0">
                 <p:stCondLst>
                   <p:cond delay="1830"/>
                 </p:stCondLst>
                 <p:childTnLst>
-                  <p:animEffect transition="in" filter="wipe(fromLeft)">
-                    <p:cBhvr>
-                      <p:cTn id="27" dur="300" fill="hold"/>
+                  <p:set>
+                    <p:cBhvr>
+                      <p:cTn id="35" dur="1" fill="hold"/>
                       <p:tgtEl>
                         <p:spTgt spid="14">
                           <p:txEl>
@@ -20152,20 +21968,38 @@
                           </p:txEl>
                         </p:spTgt>
                       </p:tgtEl>
+                      <p:attrNameLst>
+                        <p:attrName>style.visibility</p:attrName>
+                      </p:attrNameLst>
+                    </p:cBhvr>
+                    <p:to>
+                      <p:strVal val="visible"/>
+                    </p:to>
+                  </p:set>
+                  <p:animEffect transition="in" filter="wipe(right)">
+                    <p:cBhvr>
+                      <p:cTn id="36" dur="300" fill="hold"/>
+                      <p:tgtEl>
+                        <p:spTgt spid="14">
+                          <p:txEl>
+                            <p:pRg st="1" end="1"/>
+                          </p:txEl>
+                        </p:spTgt>
+                      </p:tgtEl>
                     </p:cBhvr>
                   </p:animEffect>
                 </p:childTnLst>
               </p:cTn>
             </p:par>
             <p:par>
-              <p:cTn id="29" fill="hold" nodeType="afterEffect">
+              <p:cTn id="38" fill="hold" nodeType="afterEffect" presetID="2819" presetClass="entr" presetSubtype="0">
                 <p:stCondLst>
                   <p:cond delay="2000"/>
                 </p:stCondLst>
                 <p:childTnLst>
-                  <p:animEffect transition="in" filter="wipe(fromLeft)">
-                    <p:cBhvr>
-                      <p:cTn id="30" dur="300" fill="hold"/>
+                  <p:set>
+                    <p:cBhvr>
+                      <p:cTn id="39" dur="1" fill="hold"/>
                       <p:tgtEl>
                         <p:spTgt spid="14">
                           <p:txEl>
@@ -20173,20 +22007,56 @@
                           </p:txEl>
                         </p:spTgt>
                       </p:tgtEl>
+                      <p:attrNameLst>
+                        <p:attrName>style.visibility</p:attrName>
+                      </p:attrNameLst>
+                    </p:cBhvr>
+                    <p:to>
+                      <p:strVal val="visible"/>
+                    </p:to>
+                  </p:set>
+                  <p:animEffect transition="in" filter="wipe(right)">
+                    <p:cBhvr>
+                      <p:cTn id="40" dur="300" fill="hold"/>
+                      <p:tgtEl>
+                        <p:spTgt spid="14">
+                          <p:txEl>
+                            <p:pRg st="2" end="2"/>
+                          </p:txEl>
+                        </p:spTgt>
+                      </p:tgtEl>
                     </p:cBhvr>
                   </p:animEffect>
                 </p:childTnLst>
               </p:cTn>
             </p:par>
             <p:par>
-              <p:cTn id="32" fill="hold" nodeType="afterEffect">
+              <p:cTn id="42" fill="hold" nodeType="afterEffect" presetID="2819" presetClass="entr" presetSubtype="0">
                 <p:stCondLst>
                   <p:cond delay="2170"/>
                 </p:stCondLst>
                 <p:childTnLst>
-                  <p:animEffect transition="in" filter="wipe(fromLeft)">
-                    <p:cBhvr>
-                      <p:cTn id="33" dur="300" fill="hold"/>
+                  <p:set>
+                    <p:cBhvr>
+                      <p:cTn id="43" dur="1" fill="hold"/>
+                      <p:tgtEl>
+                        <p:spTgt spid="14">
+                          <p:txEl>
+                            <p:pRg st="3" end="3"/>
+                          </p:txEl>
+                        </p:spTgt>
+                      </p:tgtEl>
+                      <p:attrNameLst>
+                        <p:attrName>style.visibility</p:attrName>
+                      </p:attrNameLst>
+                    </p:cBhvr>
+                    <p:to>
+                      <p:strVal val="visible"/>
+                    </p:to>
+                  </p:set>
+                  <p:animEffect transition="in" filter="wipe(right)">
+                    <p:cBhvr>
+                      <p:cTn id="44" dur="300" fill="hold"/>
                       <p:tgtEl>
                         <p:spTgt spid="14">
                           <p:txEl>

</xml_diff>